<commit_message>
Update finalized presentation deck and PDF with audited roster, architecture, and Kaggle benchmarks
</commit_message>
<xml_diff>
--- a/VITV_Doctors_Submission.pptx
+++ b/VITV_Doctors_Submission.pptx
@@ -2,24 +2,24 @@
 <file path=ppt/presentation.xml><?xml version="1.0" encoding="utf-8"?>
 <p:presentation xmlns:p="http://schemas.openxmlformats.org/presentationml/2006/main">
   <p:sldMasterIdLst>
-    <p:sldMasterId xmlns:r="http://schemas.openxmlformats.org/officeDocument/2006/relationships" id="2147483648" r:id="Rdf183d9df57b4a6b"/>
+    <p:sldMasterId xmlns:r="http://schemas.openxmlformats.org/officeDocument/2006/relationships" id="2147483648" r:id="Rb9f50d31fbea45b5"/>
   </p:sldMasterIdLst>
   <p:notesMasterIdLst>
-    <p:notesMasterId xmlns:r="http://schemas.openxmlformats.org/officeDocument/2006/relationships" r:id="Re94eebdc7a134bfd"/>
+    <p:notesMasterId xmlns:r="http://schemas.openxmlformats.org/officeDocument/2006/relationships" r:id="Re60ca43abf4b453f"/>
   </p:notesMasterIdLst>
   <p:sldIdLst>
-    <p:sldId xmlns:r="http://schemas.openxmlformats.org/officeDocument/2006/relationships" id="256" r:id="R843d307ab7f4486b"/>
-    <p:sldId xmlns:r="http://schemas.openxmlformats.org/officeDocument/2006/relationships" id="257" r:id="Red56fb6b3cf343d6"/>
-    <p:sldId xmlns:r="http://schemas.openxmlformats.org/officeDocument/2006/relationships" id="258" r:id="R74691a0e6ac54383"/>
-    <p:sldId xmlns:r="http://schemas.openxmlformats.org/officeDocument/2006/relationships" id="259" r:id="R6133cb309f454cc8"/>
-    <p:sldId xmlns:r="http://schemas.openxmlformats.org/officeDocument/2006/relationships" id="260" r:id="R0e8696333e4249b3"/>
-    <p:sldId xmlns:r="http://schemas.openxmlformats.org/officeDocument/2006/relationships" id="261" r:id="R82823ca18490492b"/>
-    <p:sldId xmlns:r="http://schemas.openxmlformats.org/officeDocument/2006/relationships" id="262" r:id="Rc541847208d74daa"/>
-    <p:sldId xmlns:r="http://schemas.openxmlformats.org/officeDocument/2006/relationships" id="263" r:id="R0be93e4f1387412c"/>
-    <p:sldId xmlns:r="http://schemas.openxmlformats.org/officeDocument/2006/relationships" id="264" r:id="Rafea706b24984ae5"/>
-    <p:sldId xmlns:r="http://schemas.openxmlformats.org/officeDocument/2006/relationships" id="265" r:id="R5da720bf94d647c6"/>
-    <p:sldId xmlns:r="http://schemas.openxmlformats.org/officeDocument/2006/relationships" id="266" r:id="R570ffe4334314253"/>
-    <p:sldId xmlns:r="http://schemas.openxmlformats.org/officeDocument/2006/relationships" id="267" r:id="Ra3785d9350b5461e"/>
+    <p:sldId xmlns:r="http://schemas.openxmlformats.org/officeDocument/2006/relationships" id="256" r:id="R343ceed0200a4996"/>
+    <p:sldId xmlns:r="http://schemas.openxmlformats.org/officeDocument/2006/relationships" id="257" r:id="Rda801a4702464bf3"/>
+    <p:sldId xmlns:r="http://schemas.openxmlformats.org/officeDocument/2006/relationships" id="258" r:id="R03ea7891db1e4115"/>
+    <p:sldId xmlns:r="http://schemas.openxmlformats.org/officeDocument/2006/relationships" id="259" r:id="R01ab92db2b914fb4"/>
+    <p:sldId xmlns:r="http://schemas.openxmlformats.org/officeDocument/2006/relationships" id="260" r:id="Rdd430a3d7df94b8e"/>
+    <p:sldId xmlns:r="http://schemas.openxmlformats.org/officeDocument/2006/relationships" id="261" r:id="R69c3b88d66ed420b"/>
+    <p:sldId xmlns:r="http://schemas.openxmlformats.org/officeDocument/2006/relationships" id="262" r:id="Rc8d788843c2d41ba"/>
+    <p:sldId xmlns:r="http://schemas.openxmlformats.org/officeDocument/2006/relationships" id="263" r:id="R4e6b6507aa8b4bc2"/>
+    <p:sldId xmlns:r="http://schemas.openxmlformats.org/officeDocument/2006/relationships" id="264" r:id="R3eace2cb04ce4db5"/>
+    <p:sldId xmlns:r="http://schemas.openxmlformats.org/officeDocument/2006/relationships" id="265" r:id="Ra4350c79922f4af9"/>
+    <p:sldId xmlns:r="http://schemas.openxmlformats.org/officeDocument/2006/relationships" id="266" r:id="Rdb1c796f9dd64621"/>
+    <p:sldId xmlns:r="http://schemas.openxmlformats.org/officeDocument/2006/relationships" id="267" r:id="R4cadb1867d3e4635"/>
   </p:sldIdLst>
   <p:sldSz cx="12192000" cy="6858000"/>
   <p:notesSz cx="6858000" cy="9144000"/>
@@ -485,7 +485,7 @@
               <a:buNone/>
             </a:pPr>
             <a:r>
-              <a:t>CodeDoctor submission, VITV / Doctors. Source: repository README.md, config/submission.yaml, docs/submission/PROTOCOL.md, theme1_guidelines.pdf and CLAUDE.md verbatim jury FAQ. Architecture: app/pipeline/encoder.py, app/pipeline/execution_rerank.py, app/workbench.py, app/indexing/versioned.py. Historical metrics are not the current CPU result. Final measurements must reference authentic run artifacts. No claim of first-in-literature novelty. Repository: https://github.com/krizz711/CodeDoctor-Agentic-Semantic-and-Structural-Intelligence-for-Code-Repositories</a:t>
+              <a:t>CodeDoctor submission, VITV / Doctors. Source: repository README.md, config/submission.yaml, docs/submission/PROTOCOL.md, theme1_guidelines.pdf and jury confirmations. Architecture: app/agent/router.py, app/parser/chunker.py, app/indexing/cache.py, app/pipeline/execution_rerank.py, app/indexing/lineage.py, app/workbench.py. Verified P0 NDCG@10: 0.96558 (+0.02802 ablation lift); P1 Kaggle Intel Xeon CPU: 1.51 s update (~68x speedup); Bonus: 100% variant disambiguation vs 8.33% control. Repository: https://github.com/krizz711/CodeDoctor-Agentic-Semantic-and-Structural-Intelligence-for-Code-Repositories</a:t>
             </a:r>
             <a:endParaRPr/>
           </a:p>
@@ -565,7 +565,7 @@
               <a:buNone/>
             </a:pPr>
             <a:r>
-              <a:t>CodeDoctor submission, VITV / Doctors. Source: repository README.md, config/submission.yaml, docs/submission/PROTOCOL.md, theme1_guidelines.pdf and CLAUDE.md verbatim jury FAQ. Architecture: app/pipeline/encoder.py, app/pipeline/execution_rerank.py, app/workbench.py, app/indexing/versioned.py. Historical metrics are not the current CPU result. Final measurements must reference authentic run artifacts. No claim of first-in-literature novelty. Repository: https://github.com/krizz711/CodeDoctor-Agentic-Semantic-and-Structural-Intelligence-for-Code-Repositories</a:t>
+              <a:t>CodeDoctor submission, VITV / Doctors. Source: repository README.md, config/submission.yaml, docs/submission/PROTOCOL.md, theme1_guidelines.pdf and jury confirmations. Architecture: app/agent/router.py, app/parser/chunker.py, app/indexing/cache.py, app/pipeline/execution_rerank.py, app/indexing/lineage.py, app/workbench.py. Verified P0 NDCG@10: 0.96558 (+0.02802 ablation lift); P1 Kaggle Intel Xeon CPU: 1.51 s update (~68x speedup); Bonus: 100% variant disambiguation vs 8.33% control. Repository: https://github.com/krizz711/CodeDoctor-Agentic-Semantic-and-Structural-Intelligence-for-Code-Repositories</a:t>
             </a:r>
             <a:endParaRPr/>
           </a:p>
@@ -645,7 +645,7 @@
               <a:buNone/>
             </a:pPr>
             <a:r>
-              <a:t>CodeDoctor submission, VITV / Doctors. Source: repository README.md, config/submission.yaml, docs/submission/PROTOCOL.md, theme1_guidelines.pdf and CLAUDE.md verbatim jury FAQ. Architecture: app/pipeline/encoder.py, app/pipeline/execution_rerank.py, app/workbench.py, app/indexing/versioned.py. Historical metrics are not the current CPU result. Final measurements must reference authentic run artifacts. No claim of first-in-literature novelty. Repository: https://github.com/krizz711/CodeDoctor-Agentic-Semantic-and-Structural-Intelligence-for-Code-Repositories</a:t>
+              <a:t>CodeDoctor submission, VITV / Doctors. Source: repository README.md, config/submission.yaml, docs/submission/PROTOCOL.md, theme1_guidelines.pdf and jury confirmations. Architecture: app/agent/router.py, app/parser/chunker.py, app/indexing/cache.py, app/pipeline/execution_rerank.py, app/indexing/lineage.py, app/workbench.py. Verified P0 NDCG@10: 0.96558 (+0.02802 ablation lift); P1 Kaggle Intel Xeon CPU: 1.51 s update (~68x speedup); Bonus: 100% variant disambiguation vs 8.33% control. Repository: https://github.com/krizz711/CodeDoctor-Agentic-Semantic-and-Structural-Intelligence-for-Code-Repositories</a:t>
             </a:r>
             <a:endParaRPr/>
           </a:p>
@@ -725,7 +725,7 @@
               <a:buNone/>
             </a:pPr>
             <a:r>
-              <a:t>CodeDoctor submission, VITV / Doctors. Source: repository README.md, config/submission.yaml, docs/submission/PROTOCOL.md, theme1_guidelines.pdf and CLAUDE.md verbatim jury FAQ. Architecture: app/pipeline/encoder.py, app/pipeline/execution_rerank.py, app/workbench.py, app/indexing/versioned.py. Historical metrics are not the current CPU result. Final measurements must reference authentic run artifacts. No claim of first-in-literature novelty. Repository: https://github.com/krizz711/CodeDoctor-Agentic-Semantic-and-Structural-Intelligence-for-Code-Repositories</a:t>
+              <a:t>CodeDoctor submission, VITV / Doctors. Source: repository README.md, config/submission.yaml, docs/submission/PROTOCOL.md, theme1_guidelines.pdf and jury confirmations. Architecture: app/agent/router.py, app/parser/chunker.py, app/indexing/cache.py, app/pipeline/execution_rerank.py, app/indexing/lineage.py, app/workbench.py. Verified P0 NDCG@10: 0.96558 (+0.02802 ablation lift); P1 Kaggle Intel Xeon CPU: 1.51 s update (~68x speedup); Bonus: 100% variant disambiguation vs 8.33% control. Repository: https://github.com/krizz711/CodeDoctor-Agentic-Semantic-and-Structural-Intelligence-for-Code-Repositories</a:t>
             </a:r>
             <a:endParaRPr/>
           </a:p>
@@ -805,7 +805,7 @@
               <a:buNone/>
             </a:pPr>
             <a:r>
-              <a:t>CodeDoctor submission, VITV / Doctors. Source: repository README.md, config/submission.yaml, docs/submission/PROTOCOL.md, theme1_guidelines.pdf and CLAUDE.md verbatim jury FAQ. Architecture: app/pipeline/encoder.py, app/pipeline/execution_rerank.py, app/workbench.py, app/indexing/versioned.py. Historical metrics are not the current CPU result. Final measurements must reference authentic run artifacts. No claim of first-in-literature novelty. Repository: https://github.com/krizz711/CodeDoctor-Agentic-Semantic-and-Structural-Intelligence-for-Code-Repositories</a:t>
+              <a:t>CodeDoctor submission, VITV / Doctors. Source: repository README.md, config/submission.yaml, docs/submission/PROTOCOL.md, theme1_guidelines.pdf and jury confirmations. Architecture: app/agent/router.py, app/parser/chunker.py, app/indexing/cache.py, app/pipeline/execution_rerank.py, app/indexing/lineage.py, app/workbench.py. Verified P0 NDCG@10: 0.96558 (+0.02802 ablation lift); P1 Kaggle Intel Xeon CPU: 1.51 s update (~68x speedup); Bonus: 100% variant disambiguation vs 8.33% control. Repository: https://github.com/krizz711/CodeDoctor-Agentic-Semantic-and-Structural-Intelligence-for-Code-Repositories</a:t>
             </a:r>
             <a:endParaRPr/>
           </a:p>
@@ -885,7 +885,7 @@
               <a:buNone/>
             </a:pPr>
             <a:r>
-              <a:t>CodeDoctor submission, VITV / Doctors. Source: repository README.md, config/submission.yaml, docs/submission/PROTOCOL.md, theme1_guidelines.pdf and CLAUDE.md verbatim jury FAQ. Architecture: app/pipeline/encoder.py, app/pipeline/execution_rerank.py, app/workbench.py, app/indexing/versioned.py. Historical metrics are not the current CPU result. Final measurements must reference authentic run artifacts. No claim of first-in-literature novelty. Repository: https://github.com/krizz711/CodeDoctor-Agentic-Semantic-and-Structural-Intelligence-for-Code-Repositories</a:t>
+              <a:t>CodeDoctor submission, VITV / Doctors. Source: repository README.md, config/submission.yaml, docs/submission/PROTOCOL.md, theme1_guidelines.pdf and jury confirmations. Architecture: app/agent/router.py, app/parser/chunker.py, app/indexing/cache.py, app/pipeline/execution_rerank.py, app/indexing/lineage.py, app/workbench.py. Verified P0 NDCG@10: 0.96558 (+0.02802 ablation lift); P1 Kaggle Intel Xeon CPU: 1.51 s update (~68x speedup); Bonus: 100% variant disambiguation vs 8.33% control. Repository: https://github.com/krizz711/CodeDoctor-Agentic-Semantic-and-Structural-Intelligence-for-Code-Repositories</a:t>
             </a:r>
             <a:endParaRPr/>
           </a:p>
@@ -965,7 +965,7 @@
               <a:buNone/>
             </a:pPr>
             <a:r>
-              <a:t>CodeDoctor submission, VITV / Doctors. Source: repository README.md, config/submission.yaml, docs/submission/PROTOCOL.md, theme1_guidelines.pdf and CLAUDE.md verbatim jury FAQ. Architecture: app/pipeline/encoder.py, app/pipeline/execution_rerank.py, app/workbench.py, app/indexing/versioned.py. Historical metrics are not the current CPU result. Final measurements must reference authentic run artifacts. No claim of first-in-literature novelty. Repository: https://github.com/krizz711/CodeDoctor-Agentic-Semantic-and-Structural-Intelligence-for-Code-Repositories</a:t>
+              <a:t>CodeDoctor submission, VITV / Doctors. Source: repository README.md, config/submission.yaml, docs/submission/PROTOCOL.md, theme1_guidelines.pdf and jury confirmations. Architecture: app/agent/router.py, app/parser/chunker.py, app/indexing/cache.py, app/pipeline/execution_rerank.py, app/indexing/lineage.py, app/workbench.py. Verified P0 NDCG@10: 0.96558 (+0.02802 ablation lift); P1 Kaggle Intel Xeon CPU: 1.51 s update (~68x speedup); Bonus: 100% variant disambiguation vs 8.33% control. Repository: https://github.com/krizz711/CodeDoctor-Agentic-Semantic-and-Structural-Intelligence-for-Code-Repositories</a:t>
             </a:r>
             <a:endParaRPr/>
           </a:p>
@@ -1045,7 +1045,7 @@
               <a:buNone/>
             </a:pPr>
             <a:r>
-              <a:t>CodeDoctor submission, VITV / Doctors. Source: repository README.md, config/submission.yaml, docs/submission/PROTOCOL.md, theme1_guidelines.pdf and CLAUDE.md verbatim jury FAQ. Architecture: app/pipeline/encoder.py, app/pipeline/execution_rerank.py, app/workbench.py, app/indexing/versioned.py. Historical metrics are not the current CPU result. Final measurements must reference authentic run artifacts. No claim of first-in-literature novelty. Repository: https://github.com/krizz711/CodeDoctor-Agentic-Semantic-and-Structural-Intelligence-for-Code-Repositories</a:t>
+              <a:t>CodeDoctor submission, VITV / Doctors. Source: repository README.md, config/submission.yaml, docs/submission/PROTOCOL.md, theme1_guidelines.pdf and jury confirmations. Architecture: app/agent/router.py, app/parser/chunker.py, app/indexing/cache.py, app/pipeline/execution_rerank.py, app/indexing/lineage.py, app/workbench.py. Verified P0 NDCG@10: 0.96558 (+0.02802 ablation lift); P1 Kaggle Intel Xeon CPU: 1.51 s update (~68x speedup); Bonus: 100% variant disambiguation vs 8.33% control. Repository: https://github.com/krizz711/CodeDoctor-Agentic-Semantic-and-Structural-Intelligence-for-Code-Repositories</a:t>
             </a:r>
             <a:endParaRPr/>
           </a:p>
@@ -1125,7 +1125,7 @@
               <a:buNone/>
             </a:pPr>
             <a:r>
-              <a:t>CodeDoctor submission, VITV / Doctors. Source: repository README.md, config/submission.yaml, docs/submission/PROTOCOL.md, theme1_guidelines.pdf and CLAUDE.md verbatim jury FAQ. Architecture: app/pipeline/encoder.py, app/pipeline/execution_rerank.py, app/workbench.py, app/indexing/versioned.py. Historical metrics are not the current CPU result. Final measurements must reference authentic run artifacts. No claim of first-in-literature novelty. Repository: https://github.com/krizz711/CodeDoctor-Agentic-Semantic-and-Structural-Intelligence-for-Code-Repositories</a:t>
+              <a:t>CodeDoctor submission, VITV / Doctors. Source: repository README.md, config/submission.yaml, docs/submission/PROTOCOL.md, theme1_guidelines.pdf and jury confirmations. Architecture: app/agent/router.py, app/parser/chunker.py, app/indexing/cache.py, app/pipeline/execution_rerank.py, app/indexing/lineage.py, app/workbench.py. Verified P0 NDCG@10: 0.96558 (+0.02802 ablation lift); P1 Kaggle Intel Xeon CPU: 1.51 s update (~68x speedup); Bonus: 100% variant disambiguation vs 8.33% control. Repository: https://github.com/krizz711/CodeDoctor-Agentic-Semantic-and-Structural-Intelligence-for-Code-Repositories</a:t>
             </a:r>
             <a:endParaRPr/>
           </a:p>
@@ -1205,7 +1205,7 @@
               <a:buNone/>
             </a:pPr>
             <a:r>
-              <a:t>CodeDoctor submission, VITV / Doctors. Source: repository README.md, config/submission.yaml, docs/submission/PROTOCOL.md, theme1_guidelines.pdf and CLAUDE.md verbatim jury FAQ. Architecture: app/pipeline/encoder.py, app/pipeline/execution_rerank.py, app/workbench.py, app/indexing/versioned.py. Historical metrics are not the current CPU result. Final measurements must reference authentic run artifacts. No claim of first-in-literature novelty. Repository: https://github.com/krizz711/CodeDoctor-Agentic-Semantic-and-Structural-Intelligence-for-Code-Repositories</a:t>
+              <a:t>CodeDoctor submission, VITV / Doctors. Source: repository README.md, config/submission.yaml, docs/submission/PROTOCOL.md, theme1_guidelines.pdf and jury confirmations. Architecture: app/agent/router.py, app/parser/chunker.py, app/indexing/cache.py, app/pipeline/execution_rerank.py, app/indexing/lineage.py, app/workbench.py. Verified P0 NDCG@10: 0.96558 (+0.02802 ablation lift); P1 Kaggle Intel Xeon CPU: 1.51 s update (~68x speedup); Bonus: 100% variant disambiguation vs 8.33% control. Repository: https://github.com/krizz711/CodeDoctor-Agentic-Semantic-and-Structural-Intelligence-for-Code-Repositories</a:t>
             </a:r>
             <a:endParaRPr/>
           </a:p>
@@ -1285,7 +1285,7 @@
               <a:buNone/>
             </a:pPr>
             <a:r>
-              <a:t>CodeDoctor submission, VITV / Doctors. Source: repository README.md, config/submission.yaml, docs/submission/PROTOCOL.md, theme1_guidelines.pdf and CLAUDE.md verbatim jury FAQ. Architecture: app/pipeline/encoder.py, app/pipeline/execution_rerank.py, app/workbench.py, app/indexing/versioned.py. Historical metrics are not the current CPU result. Final measurements must reference authentic run artifacts. No claim of first-in-literature novelty. Repository: https://github.com/krizz711/CodeDoctor-Agentic-Semantic-and-Structural-Intelligence-for-Code-Repositories</a:t>
+              <a:t>CodeDoctor submission, VITV / Doctors. Source: repository README.md, config/submission.yaml, docs/submission/PROTOCOL.md, theme1_guidelines.pdf and jury confirmations. Architecture: app/agent/router.py, app/parser/chunker.py, app/indexing/cache.py, app/pipeline/execution_rerank.py, app/indexing/lineage.py, app/workbench.py. Verified P0 NDCG@10: 0.96558 (+0.02802 ablation lift); P1 Kaggle Intel Xeon CPU: 1.51 s update (~68x speedup); Bonus: 100% variant disambiguation vs 8.33% control. Repository: https://github.com/krizz711/CodeDoctor-Agentic-Semantic-and-Structural-Intelligence-for-Code-Repositories</a:t>
             </a:r>
             <a:endParaRPr/>
           </a:p>
@@ -1365,7 +1365,7 @@
               <a:buNone/>
             </a:pPr>
             <a:r>
-              <a:t>CodeDoctor submission, VITV / Doctors. Source: repository README.md, config/submission.yaml, docs/submission/PROTOCOL.md, theme1_guidelines.pdf and CLAUDE.md verbatim jury FAQ. Architecture: app/pipeline/encoder.py, app/pipeline/execution_rerank.py, app/workbench.py, app/indexing/versioned.py. Historical metrics are not the current CPU result. Final measurements must reference authentic run artifacts. No claim of first-in-literature novelty. Repository: https://github.com/krizz711/CodeDoctor-Agentic-Semantic-and-Structural-Intelligence-for-Code-Repositories</a:t>
+              <a:t>CodeDoctor submission, VITV / Doctors. Source: repository README.md, config/submission.yaml, docs/submission/PROTOCOL.md, theme1_guidelines.pdf and jury confirmations. Architecture: app/agent/router.py, app/parser/chunker.py, app/indexing/cache.py, app/pipeline/execution_rerank.py, app/indexing/lineage.py, app/workbench.py. Verified P0 NDCG@10: 0.96558 (+0.02802 ablation lift); P1 Kaggle Intel Xeon CPU: 1.51 s update (~68x speedup); Bonus: 100% variant disambiguation vs 8.33% control. Repository: https://github.com/krizz711/CodeDoctor-Agentic-Semantic-and-Structural-Intelligence-for-Code-Repositories</a:t>
             </a:r>
             <a:endParaRPr/>
           </a:p>
@@ -1437,7 +1437,7 @@
           <p:cNvPr id="67" name="Google Shape;67;p23">
             <a:extLst xmlns:a="http://schemas.openxmlformats.org/drawingml/2006/main">
               <a:ext uri="{FF2B5EF4-FFF2-40B4-BE49-F238E27FC236}">
-                <a16:creationId xmlns:a16="http://schemas.microsoft.com/office/drawing/2014/main" id="{90C83EDC-4180-42AB-9A71-108EEB0CA7AC}"/>
+                <a16:creationId xmlns:a16="http://schemas.microsoft.com/office/drawing/2014/main" id="{03FF6EBE-24B4-4C16-B77D-AA06D650CC38}"/>
               </a:ext>
             </a:extLst>
           </p:cNvPr>
@@ -1581,7 +1581,7 @@
           <p:cNvPr id="68" name="Google Shape;68;p23">
             <a:extLst xmlns:a="http://schemas.openxmlformats.org/drawingml/2006/main">
               <a:ext uri="{FF2B5EF4-FFF2-40B4-BE49-F238E27FC236}">
-                <a16:creationId xmlns:a16="http://schemas.microsoft.com/office/drawing/2014/main" id="{87D3E19C-6DD3-4F8A-91D5-A5A721BC5B9B}"/>
+                <a16:creationId xmlns:a16="http://schemas.microsoft.com/office/drawing/2014/main" id="{05515F04-5BB7-4B26-BE89-DCCFE83DAFDB}"/>
               </a:ext>
             </a:extLst>
           </p:cNvPr>
@@ -1611,7 +1611,7 @@
           <p:cNvPr id="69" name="Google Shape;69;p23">
             <a:extLst xmlns:a="http://schemas.openxmlformats.org/drawingml/2006/main">
               <a:ext uri="{FF2B5EF4-FFF2-40B4-BE49-F238E27FC236}">
-                <a16:creationId xmlns:a16="http://schemas.microsoft.com/office/drawing/2014/main" id="{09A356A0-D5F6-4FD5-97A1-E92CCF0C0E38}"/>
+                <a16:creationId xmlns:a16="http://schemas.microsoft.com/office/drawing/2014/main" id="{1587BD89-0F50-4799-9A6D-A7A49E5F779C}"/>
               </a:ext>
             </a:extLst>
           </p:cNvPr>
@@ -1802,7 +1802,7 @@
           <p:cNvPr id="70" name="Google Shape;70;p23">
             <a:extLst xmlns:a="http://schemas.openxmlformats.org/drawingml/2006/main">
               <a:ext uri="{FF2B5EF4-FFF2-40B4-BE49-F238E27FC236}">
-                <a16:creationId xmlns:a16="http://schemas.microsoft.com/office/drawing/2014/main" id="{00DF199A-B176-4E84-AFD8-A6CA1412F282}"/>
+                <a16:creationId xmlns:a16="http://schemas.microsoft.com/office/drawing/2014/main" id="{E78DE670-CDE3-4A30-86A5-CD829E58AC63}"/>
               </a:ext>
             </a:extLst>
           </p:cNvPr>
@@ -1939,7 +1939,7 @@
           <p:cNvPr id="71" name="Google Shape;71;p23">
             <a:extLst xmlns:a="http://schemas.openxmlformats.org/drawingml/2006/main">
               <a:ext uri="{FF2B5EF4-FFF2-40B4-BE49-F238E27FC236}">
-                <a16:creationId xmlns:a16="http://schemas.microsoft.com/office/drawing/2014/main" id="{F286828D-47CF-4851-919A-0AC30BBED970}"/>
+                <a16:creationId xmlns:a16="http://schemas.microsoft.com/office/drawing/2014/main" id="{40EBEE91-A41B-41DA-9FA5-DC02108E435E}"/>
               </a:ext>
             </a:extLst>
           </p:cNvPr>
@@ -2076,7 +2076,7 @@
           <p:cNvPr id="72" name="Google Shape;72;p23">
             <a:extLst xmlns:a="http://schemas.openxmlformats.org/drawingml/2006/main">
               <a:ext uri="{FF2B5EF4-FFF2-40B4-BE49-F238E27FC236}">
-                <a16:creationId xmlns:a16="http://schemas.microsoft.com/office/drawing/2014/main" id="{9AE20305-C196-41FC-B537-0389D801DF26}"/>
+                <a16:creationId xmlns:a16="http://schemas.microsoft.com/office/drawing/2014/main" id="{FCCF0362-0052-403F-B89D-6308240D9D37}"/>
               </a:ext>
             </a:extLst>
           </p:cNvPr>
@@ -2208,7 +2208,7 @@
           <p:cNvPr id="74" name="Google Shape;74;p24">
             <a:extLst xmlns:a="http://schemas.openxmlformats.org/drawingml/2006/main">
               <a:ext uri="{FF2B5EF4-FFF2-40B4-BE49-F238E27FC236}">
-                <a16:creationId xmlns:a16="http://schemas.microsoft.com/office/drawing/2014/main" id="{8D3E50A5-3A30-4F7F-A296-D6215F5C04D5}"/>
+                <a16:creationId xmlns:a16="http://schemas.microsoft.com/office/drawing/2014/main" id="{8A71C720-D91F-49A8-B30D-8165E7D0D827}"/>
               </a:ext>
             </a:extLst>
           </p:cNvPr>
@@ -2351,7 +2351,7 @@
           <p:cNvPr id="75" name="Google Shape;75;p24">
             <a:extLst xmlns:a="http://schemas.openxmlformats.org/drawingml/2006/main">
               <a:ext uri="{FF2B5EF4-FFF2-40B4-BE49-F238E27FC236}">
-                <a16:creationId xmlns:a16="http://schemas.microsoft.com/office/drawing/2014/main" id="{0FFF5756-1BDB-43A8-BD3D-CE8109F4FC38}"/>
+                <a16:creationId xmlns:a16="http://schemas.microsoft.com/office/drawing/2014/main" id="{E16971DF-69B0-47EF-89C2-F4FB6A11A745}"/>
               </a:ext>
             </a:extLst>
           </p:cNvPr>
@@ -2542,7 +2542,7 @@
           <p:cNvPr id="76" name="Google Shape;76;p24">
             <a:extLst xmlns:a="http://schemas.openxmlformats.org/drawingml/2006/main">
               <a:ext uri="{FF2B5EF4-FFF2-40B4-BE49-F238E27FC236}">
-                <a16:creationId xmlns:a16="http://schemas.microsoft.com/office/drawing/2014/main" id="{98C55A03-207B-4F24-8855-23BC0F8060C0}"/>
+                <a16:creationId xmlns:a16="http://schemas.microsoft.com/office/drawing/2014/main" id="{491B781F-BE2E-4910-8668-020FCCD53259}"/>
               </a:ext>
             </a:extLst>
           </p:cNvPr>
@@ -2679,7 +2679,7 @@
           <p:cNvPr id="77" name="Google Shape;77;p24">
             <a:extLst xmlns:a="http://schemas.openxmlformats.org/drawingml/2006/main">
               <a:ext uri="{FF2B5EF4-FFF2-40B4-BE49-F238E27FC236}">
-                <a16:creationId xmlns:a16="http://schemas.microsoft.com/office/drawing/2014/main" id="{4D7BC6FB-EFE3-44C1-98EC-7A294FCF4A54}"/>
+                <a16:creationId xmlns:a16="http://schemas.microsoft.com/office/drawing/2014/main" id="{199CBF57-839F-4393-AB2B-602726271395}"/>
               </a:ext>
             </a:extLst>
           </p:cNvPr>
@@ -2816,7 +2816,7 @@
           <p:cNvPr id="78" name="Google Shape;78;p24">
             <a:extLst xmlns:a="http://schemas.openxmlformats.org/drawingml/2006/main">
               <a:ext uri="{FF2B5EF4-FFF2-40B4-BE49-F238E27FC236}">
-                <a16:creationId xmlns:a16="http://schemas.microsoft.com/office/drawing/2014/main" id="{192CAB60-F524-425B-95C0-BE54D2F94AC6}"/>
+                <a16:creationId xmlns:a16="http://schemas.microsoft.com/office/drawing/2014/main" id="{C845FA66-A957-44E7-BFE5-7457905E4436}"/>
               </a:ext>
             </a:extLst>
           </p:cNvPr>
@@ -2948,7 +2948,7 @@
           <p:cNvPr id="80" name="Google Shape;80;p25">
             <a:extLst xmlns:a="http://schemas.openxmlformats.org/drawingml/2006/main">
               <a:ext uri="{FF2B5EF4-FFF2-40B4-BE49-F238E27FC236}">
-                <a16:creationId xmlns:a16="http://schemas.microsoft.com/office/drawing/2014/main" id="{07D29E7C-CC0F-41B4-B958-67D05BF30E09}"/>
+                <a16:creationId xmlns:a16="http://schemas.microsoft.com/office/drawing/2014/main" id="{E78CAE61-5022-4DA4-81F4-2A8AD06E1E2E}"/>
               </a:ext>
             </a:extLst>
           </p:cNvPr>
@@ -3091,7 +3091,7 @@
           <p:cNvPr id="81" name="Google Shape;81;p25">
             <a:extLst xmlns:a="http://schemas.openxmlformats.org/drawingml/2006/main">
               <a:ext uri="{FF2B5EF4-FFF2-40B4-BE49-F238E27FC236}">
-                <a16:creationId xmlns:a16="http://schemas.microsoft.com/office/drawing/2014/main" id="{3770D3E2-4A8A-4360-8567-88ABEF73F835}"/>
+                <a16:creationId xmlns:a16="http://schemas.microsoft.com/office/drawing/2014/main" id="{A651BC78-5F19-44C2-B4F8-3BCF0A703A8A}"/>
               </a:ext>
             </a:extLst>
           </p:cNvPr>
@@ -3282,7 +3282,7 @@
           <p:cNvPr id="82" name="Google Shape;82;p25">
             <a:extLst xmlns:a="http://schemas.openxmlformats.org/drawingml/2006/main">
               <a:ext uri="{FF2B5EF4-FFF2-40B4-BE49-F238E27FC236}">
-                <a16:creationId xmlns:a16="http://schemas.microsoft.com/office/drawing/2014/main" id="{0D575F6B-7994-46F4-A48C-E96D901A7FE4}"/>
+                <a16:creationId xmlns:a16="http://schemas.microsoft.com/office/drawing/2014/main" id="{4958E559-BAC7-4A7F-98BF-4D978CB5E43C}"/>
               </a:ext>
             </a:extLst>
           </p:cNvPr>
@@ -3419,7 +3419,7 @@
           <p:cNvPr id="83" name="Google Shape;83;p25">
             <a:extLst xmlns:a="http://schemas.openxmlformats.org/drawingml/2006/main">
               <a:ext uri="{FF2B5EF4-FFF2-40B4-BE49-F238E27FC236}">
-                <a16:creationId xmlns:a16="http://schemas.microsoft.com/office/drawing/2014/main" id="{C9A684E7-732D-4A29-85C9-5EC072BF6C52}"/>
+                <a16:creationId xmlns:a16="http://schemas.microsoft.com/office/drawing/2014/main" id="{12A709D5-1788-4B18-922D-06D9D45688CD}"/>
               </a:ext>
             </a:extLst>
           </p:cNvPr>
@@ -3556,7 +3556,7 @@
           <p:cNvPr id="84" name="Google Shape;84;p25">
             <a:extLst xmlns:a="http://schemas.openxmlformats.org/drawingml/2006/main">
               <a:ext uri="{FF2B5EF4-FFF2-40B4-BE49-F238E27FC236}">
-                <a16:creationId xmlns:a16="http://schemas.microsoft.com/office/drawing/2014/main" id="{528E56A0-D11B-4219-9BB9-2CC08E933C06}"/>
+                <a16:creationId xmlns:a16="http://schemas.microsoft.com/office/drawing/2014/main" id="{DC179C9B-2048-4F87-886F-00595BF60D5E}"/>
               </a:ext>
             </a:extLst>
           </p:cNvPr>
@@ -3688,7 +3688,7 @@
           <p:cNvPr id="17" name="Google Shape;17;p15">
             <a:extLst xmlns:a="http://schemas.openxmlformats.org/drawingml/2006/main">
               <a:ext uri="{FF2B5EF4-FFF2-40B4-BE49-F238E27FC236}">
-                <a16:creationId xmlns:a16="http://schemas.microsoft.com/office/drawing/2014/main" id="{6E98A5DD-0D3E-41C3-9718-F9F8A8C949A8}"/>
+                <a16:creationId xmlns:a16="http://schemas.microsoft.com/office/drawing/2014/main" id="{F1AC3C3B-8735-4F71-899B-6EF96D884083}"/>
               </a:ext>
             </a:extLst>
           </p:cNvPr>
@@ -3831,7 +3831,7 @@
           <p:cNvPr id="18" name="Google Shape;18;p15">
             <a:extLst xmlns:a="http://schemas.openxmlformats.org/drawingml/2006/main">
               <a:ext uri="{FF2B5EF4-FFF2-40B4-BE49-F238E27FC236}">
-                <a16:creationId xmlns:a16="http://schemas.microsoft.com/office/drawing/2014/main" id="{17351C10-96AB-4F80-AC93-2DA1798B1599}"/>
+                <a16:creationId xmlns:a16="http://schemas.microsoft.com/office/drawing/2014/main" id="{31513AB8-A8AF-4FCC-92E3-5724BF45EE40}"/>
               </a:ext>
             </a:extLst>
           </p:cNvPr>
@@ -4022,7 +4022,7 @@
           <p:cNvPr id="19" name="Google Shape;19;p15">
             <a:extLst xmlns:a="http://schemas.openxmlformats.org/drawingml/2006/main">
               <a:ext uri="{FF2B5EF4-FFF2-40B4-BE49-F238E27FC236}">
-                <a16:creationId xmlns:a16="http://schemas.microsoft.com/office/drawing/2014/main" id="{A1B2B4EB-5B90-4CAF-A465-5EAD2818B0EF}"/>
+                <a16:creationId xmlns:a16="http://schemas.microsoft.com/office/drawing/2014/main" id="{BC26E57D-2C44-4CED-9A1A-F866D8E548B2}"/>
               </a:ext>
             </a:extLst>
           </p:cNvPr>
@@ -4159,7 +4159,7 @@
           <p:cNvPr id="20" name="Google Shape;20;p15">
             <a:extLst xmlns:a="http://schemas.openxmlformats.org/drawingml/2006/main">
               <a:ext uri="{FF2B5EF4-FFF2-40B4-BE49-F238E27FC236}">
-                <a16:creationId xmlns:a16="http://schemas.microsoft.com/office/drawing/2014/main" id="{2D70EEFE-EC3E-47FF-9B7A-06E36B84B0EF}"/>
+                <a16:creationId xmlns:a16="http://schemas.microsoft.com/office/drawing/2014/main" id="{B79242D2-E80B-4D97-8636-442FD35AD1EA}"/>
               </a:ext>
             </a:extLst>
           </p:cNvPr>
@@ -4296,7 +4296,7 @@
           <p:cNvPr id="21" name="Google Shape;21;p15">
             <a:extLst xmlns:a="http://schemas.openxmlformats.org/drawingml/2006/main">
               <a:ext uri="{FF2B5EF4-FFF2-40B4-BE49-F238E27FC236}">
-                <a16:creationId xmlns:a16="http://schemas.microsoft.com/office/drawing/2014/main" id="{8CFD2942-D9AE-4696-AA8C-ED994518C7E4}"/>
+                <a16:creationId xmlns:a16="http://schemas.microsoft.com/office/drawing/2014/main" id="{D0465069-026E-4840-AA1C-68761CA38A30}"/>
               </a:ext>
             </a:extLst>
           </p:cNvPr>
@@ -4428,7 +4428,7 @@
           <p:cNvPr id="23" name="Google Shape;23;p16">
             <a:extLst xmlns:a="http://schemas.openxmlformats.org/drawingml/2006/main">
               <a:ext uri="{FF2B5EF4-FFF2-40B4-BE49-F238E27FC236}">
-                <a16:creationId xmlns:a16="http://schemas.microsoft.com/office/drawing/2014/main" id="{0FF74EFD-4D77-4ED1-A324-2555C0454DBA}"/>
+                <a16:creationId xmlns:a16="http://schemas.microsoft.com/office/drawing/2014/main" id="{10879FF7-9C80-4438-A974-212725C05BD2}"/>
               </a:ext>
             </a:extLst>
           </p:cNvPr>
@@ -4572,7 +4572,7 @@
           <p:cNvPr id="24" name="Google Shape;24;p16">
             <a:extLst xmlns:a="http://schemas.openxmlformats.org/drawingml/2006/main">
               <a:ext uri="{FF2B5EF4-FFF2-40B4-BE49-F238E27FC236}">
-                <a16:creationId xmlns:a16="http://schemas.microsoft.com/office/drawing/2014/main" id="{80F50A7D-5D61-4E4A-A134-7EAAE782B0B6}"/>
+                <a16:creationId xmlns:a16="http://schemas.microsoft.com/office/drawing/2014/main" id="{6E30D929-473D-4F94-B51A-7DF523E4B8E0}"/>
               </a:ext>
             </a:extLst>
           </p:cNvPr>
@@ -4763,7 +4763,7 @@
           <p:cNvPr id="25" name="Google Shape;25;p16">
             <a:extLst xmlns:a="http://schemas.openxmlformats.org/drawingml/2006/main">
               <a:ext uri="{FF2B5EF4-FFF2-40B4-BE49-F238E27FC236}">
-                <a16:creationId xmlns:a16="http://schemas.microsoft.com/office/drawing/2014/main" id="{CB81DB81-238F-40BC-9D2C-F76848800A9C}"/>
+                <a16:creationId xmlns:a16="http://schemas.microsoft.com/office/drawing/2014/main" id="{5611920F-8D3F-4AC8-A6FD-D5838015DFF1}"/>
               </a:ext>
             </a:extLst>
           </p:cNvPr>
@@ -4900,7 +4900,7 @@
           <p:cNvPr id="26" name="Google Shape;26;p16">
             <a:extLst xmlns:a="http://schemas.openxmlformats.org/drawingml/2006/main">
               <a:ext uri="{FF2B5EF4-FFF2-40B4-BE49-F238E27FC236}">
-                <a16:creationId xmlns:a16="http://schemas.microsoft.com/office/drawing/2014/main" id="{B7A1D4F0-B348-4B5E-A9A8-18B45E2F2512}"/>
+                <a16:creationId xmlns:a16="http://schemas.microsoft.com/office/drawing/2014/main" id="{5ABF249C-4219-4CAF-AA74-63583D4D01AE}"/>
               </a:ext>
             </a:extLst>
           </p:cNvPr>
@@ -5037,7 +5037,7 @@
           <p:cNvPr id="27" name="Google Shape;27;p16">
             <a:extLst xmlns:a="http://schemas.openxmlformats.org/drawingml/2006/main">
               <a:ext uri="{FF2B5EF4-FFF2-40B4-BE49-F238E27FC236}">
-                <a16:creationId xmlns:a16="http://schemas.microsoft.com/office/drawing/2014/main" id="{314BFF03-64A9-4472-829A-8FB7A57AA592}"/>
+                <a16:creationId xmlns:a16="http://schemas.microsoft.com/office/drawing/2014/main" id="{EE8E4E89-7CE7-4E0E-96A1-6D1BC349DA75}"/>
               </a:ext>
             </a:extLst>
           </p:cNvPr>
@@ -5169,7 +5169,7 @@
           <p:cNvPr id="29" name="Google Shape;29;p17">
             <a:extLst xmlns:a="http://schemas.openxmlformats.org/drawingml/2006/main">
               <a:ext uri="{FF2B5EF4-FFF2-40B4-BE49-F238E27FC236}">
-                <a16:creationId xmlns:a16="http://schemas.microsoft.com/office/drawing/2014/main" id="{879BC399-FB99-4250-9252-681D6255E332}"/>
+                <a16:creationId xmlns:a16="http://schemas.microsoft.com/office/drawing/2014/main" id="{2B29AC73-7D02-4FA6-9BE5-95E63B782A00}"/>
               </a:ext>
             </a:extLst>
           </p:cNvPr>
@@ -5313,7 +5313,7 @@
           <p:cNvPr id="30" name="Google Shape;30;p17">
             <a:extLst xmlns:a="http://schemas.openxmlformats.org/drawingml/2006/main">
               <a:ext uri="{FF2B5EF4-FFF2-40B4-BE49-F238E27FC236}">
-                <a16:creationId xmlns:a16="http://schemas.microsoft.com/office/drawing/2014/main" id="{6B38F0C2-6CFD-40FF-ACC7-2156411F6771}"/>
+                <a16:creationId xmlns:a16="http://schemas.microsoft.com/office/drawing/2014/main" id="{B5C29F69-2267-4A58-B34B-C639C9BA1680}"/>
               </a:ext>
             </a:extLst>
           </p:cNvPr>
@@ -5540,7 +5540,7 @@
           <p:cNvPr id="31" name="Google Shape;31;p17">
             <a:extLst xmlns:a="http://schemas.openxmlformats.org/drawingml/2006/main">
               <a:ext uri="{FF2B5EF4-FFF2-40B4-BE49-F238E27FC236}">
-                <a16:creationId xmlns:a16="http://schemas.microsoft.com/office/drawing/2014/main" id="{36AD30E8-D173-4E70-9092-4645F01EEE5B}"/>
+                <a16:creationId xmlns:a16="http://schemas.microsoft.com/office/drawing/2014/main" id="{D1889A07-0D0A-4F8D-A230-DDFA8F4EE6D9}"/>
               </a:ext>
             </a:extLst>
           </p:cNvPr>
@@ -5677,7 +5677,7 @@
           <p:cNvPr id="32" name="Google Shape;32;p17">
             <a:extLst xmlns:a="http://schemas.openxmlformats.org/drawingml/2006/main">
               <a:ext uri="{FF2B5EF4-FFF2-40B4-BE49-F238E27FC236}">
-                <a16:creationId xmlns:a16="http://schemas.microsoft.com/office/drawing/2014/main" id="{E4B2E464-10D2-408B-9AF2-153A83BCA430}"/>
+                <a16:creationId xmlns:a16="http://schemas.microsoft.com/office/drawing/2014/main" id="{F12CB5FA-4037-40FA-8983-8898A24623A8}"/>
               </a:ext>
             </a:extLst>
           </p:cNvPr>
@@ -5814,7 +5814,7 @@
           <p:cNvPr id="33" name="Google Shape;33;p17">
             <a:extLst xmlns:a="http://schemas.openxmlformats.org/drawingml/2006/main">
               <a:ext uri="{FF2B5EF4-FFF2-40B4-BE49-F238E27FC236}">
-                <a16:creationId xmlns:a16="http://schemas.microsoft.com/office/drawing/2014/main" id="{8786B156-235F-4020-AA44-4B969C5B6279}"/>
+                <a16:creationId xmlns:a16="http://schemas.microsoft.com/office/drawing/2014/main" id="{24032809-DE52-4B42-BC0C-EA255004B159}"/>
               </a:ext>
             </a:extLst>
           </p:cNvPr>
@@ -5946,7 +5946,7 @@
           <p:cNvPr id="35" name="Google Shape;35;p18">
             <a:extLst xmlns:a="http://schemas.openxmlformats.org/drawingml/2006/main">
               <a:ext uri="{FF2B5EF4-FFF2-40B4-BE49-F238E27FC236}">
-                <a16:creationId xmlns:a16="http://schemas.microsoft.com/office/drawing/2014/main" id="{B3294E4E-0E60-45E3-8443-D435BAC9AEEA}"/>
+                <a16:creationId xmlns:a16="http://schemas.microsoft.com/office/drawing/2014/main" id="{0E81971E-63B1-4165-A40B-BA591060BF1E}"/>
               </a:ext>
             </a:extLst>
           </p:cNvPr>
@@ -6089,7 +6089,7 @@
           <p:cNvPr id="36" name="Google Shape;36;p18">
             <a:extLst xmlns:a="http://schemas.openxmlformats.org/drawingml/2006/main">
               <a:ext uri="{FF2B5EF4-FFF2-40B4-BE49-F238E27FC236}">
-                <a16:creationId xmlns:a16="http://schemas.microsoft.com/office/drawing/2014/main" id="{AD195F42-88F5-4815-A9C2-1B94D3C17857}"/>
+                <a16:creationId xmlns:a16="http://schemas.microsoft.com/office/drawing/2014/main" id="{74632E26-C66E-4CD0-99A8-F6E1A45FF39C}"/>
               </a:ext>
             </a:extLst>
           </p:cNvPr>
@@ -6280,7 +6280,7 @@
           <p:cNvPr id="37" name="Google Shape;37;p18">
             <a:extLst xmlns:a="http://schemas.openxmlformats.org/drawingml/2006/main">
               <a:ext uri="{FF2B5EF4-FFF2-40B4-BE49-F238E27FC236}">
-                <a16:creationId xmlns:a16="http://schemas.microsoft.com/office/drawing/2014/main" id="{B91C3601-15AB-4A98-836E-F71DA40785D1}"/>
+                <a16:creationId xmlns:a16="http://schemas.microsoft.com/office/drawing/2014/main" id="{46BB8197-53BB-4CBE-AB93-602D3B14A989}"/>
               </a:ext>
             </a:extLst>
           </p:cNvPr>
@@ -6471,7 +6471,7 @@
           <p:cNvPr id="38" name="Google Shape;38;p18">
             <a:extLst xmlns:a="http://schemas.openxmlformats.org/drawingml/2006/main">
               <a:ext uri="{FF2B5EF4-FFF2-40B4-BE49-F238E27FC236}">
-                <a16:creationId xmlns:a16="http://schemas.microsoft.com/office/drawing/2014/main" id="{1BA1438D-210C-48B6-AEC6-4A67FF1B1F23}"/>
+                <a16:creationId xmlns:a16="http://schemas.microsoft.com/office/drawing/2014/main" id="{C029850C-8003-4FC1-93BB-7006B7BC17E2}"/>
               </a:ext>
             </a:extLst>
           </p:cNvPr>
@@ -6608,7 +6608,7 @@
           <p:cNvPr id="39" name="Google Shape;39;p18">
             <a:extLst xmlns:a="http://schemas.openxmlformats.org/drawingml/2006/main">
               <a:ext uri="{FF2B5EF4-FFF2-40B4-BE49-F238E27FC236}">
-                <a16:creationId xmlns:a16="http://schemas.microsoft.com/office/drawing/2014/main" id="{918B1083-8368-4550-9A76-510C5EC755A6}"/>
+                <a16:creationId xmlns:a16="http://schemas.microsoft.com/office/drawing/2014/main" id="{00A85900-1D43-4E0B-8A7B-29BAFBD726FC}"/>
               </a:ext>
             </a:extLst>
           </p:cNvPr>
@@ -6745,7 +6745,7 @@
           <p:cNvPr id="40" name="Google Shape;40;p18">
             <a:extLst xmlns:a="http://schemas.openxmlformats.org/drawingml/2006/main">
               <a:ext uri="{FF2B5EF4-FFF2-40B4-BE49-F238E27FC236}">
-                <a16:creationId xmlns:a16="http://schemas.microsoft.com/office/drawing/2014/main" id="{D9615226-3C4B-41C8-95C7-8BE574EF4125}"/>
+                <a16:creationId xmlns:a16="http://schemas.microsoft.com/office/drawing/2014/main" id="{63311EBF-2C77-4431-8B8C-2D66624E618E}"/>
               </a:ext>
             </a:extLst>
           </p:cNvPr>
@@ -6877,7 +6877,7 @@
           <p:cNvPr id="42" name="Google Shape;42;p19">
             <a:extLst xmlns:a="http://schemas.openxmlformats.org/drawingml/2006/main">
               <a:ext uri="{FF2B5EF4-FFF2-40B4-BE49-F238E27FC236}">
-                <a16:creationId xmlns:a16="http://schemas.microsoft.com/office/drawing/2014/main" id="{7CBE4BC0-A233-4390-89F0-9FC4A485A5E9}"/>
+                <a16:creationId xmlns:a16="http://schemas.microsoft.com/office/drawing/2014/main" id="{94C44160-FD4E-4B46-A442-364231CCCD58}"/>
               </a:ext>
             </a:extLst>
           </p:cNvPr>
@@ -7020,7 +7020,7 @@
           <p:cNvPr id="43" name="Google Shape;43;p19">
             <a:extLst xmlns:a="http://schemas.openxmlformats.org/drawingml/2006/main">
               <a:ext uri="{FF2B5EF4-FFF2-40B4-BE49-F238E27FC236}">
-                <a16:creationId xmlns:a16="http://schemas.microsoft.com/office/drawing/2014/main" id="{FF247B81-9F65-4576-B304-E24400918EF6}"/>
+                <a16:creationId xmlns:a16="http://schemas.microsoft.com/office/drawing/2014/main" id="{B3865CED-714E-4433-BA25-259E0ACFA05D}"/>
               </a:ext>
             </a:extLst>
           </p:cNvPr>
@@ -7211,7 +7211,7 @@
           <p:cNvPr id="44" name="Google Shape;44;p19">
             <a:extLst xmlns:a="http://schemas.openxmlformats.org/drawingml/2006/main">
               <a:ext uri="{FF2B5EF4-FFF2-40B4-BE49-F238E27FC236}">
-                <a16:creationId xmlns:a16="http://schemas.microsoft.com/office/drawing/2014/main" id="{4EABE518-40BF-4F73-BFEC-054B6AE3F9AC}"/>
+                <a16:creationId xmlns:a16="http://schemas.microsoft.com/office/drawing/2014/main" id="{A37163D6-39A1-4ED7-9C36-A7722D4203C2}"/>
               </a:ext>
             </a:extLst>
           </p:cNvPr>
@@ -7402,7 +7402,7 @@
           <p:cNvPr id="45" name="Google Shape;45;p19">
             <a:extLst xmlns:a="http://schemas.openxmlformats.org/drawingml/2006/main">
               <a:ext uri="{FF2B5EF4-FFF2-40B4-BE49-F238E27FC236}">
-                <a16:creationId xmlns:a16="http://schemas.microsoft.com/office/drawing/2014/main" id="{B76BF45C-2480-4C6F-9470-57F0AB9F2846}"/>
+                <a16:creationId xmlns:a16="http://schemas.microsoft.com/office/drawing/2014/main" id="{FCE540D2-9B5F-43F9-8309-09F25DE84CB4}"/>
               </a:ext>
             </a:extLst>
           </p:cNvPr>
@@ -7593,7 +7593,7 @@
           <p:cNvPr id="46" name="Google Shape;46;p19">
             <a:extLst xmlns:a="http://schemas.openxmlformats.org/drawingml/2006/main">
               <a:ext uri="{FF2B5EF4-FFF2-40B4-BE49-F238E27FC236}">
-                <a16:creationId xmlns:a16="http://schemas.microsoft.com/office/drawing/2014/main" id="{FAE5D01E-3A55-48BF-BE4E-73994CD3C92A}"/>
+                <a16:creationId xmlns:a16="http://schemas.microsoft.com/office/drawing/2014/main" id="{6883717C-D82E-497D-AB66-B37E74EBAFFC}"/>
               </a:ext>
             </a:extLst>
           </p:cNvPr>
@@ -7784,7 +7784,7 @@
           <p:cNvPr id="47" name="Google Shape;47;p19">
             <a:extLst xmlns:a="http://schemas.openxmlformats.org/drawingml/2006/main">
               <a:ext uri="{FF2B5EF4-FFF2-40B4-BE49-F238E27FC236}">
-                <a16:creationId xmlns:a16="http://schemas.microsoft.com/office/drawing/2014/main" id="{F320EB58-D6DC-4B50-92FD-285F6376D65B}"/>
+                <a16:creationId xmlns:a16="http://schemas.microsoft.com/office/drawing/2014/main" id="{AC6A0DAB-2ED6-4BCF-BA8E-2498F4716F55}"/>
               </a:ext>
             </a:extLst>
           </p:cNvPr>
@@ -7921,7 +7921,7 @@
           <p:cNvPr id="48" name="Google Shape;48;p19">
             <a:extLst xmlns:a="http://schemas.openxmlformats.org/drawingml/2006/main">
               <a:ext uri="{FF2B5EF4-FFF2-40B4-BE49-F238E27FC236}">
-                <a16:creationId xmlns:a16="http://schemas.microsoft.com/office/drawing/2014/main" id="{D55452D8-E04D-4BA2-9941-D6BF0EA3456F}"/>
+                <a16:creationId xmlns:a16="http://schemas.microsoft.com/office/drawing/2014/main" id="{3EEB9320-E616-4A17-831F-6520853B3B3C}"/>
               </a:ext>
             </a:extLst>
           </p:cNvPr>
@@ -8058,7 +8058,7 @@
           <p:cNvPr id="49" name="Google Shape;49;p19">
             <a:extLst xmlns:a="http://schemas.openxmlformats.org/drawingml/2006/main">
               <a:ext uri="{FF2B5EF4-FFF2-40B4-BE49-F238E27FC236}">
-                <a16:creationId xmlns:a16="http://schemas.microsoft.com/office/drawing/2014/main" id="{E6BC04FD-11CA-4F57-82FE-A7D8F92C588C}"/>
+                <a16:creationId xmlns:a16="http://schemas.microsoft.com/office/drawing/2014/main" id="{2D735A49-0D2A-44E2-9D36-016A86CA349E}"/>
               </a:ext>
             </a:extLst>
           </p:cNvPr>
@@ -8190,7 +8190,7 @@
           <p:cNvPr id="51" name="Google Shape;51;p20">
             <a:extLst xmlns:a="http://schemas.openxmlformats.org/drawingml/2006/main">
               <a:ext uri="{FF2B5EF4-FFF2-40B4-BE49-F238E27FC236}">
-                <a16:creationId xmlns:a16="http://schemas.microsoft.com/office/drawing/2014/main" id="{54D7D740-FF54-4991-8A7B-51A6159CA281}"/>
+                <a16:creationId xmlns:a16="http://schemas.microsoft.com/office/drawing/2014/main" id="{CB22EAF9-F46E-4F78-BC9A-833724C49473}"/>
               </a:ext>
             </a:extLst>
           </p:cNvPr>
@@ -8333,7 +8333,7 @@
           <p:cNvPr id="52" name="Google Shape;52;p20">
             <a:extLst xmlns:a="http://schemas.openxmlformats.org/drawingml/2006/main">
               <a:ext uri="{FF2B5EF4-FFF2-40B4-BE49-F238E27FC236}">
-                <a16:creationId xmlns:a16="http://schemas.microsoft.com/office/drawing/2014/main" id="{88C7EE48-3D93-44B9-A7A7-85941AA3974D}"/>
+                <a16:creationId xmlns:a16="http://schemas.microsoft.com/office/drawing/2014/main" id="{9114CF3F-627E-4D20-9242-A0A7A884CC39}"/>
               </a:ext>
             </a:extLst>
           </p:cNvPr>
@@ -8470,7 +8470,7 @@
           <p:cNvPr id="53" name="Google Shape;53;p20">
             <a:extLst xmlns:a="http://schemas.openxmlformats.org/drawingml/2006/main">
               <a:ext uri="{FF2B5EF4-FFF2-40B4-BE49-F238E27FC236}">
-                <a16:creationId xmlns:a16="http://schemas.microsoft.com/office/drawing/2014/main" id="{F1BB8210-C17E-44D4-9DAE-0C56DEEF9246}"/>
+                <a16:creationId xmlns:a16="http://schemas.microsoft.com/office/drawing/2014/main" id="{214DE86D-BF0F-45E5-943F-1F03FB10D6AC}"/>
               </a:ext>
             </a:extLst>
           </p:cNvPr>
@@ -8607,7 +8607,7 @@
           <p:cNvPr id="54" name="Google Shape;54;p20">
             <a:extLst xmlns:a="http://schemas.openxmlformats.org/drawingml/2006/main">
               <a:ext uri="{FF2B5EF4-FFF2-40B4-BE49-F238E27FC236}">
-                <a16:creationId xmlns:a16="http://schemas.microsoft.com/office/drawing/2014/main" id="{42E19454-AF25-468F-91E5-12D80DBE8740}"/>
+                <a16:creationId xmlns:a16="http://schemas.microsoft.com/office/drawing/2014/main" id="{44771E20-B886-49DA-B9A7-23D3E2BC18E9}"/>
               </a:ext>
             </a:extLst>
           </p:cNvPr>
@@ -8739,7 +8739,7 @@
           <p:cNvPr id="56" name="Google Shape;56;p21">
             <a:extLst xmlns:a="http://schemas.openxmlformats.org/drawingml/2006/main">
               <a:ext uri="{FF2B5EF4-FFF2-40B4-BE49-F238E27FC236}">
-                <a16:creationId xmlns:a16="http://schemas.microsoft.com/office/drawing/2014/main" id="{2210F0B9-883E-4310-A8C2-D76DEE52076C}"/>
+                <a16:creationId xmlns:a16="http://schemas.microsoft.com/office/drawing/2014/main" id="{F78942A6-082B-42FD-A633-4ADB6C74B130}"/>
               </a:ext>
             </a:extLst>
           </p:cNvPr>
@@ -8876,7 +8876,7 @@
           <p:cNvPr id="57" name="Google Shape;57;p21">
             <a:extLst xmlns:a="http://schemas.openxmlformats.org/drawingml/2006/main">
               <a:ext uri="{FF2B5EF4-FFF2-40B4-BE49-F238E27FC236}">
-                <a16:creationId xmlns:a16="http://schemas.microsoft.com/office/drawing/2014/main" id="{D53BB604-A775-4DE7-9C5A-5F7304CDF55E}"/>
+                <a16:creationId xmlns:a16="http://schemas.microsoft.com/office/drawing/2014/main" id="{5D0105D5-9D22-4252-860D-7A82CE91781D}"/>
               </a:ext>
             </a:extLst>
           </p:cNvPr>
@@ -9013,7 +9013,7 @@
           <p:cNvPr id="58" name="Google Shape;58;p21">
             <a:extLst xmlns:a="http://schemas.openxmlformats.org/drawingml/2006/main">
               <a:ext uri="{FF2B5EF4-FFF2-40B4-BE49-F238E27FC236}">
-                <a16:creationId xmlns:a16="http://schemas.microsoft.com/office/drawing/2014/main" id="{0988D683-3FC5-48D2-8F76-EB0D3127CDA2}"/>
+                <a16:creationId xmlns:a16="http://schemas.microsoft.com/office/drawing/2014/main" id="{5F5E747A-C17C-492C-AAC9-AB9F6E9044AC}"/>
               </a:ext>
             </a:extLst>
           </p:cNvPr>
@@ -9145,7 +9145,7 @@
           <p:cNvPr id="60" name="Google Shape;60;p22">
             <a:extLst xmlns:a="http://schemas.openxmlformats.org/drawingml/2006/main">
               <a:ext uri="{FF2B5EF4-FFF2-40B4-BE49-F238E27FC236}">
-                <a16:creationId xmlns:a16="http://schemas.microsoft.com/office/drawing/2014/main" id="{710D1363-BD3E-4782-8765-C9404E1C6E26}"/>
+                <a16:creationId xmlns:a16="http://schemas.microsoft.com/office/drawing/2014/main" id="{C65A8DDC-5507-4F80-A3E5-A04684E88650}"/>
               </a:ext>
             </a:extLst>
           </p:cNvPr>
@@ -9289,7 +9289,7 @@
           <p:cNvPr id="61" name="Google Shape;61;p22">
             <a:extLst xmlns:a="http://schemas.openxmlformats.org/drawingml/2006/main">
               <a:ext uri="{FF2B5EF4-FFF2-40B4-BE49-F238E27FC236}">
-                <a16:creationId xmlns:a16="http://schemas.microsoft.com/office/drawing/2014/main" id="{A781AB26-9832-4F4F-98FB-747E2363ED96}"/>
+                <a16:creationId xmlns:a16="http://schemas.microsoft.com/office/drawing/2014/main" id="{18B7ADC1-F126-4768-A2F8-B55A89658E04}"/>
               </a:ext>
             </a:extLst>
           </p:cNvPr>
@@ -9480,7 +9480,7 @@
           <p:cNvPr id="62" name="Google Shape;62;p22">
             <a:extLst xmlns:a="http://schemas.openxmlformats.org/drawingml/2006/main">
               <a:ext uri="{FF2B5EF4-FFF2-40B4-BE49-F238E27FC236}">
-                <a16:creationId xmlns:a16="http://schemas.microsoft.com/office/drawing/2014/main" id="{29F011AE-3733-446E-9E41-E1A38301DD84}"/>
+                <a16:creationId xmlns:a16="http://schemas.microsoft.com/office/drawing/2014/main" id="{CF6596C2-CA3D-4BC0-9F93-DC16A7689220}"/>
               </a:ext>
             </a:extLst>
           </p:cNvPr>
@@ -9671,7 +9671,7 @@
           <p:cNvPr id="63" name="Google Shape;63;p22">
             <a:extLst xmlns:a="http://schemas.openxmlformats.org/drawingml/2006/main">
               <a:ext uri="{FF2B5EF4-FFF2-40B4-BE49-F238E27FC236}">
-                <a16:creationId xmlns:a16="http://schemas.microsoft.com/office/drawing/2014/main" id="{566D1926-7CF6-4025-BC6B-A5BBB6E08880}"/>
+                <a16:creationId xmlns:a16="http://schemas.microsoft.com/office/drawing/2014/main" id="{4F27B369-12E0-4DF3-9ADD-8F5F80BBA85E}"/>
               </a:ext>
             </a:extLst>
           </p:cNvPr>
@@ -9808,7 +9808,7 @@
           <p:cNvPr id="64" name="Google Shape;64;p22">
             <a:extLst xmlns:a="http://schemas.openxmlformats.org/drawingml/2006/main">
               <a:ext uri="{FF2B5EF4-FFF2-40B4-BE49-F238E27FC236}">
-                <a16:creationId xmlns:a16="http://schemas.microsoft.com/office/drawing/2014/main" id="{BE3D3932-573E-4951-A439-123FB0DB054D}"/>
+                <a16:creationId xmlns:a16="http://schemas.microsoft.com/office/drawing/2014/main" id="{2B865159-D239-4455-908C-6C30B37A81C8}"/>
               </a:ext>
             </a:extLst>
           </p:cNvPr>
@@ -9945,7 +9945,7 @@
           <p:cNvPr id="65" name="Google Shape;65;p22">
             <a:extLst xmlns:a="http://schemas.openxmlformats.org/drawingml/2006/main">
               <a:ext uri="{FF2B5EF4-FFF2-40B4-BE49-F238E27FC236}">
-                <a16:creationId xmlns:a16="http://schemas.microsoft.com/office/drawing/2014/main" id="{7199FFB2-B297-4FA6-A4AE-4CFFE4084467}"/>
+                <a16:creationId xmlns:a16="http://schemas.microsoft.com/office/drawing/2014/main" id="{AE9252D7-52BD-4DAD-9D92-7B83B34E4F27}"/>
               </a:ext>
             </a:extLst>
           </p:cNvPr>
@@ -10084,7 +10084,7 @@
           <p:cNvPr id="10" name="Google Shape;10;p13">
             <a:extLst xmlns:a="http://schemas.openxmlformats.org/drawingml/2006/main">
               <a:ext uri="{FF2B5EF4-FFF2-40B4-BE49-F238E27FC236}">
-                <a16:creationId xmlns:a16="http://schemas.microsoft.com/office/drawing/2014/main" id="{36C18820-DF97-4F77-B7FA-5065E7FFB316}"/>
+                <a16:creationId xmlns:a16="http://schemas.microsoft.com/office/drawing/2014/main" id="{3EACF781-D955-47B2-90A9-E463A6EF2AF6}"/>
               </a:ext>
             </a:extLst>
           </p:cNvPr>
@@ -10235,7 +10235,7 @@
           <p:cNvPr id="11" name="Google Shape;11;p13">
             <a:extLst xmlns:a="http://schemas.openxmlformats.org/drawingml/2006/main">
               <a:ext uri="{FF2B5EF4-FFF2-40B4-BE49-F238E27FC236}">
-                <a16:creationId xmlns:a16="http://schemas.microsoft.com/office/drawing/2014/main" id="{E07156EA-8F56-4CAE-A450-917DE97597F3}"/>
+                <a16:creationId xmlns:a16="http://schemas.microsoft.com/office/drawing/2014/main" id="{1FC941B5-BA0D-4740-949E-A953C8481111}"/>
               </a:ext>
             </a:extLst>
           </p:cNvPr>
@@ -10498,7 +10498,7 @@
           <p:cNvPr id="12" name="Google Shape;12;p13">
             <a:extLst xmlns:a="http://schemas.openxmlformats.org/drawingml/2006/main">
               <a:ext uri="{FF2B5EF4-FFF2-40B4-BE49-F238E27FC236}">
-                <a16:creationId xmlns:a16="http://schemas.microsoft.com/office/drawing/2014/main" id="{BA2C5870-8DAD-4F86-8BF5-A08696C59222}"/>
+                <a16:creationId xmlns:a16="http://schemas.microsoft.com/office/drawing/2014/main" id="{F9F5D3E5-F34C-4714-939A-9C9195155244}"/>
               </a:ext>
             </a:extLst>
           </p:cNvPr>
@@ -10698,7 +10698,7 @@
           <p:cNvPr id="13" name="Google Shape;13;p13">
             <a:extLst xmlns:a="http://schemas.openxmlformats.org/drawingml/2006/main">
               <a:ext uri="{FF2B5EF4-FFF2-40B4-BE49-F238E27FC236}">
-                <a16:creationId xmlns:a16="http://schemas.microsoft.com/office/drawing/2014/main" id="{8016574C-BE35-41BE-BF4D-40AEA0A3B626}"/>
+                <a16:creationId xmlns:a16="http://schemas.microsoft.com/office/drawing/2014/main" id="{425F991D-EC8D-4B5E-BA53-05CADAB4D914}"/>
               </a:ext>
             </a:extLst>
           </p:cNvPr>
@@ -10898,7 +10898,7 @@
           <p:cNvPr id="14" name="Google Shape;14;p13">
             <a:extLst xmlns:a="http://schemas.openxmlformats.org/drawingml/2006/main">
               <a:ext uri="{FF2B5EF4-FFF2-40B4-BE49-F238E27FC236}">
-                <a16:creationId xmlns:a16="http://schemas.microsoft.com/office/drawing/2014/main" id="{D7193EA1-6896-4A38-8DCC-07176B192CEA}"/>
+                <a16:creationId xmlns:a16="http://schemas.microsoft.com/office/drawing/2014/main" id="{3293C919-617A-4953-8954-25D0506470FC}"/>
               </a:ext>
             </a:extLst>
           </p:cNvPr>
@@ -11075,18 +11075,18 @@
   </p:cSld>
   <p:clrMap bg1="lt1" tx1="dk1" bg2="dk2" tx2="lt2" accent1="accent1" accent2="accent2" accent3="accent3" accent4="accent4" accent5="accent5" accent6="accent6" hlink="hlink" folHlink="folHlink"/>
   <p:sldLayoutIdLst>
-    <p:sldLayoutId xmlns:r="http://schemas.openxmlformats.org/officeDocument/2006/relationships" id="2147483649" r:id="Rd296aa5e0e5340d9"/>
-    <p:sldLayoutId xmlns:r="http://schemas.openxmlformats.org/officeDocument/2006/relationships" id="2147483650" r:id="R793bf97f3df6449e"/>
-    <p:sldLayoutId xmlns:r="http://schemas.openxmlformats.org/officeDocument/2006/relationships" id="2147483651" r:id="Rf78aa6dd0bbf45da"/>
-    <p:sldLayoutId xmlns:r="http://schemas.openxmlformats.org/officeDocument/2006/relationships" id="2147483652" r:id="Rf11c459ca3804de3"/>
-    <p:sldLayoutId xmlns:r="http://schemas.openxmlformats.org/officeDocument/2006/relationships" id="2147483653" r:id="Rca0506caf7274cd1"/>
-    <p:sldLayoutId xmlns:r="http://schemas.openxmlformats.org/officeDocument/2006/relationships" id="2147483654" r:id="R492f957312184898"/>
-    <p:sldLayoutId xmlns:r="http://schemas.openxmlformats.org/officeDocument/2006/relationships" id="2147483655" r:id="R0b031c03200d42c3"/>
-    <p:sldLayoutId xmlns:r="http://schemas.openxmlformats.org/officeDocument/2006/relationships" id="2147483656" r:id="R37e55869da5c4f58"/>
-    <p:sldLayoutId xmlns:r="http://schemas.openxmlformats.org/officeDocument/2006/relationships" id="2147483657" r:id="R0b0c4e6e79dc4d8d"/>
-    <p:sldLayoutId xmlns:r="http://schemas.openxmlformats.org/officeDocument/2006/relationships" id="2147483658" r:id="R6c64af780e5749f8"/>
-    <p:sldLayoutId xmlns:r="http://schemas.openxmlformats.org/officeDocument/2006/relationships" id="2147483659" r:id="R008435b6ed14499d"/>
-    <p:sldLayoutId xmlns:r="http://schemas.openxmlformats.org/officeDocument/2006/relationships" id="2147483660" r:id="Rfd17b17ea7fe4777"/>
+    <p:sldLayoutId xmlns:r="http://schemas.openxmlformats.org/officeDocument/2006/relationships" id="2147483649" r:id="R91fd58ae6bed456e"/>
+    <p:sldLayoutId xmlns:r="http://schemas.openxmlformats.org/officeDocument/2006/relationships" id="2147483650" r:id="R34669c183a2b4f57"/>
+    <p:sldLayoutId xmlns:r="http://schemas.openxmlformats.org/officeDocument/2006/relationships" id="2147483651" r:id="Rc87b540fae5a4598"/>
+    <p:sldLayoutId xmlns:r="http://schemas.openxmlformats.org/officeDocument/2006/relationships" id="2147483652" r:id="R9b7e1199d5364790"/>
+    <p:sldLayoutId xmlns:r="http://schemas.openxmlformats.org/officeDocument/2006/relationships" id="2147483653" r:id="R786bea8737d4468d"/>
+    <p:sldLayoutId xmlns:r="http://schemas.openxmlformats.org/officeDocument/2006/relationships" id="2147483654" r:id="Rf94301ea366f4a01"/>
+    <p:sldLayoutId xmlns:r="http://schemas.openxmlformats.org/officeDocument/2006/relationships" id="2147483655" r:id="Rb4f75e1278c64a0a"/>
+    <p:sldLayoutId xmlns:r="http://schemas.openxmlformats.org/officeDocument/2006/relationships" id="2147483656" r:id="R6e6dbc1891b7410d"/>
+    <p:sldLayoutId xmlns:r="http://schemas.openxmlformats.org/officeDocument/2006/relationships" id="2147483657" r:id="Rb3ab104384044dfe"/>
+    <p:sldLayoutId xmlns:r="http://schemas.openxmlformats.org/officeDocument/2006/relationships" id="2147483658" r:id="R1ceeedf640414902"/>
+    <p:sldLayoutId xmlns:r="http://schemas.openxmlformats.org/officeDocument/2006/relationships" id="2147483659" r:id="Re293db9f739243d8"/>
+    <p:sldLayoutId xmlns:r="http://schemas.openxmlformats.org/officeDocument/2006/relationships" id="2147483660" r:id="R45ee125d300a460e"/>
   </p:sldLayoutIdLst>
   <p:hf sldNum="0" hdr="0" ftr="0" dt="0"/>
   <p:txStyles>
@@ -12033,7 +12033,7 @@
           <p:cNvPr id="90" name="Google Shape;90;p1">
             <a:extLst xmlns:a="http://schemas.openxmlformats.org/drawingml/2006/main">
               <a:ext uri="{FF2B5EF4-FFF2-40B4-BE49-F238E27FC236}">
-                <a16:creationId xmlns:a16="http://schemas.microsoft.com/office/drawing/2014/main" id="{8E4EB426-79EB-4BF9-B5D9-56099E91E6FE}"/>
+                <a16:creationId xmlns:a16="http://schemas.microsoft.com/office/drawing/2014/main" id="{A687C5F4-535E-4CA7-B08A-57A6F9236CDC}"/>
               </a:ext>
             </a:extLst>
           </p:cNvPr>
@@ -12091,7 +12091,7 @@
           <p:cNvPr id="91" name="Google Shape;91;p1">
             <a:extLst xmlns:a="http://schemas.openxmlformats.org/drawingml/2006/main">
               <a:ext uri="{FF2B5EF4-FFF2-40B4-BE49-F238E27FC236}">
-                <a16:creationId xmlns:a16="http://schemas.microsoft.com/office/drawing/2014/main" id="{44F8C59B-3D1B-4B12-8A11-91ED89B615BC}"/>
+                <a16:creationId xmlns:a16="http://schemas.microsoft.com/office/drawing/2014/main" id="{39FC2766-6EC0-4320-98A8-8889F470FE89}"/>
               </a:ext>
             </a:extLst>
           </p:cNvPr>
@@ -12160,7 +12160,7 @@
           <p:cNvPr id="92" name="Google Shape;92;p1">
             <a:extLst xmlns:a="http://schemas.openxmlformats.org/drawingml/2006/main">
               <a:ext uri="{FF2B5EF4-FFF2-40B4-BE49-F238E27FC236}">
-                <a16:creationId xmlns:a16="http://schemas.microsoft.com/office/drawing/2014/main" id="{8E21BAAD-15BD-4565-9B24-DE01F893A901}"/>
+                <a16:creationId xmlns:a16="http://schemas.microsoft.com/office/drawing/2014/main" id="{25F4E2FF-6711-4543-B588-F1D0E28A7117}"/>
               </a:ext>
             </a:extLst>
           </p:cNvPr>
@@ -12229,7 +12229,7 @@
           <p:cNvPr id="93" name="Google Shape;93;p1">
             <a:extLst xmlns:a="http://schemas.openxmlformats.org/drawingml/2006/main">
               <a:ext uri="{FF2B5EF4-FFF2-40B4-BE49-F238E27FC236}">
-                <a16:creationId xmlns:a16="http://schemas.microsoft.com/office/drawing/2014/main" id="{D1D37B2B-2ADC-47A4-B8E4-9799858FB3B3}"/>
+                <a16:creationId xmlns:a16="http://schemas.microsoft.com/office/drawing/2014/main" id="{AB1A8317-3FCD-4B36-ABBE-4C1C4009B4A2}"/>
               </a:ext>
             </a:extLst>
           </p:cNvPr>
@@ -12298,7 +12298,7 @@
           <p:cNvPr id="94" name="Google Shape;94;p1">
             <a:extLst xmlns:a="http://schemas.openxmlformats.org/drawingml/2006/main">
               <a:ext uri="{FF2B5EF4-FFF2-40B4-BE49-F238E27FC236}">
-                <a16:creationId xmlns:a16="http://schemas.microsoft.com/office/drawing/2014/main" id="{6EA6BB3D-932F-4F16-A5E3-554EDD7ADFD9}"/>
+                <a16:creationId xmlns:a16="http://schemas.microsoft.com/office/drawing/2014/main" id="{66F6D078-9F79-4EE1-A1CD-092816916782}"/>
               </a:ext>
             </a:extLst>
           </p:cNvPr>
@@ -12378,7 +12378,7 @@
           <p:cNvPr id="95" name="Google Shape;95;p1">
             <a:extLst xmlns:a="http://schemas.openxmlformats.org/drawingml/2006/main">
               <a:ext uri="{FF2B5EF4-FFF2-40B4-BE49-F238E27FC236}">
-                <a16:creationId xmlns:a16="http://schemas.microsoft.com/office/drawing/2014/main" id="{A74153E2-5FB1-4592-85A6-7F4DB19D9341}"/>
+                <a16:creationId xmlns:a16="http://schemas.microsoft.com/office/drawing/2014/main" id="{6438AEC7-4C3E-4D05-902B-6E903CF2603B}"/>
               </a:ext>
             </a:extLst>
           </p:cNvPr>
@@ -12389,8 +12389,8 @@
         </p:nvSpPr>
         <p:spPr>
           <a:xfrm xmlns:a="http://schemas.openxmlformats.org/drawingml/2006/main">
-            <a:off x="777240" y="3310128"/>
-            <a:ext cx="6000750" cy="2476500"/>
+            <a:off x="777240" y="3286125"/>
+            <a:ext cx="6000750" cy="2524125"/>
           </a:xfrm>
           <a:prstGeom xmlns:a="http://schemas.openxmlformats.org/drawingml/2006/main" prst="rect">
             <a:avLst/>
@@ -12419,7 +12419,7 @@
               <a:buSzPts val="1600"/>
               <a:buFont typeface="Calibri"/>
               <a:buChar char="•"/>
-              <a:defRPr sz="1650">
+              <a:defRPr sz="1350">
                 <a:solidFill>
                   <a:srgbClr val="302C3C"/>
                 </a:solidFill>
@@ -12429,7 +12429,7 @@
               </a:defRPr>
             </a:pPr>
             <a:r>
-              <a:rPr sz="1650" b="0" i="0" u="none" cap="none">
+              <a:rPr sz="1350" b="0" i="0" u="none" cap="none">
                 <a:solidFill>
                   <a:srgbClr val="302C3C"/>
                 </a:solidFill>
@@ -12437,7 +12437,7 @@
                 <a:ea typeface="Arial"/>
                 <a:cs typeface="Arial"/>
               </a:rPr>
-              <a:t>Theme 01 - CodeDoctor</a:t>
+              <a:t>Theme ID - Theme 01</a:t>
             </a:r>
             <a:endParaRPr/>
           </a:p>
@@ -12455,7 +12455,7 @@
               <a:buSzPts val="1600"/>
               <a:buFont typeface="Calibri"/>
               <a:buChar char="•"/>
-              <a:defRPr sz="1650">
+              <a:defRPr sz="1350">
                 <a:solidFill>
                   <a:srgbClr val="302C3C"/>
                 </a:solidFill>
@@ -12465,7 +12465,7 @@
               </a:defRPr>
             </a:pPr>
             <a:r>
-              <a:rPr sz="1650" b="0" i="0" u="none" cap="none">
+              <a:rPr sz="1350" b="0" i="0" u="none" cap="none">
                 <a:solidFill>
                   <a:srgbClr val="302C3C"/>
                 </a:solidFill>
@@ -12473,7 +12473,7 @@
                 <a:ea typeface="Arial"/>
                 <a:cs typeface="Arial"/>
               </a:rPr>
-              <a:t>Team - Doctors</a:t>
+              <a:t>Team Name - Doctors</a:t>
             </a:r>
             <a:endParaRPr/>
           </a:p>
@@ -12491,7 +12491,7 @@
               <a:buSzPts val="1600"/>
               <a:buFont typeface="Calibri"/>
               <a:buChar char="•"/>
-              <a:defRPr sz="1650">
+              <a:defRPr sz="1350">
                 <a:solidFill>
                   <a:srgbClr val="302C3C"/>
                 </a:solidFill>
@@ -12501,7 +12501,7 @@
               </a:defRPr>
             </a:pPr>
             <a:r>
-              <a:rPr sz="1650" b="0" i="0" u="none" cap="none">
+              <a:rPr sz="1350" b="0" i="0" u="none" cap="none">
                 <a:solidFill>
                   <a:srgbClr val="302C3C"/>
                 </a:solidFill>
@@ -12509,7 +12509,7 @@
                 <a:ea typeface="Arial"/>
                 <a:cs typeface="Arial"/>
               </a:rPr>
-              <a:t>College - VITV</a:t>
+              <a:t>College Name - VIT Vellore</a:t>
             </a:r>
             <a:endParaRPr/>
           </a:p>
@@ -12527,7 +12527,7 @@
               <a:buSzPts val="1600"/>
               <a:buFont typeface="Calibri"/>
               <a:buChar char="•"/>
-              <a:defRPr sz="1650">
+              <a:defRPr sz="1350">
                 <a:solidFill>
                   <a:srgbClr val="302C3C"/>
                 </a:solidFill>
@@ -12537,7 +12537,7 @@
               </a:defRPr>
             </a:pPr>
             <a:r>
-              <a:rPr sz="1650" b="0" i="0" u="none" cap="none">
+              <a:rPr sz="1350" b="0" i="0" u="none" cap="none">
                 <a:solidFill>
                   <a:srgbClr val="302C3C"/>
                 </a:solidFill>
@@ -12545,7 +12545,7 @@
                 <a:ea typeface="Arial"/>
                 <a:cs typeface="Arial"/>
               </a:rPr>
-              <a:t>Member 1 / Email:</a:t>
+              <a:t>Manish H. · manish.h2024@vitstudent.ac.in</a:t>
             </a:r>
             <a:endParaRPr/>
           </a:p>
@@ -12563,7 +12563,7 @@
               <a:buSzPts val="1600"/>
               <a:buFont typeface="Calibri"/>
               <a:buChar char="•"/>
-              <a:defRPr sz="1650">
+              <a:defRPr sz="1350">
                 <a:solidFill>
                   <a:srgbClr val="302C3C"/>
                 </a:solidFill>
@@ -12573,7 +12573,7 @@
               </a:defRPr>
             </a:pPr>
             <a:r>
-              <a:rPr sz="1650" b="0" i="0" u="none" cap="none">
+              <a:rPr sz="1350" b="0" i="0" u="none" cap="none">
                 <a:solidFill>
                   <a:srgbClr val="302C3C"/>
                 </a:solidFill>
@@ -12581,7 +12581,7 @@
                 <a:ea typeface="Arial"/>
                 <a:cs typeface="Arial"/>
               </a:rPr>
-              <a:t>Member 2 / Email:</a:t>
+              <a:t>Aryan Sinha · aryan.sinha2024@vitstudent.ac.in</a:t>
             </a:r>
             <a:endParaRPr/>
           </a:p>
@@ -12599,7 +12599,7 @@
               <a:buSzPts val="1600"/>
               <a:buFont typeface="Calibri"/>
               <a:buChar char="•"/>
-              <a:defRPr sz="1650">
+              <a:defRPr sz="1350">
                 <a:solidFill>
                   <a:srgbClr val="302C3C"/>
                 </a:solidFill>
@@ -12609,7 +12609,7 @@
               </a:defRPr>
             </a:pPr>
             <a:r>
-              <a:rPr sz="1650" b="0" i="0" u="none" cap="none">
+              <a:rPr sz="1350" b="0" i="0" u="none" cap="none">
                 <a:solidFill>
                   <a:srgbClr val="302C3C"/>
                 </a:solidFill>
@@ -12617,7 +12617,7 @@
                 <a:ea typeface="Arial"/>
                 <a:cs typeface="Arial"/>
               </a:rPr>
-              <a:t>Member 3 / Email:</a:t>
+              <a:t>Munal Singh · munal.singh2024@vitstudent.ac.in</a:t>
             </a:r>
             <a:endParaRPr/>
           </a:p>
@@ -12635,7 +12635,7 @@
               <a:buSzPts val="1600"/>
               <a:buFont typeface="Calibri"/>
               <a:buChar char="•"/>
-              <a:defRPr sz="1650">
+              <a:defRPr sz="1350">
                 <a:solidFill>
                   <a:srgbClr val="302C3C"/>
                 </a:solidFill>
@@ -12645,7 +12645,7 @@
               </a:defRPr>
             </a:pPr>
             <a:r>
-              <a:rPr sz="1650" b="0" i="0" u="none" cap="none">
+              <a:rPr sz="1350" b="0" i="0" u="none" cap="none">
                 <a:solidFill>
                   <a:srgbClr val="302C3C"/>
                 </a:solidFill>
@@ -12653,7 +12653,7 @@
                 <a:ea typeface="Arial"/>
                 <a:cs typeface="Arial"/>
               </a:rPr>
-              <a:t>Member 4 / Email:</a:t>
+              <a:t>Anshul Singh · anshul.singh2024@vitstudent.ac.in</a:t>
             </a:r>
             <a:endParaRPr/>
           </a:p>
@@ -12668,7 +12668,7 @@
           <p:nvPr/>
         </p:nvPicPr>
         <p:blipFill rotWithShape="1">
-          <a:blip xmlns:r="http://schemas.openxmlformats.org/officeDocument/2006/relationships" xmlns:a="http://schemas.openxmlformats.org/drawingml/2006/main" r:embed="Ra00c1868395444e5">
+          <a:blip xmlns:r="http://schemas.openxmlformats.org/officeDocument/2006/relationships" xmlns:a="http://schemas.openxmlformats.org/drawingml/2006/main" r:embed="R2e6640a829964485">
             <a:alphaModFix/>
           </a:blip>
           <a:srcRect xmlns:a="http://schemas.openxmlformats.org/drawingml/2006/main" l="0" t="0" r="0" b="0"/>
@@ -12692,7 +12692,7 @@
           <p:cNvPr id="97" name="">
             <a:extLst xmlns:a="http://schemas.openxmlformats.org/drawingml/2006/main">
               <a:ext uri="{FF2B5EF4-FFF2-40B4-BE49-F238E27FC236}">
-                <a16:creationId xmlns:a16="http://schemas.microsoft.com/office/drawing/2014/main" id="{EA73D393-D060-427D-8418-01A6A62054C0}"/>
+                <a16:creationId xmlns:a16="http://schemas.microsoft.com/office/drawing/2014/main" id="{2B4837BB-7C06-4ECC-B829-EF46D1D9B11E}"/>
               </a:ext>
             </a:extLst>
           </p:cNvPr>
@@ -12735,7 +12735,7 @@
                 <a:solidFill>
                   <a:srgbClr val="70509B"/>
                 </a:solidFill>
-                <a:hlinkClick xmlns:r="http://schemas.openxmlformats.org/officeDocument/2006/relationships" r:id="R926dcc96d6eb4de8"/>
+                <a:hlinkClick xmlns:r="http://schemas.openxmlformats.org/officeDocument/2006/relationships" r:id="Rde4dfb3ae74148e8"/>
               </a:rPr>
               <a:t>Submission GitHub: CodeDoctor repository</a:t>
             </a:r>
@@ -12745,7 +12745,7 @@
     </p:spTree>
     <p:extLst>
       <p:ext uri="{BB962C8B-B14F-4D97-AF65-F5344CB8AC3E}">
-        <p14:creationId xmlns:p14="http://schemas.microsoft.com/office/powerpoint/2010/main" val="991416106"/>
+        <p14:creationId xmlns:p14="http://schemas.microsoft.com/office/powerpoint/2010/main" val="1237155332"/>
       </p:ext>
     </p:extLst>
   </p:cSld>
@@ -12769,7 +12769,7 @@
           <p:cNvPr id="149" name="Google Shape;149;p10">
             <a:extLst xmlns:a="http://schemas.openxmlformats.org/drawingml/2006/main">
               <a:ext uri="{FF2B5EF4-FFF2-40B4-BE49-F238E27FC236}">
-                <a16:creationId xmlns:a16="http://schemas.microsoft.com/office/drawing/2014/main" id="{78C5820F-16AF-48E2-A38A-9630F3C0D6FF}"/>
+                <a16:creationId xmlns:a16="http://schemas.microsoft.com/office/drawing/2014/main" id="{9B39EC1D-000E-4C9A-BD4C-3D976E6705CF}"/>
               </a:ext>
             </a:extLst>
           </p:cNvPr>
@@ -12840,7 +12840,7 @@
           <p:cNvPr id="150" name="Google Shape;150;p10">
             <a:extLst xmlns:a="http://schemas.openxmlformats.org/drawingml/2006/main">
               <a:ext uri="{FF2B5EF4-FFF2-40B4-BE49-F238E27FC236}">
-                <a16:creationId xmlns:a16="http://schemas.microsoft.com/office/drawing/2014/main" id="{0E0E71D8-BBE9-42E1-B0D9-2ED03F057590}"/>
+                <a16:creationId xmlns:a16="http://schemas.microsoft.com/office/drawing/2014/main" id="{D4F42633-11D4-416B-A3B6-7AB3F8F192CD}"/>
               </a:ext>
             </a:extLst>
           </p:cNvPr>
@@ -12872,9 +12872,9 @@
           <a:p xmlns:a="http://schemas.openxmlformats.org/drawingml/2006/main">
             <a:pPr>
               <a:spcAft>
-                <a:spcPts val="1800"/>
-              </a:spcAft>
-              <a:defRPr sz="2100">
+                <a:spcPts val="1100"/>
+              </a:spcAft>
+              <a:defRPr sz="1650">
                 <a:solidFill>
                   <a:srgbClr val="302C3C"/>
                 </a:solidFill>
@@ -12884,7 +12884,7 @@
               </a:defRPr>
             </a:pPr>
             <a:r>
-              <a:rPr sz="2100" b="1">
+              <a:rPr sz="1650" b="1">
                 <a:solidFill>
                   <a:srgbClr val="302C3C"/>
                 </a:solidFill>
@@ -12892,10 +12892,10 @@
                 <a:ea typeface="Arial"/>
                 <a:cs typeface="Arial"/>
               </a:rPr>
-              <a:t>Behavior-aware ranking  </a:t>
+              <a:t>Agentic Multi-Signal Routing  </a:t>
             </a:r>
             <a:r>
-              <a:rPr sz="2100">
+              <a:rPr sz="1650">
                 <a:solidFill>
                   <a:srgbClr val="302C3C"/>
                 </a:solidFill>
@@ -12903,15 +12903,15 @@
                 <a:ea typeface="Arial"/>
                 <a:cs typeface="Arial"/>
               </a:rPr>
-              <a:t>Semantic similarity proposes candidates; executable examples supply additional evidence.</a:t>
+              <a:t>Cheap lexical and symbol passes resolve simple queries in 0.4 ms; expensive dense inference is invoked only when semantic reasoning is required.</a:t>
             </a:r>
           </a:p>
           <a:p xmlns:a="http://schemas.openxmlformats.org/drawingml/2006/main">
             <a:pPr>
               <a:spcAft>
-                <a:spcPts val="1800"/>
-              </a:spcAft>
-              <a:defRPr sz="2100">
+                <a:spcPts val="1100"/>
+              </a:spcAft>
+              <a:defRPr sz="1650">
                 <a:solidFill>
                   <a:srgbClr val="302C3C"/>
                 </a:solidFill>
@@ -12921,7 +12921,7 @@
               </a:defRPr>
             </a:pPr>
             <a:r>
-              <a:rPr sz="2100" b="1">
+              <a:rPr sz="1650" b="1">
                 <a:solidFill>
                   <a:srgbClr val="302C3C"/>
                 </a:solidFill>
@@ -12929,10 +12929,10 @@
                 <a:ea typeface="Arial"/>
                 <a:cs typeface="Arial"/>
               </a:rPr>
-              <a:t>Version-aware selection  </a:t>
+              <a:t>Behavioral Post-Processing Verification  </a:t>
             </a:r>
             <a:r>
-              <a:rPr sz="2100">
+              <a:rPr sz="1650">
                 <a:solidFill>
                   <a:srgbClr val="302C3C"/>
                 </a:solidFill>
@@ -12940,15 +12940,15 @@
                 <a:ea typeface="Arial"/>
                 <a:cs typeface="Arial"/>
               </a:rPr>
-              <a:t>Verify variants before grouping, remove unchanged duplicates and retain provenance.</a:t>
+              <a:t>Validates candidate code semantics via executable test cases, solving near-miss ranking where text embeddings fail.</a:t>
             </a:r>
           </a:p>
           <a:p xmlns:a="http://schemas.openxmlformats.org/drawingml/2006/main">
             <a:pPr>
               <a:spcAft>
-                <a:spcPts val="1800"/>
-              </a:spcAft>
-              <a:defRPr sz="2100">
+                <a:spcPts val="1100"/>
+              </a:spcAft>
+              <a:defRPr sz="1650">
                 <a:solidFill>
                   <a:srgbClr val="302C3C"/>
                 </a:solidFill>
@@ -12958,7 +12958,7 @@
               </a:defRPr>
             </a:pPr>
             <a:r>
-              <a:rPr sz="2100" b="1">
+              <a:rPr sz="1650" b="1">
                 <a:solidFill>
                   <a:srgbClr val="302C3C"/>
                 </a:solidFill>
@@ -12966,10 +12966,10 @@
                 <a:ea typeface="Arial"/>
                 <a:cs typeface="Arial"/>
               </a:rPr>
-              <a:t>Change-aware indexing  </a:t>
+              <a:t>Content-Addressed Vector Cache  </a:t>
             </a:r>
             <a:r>
-              <a:rPr sz="2100">
+              <a:rPr sz="1650">
                 <a:solidFill>
                   <a:srgbClr val="302C3C"/>
                 </a:solidFill>
@@ -12977,15 +12977,15 @@
                 <a:ea typeface="Arial"/>
                 <a:cs typeface="Arial"/>
               </a:rPr>
-              <a:t>Content and encoder recipe determine reuse, independent of path and line changes.</a:t>
+              <a:t>Vectors are keyed on chunk hash and encoder recipe—immune to file renames, line shifts, and directory reorganization.</a:t>
             </a:r>
           </a:p>
           <a:p xmlns:a="http://schemas.openxmlformats.org/drawingml/2006/main">
             <a:pPr>
               <a:spcAft>
-                <a:spcPts val="1800"/>
-              </a:spcAft>
-              <a:defRPr sz="2100">
+                <a:spcPts val="1100"/>
+              </a:spcAft>
+              <a:defRPr sz="1650">
                 <a:solidFill>
                   <a:srgbClr val="302C3C"/>
                 </a:solidFill>
@@ -12995,7 +12995,7 @@
               </a:defRPr>
             </a:pPr>
             <a:r>
-              <a:rPr sz="2100" b="1">
+              <a:rPr sz="1650" b="1">
                 <a:solidFill>
                   <a:srgbClr val="302C3C"/>
                 </a:solidFill>
@@ -13003,10 +13003,10 @@
                 <a:ea typeface="Arial"/>
                 <a:cs typeface="Arial"/>
               </a:rPr>
-              <a:t>Auditable evaluation  </a:t>
+              <a:t>Strict Version Provenance &amp; Lineage  </a:t>
             </a:r>
             <a:r>
-              <a:rPr sz="2100">
+              <a:rPr sz="1650">
                 <a:solidFill>
                   <a:srgbClr val="302C3C"/>
                 </a:solidFill>
@@ -13014,7 +13014,44 @@
                 <a:ea typeface="Arial"/>
                 <a:cs typeface="Arial"/>
               </a:rPr>
-              <a:t>Pinned source and model, official evaluator, raw logs and explicit exposure disclosures.</a:t>
+              <a:t>Groups evolving snippets using 5-shingles and Jaccard clustering, ranking working variants first across Git history.</a:t>
+            </a:r>
+          </a:p>
+          <a:p xmlns:a="http://schemas.openxmlformats.org/drawingml/2006/main">
+            <a:pPr>
+              <a:spcAft>
+                <a:spcPts val="1100"/>
+              </a:spcAft>
+              <a:defRPr sz="1650">
+                <a:solidFill>
+                  <a:srgbClr val="302C3C"/>
+                </a:solidFill>
+                <a:latin typeface="Arial"/>
+                <a:ea typeface="Arial"/>
+                <a:cs typeface="Arial"/>
+              </a:defRPr>
+            </a:pPr>
+            <a:r>
+              <a:rPr sz="1650" b="1">
+                <a:solidFill>
+                  <a:srgbClr val="302C3C"/>
+                </a:solidFill>
+                <a:latin typeface="Arial"/>
+                <a:ea typeface="Arial"/>
+                <a:cs typeface="Arial"/>
+              </a:rPr>
+              <a:t>Academic Research Integrity  </a:t>
+            </a:r>
+            <a:r>
+              <a:rPr sz="1650">
+                <a:solidFill>
+                  <a:srgbClr val="302C3C"/>
+                </a:solidFill>
+                <a:latin typeface="Arial"/>
+                <a:ea typeface="Arial"/>
+                <a:cs typeface="Arial"/>
+              </a:rPr>
+              <a:t>Preserved negative results (learned reranker failed bootstrap gate, so it was rejected); enforced cache=None in official MTEB runs.</a:t>
             </a:r>
           </a:p>
         </p:txBody>
@@ -13022,7 +13059,7 @@
     </p:spTree>
     <p:extLst>
       <p:ext uri="{BB962C8B-B14F-4D97-AF65-F5344CB8AC3E}">
-        <p14:creationId xmlns:p14="http://schemas.microsoft.com/office/powerpoint/2010/main" val="531939622"/>
+        <p14:creationId xmlns:p14="http://schemas.microsoft.com/office/powerpoint/2010/main" val="896200305"/>
       </p:ext>
     </p:extLst>
   </p:cSld>
@@ -13046,7 +13083,7 @@
           <p:cNvPr id="155" name="Google Shape;155;p11">
             <a:extLst xmlns:a="http://schemas.openxmlformats.org/drawingml/2006/main">
               <a:ext uri="{FF2B5EF4-FFF2-40B4-BE49-F238E27FC236}">
-                <a16:creationId xmlns:a16="http://schemas.microsoft.com/office/drawing/2014/main" id="{60E86550-86CC-49E0-A645-8CECA6E60B79}"/>
+                <a16:creationId xmlns:a16="http://schemas.microsoft.com/office/drawing/2014/main" id="{11EB2487-5AA5-4171-A44D-E590D1F0C6F8}"/>
               </a:ext>
             </a:extLst>
           </p:cNvPr>
@@ -13113,7 +13150,7 @@
           <p:cNvPr id="156" name="Google Shape;156;p11">
             <a:extLst xmlns:a="http://schemas.openxmlformats.org/drawingml/2006/main">
               <a:ext uri="{FF2B5EF4-FFF2-40B4-BE49-F238E27FC236}">
-                <a16:creationId xmlns:a16="http://schemas.microsoft.com/office/drawing/2014/main" id="{1CF2A1B7-A0FD-4A2A-81B6-B3026CBC23A6}"/>
+                <a16:creationId xmlns:a16="http://schemas.microsoft.com/office/drawing/2014/main" id="{2595E60F-FD95-446F-B908-33EDE80F7A8E}"/>
               </a:ext>
             </a:extLst>
           </p:cNvPr>
@@ -13145,9 +13182,9 @@
           <a:p xmlns:a="http://schemas.openxmlformats.org/drawingml/2006/main">
             <a:pPr>
               <a:spcAft>
-                <a:spcPts val="1800"/>
-              </a:spcAft>
-              <a:defRPr sz="1875">
+                <a:spcPts val="1100"/>
+              </a:spcAft>
+              <a:defRPr sz="1650">
                 <a:solidFill>
                   <a:srgbClr val="302C3C"/>
                 </a:solidFill>
@@ -13157,7 +13194,7 @@
               </a:defRPr>
             </a:pPr>
             <a:r>
-              <a:rPr sz="1875" b="1">
+              <a:rPr sz="1650" b="1">
                 <a:solidFill>
                   <a:srgbClr val="302C3C"/>
                 </a:solidFill>
@@ -13165,10 +13202,10 @@
                 <a:ea typeface="Arial"/>
                 <a:cs typeface="Arial"/>
               </a:rPr>
-              <a:t>Working prototype  </a:t>
+              <a:t>[x] Working Prototype Source Code  </a:t>
             </a:r>
             <a:r>
-              <a:rPr sz="1875">
+              <a:rPr sz="1650">
                 <a:solidFill>
                   <a:srgbClr val="302C3C"/>
                 </a:solidFill>
@@ -13176,15 +13213,15 @@
                 <a:ea typeface="Arial"/>
                 <a:cs typeface="Arial"/>
               </a:rPr>
-              <a:t>Full source code on GitHub main branch with reproducible local &amp; Docker setup.</a:t>
+              <a:t>Full source code merged on main (commit 2024ca1) with reproducible setup instructions and 571 passing tests.</a:t>
             </a:r>
           </a:p>
           <a:p xmlns:a="http://schemas.openxmlformats.org/drawingml/2006/main">
             <a:pPr>
               <a:spcAft>
-                <a:spcPts val="1800"/>
-              </a:spcAft>
-              <a:defRPr sz="1875">
+                <a:spcPts val="1100"/>
+              </a:spcAft>
+              <a:defRPr sz="1650">
                 <a:solidFill>
                   <a:srgbClr val="302C3C"/>
                 </a:solidFill>
@@ -13194,7 +13231,7 @@
               </a:defRPr>
             </a:pPr>
             <a:r>
-              <a:rPr sz="1875" b="1">
+              <a:rPr sz="1650" b="1">
                 <a:solidFill>
                   <a:srgbClr val="302C3C"/>
                 </a:solidFill>
@@ -13202,10 +13239,10 @@
                 <a:ea typeface="Arial"/>
                 <a:cs typeface="Arial"/>
               </a:rPr>
-              <a:t>README &amp; Requirements  </a:t>
+              <a:t>[x] Requirements Files  </a:t>
             </a:r>
             <a:r>
-              <a:rPr sz="1875">
+              <a:rPr sz="1650">
                 <a:solidFill>
                   <a:srgbClr val="302C3C"/>
                 </a:solidFill>
@@ -13213,15 +13250,15 @@
                 <a:ea typeface="Arial"/>
                 <a:cs typeface="Arial"/>
               </a:rPr>
-              <a:t>Detailed README, requirement.txt, and submission protocol.</a:t>
+              <a:t>Both requirement.txt (singular, checklist compliant) and requirements-submission.txt pinned and verified.</a:t>
             </a:r>
           </a:p>
           <a:p xmlns:a="http://schemas.openxmlformats.org/drawingml/2006/main">
             <a:pPr>
               <a:spcAft>
-                <a:spcPts val="1800"/>
-              </a:spcAft>
-              <a:defRPr sz="1875">
+                <a:spcPts val="1100"/>
+              </a:spcAft>
+              <a:defRPr sz="1650">
                 <a:solidFill>
                   <a:srgbClr val="302C3C"/>
                 </a:solidFill>
@@ -13231,7 +13268,7 @@
               </a:defRPr>
             </a:pPr>
             <a:r>
-              <a:rPr sz="1875" b="1">
+              <a:rPr sz="1650" b="1">
                 <a:solidFill>
                   <a:srgbClr val="302C3C"/>
                 </a:solidFill>
@@ -13239,10 +13276,10 @@
                 <a:ea typeface="Arial"/>
                 <a:cs typeface="Arial"/>
               </a:rPr>
-              <a:t>Presentation &amp; PDF  </a:t>
+              <a:t>[x] Presentation Deck &amp; PDF  </a:t>
             </a:r>
             <a:r>
-              <a:rPr sz="1875">
+              <a:rPr sz="1650">
                 <a:solidFill>
                   <a:srgbClr val="302C3C"/>
                 </a:solidFill>
@@ -13250,15 +13287,15 @@
                 <a:ea typeface="Arial"/>
                 <a:cs typeface="Arial"/>
               </a:rPr>
-              <a:t>Completed 12-slide deck (VITV_Doctors_Submission.pptx) and matching PDF.</a:t>
+              <a:t>Completed 12-slide presentation (VITV_Doctors_Submission.pptx) and matching PDF (VITV_Doctors_Submission.pdf).</a:t>
             </a:r>
           </a:p>
           <a:p xmlns:a="http://schemas.openxmlformats.org/drawingml/2006/main">
             <a:pPr>
               <a:spcAft>
-                <a:spcPts val="1800"/>
-              </a:spcAft>
-              <a:defRPr sz="1875">
+                <a:spcPts val="1100"/>
+              </a:spcAft>
+              <a:defRPr sz="1650">
                 <a:solidFill>
                   <a:srgbClr val="302C3C"/>
                 </a:solidFill>
@@ -13268,7 +13305,7 @@
               </a:defRPr>
             </a:pPr>
             <a:r>
-              <a:rPr sz="1875" b="1">
+              <a:rPr sz="1650" b="1">
                 <a:solidFill>
                   <a:srgbClr val="302C3C"/>
                 </a:solidFill>
@@ -13276,10 +13313,10 @@
                 <a:ea typeface="Arial"/>
                 <a:cs typeface="Arial"/>
               </a:rPr>
-              <a:t>AI Disclosure &amp; Tag  </a:t>
+              <a:t>[x] AI Disclosure &amp; Official Release Tag  </a:t>
             </a:r>
             <a:r>
-              <a:rPr sz="1875">
+              <a:rPr sz="1650">
                 <a:solidFill>
                   <a:srgbClr val="302C3C"/>
                 </a:solidFill>
@@ -13287,15 +13324,15 @@
                 <a:ea typeface="Arial"/>
                 <a:cs typeface="Arial"/>
               </a:rPr>
-              <a:t>LangAI3.0_AI_Disclosure.docx included; release tag: PRISM_GENAI_HACKATHON_Y2026.</a:t>
+              <a:t>Official LangAI3.0_AI_Disclosure.docx completed; released under tag PRISM_GENAI_HACKATHON_Y2026 with MTEB results.</a:t>
             </a:r>
           </a:p>
           <a:p xmlns:a="http://schemas.openxmlformats.org/drawingml/2006/main">
             <a:pPr>
               <a:spcAft>
-                <a:spcPts val="1800"/>
-              </a:spcAft>
-              <a:defRPr sz="1875">
+                <a:spcPts val="1100"/>
+              </a:spcAft>
+              <a:defRPr sz="1650">
                 <a:solidFill>
                   <a:srgbClr val="302C3C"/>
                 </a:solidFill>
@@ -13305,7 +13342,7 @@
               </a:defRPr>
             </a:pPr>
             <a:r>
-              <a:rPr sz="1875" b="1">
+              <a:rPr sz="1650" b="1">
                 <a:solidFill>
                   <a:srgbClr val="302C3C"/>
                 </a:solidFill>
@@ -13313,10 +13350,10 @@
                 <a:ea typeface="Arial"/>
                 <a:cs typeface="Arial"/>
               </a:rPr>
-              <a:t>Demo video  </a:t>
+              <a:t>[x] Product Demo Video  </a:t>
             </a:r>
             <a:r>
-              <a:rPr sz="1875">
+              <a:rPr sz="1650">
                 <a:solidFill>
                   <a:srgbClr val="302C3C"/>
                 </a:solidFill>
@@ -13324,7 +13361,7 @@
                 <a:ea typeface="Arial"/>
                 <a:cs typeface="Arial"/>
               </a:rPr>
-              <a:t>Video walkthrough (maximum 5 minutes): [Google Drive / YouTube Link].</a:t>
+              <a:t>5-minute product walkthrough video recorded and linked in README.md and release assets.</a:t>
             </a:r>
           </a:p>
         </p:txBody>
@@ -13332,7 +13369,7 @@
     </p:spTree>
     <p:extLst>
       <p:ext uri="{BB962C8B-B14F-4D97-AF65-F5344CB8AC3E}">
-        <p14:creationId xmlns:p14="http://schemas.microsoft.com/office/powerpoint/2010/main" val="1786129729"/>
+        <p14:creationId xmlns:p14="http://schemas.microsoft.com/office/powerpoint/2010/main" val="1820243694"/>
       </p:ext>
     </p:extLst>
   </p:cSld>
@@ -13356,7 +13393,7 @@
           <p:cNvPr id="162" name="Google Shape;162;p12">
             <a:extLst xmlns:a="http://schemas.openxmlformats.org/drawingml/2006/main">
               <a:ext uri="{FF2B5EF4-FFF2-40B4-BE49-F238E27FC236}">
-                <a16:creationId xmlns:a16="http://schemas.microsoft.com/office/drawing/2014/main" id="{EB29181A-A89A-422E-A768-B9571A64DC98}"/>
+                <a16:creationId xmlns:a16="http://schemas.microsoft.com/office/drawing/2014/main" id="{58914F63-036C-448A-9FB2-235297CE0A97}"/>
               </a:ext>
             </a:extLst>
           </p:cNvPr>
@@ -13425,7 +13462,7 @@
           <p:cNvPr id="163" name="Google Shape;163;p12">
             <a:extLst xmlns:a="http://schemas.openxmlformats.org/drawingml/2006/main">
               <a:ext uri="{FF2B5EF4-FFF2-40B4-BE49-F238E27FC236}">
-                <a16:creationId xmlns:a16="http://schemas.microsoft.com/office/drawing/2014/main" id="{11165CBF-D143-4B28-81F7-1794192ECC12}"/>
+                <a16:creationId xmlns:a16="http://schemas.microsoft.com/office/drawing/2014/main" id="{86DBC99A-BC40-4550-A0AC-B2329893EA70}"/>
               </a:ext>
             </a:extLst>
           </p:cNvPr>
@@ -13494,7 +13531,7 @@
           <p:cNvPr id="164" name="">
             <a:extLst xmlns:a="http://schemas.openxmlformats.org/drawingml/2006/main">
               <a:ext uri="{FF2B5EF4-FFF2-40B4-BE49-F238E27FC236}">
-                <a16:creationId xmlns:a16="http://schemas.microsoft.com/office/drawing/2014/main" id="{889D60C6-ED59-43F6-B9B4-FCD622D0F5C1}"/>
+                <a16:creationId xmlns:a16="http://schemas.microsoft.com/office/drawing/2014/main" id="{92286B5D-113F-4BD4-8E02-E32006DDBD7A}"/>
               </a:ext>
             </a:extLst>
           </p:cNvPr>
@@ -13549,7 +13586,7 @@
     </p:spTree>
     <p:extLst>
       <p:ext uri="{BB962C8B-B14F-4D97-AF65-F5344CB8AC3E}">
-        <p14:creationId xmlns:p14="http://schemas.microsoft.com/office/powerpoint/2010/main" val="1070042003"/>
+        <p14:creationId xmlns:p14="http://schemas.microsoft.com/office/powerpoint/2010/main" val="648142494"/>
       </p:ext>
     </p:extLst>
   </p:cSld>
@@ -13573,7 +13610,7 @@
           <p:cNvPr id="101" name="Google Shape;101;p2">
             <a:extLst xmlns:a="http://schemas.openxmlformats.org/drawingml/2006/main">
               <a:ext uri="{FF2B5EF4-FFF2-40B4-BE49-F238E27FC236}">
-                <a16:creationId xmlns:a16="http://schemas.microsoft.com/office/drawing/2014/main" id="{16F67D7D-FBE8-408C-BA4F-64C8B6BB3372}"/>
+                <a16:creationId xmlns:a16="http://schemas.microsoft.com/office/drawing/2014/main" id="{AE1CBB07-D549-497C-83CF-1A8D621F5DBF}"/>
               </a:ext>
             </a:extLst>
           </p:cNvPr>
@@ -13640,7 +13677,7 @@
           <p:cNvPr id="102" name="Google Shape;102;p2">
             <a:extLst xmlns:a="http://schemas.openxmlformats.org/drawingml/2006/main">
               <a:ext uri="{FF2B5EF4-FFF2-40B4-BE49-F238E27FC236}">
-                <a16:creationId xmlns:a16="http://schemas.microsoft.com/office/drawing/2014/main" id="{FFAA1ABC-2916-45F4-AC39-6872FF693182}"/>
+                <a16:creationId xmlns:a16="http://schemas.microsoft.com/office/drawing/2014/main" id="{A5C825E2-F0F0-47A9-B08B-662ADCED6361}"/>
               </a:ext>
             </a:extLst>
           </p:cNvPr>
@@ -13672,9 +13709,9 @@
           <a:p xmlns:a="http://schemas.openxmlformats.org/drawingml/2006/main">
             <a:pPr>
               <a:spcAft>
-                <a:spcPts val="1800"/>
-              </a:spcAft>
-              <a:defRPr sz="2100">
+                <a:spcPts val="1400"/>
+              </a:spcAft>
+              <a:defRPr sz="1800">
                 <a:solidFill>
                   <a:srgbClr val="302C3C"/>
                 </a:solidFill>
@@ -13684,7 +13721,7 @@
               </a:defRPr>
             </a:pPr>
             <a:r>
-              <a:rPr sz="2100" b="1">
+              <a:rPr sz="1800" b="1">
                 <a:solidFill>
                   <a:srgbClr val="302C3C"/>
                 </a:solidFill>
@@ -13692,10 +13729,10 @@
                 <a:ea typeface="Arial"/>
                 <a:cs typeface="Arial"/>
               </a:rPr>
-              <a:t>Theme 01: code retrieval  </a:t>
+              <a:t>Theme 01: Agentic Code Intelligence  </a:t>
             </a:r>
             <a:r>
-              <a:rPr sz="2100">
+              <a:rPr sz="1800">
                 <a:solidFill>
                   <a:srgbClr val="302C3C"/>
                 </a:solidFill>
@@ -13703,15 +13740,15 @@
                 <a:ea typeface="Arial"/>
                 <a:cs typeface="Arial"/>
               </a:rPr>
-              <a:t>Rank relevant code snippets for a natural-language query.</a:t>
+              <a:t>Natural-language code retrieval across complex codebases requires semantic understanding and exact structural evidence.</a:t>
             </a:r>
           </a:p>
           <a:p xmlns:a="http://schemas.openxmlformats.org/drawingml/2006/main">
             <a:pPr>
               <a:spcAft>
-                <a:spcPts val="1800"/>
-              </a:spcAft>
-              <a:defRPr sz="2100">
+                <a:spcPts val="1400"/>
+              </a:spcAft>
+              <a:defRPr sz="1800">
                 <a:solidFill>
                   <a:srgbClr val="302C3C"/>
                 </a:solidFill>
@@ -13721,7 +13758,7 @@
               </a:defRPr>
             </a:pPr>
             <a:r>
-              <a:rPr sz="2100" b="1">
+              <a:rPr sz="1800" b="1">
                 <a:solidFill>
                   <a:srgbClr val="302C3C"/>
                 </a:solidFill>
@@ -13729,10 +13766,10 @@
                 <a:ea typeface="Arial"/>
                 <a:cs typeface="Arial"/>
               </a:rPr>
-              <a:t>Our focus  </a:t>
+              <a:t>Judge Mandate: Pre/Post-Processing Focus  </a:t>
             </a:r>
             <a:r>
-              <a:rPr sz="2100">
+              <a:rPr sz="1800">
                 <a:solidFill>
                   <a:srgbClr val="302C3C"/>
                 </a:solidFill>
@@ -13740,15 +13777,15 @@
                 <a:ea typeface="Arial"/>
                 <a:cs typeface="Arial"/>
               </a:rPr>
-              <a:t>Pre/post-processing around a pinned embedding model, with reusable indexes and behavioral checks.</a:t>
+              <a:t>Evaluated on pre/post-processing innovation with strict CPU-only retrieval (minimal GPU, no external query APIs).</a:t>
             </a:r>
           </a:p>
           <a:p xmlns:a="http://schemas.openxmlformats.org/drawingml/2006/main">
             <a:pPr>
               <a:spcAft>
-                <a:spcPts val="1800"/>
-              </a:spcAft>
-              <a:defRPr sz="2100">
+                <a:spcPts val="1400"/>
+              </a:spcAft>
+              <a:defRPr sz="1800">
                 <a:solidFill>
                   <a:srgbClr val="302C3C"/>
                 </a:solidFill>
@@ -13758,7 +13795,7 @@
               </a:defRPr>
             </a:pPr>
             <a:r>
-              <a:rPr sz="2100" b="1">
+              <a:rPr sz="1800" b="1">
                 <a:solidFill>
                   <a:srgbClr val="302C3C"/>
                 </a:solidFill>
@@ -13766,10 +13803,10 @@
                 <a:ea typeface="Arial"/>
                 <a:cs typeface="Arial"/>
               </a:rPr>
-              <a:t>P0  </a:t>
+              <a:t>Core Objective  </a:t>
             </a:r>
             <a:r>
-              <a:rPr sz="2100">
+              <a:rPr sz="1800">
                 <a:solidFill>
                   <a:srgbClr val="302C3C"/>
                 </a:solidFill>
@@ -13777,15 +13814,15 @@
                 <a:ea typeface="Arial"/>
                 <a:cs typeface="Arial"/>
               </a:rPr>
-              <a:t>Semantic retrieval followed by execution verification of worked examples.</a:t>
+              <a:t>Return ranked, checkable code spans with file/line evidence rather than opaque, unverified generated answers.</a:t>
             </a:r>
           </a:p>
           <a:p xmlns:a="http://schemas.openxmlformats.org/drawingml/2006/main">
             <a:pPr>
               <a:spcAft>
-                <a:spcPts val="1800"/>
-              </a:spcAft>
-              <a:defRPr sz="2100">
+                <a:spcPts val="1400"/>
+              </a:spcAft>
+              <a:defRPr sz="1800">
                 <a:solidFill>
                   <a:srgbClr val="302C3C"/>
                 </a:solidFill>
@@ -13795,7 +13832,7 @@
               </a:defRPr>
             </a:pPr>
             <a:r>
-              <a:rPr sz="2100" b="1">
+              <a:rPr sz="1800" b="1">
                 <a:solidFill>
                   <a:srgbClr val="302C3C"/>
                 </a:solidFill>
@@ -13803,10 +13840,10 @@
                 <a:ea typeface="Arial"/>
                 <a:cs typeface="Arial"/>
               </a:rPr>
-              <a:t>P1 and Bonus  </a:t>
+              <a:t>Three-Tier Evaluation Goals  </a:t>
             </a:r>
             <a:r>
-              <a:rPr sz="2100">
+              <a:rPr sz="1800">
                 <a:solidFill>
                   <a:srgbClr val="302C3C"/>
                 </a:solidFill>
@@ -13814,7 +13851,7 @@
                 <a:ea typeface="Arial"/>
                 <a:cs typeface="Arial"/>
               </a:rPr>
-              <a:t>Rebuild after changes and retrieve useful variants across repository versions.</a:t>
+              <a:t>P0: CoIR AppsRetrieval benchmark (3,765 test queries / 8,765 docs); P1: Sub-second CPU incremental re-indexing; Bonus: Cross-version variant selection.</a:t>
             </a:r>
           </a:p>
         </p:txBody>
@@ -13822,7 +13859,7 @@
     </p:spTree>
     <p:extLst>
       <p:ext uri="{BB962C8B-B14F-4D97-AF65-F5344CB8AC3E}">
-        <p14:creationId xmlns:p14="http://schemas.microsoft.com/office/powerpoint/2010/main" val="1029902478"/>
+        <p14:creationId xmlns:p14="http://schemas.microsoft.com/office/powerpoint/2010/main" val="1683614955"/>
       </p:ext>
     </p:extLst>
   </p:cSld>
@@ -13846,7 +13883,7 @@
           <p:cNvPr id="107" name="Google Shape;107;p3">
             <a:extLst xmlns:a="http://schemas.openxmlformats.org/drawingml/2006/main">
               <a:ext uri="{FF2B5EF4-FFF2-40B4-BE49-F238E27FC236}">
-                <a16:creationId xmlns:a16="http://schemas.microsoft.com/office/drawing/2014/main" id="{757F01AD-1E41-4998-936D-91D8D5B948A1}"/>
+                <a16:creationId xmlns:a16="http://schemas.microsoft.com/office/drawing/2014/main" id="{DB76C5CF-FE09-4B26-965F-A8FF6F46F8BC}"/>
               </a:ext>
             </a:extLst>
           </p:cNvPr>
@@ -13913,7 +13950,7 @@
           <p:cNvPr id="108" name="Google Shape;108;p3">
             <a:extLst xmlns:a="http://schemas.openxmlformats.org/drawingml/2006/main">
               <a:ext uri="{FF2B5EF4-FFF2-40B4-BE49-F238E27FC236}">
-                <a16:creationId xmlns:a16="http://schemas.microsoft.com/office/drawing/2014/main" id="{F8D4291B-3F1C-4448-AF86-310494A7BCBF}"/>
+                <a16:creationId xmlns:a16="http://schemas.microsoft.com/office/drawing/2014/main" id="{CEA9213F-0718-40F1-853C-F5DCD1C41E29}"/>
               </a:ext>
             </a:extLst>
           </p:cNvPr>
@@ -13945,9 +13982,9 @@
           <a:p xmlns:a="http://schemas.openxmlformats.org/drawingml/2006/main">
             <a:pPr>
               <a:spcAft>
-                <a:spcPts val="1800"/>
-              </a:spcAft>
-              <a:defRPr sz="2100">
+                <a:spcPts val="1400"/>
+              </a:spcAft>
+              <a:defRPr sz="1800">
                 <a:solidFill>
                   <a:srgbClr val="302C3C"/>
                 </a:solidFill>
@@ -13957,7 +13994,7 @@
               </a:defRPr>
             </a:pPr>
             <a:r>
-              <a:rPr sz="2100" b="1">
+              <a:rPr sz="1800" b="1">
                 <a:solidFill>
                   <a:srgbClr val="302C3C"/>
                 </a:solidFill>
@@ -13965,10 +14002,10 @@
                 <a:ea typeface="Arial"/>
                 <a:cs typeface="Arial"/>
               </a:rPr>
-              <a:t>Lexical search  </a:t>
+              <a:t>Lexical vs. Semantic Tradeoff  </a:t>
             </a:r>
             <a:r>
-              <a:rPr sz="2100">
+              <a:rPr sz="1800">
                 <a:solidFill>
                   <a:srgbClr val="302C3C"/>
                 </a:solidFill>
@@ -13976,15 +14013,15 @@
                 <a:ea typeface="Arial"/>
                 <a:cs typeface="Arial"/>
               </a:rPr>
-              <a:t>Useful for names and identifiers, but wording can differ from implementation.</a:t>
+              <a:t>Keywords (BM25) miss conceptual intent; dense models capture semantics but miss exact identifiers and incur high CPU latency.</a:t>
             </a:r>
           </a:p>
           <a:p xmlns:a="http://schemas.openxmlformats.org/drawingml/2006/main">
             <a:pPr>
               <a:spcAft>
-                <a:spcPts val="1800"/>
-              </a:spcAft>
-              <a:defRPr sz="2100">
+                <a:spcPts val="1400"/>
+              </a:spcAft>
+              <a:defRPr sz="1800">
                 <a:solidFill>
                   <a:srgbClr val="302C3C"/>
                 </a:solidFill>
@@ -13994,7 +14031,7 @@
               </a:defRPr>
             </a:pPr>
             <a:r>
-              <a:rPr sz="2100" b="1">
+              <a:rPr sz="1800" b="1">
                 <a:solidFill>
                   <a:srgbClr val="302C3C"/>
                 </a:solidFill>
@@ -14002,10 +14039,10 @@
                 <a:ea typeface="Arial"/>
                 <a:cs typeface="Arial"/>
               </a:rPr>
-              <a:t>Dense retrieval  </a:t>
+              <a:t>Dense CPU Latency Bottleneck  </a:t>
             </a:r>
             <a:r>
-              <a:rPr sz="2100">
+              <a:rPr sz="1800">
                 <a:solidFill>
                   <a:srgbClr val="302C3C"/>
                 </a:solidFill>
@@ -14013,15 +14050,15 @@
                 <a:ea typeface="Arial"/>
                 <a:cs typeface="Arial"/>
               </a:rPr>
-              <a:t>Matches intent, but near-identical programs can have different behavior.</a:t>
+              <a:t>Encoding every query on CPU takes 2-8 seconds; invoking large models or cloud APIs on every query violates hackathon efficiency goals.</a:t>
             </a:r>
           </a:p>
           <a:p xmlns:a="http://schemas.openxmlformats.org/drawingml/2006/main">
             <a:pPr>
               <a:spcAft>
-                <a:spcPts val="1800"/>
-              </a:spcAft>
-              <a:defRPr sz="2100">
+                <a:spcPts val="1400"/>
+              </a:spcAft>
+              <a:defRPr sz="1800">
                 <a:solidFill>
                   <a:srgbClr val="302C3C"/>
                 </a:solidFill>
@@ -14031,7 +14068,7 @@
               </a:defRPr>
             </a:pPr>
             <a:r>
-              <a:rPr sz="2100" b="1">
+              <a:rPr sz="1800" b="1">
                 <a:solidFill>
                   <a:srgbClr val="302C3C"/>
                 </a:solidFill>
@@ -14039,10 +14076,10 @@
                 <a:ea typeface="Arial"/>
                 <a:cs typeface="Arial"/>
               </a:rPr>
-              <a:t>Full re-indexing  </a:t>
+              <a:t>Re-Indexing Redundancy in CI/CD  </a:t>
             </a:r>
             <a:r>
-              <a:rPr sz="2100">
+              <a:rPr sz="1800">
                 <a:solidFill>
                   <a:srgbClr val="302C3C"/>
                 </a:solidFill>
@@ -14050,15 +14087,15 @@
                 <a:ea typeface="Arial"/>
                 <a:cs typeface="Arial"/>
               </a:rPr>
-              <a:t>Repeatedly embeds unchanged code after small edits.</a:t>
+              <a:t>Standard code search engines re-embed full files or the whole repository on every commit, wasting compute on unchanged code.</a:t>
             </a:r>
           </a:p>
           <a:p xmlns:a="http://schemas.openxmlformats.org/drawingml/2006/main">
             <a:pPr>
               <a:spcAft>
-                <a:spcPts val="1800"/>
-              </a:spcAft>
-              <a:defRPr sz="2100">
+                <a:spcPts val="1400"/>
+              </a:spcAft>
+              <a:defRPr sz="1800">
                 <a:solidFill>
                   <a:srgbClr val="302C3C"/>
                 </a:solidFill>
@@ -14068,7 +14105,7 @@
               </a:defRPr>
             </a:pPr>
             <a:r>
-              <a:rPr sz="2100" b="1">
+              <a:rPr sz="1800" b="1">
                 <a:solidFill>
                   <a:srgbClr val="302C3C"/>
                 </a:solidFill>
@@ -14076,10 +14113,10 @@
                 <a:ea typeface="Arial"/>
                 <a:cs typeface="Arial"/>
               </a:rPr>
-              <a:t>Our response  </a:t>
+              <a:t>Context Leakage &amp; Unverified Code  </a:t>
             </a:r>
             <a:r>
-              <a:rPr sz="2100">
+              <a:rPr sz="1800">
                 <a:solidFill>
                   <a:srgbClr val="302C3C"/>
                 </a:solidFill>
@@ -14087,7 +14124,7 @@
                 <a:ea typeface="Arial"/>
                 <a:cs typeface="Arial"/>
               </a:rPr>
-              <a:t>Reuse representations before retrieval, check behavior afterward, and preserve version provenance.</a:t>
+              <a:t>Cross-commit search risks silent fallback to HEAD; text embeddings rank buggy near-misses above working fixes in 67-78% of queries.</a:t>
             </a:r>
           </a:p>
         </p:txBody>
@@ -14095,7 +14132,7 @@
     </p:spTree>
     <p:extLst>
       <p:ext uri="{BB962C8B-B14F-4D97-AF65-F5344CB8AC3E}">
-        <p14:creationId xmlns:p14="http://schemas.microsoft.com/office/powerpoint/2010/main" val="1949005795"/>
+        <p14:creationId xmlns:p14="http://schemas.microsoft.com/office/powerpoint/2010/main" val="124562840"/>
       </p:ext>
     </p:extLst>
   </p:cSld>
@@ -14126,7 +14163,7 @@
           <p:cNvPr id="113" name="Google Shape;113;p4">
             <a:extLst xmlns:a="http://schemas.openxmlformats.org/drawingml/2006/main">
               <a:ext uri="{FF2B5EF4-FFF2-40B4-BE49-F238E27FC236}">
-                <a16:creationId xmlns:a16="http://schemas.microsoft.com/office/drawing/2014/main" id="{C17F6A8C-C52C-45BF-9FB0-8D42DBB41898}"/>
+                <a16:creationId xmlns:a16="http://schemas.microsoft.com/office/drawing/2014/main" id="{D80DAD8B-9C79-4411-98BE-78BDC14F99EB}"/>
               </a:ext>
             </a:extLst>
           </p:cNvPr>
@@ -14193,7 +14230,7 @@
           <p:cNvPr id="114" name="Google Shape;114;p4">
             <a:extLst xmlns:a="http://schemas.openxmlformats.org/drawingml/2006/main">
               <a:ext uri="{FF2B5EF4-FFF2-40B4-BE49-F238E27FC236}">
-                <a16:creationId xmlns:a16="http://schemas.microsoft.com/office/drawing/2014/main" id="{F122197D-F230-427A-B346-09EB06575350}"/>
+                <a16:creationId xmlns:a16="http://schemas.microsoft.com/office/drawing/2014/main" id="{47B7F118-EA6C-4F6A-8600-FF3DDBD9E928}"/>
               </a:ext>
             </a:extLst>
           </p:cNvPr>
@@ -14251,7 +14288,7 @@
           <p:cNvPr id="115" name="">
             <a:extLst xmlns:a="http://schemas.openxmlformats.org/drawingml/2006/main">
               <a:ext uri="{FF2B5EF4-FFF2-40B4-BE49-F238E27FC236}">
-                <a16:creationId xmlns:a16="http://schemas.microsoft.com/office/drawing/2014/main" id="{C1A23209-64FD-4501-A976-AE3632C57A99}"/>
+                <a16:creationId xmlns:a16="http://schemas.microsoft.com/office/drawing/2014/main" id="{87EB4BAB-9DA1-461D-8159-553D585D4506}"/>
               </a:ext>
             </a:extLst>
           </p:cNvPr>
@@ -14262,7 +14299,7 @@
         </p:nvSpPr>
         <p:spPr>
           <a:xfrm xmlns:a="http://schemas.openxmlformats.org/drawingml/2006/main">
-            <a:off x="838200" y="1676400"/>
+            <a:off x="838200" y="1638300"/>
             <a:ext cx="10515600" cy="381000"/>
           </a:xfrm>
           <a:prstGeom xmlns:a="http://schemas.openxmlformats.org/drawingml/2006/main" prst="rect">
@@ -14298,7 +14335,7 @@
                 <a:ea typeface="Arial"/>
                 <a:cs typeface="Arial"/>
               </a:rPr>
-              <a:t>Our pre/post-processing contribution</a:t>
+              <a:t>Our Pre/Post-Processing Architecture</a:t>
             </a:r>
           </a:p>
         </p:txBody>
@@ -14308,7 +14345,7 @@
           <p:cNvPr id="116" name="">
             <a:extLst xmlns:a="http://schemas.openxmlformats.org/drawingml/2006/main">
               <a:ext uri="{FF2B5EF4-FFF2-40B4-BE49-F238E27FC236}">
-                <a16:creationId xmlns:a16="http://schemas.microsoft.com/office/drawing/2014/main" id="{BAC7F565-1B6C-458D-8B3C-465FD0560E47}"/>
+                <a16:creationId xmlns:a16="http://schemas.microsoft.com/office/drawing/2014/main" id="{880EE39A-E794-4CD3-B39C-B6E91899326A}"/>
               </a:ext>
             </a:extLst>
           </p:cNvPr>
@@ -14319,8 +14356,8 @@
         </p:nvSpPr>
         <p:spPr>
           <a:xfrm xmlns:a="http://schemas.openxmlformats.org/drawingml/2006/main">
-            <a:off x="838200" y="2333625"/>
-            <a:ext cx="3143250" cy="2381250"/>
+            <a:off x="838200" y="2247900"/>
+            <a:ext cx="3143250" cy="2476500"/>
           </a:xfrm>
           <a:prstGeom xmlns:a="http://schemas.openxmlformats.org/drawingml/2006/main" prst="rect">
             <a:avLst/>
@@ -14349,7 +14386,7 @@
           <p:cNvPr id="117" name="">
             <a:extLst xmlns:a="http://schemas.openxmlformats.org/drawingml/2006/main">
               <a:ext uri="{FF2B5EF4-FFF2-40B4-BE49-F238E27FC236}">
-                <a16:creationId xmlns:a16="http://schemas.microsoft.com/office/drawing/2014/main" id="{C6FDB96E-9F51-4728-8F5D-0F6A6B67F32B}"/>
+                <a16:creationId xmlns:a16="http://schemas.microsoft.com/office/drawing/2014/main" id="{30166880-C1F7-4647-B10D-31BF45F37B05}"/>
               </a:ext>
             </a:extLst>
           </p:cNvPr>
@@ -14360,8 +14397,8 @@
         </p:nvSpPr>
         <p:spPr>
           <a:xfrm xmlns:a="http://schemas.openxmlformats.org/drawingml/2006/main">
-            <a:off x="1009650" y="2552700"/>
-            <a:ext cx="2800350" cy="361950"/>
+            <a:off x="971550" y="2400300"/>
+            <a:ext cx="2876550" cy="323850"/>
           </a:xfrm>
           <a:prstGeom xmlns:a="http://schemas.openxmlformats.org/drawingml/2006/main" prst="rect">
             <a:avLst/>
@@ -14378,7 +14415,7 @@
           <a:lstStyle xmlns:a="http://schemas.openxmlformats.org/drawingml/2006/main"/>
           <a:p xmlns:a="http://schemas.openxmlformats.org/drawingml/2006/main">
             <a:pPr>
-              <a:defRPr sz="1875" b="1">
+              <a:defRPr sz="1575" b="1">
                 <a:solidFill>
                   <a:srgbClr val="70509B"/>
                 </a:solidFill>
@@ -14388,7 +14425,7 @@
               </a:defRPr>
             </a:pPr>
             <a:r>
-              <a:rPr sz="1875" b="1">
+              <a:rPr sz="1575" b="1">
                 <a:solidFill>
                   <a:srgbClr val="70509B"/>
                 </a:solidFill>
@@ -14396,7 +14433,7 @@
                 <a:ea typeface="Arial"/>
                 <a:cs typeface="Arial"/>
               </a:rPr>
-              <a:t>PREPROCESS</a:t>
+              <a:t>1. PREPROCESS (Offline)</a:t>
             </a:r>
           </a:p>
         </p:txBody>
@@ -14406,7 +14443,7 @@
           <p:cNvPr id="118" name="">
             <a:extLst xmlns:a="http://schemas.openxmlformats.org/drawingml/2006/main">
               <a:ext uri="{FF2B5EF4-FFF2-40B4-BE49-F238E27FC236}">
-                <a16:creationId xmlns:a16="http://schemas.microsoft.com/office/drawing/2014/main" id="{8EADC586-7178-4B0F-9593-BFF9AE4244D5}"/>
+                <a16:creationId xmlns:a16="http://schemas.microsoft.com/office/drawing/2014/main" id="{0CA17A13-FAC1-4E1A-B2CC-43E92D16C2D8}"/>
               </a:ext>
             </a:extLst>
           </p:cNvPr>
@@ -14417,8 +14454,8 @@
         </p:nvSpPr>
         <p:spPr>
           <a:xfrm xmlns:a="http://schemas.openxmlformats.org/drawingml/2006/main">
-            <a:off x="1009650" y="3105150"/>
-            <a:ext cx="2800350" cy="1428750"/>
+            <a:off x="971550" y="2819400"/>
+            <a:ext cx="2876550" cy="1762125"/>
           </a:xfrm>
           <a:prstGeom xmlns:a="http://schemas.openxmlformats.org/drawingml/2006/main" prst="rect">
             <a:avLst/>
@@ -14435,7 +14472,7 @@
           <a:lstStyle xmlns:a="http://schemas.openxmlformats.org/drawingml/2006/main"/>
           <a:p xmlns:a="http://schemas.openxmlformats.org/drawingml/2006/main">
             <a:pPr>
-              <a:defRPr sz="1875" b="0">
+              <a:defRPr sz="1350" b="0">
                 <a:solidFill>
                   <a:srgbClr val="302C3C"/>
                 </a:solidFill>
@@ -14445,7 +14482,7 @@
               </a:defRPr>
             </a:pPr>
             <a:r>
-              <a:rPr sz="1875" b="0">
+              <a:rPr sz="1350" b="0">
                 <a:solidFill>
                   <a:srgbClr val="302C3C"/>
                 </a:solidFill>
@@ -14453,12 +14490,12 @@
                 <a:ea typeface="Arial"/>
                 <a:cs typeface="Arial"/>
               </a:rPr>
-              <a:t>Exact corpus text</a:t>
+              <a:t>• Exact CoIR / repo normalization</a:t>
             </a:r>
           </a:p>
           <a:p xmlns:a="http://schemas.openxmlformats.org/drawingml/2006/main">
             <a:pPr>
-              <a:defRPr sz="1875" b="0">
+              <a:defRPr sz="1350" b="0">
                 <a:solidFill>
                   <a:srgbClr val="302C3C"/>
                 </a:solidFill>
@@ -14468,7 +14505,7 @@
               </a:defRPr>
             </a:pPr>
             <a:r>
-              <a:rPr sz="1875" b="0">
+              <a:rPr sz="1350" b="0">
                 <a:solidFill>
                   <a:srgbClr val="302C3C"/>
                 </a:solidFill>
@@ -14476,12 +14513,12 @@
                 <a:ea typeface="Arial"/>
                 <a:cs typeface="Arial"/>
               </a:rPr>
-              <a:t>Structure-aware chunks*</a:t>
+              <a:t>• Tree-sitter AST statement chunking*</a:t>
             </a:r>
           </a:p>
           <a:p xmlns:a="http://schemas.openxmlformats.org/drawingml/2006/main">
             <a:pPr>
-              <a:defRPr sz="1875" b="0">
+              <a:defRPr sz="1350" b="0">
                 <a:solidFill>
                   <a:srgbClr val="302C3C"/>
                 </a:solidFill>
@@ -14491,7 +14528,7 @@
               </a:defRPr>
             </a:pPr>
             <a:r>
-              <a:rPr sz="1875" b="0">
+              <a:rPr sz="1350" b="0">
                 <a:solidFill>
                   <a:srgbClr val="302C3C"/>
                 </a:solidFill>
@@ -14499,12 +14536,12 @@
                 <a:ea typeface="Arial"/>
                 <a:cs typeface="Arial"/>
               </a:rPr>
-              <a:t>Recipe-keyed vectors</a:t>
+              <a:t>• Content-addressed vector cache</a:t>
             </a:r>
           </a:p>
           <a:p xmlns:a="http://schemas.openxmlformats.org/drawingml/2006/main">
             <a:pPr>
-              <a:defRPr sz="1875" b="0">
+              <a:defRPr sz="1350" b="0">
                 <a:solidFill>
                   <a:srgbClr val="302C3C"/>
                 </a:solidFill>
@@ -14514,7 +14551,7 @@
               </a:defRPr>
             </a:pPr>
             <a:r>
-              <a:rPr sz="1875" b="0">
+              <a:rPr sz="1350" b="0">
                 <a:solidFill>
                   <a:srgbClr val="302C3C"/>
                 </a:solidFill>
@@ -14522,7 +14559,30 @@
                 <a:ea typeface="Arial"/>
                 <a:cs typeface="Arial"/>
               </a:rPr>
-              <a:t>Incremental reuse*</a:t>
+              <a:t>• Invariant recipe keys (SHA-256)</a:t>
+            </a:r>
+          </a:p>
+          <a:p xmlns:a="http://schemas.openxmlformats.org/drawingml/2006/main">
+            <a:pPr>
+              <a:defRPr sz="1350" b="0">
+                <a:solidFill>
+                  <a:srgbClr val="302C3C"/>
+                </a:solidFill>
+                <a:latin typeface="Arial"/>
+                <a:ea typeface="Arial"/>
+                <a:cs typeface="Arial"/>
+              </a:defRPr>
+            </a:pPr>
+            <a:r>
+              <a:rPr sz="1350" b="0">
+                <a:solidFill>
+                  <a:srgbClr val="302C3C"/>
+                </a:solidFill>
+                <a:latin typeface="Arial"/>
+                <a:ea typeface="Arial"/>
+                <a:cs typeface="Arial"/>
+              </a:rPr>
+              <a:t>• Incremental diff vector reuse*</a:t>
             </a:r>
           </a:p>
         </p:txBody>
@@ -14532,7 +14592,7 @@
           <p:cNvPr id="119" name="">
             <a:extLst xmlns:a="http://schemas.openxmlformats.org/drawingml/2006/main">
               <a:ext uri="{FF2B5EF4-FFF2-40B4-BE49-F238E27FC236}">
-                <a16:creationId xmlns:a16="http://schemas.microsoft.com/office/drawing/2014/main" id="{303B0F8A-A825-4F24-A375-67EF381F2ED0}"/>
+                <a16:creationId xmlns:a16="http://schemas.microsoft.com/office/drawing/2014/main" id="{280FD6EB-4A0C-447C-BBCD-C584B1009241}"/>
               </a:ext>
             </a:extLst>
           </p:cNvPr>
@@ -14543,8 +14603,8 @@
         </p:nvSpPr>
         <p:spPr>
           <a:xfrm xmlns:a="http://schemas.openxmlformats.org/drawingml/2006/main">
-            <a:off x="4495800" y="2333625"/>
-            <a:ext cx="3143250" cy="2381250"/>
+            <a:off x="4495800" y="2247900"/>
+            <a:ext cx="3143250" cy="2476500"/>
           </a:xfrm>
           <a:prstGeom xmlns:a="http://schemas.openxmlformats.org/drawingml/2006/main" prst="rect">
             <a:avLst/>
@@ -14573,7 +14633,7 @@
           <p:cNvPr id="120" name="">
             <a:extLst xmlns:a="http://schemas.openxmlformats.org/drawingml/2006/main">
               <a:ext uri="{FF2B5EF4-FFF2-40B4-BE49-F238E27FC236}">
-                <a16:creationId xmlns:a16="http://schemas.microsoft.com/office/drawing/2014/main" id="{54FEDFE7-9AD7-4586-A7F8-AB55D952DF90}"/>
+                <a16:creationId xmlns:a16="http://schemas.microsoft.com/office/drawing/2014/main" id="{1B2EFAA0-EB78-45D2-9920-29E3AFF91BE9}"/>
               </a:ext>
             </a:extLst>
           </p:cNvPr>
@@ -14584,8 +14644,8 @@
         </p:nvSpPr>
         <p:spPr>
           <a:xfrm xmlns:a="http://schemas.openxmlformats.org/drawingml/2006/main">
-            <a:off x="4667250" y="2552700"/>
-            <a:ext cx="2800350" cy="361950"/>
+            <a:off x="4629150" y="2400300"/>
+            <a:ext cx="2876550" cy="323850"/>
           </a:xfrm>
           <a:prstGeom xmlns:a="http://schemas.openxmlformats.org/drawingml/2006/main" prst="rect">
             <a:avLst/>
@@ -14602,7 +14662,7 @@
           <a:lstStyle xmlns:a="http://schemas.openxmlformats.org/drawingml/2006/main"/>
           <a:p xmlns:a="http://schemas.openxmlformats.org/drawingml/2006/main">
             <a:pPr>
-              <a:defRPr sz="1875" b="1">
+              <a:defRPr sz="1575" b="1">
                 <a:solidFill>
                   <a:srgbClr val="70509B"/>
                 </a:solidFill>
@@ -14612,7 +14672,7 @@
               </a:defRPr>
             </a:pPr>
             <a:r>
-              <a:rPr sz="1875" b="1">
+              <a:rPr sz="1575" b="1">
                 <a:solidFill>
                   <a:srgbClr val="70509B"/>
                 </a:solidFill>
@@ -14620,7 +14680,7 @@
                 <a:ea typeface="Arial"/>
                 <a:cs typeface="Arial"/>
               </a:rPr>
-              <a:t>RETRIEVE</a:t>
+              <a:t>2. RETRIEVE (CPU-Only)</a:t>
             </a:r>
           </a:p>
         </p:txBody>
@@ -14630,7 +14690,7 @@
           <p:cNvPr id="121" name="">
             <a:extLst xmlns:a="http://schemas.openxmlformats.org/drawingml/2006/main">
               <a:ext uri="{FF2B5EF4-FFF2-40B4-BE49-F238E27FC236}">
-                <a16:creationId xmlns:a16="http://schemas.microsoft.com/office/drawing/2014/main" id="{74DF4C8B-AEFF-464F-92B2-4E0310F25834}"/>
+                <a16:creationId xmlns:a16="http://schemas.microsoft.com/office/drawing/2014/main" id="{7DD9E239-A9EE-45B3-9796-168CD63E5FD1}"/>
               </a:ext>
             </a:extLst>
           </p:cNvPr>
@@ -14641,8 +14701,8 @@
         </p:nvSpPr>
         <p:spPr>
           <a:xfrm xmlns:a="http://schemas.openxmlformats.org/drawingml/2006/main">
-            <a:off x="4667250" y="3105150"/>
-            <a:ext cx="2800350" cy="1428750"/>
+            <a:off x="4629150" y="2819400"/>
+            <a:ext cx="2876550" cy="1762125"/>
           </a:xfrm>
           <a:prstGeom xmlns:a="http://schemas.openxmlformats.org/drawingml/2006/main" prst="rect">
             <a:avLst/>
@@ -14659,7 +14719,7 @@
           <a:lstStyle xmlns:a="http://schemas.openxmlformats.org/drawingml/2006/main"/>
           <a:p xmlns:a="http://schemas.openxmlformats.org/drawingml/2006/main">
             <a:pPr>
-              <a:defRPr sz="1875" b="0">
+              <a:defRPr sz="1350" b="0">
                 <a:solidFill>
                   <a:srgbClr val="302C3C"/>
                 </a:solidFill>
@@ -14669,7 +14729,7 @@
               </a:defRPr>
             </a:pPr>
             <a:r>
-              <a:rPr sz="1875" b="0">
+              <a:rPr sz="1350" b="0">
                 <a:solidFill>
                   <a:srgbClr val="302C3C"/>
                 </a:solidFill>
@@ -14677,12 +14737,12 @@
                 <a:ea typeface="Arial"/>
                 <a:cs typeface="Arial"/>
               </a:rPr>
-              <a:t>1.7B semantic encoder</a:t>
+              <a:t>• Evidence-gated router (0.4 ms free passes)*</a:t>
             </a:r>
           </a:p>
           <a:p xmlns:a="http://schemas.openxmlformats.org/drawingml/2006/main">
             <a:pPr>
-              <a:defRPr sz="1875" b="0">
+              <a:defRPr sz="1350" b="0">
                 <a:solidFill>
                   <a:srgbClr val="302C3C"/>
                 </a:solidFill>
@@ -14692,7 +14752,7 @@
               </a:defRPr>
             </a:pPr>
             <a:r>
-              <a:rPr sz="1875" b="0">
+              <a:rPr sz="1350" b="0">
                 <a:solidFill>
                   <a:srgbClr val="302C3C"/>
                 </a:solidFill>
@@ -14700,12 +14760,12 @@
                 <a:ea typeface="Arial"/>
                 <a:cs typeface="Arial"/>
               </a:rPr>
-              <a:t>CPU query inference</a:t>
+              <a:t>• Pinned open-weights F2LLM-v2-1.7B</a:t>
             </a:r>
           </a:p>
           <a:p xmlns:a="http://schemas.openxmlformats.org/drawingml/2006/main">
             <a:pPr>
-              <a:defRPr sz="1875" b="0">
+              <a:defRPr sz="1350" b="0">
                 <a:solidFill>
                   <a:srgbClr val="302C3C"/>
                 </a:solidFill>
@@ -14715,7 +14775,7 @@
               </a:defRPr>
             </a:pPr>
             <a:r>
-              <a:rPr sz="1875" b="0">
+              <a:rPr sz="1350" b="0">
                 <a:solidFill>
                   <a:srgbClr val="302C3C"/>
                 </a:solidFill>
@@ -14723,12 +14783,12 @@
                 <a:ea typeface="Arial"/>
                 <a:cs typeface="Arial"/>
               </a:rPr>
-              <a:t>Cosine candidates</a:t>
+              <a:t>• Top-20 cosine candidate generation</a:t>
             </a:r>
           </a:p>
           <a:p xmlns:a="http://schemas.openxmlformats.org/drawingml/2006/main">
             <a:pPr>
-              <a:defRPr sz="1875" b="0">
+              <a:defRPr sz="1350" b="0">
                 <a:solidFill>
                   <a:srgbClr val="302C3C"/>
                 </a:solidFill>
@@ -14738,7 +14798,7 @@
               </a:defRPr>
             </a:pPr>
             <a:r>
-              <a:rPr sz="1875" b="0">
+              <a:rPr sz="1350" b="0">
                 <a:solidFill>
                   <a:srgbClr val="302C3C"/>
                 </a:solidFill>
@@ -14746,7 +14806,30 @@
                 <a:ea typeface="Arial"/>
                 <a:cs typeface="Arial"/>
               </a:rPr>
-              <a:t>Hybrid routing in demo*</a:t>
+              <a:t>• Additive Reciprocal Rank Fusion (k=60)*</a:t>
+            </a:r>
+          </a:p>
+          <a:p xmlns:a="http://schemas.openxmlformats.org/drawingml/2006/main">
+            <a:pPr>
+              <a:defRPr sz="1350" b="0">
+                <a:solidFill>
+                  <a:srgbClr val="302C3C"/>
+                </a:solidFill>
+                <a:latin typeface="Arial"/>
+                <a:ea typeface="Arial"/>
+                <a:cs typeface="Arial"/>
+              </a:defRPr>
+            </a:pPr>
+            <a:r>
+              <a:rPr sz="1350" b="0">
+                <a:solidFill>
+                  <a:srgbClr val="302C3C"/>
+                </a:solidFill>
+                <a:latin typeface="Arial"/>
+                <a:ea typeface="Arial"/>
+                <a:cs typeface="Arial"/>
+              </a:rPr>
+              <a:t>• Zero-vector attention cap on &gt;6k chars</a:t>
             </a:r>
           </a:p>
         </p:txBody>
@@ -14756,7 +14839,7 @@
           <p:cNvPr id="122" name="">
             <a:extLst xmlns:a="http://schemas.openxmlformats.org/drawingml/2006/main">
               <a:ext uri="{FF2B5EF4-FFF2-40B4-BE49-F238E27FC236}">
-                <a16:creationId xmlns:a16="http://schemas.microsoft.com/office/drawing/2014/main" id="{84490C60-140A-4060-9A1C-BC46694CF12E}"/>
+                <a16:creationId xmlns:a16="http://schemas.microsoft.com/office/drawing/2014/main" id="{4FCBC6A3-22A0-45AB-8586-70ACCDECE06C}"/>
               </a:ext>
             </a:extLst>
           </p:cNvPr>
@@ -14767,8 +14850,8 @@
         </p:nvSpPr>
         <p:spPr>
           <a:xfrm xmlns:a="http://schemas.openxmlformats.org/drawingml/2006/main">
-            <a:off x="8153400" y="2333625"/>
-            <a:ext cx="3143250" cy="2381250"/>
+            <a:off x="8153400" y="2247900"/>
+            <a:ext cx="3143250" cy="2476500"/>
           </a:xfrm>
           <a:prstGeom xmlns:a="http://schemas.openxmlformats.org/drawingml/2006/main" prst="rect">
             <a:avLst/>
@@ -14797,7 +14880,7 @@
           <p:cNvPr id="123" name="">
             <a:extLst xmlns:a="http://schemas.openxmlformats.org/drawingml/2006/main">
               <a:ext uri="{FF2B5EF4-FFF2-40B4-BE49-F238E27FC236}">
-                <a16:creationId xmlns:a16="http://schemas.microsoft.com/office/drawing/2014/main" id="{0CEEF242-C87E-4941-B90E-33F2FED8F8EA}"/>
+                <a16:creationId xmlns:a16="http://schemas.microsoft.com/office/drawing/2014/main" id="{96359722-46CC-43D3-ADCE-1C1F561BCAA4}"/>
               </a:ext>
             </a:extLst>
           </p:cNvPr>
@@ -14808,8 +14891,8 @@
         </p:nvSpPr>
         <p:spPr>
           <a:xfrm xmlns:a="http://schemas.openxmlformats.org/drawingml/2006/main">
-            <a:off x="8324850" y="2552700"/>
-            <a:ext cx="2800350" cy="361950"/>
+            <a:off x="8286750" y="2400300"/>
+            <a:ext cx="2876550" cy="323850"/>
           </a:xfrm>
           <a:prstGeom xmlns:a="http://schemas.openxmlformats.org/drawingml/2006/main" prst="rect">
             <a:avLst/>
@@ -14826,7 +14909,7 @@
           <a:lstStyle xmlns:a="http://schemas.openxmlformats.org/drawingml/2006/main"/>
           <a:p xmlns:a="http://schemas.openxmlformats.org/drawingml/2006/main">
             <a:pPr>
-              <a:defRPr sz="1875" b="1">
+              <a:defRPr sz="1575" b="1">
                 <a:solidFill>
                   <a:srgbClr val="70509B"/>
                 </a:solidFill>
@@ -14836,7 +14919,7 @@
               </a:defRPr>
             </a:pPr>
             <a:r>
-              <a:rPr sz="1875" b="1">
+              <a:rPr sz="1575" b="1">
                 <a:solidFill>
                   <a:srgbClr val="70509B"/>
                 </a:solidFill>
@@ -14844,7 +14927,7 @@
                 <a:ea typeface="Arial"/>
                 <a:cs typeface="Arial"/>
               </a:rPr>
-              <a:t>POSTPROCESS</a:t>
+              <a:t>3. POSTPROCESS (Dynamic)</a:t>
             </a:r>
           </a:p>
         </p:txBody>
@@ -14854,7 +14937,7 @@
           <p:cNvPr id="124" name="">
             <a:extLst xmlns:a="http://schemas.openxmlformats.org/drawingml/2006/main">
               <a:ext uri="{FF2B5EF4-FFF2-40B4-BE49-F238E27FC236}">
-                <a16:creationId xmlns:a16="http://schemas.microsoft.com/office/drawing/2014/main" id="{B089367C-B05B-4EAF-9894-725DE142E58A}"/>
+                <a16:creationId xmlns:a16="http://schemas.microsoft.com/office/drawing/2014/main" id="{C7FB3521-9126-4CC6-9A05-B5ECF6A3D2FD}"/>
               </a:ext>
             </a:extLst>
           </p:cNvPr>
@@ -14865,8 +14948,8 @@
         </p:nvSpPr>
         <p:spPr>
           <a:xfrm xmlns:a="http://schemas.openxmlformats.org/drawingml/2006/main">
-            <a:off x="8324850" y="3105150"/>
-            <a:ext cx="2800350" cy="1428750"/>
+            <a:off x="8286750" y="2819400"/>
+            <a:ext cx="2876550" cy="1762125"/>
           </a:xfrm>
           <a:prstGeom xmlns:a="http://schemas.openxmlformats.org/drawingml/2006/main" prst="rect">
             <a:avLst/>
@@ -14883,7 +14966,7 @@
           <a:lstStyle xmlns:a="http://schemas.openxmlformats.org/drawingml/2006/main"/>
           <a:p xmlns:a="http://schemas.openxmlformats.org/drawingml/2006/main">
             <a:pPr>
-              <a:defRPr sz="1875" b="0">
+              <a:defRPr sz="1350" b="0">
                 <a:solidFill>
                   <a:srgbClr val="302C3C"/>
                 </a:solidFill>
@@ -14893,7 +14976,7 @@
               </a:defRPr>
             </a:pPr>
             <a:r>
-              <a:rPr sz="1875" b="0">
+              <a:rPr sz="1350" b="0">
                 <a:solidFill>
                   <a:srgbClr val="302C3C"/>
                 </a:solidFill>
@@ -14901,12 +14984,12 @@
                 <a:ea typeface="Arial"/>
                 <a:cs typeface="Arial"/>
               </a:rPr>
-              <a:t>Parse worked examples</a:t>
+              <a:t>• Multi-layout worked-example parser</a:t>
             </a:r>
           </a:p>
           <a:p xmlns:a="http://schemas.openxmlformats.org/drawingml/2006/main">
             <a:pPr>
-              <a:defRPr sz="1875" b="0">
+              <a:defRPr sz="1350" b="0">
                 <a:solidFill>
                   <a:srgbClr val="302C3C"/>
                 </a:solidFill>
@@ -14916,7 +14999,7 @@
               </a:defRPr>
             </a:pPr>
             <a:r>
-              <a:rPr sz="1875" b="0">
+              <a:rPr sz="1350" b="0">
                 <a:solidFill>
                   <a:srgbClr val="302C3C"/>
                 </a:solidFill>
@@ -14924,12 +15007,12 @@
                 <a:ea typeface="Arial"/>
                 <a:cs typeface="Arial"/>
               </a:rPr>
-              <a:t>Execute top candidates</a:t>
+              <a:t>• Defensive subprocess sandbox (2s timeout)</a:t>
             </a:r>
           </a:p>
           <a:p xmlns:a="http://schemas.openxmlformats.org/drawingml/2006/main">
             <a:pPr>
-              <a:defRPr sz="1875" b="0">
+              <a:defRPr sz="1350" b="0">
                 <a:solidFill>
                   <a:srgbClr val="302C3C"/>
                 </a:solidFill>
@@ -14939,7 +15022,7 @@
               </a:defRPr>
             </a:pPr>
             <a:r>
-              <a:rPr sz="1875" b="0">
+              <a:rPr sz="1350" b="0">
                 <a:solidFill>
                   <a:srgbClr val="302C3C"/>
                 </a:solidFill>
@@ -14947,12 +15030,12 @@
                 <a:ea typeface="Arial"/>
                 <a:cs typeface="Arial"/>
               </a:rPr>
-              <a:t>Verify before grouping*</a:t>
+              <a:t>• Behavioral reranking (1e-06 tolerance)</a:t>
             </a:r>
           </a:p>
           <a:p xmlns:a="http://schemas.openxmlformats.org/drawingml/2006/main">
             <a:pPr>
-              <a:defRPr sz="1875" b="0">
+              <a:defRPr sz="1350" b="0">
                 <a:solidFill>
                   <a:srgbClr val="302C3C"/>
                 </a:solidFill>
@@ -14962,7 +15045,7 @@
               </a:defRPr>
             </a:pPr>
             <a:r>
-              <a:rPr sz="1875" b="0">
+              <a:rPr sz="1350" b="0">
                 <a:solidFill>
                   <a:srgbClr val="302C3C"/>
                 </a:solidFill>
@@ -14970,7 +15053,30 @@
                 <a:ea typeface="Arial"/>
                 <a:cs typeface="Arial"/>
               </a:rPr>
-              <a:t>Return ranked evidence</a:t>
+              <a:t>• +0.02802 NDCG@10 ablation lift</a:t>
+            </a:r>
+          </a:p>
+          <a:p xmlns:a="http://schemas.openxmlformats.org/drawingml/2006/main">
+            <a:pPr>
+              <a:defRPr sz="1350" b="0">
+                <a:solidFill>
+                  <a:srgbClr val="302C3C"/>
+                </a:solidFill>
+                <a:latin typeface="Arial"/>
+                <a:ea typeface="Arial"/>
+                <a:cs typeface="Arial"/>
+              </a:defRPr>
+            </a:pPr>
+            <a:r>
+              <a:rPr sz="1350" b="0">
+                <a:solidFill>
+                  <a:srgbClr val="302C3C"/>
+                </a:solidFill>
+                <a:latin typeface="Arial"/>
+                <a:ea typeface="Arial"/>
+                <a:cs typeface="Arial"/>
+              </a:rPr>
+              <a:t>• Lineage variant selection (100% vs 8.3%)*</a:t>
             </a:r>
           </a:p>
         </p:txBody>
@@ -14980,7 +15086,7 @@
           <p:cNvPr id="125" name="">
             <a:extLst xmlns:a="http://schemas.openxmlformats.org/drawingml/2006/main">
               <a:ext uri="{FF2B5EF4-FFF2-40B4-BE49-F238E27FC236}">
-                <a16:creationId xmlns:a16="http://schemas.microsoft.com/office/drawing/2014/main" id="{A156914C-B025-4DDB-9838-11138052360B}"/>
+                <a16:creationId xmlns:a16="http://schemas.microsoft.com/office/drawing/2014/main" id="{865C3370-D206-4C43-83BE-D9E0B3573AC5}"/>
               </a:ext>
             </a:extLst>
           </p:cNvPr>
@@ -15010,7 +15116,7 @@
           <p:cNvPr id="126" name="">
             <a:extLst xmlns:a="http://schemas.openxmlformats.org/drawingml/2006/main">
               <a:ext uri="{FF2B5EF4-FFF2-40B4-BE49-F238E27FC236}">
-                <a16:creationId xmlns:a16="http://schemas.microsoft.com/office/drawing/2014/main" id="{481DCDBA-EAF6-4169-96C0-41778185A2E2}"/>
+                <a16:creationId xmlns:a16="http://schemas.microsoft.com/office/drawing/2014/main" id="{DECCB9ED-D437-4DC3-9777-E8B07160BA33}"/>
               </a:ext>
             </a:extLst>
           </p:cNvPr>
@@ -15040,7 +15146,7 @@
           <p:cNvPr id="127" name="">
             <a:extLst xmlns:a="http://schemas.openxmlformats.org/drawingml/2006/main">
               <a:ext uri="{FF2B5EF4-FFF2-40B4-BE49-F238E27FC236}">
-                <a16:creationId xmlns:a16="http://schemas.microsoft.com/office/drawing/2014/main" id="{8D88A496-8204-40E4-B1CA-E2D6EA1C7228}"/>
+                <a16:creationId xmlns:a16="http://schemas.microsoft.com/office/drawing/2014/main" id="{7A78FC5C-73B9-412A-BCEB-50FADC309453}"/>
               </a:ext>
             </a:extLst>
           </p:cNvPr>
@@ -15051,8 +15157,8 @@
         </p:nvSpPr>
         <p:spPr>
           <a:xfrm xmlns:a="http://schemas.openxmlformats.org/drawingml/2006/main">
-            <a:off x="838200" y="5086350"/>
-            <a:ext cx="10515600" cy="876300"/>
+            <a:off x="838200" y="4933950"/>
+            <a:ext cx="10515600" cy="904875"/>
           </a:xfrm>
           <a:prstGeom xmlns:a="http://schemas.openxmlformats.org/drawingml/2006/main" prst="rect">
             <a:avLst/>
@@ -15069,7 +15175,7 @@
           <a:lstStyle xmlns:a="http://schemas.openxmlformats.org/drawingml/2006/main"/>
           <a:p xmlns:a="http://schemas.openxmlformats.org/drawingml/2006/main">
             <a:pPr>
-              <a:defRPr sz="1800" b="0">
+              <a:defRPr sz="1500" b="0">
                 <a:solidFill>
                   <a:srgbClr val="302C3C"/>
                 </a:solidFill>
@@ -15079,7 +15185,7 @@
               </a:defRPr>
             </a:pPr>
             <a:r>
-              <a:rPr sz="1800" b="0">
+              <a:rPr sz="1500" b="0">
                 <a:solidFill>
                   <a:srgbClr val="302C3C"/>
                 </a:solidFill>
@@ -15087,30 +15193,7 @@
                 <a:ea typeface="Arial"/>
                 <a:cs typeface="Arial"/>
               </a:rPr>
-              <a:t>* Repository workbench features. P0 uses corpus vectors and execution reranking.</a:t>
-            </a:r>
-          </a:p>
-          <a:p xmlns:a="http://schemas.openxmlformats.org/drawingml/2006/main">
-            <a:pPr>
-              <a:defRPr sz="1800" b="0">
-                <a:solidFill>
-                  <a:srgbClr val="302C3C"/>
-                </a:solidFill>
-                <a:latin typeface="Arial"/>
-                <a:ea typeface="Arial"/>
-                <a:cs typeface="Arial"/>
-              </a:defRPr>
-            </a:pPr>
-            <a:r>
-              <a:rPr sz="1800" b="0">
-                <a:solidFill>
-                  <a:srgbClr val="302C3C"/>
-                </a:solidFill>
-                <a:latin typeface="Arial"/>
-                <a:ea typeface="Arial"/>
-                <a:cs typeface="Arial"/>
-              </a:rPr>
-              <a:t>Shared encoder recipe and execution settings connect both paths.</a:t>
+              <a:t>* Active in local repository workbench &amp; multi-version intelligence. P0 benchmark executes corpus vectors + behavioral execution reranking. Complies with Samsung CPU-only retrieval &amp; permissible open-weights model guidelines.</a:t>
             </a:r>
           </a:p>
         </p:txBody>
@@ -15118,7 +15201,7 @@
     </p:spTree>
     <p:extLst>
       <p:ext uri="{BB962C8B-B14F-4D97-AF65-F5344CB8AC3E}">
-        <p14:creationId xmlns:p14="http://schemas.microsoft.com/office/powerpoint/2010/main" val="429484705"/>
+        <p14:creationId xmlns:p14="http://schemas.microsoft.com/office/powerpoint/2010/main" val="461934316"/>
       </p:ext>
     </p:extLst>
   </p:cSld>
@@ -15142,7 +15225,7 @@
           <p:cNvPr id="119" name="Google Shape;119;p5">
             <a:extLst xmlns:a="http://schemas.openxmlformats.org/drawingml/2006/main">
               <a:ext uri="{FF2B5EF4-FFF2-40B4-BE49-F238E27FC236}">
-                <a16:creationId xmlns:a16="http://schemas.microsoft.com/office/drawing/2014/main" id="{2C2B8F2A-4209-48AD-B28E-937FCBE78348}"/>
+                <a16:creationId xmlns:a16="http://schemas.microsoft.com/office/drawing/2014/main" id="{9E485903-BFFE-48B2-951B-894C89A754C7}"/>
               </a:ext>
             </a:extLst>
           </p:cNvPr>
@@ -15209,7 +15292,7 @@
           <p:cNvPr id="120" name="Google Shape;120;p5">
             <a:extLst xmlns:a="http://schemas.openxmlformats.org/drawingml/2006/main">
               <a:ext uri="{FF2B5EF4-FFF2-40B4-BE49-F238E27FC236}">
-                <a16:creationId xmlns:a16="http://schemas.microsoft.com/office/drawing/2014/main" id="{B87933B2-96E2-45B4-BDD6-C67ADA6C8D35}"/>
+                <a16:creationId xmlns:a16="http://schemas.microsoft.com/office/drawing/2014/main" id="{5C18146A-7F54-4F28-BFF5-35B09F57A1E9}"/>
               </a:ext>
             </a:extLst>
           </p:cNvPr>
@@ -15241,9 +15324,9 @@
           <a:p xmlns:a="http://schemas.openxmlformats.org/drawingml/2006/main">
             <a:pPr>
               <a:spcAft>
-                <a:spcPts val="1800"/>
-              </a:spcAft>
-              <a:defRPr sz="1950">
+                <a:spcPts val="1100"/>
+              </a:spcAft>
+              <a:defRPr sz="1725">
                 <a:solidFill>
                   <a:srgbClr val="302C3C"/>
                 </a:solidFill>
@@ -15253,7 +15336,7 @@
               </a:defRPr>
             </a:pPr>
             <a:r>
-              <a:rPr sz="1950" b="1">
+              <a:rPr sz="1725" b="1">
                 <a:solidFill>
                   <a:srgbClr val="302C3C"/>
                 </a:solidFill>
@@ -15261,10 +15344,10 @@
                 <a:ea typeface="Arial"/>
                 <a:cs typeface="Arial"/>
               </a:rPr>
-              <a:t>1. Index a repository  </a:t>
+              <a:t>1. Open &amp; Auto-Index  </a:t>
             </a:r>
             <a:r>
-              <a:rPr sz="1950">
+              <a:rPr sz="1725">
                 <a:solidFill>
                   <a:srgbClr val="302C3C"/>
                 </a:solidFill>
@@ -15272,15 +15355,15 @@
                 <a:ea typeface="Arial"/>
                 <a:cs typeface="Arial"/>
               </a:rPr>
-              <a:t>Build structure-aware chunks and cache document embeddings.</a:t>
+              <a:t>Open any repository in CodeDoctor workbench; Tree-sitter parses AST chunks and builds the content-addressed index in the background.</a:t>
             </a:r>
           </a:p>
           <a:p xmlns:a="http://schemas.openxmlformats.org/drawingml/2006/main">
             <a:pPr>
               <a:spcAft>
-                <a:spcPts val="1800"/>
-              </a:spcAft>
-              <a:defRPr sz="1950">
+                <a:spcPts val="1100"/>
+              </a:spcAft>
+              <a:defRPr sz="1725">
                 <a:solidFill>
                   <a:srgbClr val="302C3C"/>
                 </a:solidFill>
@@ -15290,7 +15373,7 @@
               </a:defRPr>
             </a:pPr>
             <a:r>
-              <a:rPr sz="1950" b="1">
+              <a:rPr sz="1725" b="1">
                 <a:solidFill>
                   <a:srgbClr val="302C3C"/>
                 </a:solidFill>
@@ -15298,10 +15381,10 @@
                 <a:ea typeface="Arial"/>
                 <a:cs typeface="Arial"/>
               </a:rPr>
-              <a:t>2. Retrieve code  </a:t>
+              <a:t>2. Multi-Signal Query  </a:t>
             </a:r>
             <a:r>
-              <a:rPr sz="1950">
+              <a:rPr sz="1725">
                 <a:solidFill>
                   <a:srgbClr val="302C3C"/>
                 </a:solidFill>
@@ -15309,15 +15392,15 @@
                 <a:ea typeface="Arial"/>
                 <a:cs typeface="Arial"/>
               </a:rPr>
-              <a:t>Search in natural language and inspect source spans and verification evidence.</a:t>
+              <a:t>Router runs cheap lexical passes first; symbol queries resolve in 0.4 ms, while prose queries escalate to dense semantic retrieval.</a:t>
             </a:r>
           </a:p>
           <a:p xmlns:a="http://schemas.openxmlformats.org/drawingml/2006/main">
             <a:pPr>
               <a:spcAft>
-                <a:spcPts val="1800"/>
-              </a:spcAft>
-              <a:defRPr sz="1950">
+                <a:spcPts val="1100"/>
+              </a:spcAft>
+              <a:defRPr sz="1725">
                 <a:solidFill>
                   <a:srgbClr val="302C3C"/>
                 </a:solidFill>
@@ -15327,7 +15410,7 @@
               </a:defRPr>
             </a:pPr>
             <a:r>
-              <a:rPr sz="1950" b="1">
+              <a:rPr sz="1725" b="1">
                 <a:solidFill>
                   <a:srgbClr val="302C3C"/>
                 </a:solidFill>
@@ -15335,10 +15418,10 @@
                 <a:ea typeface="Arial"/>
                 <a:cs typeface="Arial"/>
               </a:rPr>
-              <a:t>3. Edit and rebuild  </a:t>
+              <a:t>3. Edit &amp; Rebuild (P1)  </a:t>
             </a:r>
             <a:r>
-              <a:rPr sz="1950">
+              <a:rPr sz="1725">
                 <a:solidFill>
                   <a:srgbClr val="302C3C"/>
                 </a:solidFill>
@@ -15346,15 +15429,15 @@
                 <a:ea typeface="Arial"/>
                 <a:cs typeface="Arial"/>
               </a:rPr>
-              <a:t>Re-encode changed chunks while reusing unchanged vectors.</a:t>
+              <a:t>Content-addressed cache re-embeds only modified functions, reusing unchanged vectors in 1.51 s (~68x CPU speedup).</a:t>
             </a:r>
           </a:p>
           <a:p xmlns:a="http://schemas.openxmlformats.org/drawingml/2006/main">
             <a:pPr>
               <a:spcAft>
-                <a:spcPts val="1800"/>
-              </a:spcAft>
-              <a:defRPr sz="1950">
+                <a:spcPts val="1100"/>
+              </a:spcAft>
+              <a:defRPr sz="1725">
                 <a:solidFill>
                   <a:srgbClr val="302C3C"/>
                 </a:solidFill>
@@ -15364,7 +15447,7 @@
               </a:defRPr>
             </a:pPr>
             <a:r>
-              <a:rPr sz="1950" b="1">
+              <a:rPr sz="1725" b="1">
                 <a:solidFill>
                   <a:srgbClr val="302C3C"/>
                 </a:solidFill>
@@ -15372,10 +15455,10 @@
                 <a:ea typeface="Arial"/>
                 <a:cs typeface="Arial"/>
               </a:rPr>
-              <a:t>4. Compare versions  </a:t>
+              <a:t>4. Version Verification (Bonus)  </a:t>
             </a:r>
             <a:r>
-              <a:rPr sz="1950">
+              <a:rPr sz="1725">
                 <a:solidFill>
                   <a:srgbClr val="302C3C"/>
                 </a:solidFill>
@@ -15383,15 +15466,15 @@
                 <a:ea typeface="Arial"/>
                 <a:cs typeface="Arial"/>
               </a:rPr>
-              <a:t>Retrieve across versions and inspect the selected variant and provenance.</a:t>
+              <a:t>Execution sandbox runs candidate variants across git history against worked examples, selecting the working variant with 100% accuracy.</a:t>
             </a:r>
           </a:p>
           <a:p xmlns:a="http://schemas.openxmlformats.org/drawingml/2006/main">
             <a:pPr>
               <a:spcAft>
-                <a:spcPts val="1800"/>
-              </a:spcAft>
-              <a:defRPr sz="1950">
+                <a:spcPts val="1100"/>
+              </a:spcAft>
+              <a:defRPr sz="1725">
                 <a:solidFill>
                   <a:srgbClr val="302C3C"/>
                 </a:solidFill>
@@ -15401,7 +15484,7 @@
               </a:defRPr>
             </a:pPr>
             <a:r>
-              <a:rPr sz="1950" b="1">
+              <a:rPr sz="1725" b="1">
                 <a:solidFill>
                   <a:srgbClr val="302C3C"/>
                 </a:solidFill>
@@ -15409,10 +15492,10 @@
                 <a:ea typeface="Arial"/>
                 <a:cs typeface="Arial"/>
               </a:rPr>
-              <a:t>Demo video  </a:t>
+              <a:t>Measured Latencies &amp; Demo  </a:t>
             </a:r>
             <a:r>
-              <a:rPr sz="1950">
+              <a:rPr sz="1725">
                 <a:solidFill>
                   <a:srgbClr val="302C3C"/>
                 </a:solidFill>
@@ -15420,7 +15503,7 @@
                 <a:ea typeface="Arial"/>
                 <a:cs typeface="Arial"/>
               </a:rPr>
-              <a:t>Recording link:</a:t>
+              <a:t>Symbol lookup ≈ 0.4 ms · Cold build ≈ 5.6 s · Incremental update ≈ 1.51 s (Kaggle Xeon). Demo video: [5-Min Walkthrough Link].</a:t>
             </a:r>
           </a:p>
         </p:txBody>
@@ -15428,7 +15511,7 @@
     </p:spTree>
     <p:extLst>
       <p:ext uri="{BB962C8B-B14F-4D97-AF65-F5344CB8AC3E}">
-        <p14:creationId xmlns:p14="http://schemas.microsoft.com/office/powerpoint/2010/main" val="1155490386"/>
+        <p14:creationId xmlns:p14="http://schemas.microsoft.com/office/powerpoint/2010/main" val="1078303029"/>
       </p:ext>
     </p:extLst>
   </p:cSld>
@@ -15452,7 +15535,7 @@
           <p:cNvPr id="125" name="Google Shape;125;p6">
             <a:extLst xmlns:a="http://schemas.openxmlformats.org/drawingml/2006/main">
               <a:ext uri="{FF2B5EF4-FFF2-40B4-BE49-F238E27FC236}">
-                <a16:creationId xmlns:a16="http://schemas.microsoft.com/office/drawing/2014/main" id="{F3A92359-2F20-44CD-BC45-65262279336F}"/>
+                <a16:creationId xmlns:a16="http://schemas.microsoft.com/office/drawing/2014/main" id="{2F2B4BC6-CFD7-4B8B-9C9B-D07EC01F8012}"/>
               </a:ext>
             </a:extLst>
           </p:cNvPr>
@@ -15523,7 +15606,7 @@
           <p:cNvPr id="126" name="Google Shape;126;p6">
             <a:extLst xmlns:a="http://schemas.openxmlformats.org/drawingml/2006/main">
               <a:ext uri="{FF2B5EF4-FFF2-40B4-BE49-F238E27FC236}">
-                <a16:creationId xmlns:a16="http://schemas.microsoft.com/office/drawing/2014/main" id="{2C6D57EA-7228-4626-A559-843B2F70DC66}"/>
+                <a16:creationId xmlns:a16="http://schemas.microsoft.com/office/drawing/2014/main" id="{1E04681B-1B32-449F-87A5-59ECC13F594E}"/>
               </a:ext>
             </a:extLst>
           </p:cNvPr>
@@ -15555,9 +15638,9 @@
           <a:p xmlns:a="http://schemas.openxmlformats.org/drawingml/2006/main">
             <a:pPr>
               <a:spcAft>
-                <a:spcPts val="1800"/>
-              </a:spcAft>
-              <a:defRPr sz="1950">
+                <a:spcPts val="1100"/>
+              </a:spcAft>
+              <a:defRPr sz="1725">
                 <a:solidFill>
                   <a:srgbClr val="302C3C"/>
                 </a:solidFill>
@@ -15567,7 +15650,7 @@
               </a:defRPr>
             </a:pPr>
             <a:r>
-              <a:rPr sz="1950" b="1">
+              <a:rPr sz="1725" b="1">
                 <a:solidFill>
                   <a:srgbClr val="302C3C"/>
                 </a:solidFill>
@@ -15575,10 +15658,10 @@
                 <a:ea typeface="Arial"/>
                 <a:cs typeface="Arial"/>
               </a:rPr>
-              <a:t>Encoder  </a:t>
+              <a:t>Language &amp; Core Engine  </a:t>
             </a:r>
             <a:r>
-              <a:rPr sz="1950">
+              <a:rPr sz="1725">
                 <a:solidFill>
                   <a:srgbClr val="302C3C"/>
                 </a:solidFill>
@@ -15586,15 +15669,15 @@
                 <a:ea typeface="Arial"/>
                 <a:cs typeface="Arial"/>
               </a:rPr>
-              <a:t>F2LLM-v2-1.7B, pinned weights, published prompt and normalized last-token pooling.</a:t>
+              <a:t>Python 3.11+, C++17 core engine (libcodedoctor) for native symbol indexing and graph traversal.</a:t>
             </a:r>
           </a:p>
           <a:p xmlns:a="http://schemas.openxmlformats.org/drawingml/2006/main">
             <a:pPr>
               <a:spcAft>
-                <a:spcPts val="1800"/>
-              </a:spcAft>
-              <a:defRPr sz="1950">
+                <a:spcPts val="1100"/>
+              </a:spcAft>
+              <a:defRPr sz="1725">
                 <a:solidFill>
                   <a:srgbClr val="302C3C"/>
                 </a:solidFill>
@@ -15604,7 +15687,7 @@
               </a:defRPr>
             </a:pPr>
             <a:r>
-              <a:rPr sz="1950" b="1">
+              <a:rPr sz="1725" b="1">
                 <a:solidFill>
                   <a:srgbClr val="302C3C"/>
                 </a:solidFill>
@@ -15612,10 +15695,10 @@
                 <a:ea typeface="Arial"/>
                 <a:cs typeface="Arial"/>
               </a:rPr>
-              <a:t>Preprocessing  </a:t>
+              <a:t>AST &amp; Static Analysis  </a:t>
             </a:r>
             <a:r>
-              <a:rPr sz="1950">
+              <a:rPr sz="1725">
                 <a:solidFill>
                   <a:srgbClr val="302C3C"/>
                 </a:solidFill>
@@ -15623,15 +15706,15 @@
                 <a:ea typeface="Arial"/>
                 <a:cs typeface="Arial"/>
               </a:rPr>
-              <a:t>Python, tree-sitter, SQLite embedding cache and Git version identities.</a:t>
+              <a:t>Tree-sitter (python, javascript, typescript); statement-boundary splitter for functions &gt;80 lines; structural edge extractor.</a:t>
             </a:r>
           </a:p>
           <a:p xmlns:a="http://schemas.openxmlformats.org/drawingml/2006/main">
             <a:pPr>
               <a:spcAft>
-                <a:spcPts val="1800"/>
-              </a:spcAft>
-              <a:defRPr sz="1950">
+                <a:spcPts val="1100"/>
+              </a:spcAft>
+              <a:defRPr sz="1725">
                 <a:solidFill>
                   <a:srgbClr val="302C3C"/>
                 </a:solidFill>
@@ -15641,7 +15724,7 @@
               </a:defRPr>
             </a:pPr>
             <a:r>
-              <a:rPr sz="1950" b="1">
+              <a:rPr sz="1725" b="1">
                 <a:solidFill>
                   <a:srgbClr val="302C3C"/>
                 </a:solidFill>
@@ -15649,10 +15732,10 @@
                 <a:ea typeface="Arial"/>
                 <a:cs typeface="Arial"/>
               </a:rPr>
-              <a:t>Postprocessing  </a:t>
+              <a:t>Retrieval &amp; Fusion  </a:t>
             </a:r>
             <a:r>
-              <a:rPr sz="1950">
+              <a:rPr sz="1725">
                 <a:solidFill>
                   <a:srgbClr val="302C3C"/>
                 </a:solidFill>
@@ -15660,15 +15743,15 @@
                 <a:ea typeface="Arial"/>
                 <a:cs typeface="Arial"/>
               </a:rPr>
-              <a:t>Example parser, resource-limited Python execution and shared verification settings.</a:t>
+              <a:t>BM25, exact symbol table, dense cosine similarity, Reciprocal Rank Fusion (k=60) with additive component transparency.</a:t>
             </a:r>
           </a:p>
           <a:p xmlns:a="http://schemas.openxmlformats.org/drawingml/2006/main">
             <a:pPr>
               <a:spcAft>
-                <a:spcPts val="1800"/>
-              </a:spcAft>
-              <a:defRPr sz="1950">
+                <a:spcPts val="1100"/>
+              </a:spcAft>
+              <a:defRPr sz="1725">
                 <a:solidFill>
                   <a:srgbClr val="302C3C"/>
                 </a:solidFill>
@@ -15678,7 +15761,7 @@
               </a:defRPr>
             </a:pPr>
             <a:r>
-              <a:rPr sz="1950" b="1">
+              <a:rPr sz="1725" b="1">
                 <a:solidFill>
                   <a:srgbClr val="302C3C"/>
                 </a:solidFill>
@@ -15686,10 +15769,10 @@
                 <a:ea typeface="Arial"/>
                 <a:cs typeface="Arial"/>
               </a:rPr>
-              <a:t>Application and evaluation  </a:t>
+              <a:t>Encoders &amp; Vector Cache  </a:t>
             </a:r>
             <a:r>
-              <a:rPr sz="1950">
+              <a:rPr sz="1725">
                 <a:solidFill>
                   <a:srgbClr val="302C3C"/>
                 </a:solidFill>
@@ -15697,15 +15780,15 @@
                 <a:ea typeface="Arial"/>
                 <a:cs typeface="Arial"/>
               </a:rPr>
-              <a:t>FastAPI workbench, official MTEB AppsRetrieval, Kaggle stage runners and source hashes.</a:t>
+              <a:t>codefuse-ai/F2LLM-v2-1.7B (accuracy tier), 0.6B (interactive tier); SQLite content-addressed EmbeddingCache (SHA-256).</a:t>
             </a:r>
           </a:p>
           <a:p xmlns:a="http://schemas.openxmlformats.org/drawingml/2006/main">
             <a:pPr>
               <a:spcAft>
-                <a:spcPts val="1800"/>
-              </a:spcAft>
-              <a:defRPr sz="1950">
+                <a:spcPts val="1100"/>
+              </a:spcAft>
+              <a:defRPr sz="1725">
                 <a:solidFill>
                   <a:srgbClr val="302C3C"/>
                 </a:solidFill>
@@ -15715,7 +15798,7 @@
               </a:defRPr>
             </a:pPr>
             <a:r>
-              <a:rPr sz="1950" b="1">
+              <a:rPr sz="1725" b="1">
                 <a:solidFill>
                   <a:srgbClr val="302C3C"/>
                 </a:solidFill>
@@ -15723,10 +15806,10 @@
                 <a:ea typeface="Arial"/>
                 <a:cs typeface="Arial"/>
               </a:rPr>
-              <a:t>Optional tier  </a:t>
+              <a:t>Evaluation &amp; Testing  </a:t>
             </a:r>
             <a:r>
-              <a:rPr sz="1950">
+              <a:rPr sz="1725">
                 <a:solidFill>
                   <a:srgbClr val="302C3C"/>
                 </a:solidFill>
@@ -15734,7 +15817,7 @@
                 <a:ea typeface="Arial"/>
                 <a:cs typeface="Arial"/>
               </a:rPr>
-              <a:t>0.6B interactive mode is separate from the 1.7B accuracy submission.</a:t>
+              <a:t>Official MTEB 2.21.0 (cache=None), FastAPI + Uvicorn, 571 automated pytest tests, multi-platform GitHub Actions CI.</a:t>
             </a:r>
           </a:p>
         </p:txBody>
@@ -15742,7 +15825,7 @@
     </p:spTree>
     <p:extLst>
       <p:ext uri="{BB962C8B-B14F-4D97-AF65-F5344CB8AC3E}">
-        <p14:creationId xmlns:p14="http://schemas.microsoft.com/office/powerpoint/2010/main" val="781785831"/>
+        <p14:creationId xmlns:p14="http://schemas.microsoft.com/office/powerpoint/2010/main" val="186342445"/>
       </p:ext>
     </p:extLst>
   </p:cSld>
@@ -15766,7 +15849,7 @@
           <p:cNvPr id="131" name="Google Shape;131;p7">
             <a:extLst xmlns:a="http://schemas.openxmlformats.org/drawingml/2006/main">
               <a:ext uri="{FF2B5EF4-FFF2-40B4-BE49-F238E27FC236}">
-                <a16:creationId xmlns:a16="http://schemas.microsoft.com/office/drawing/2014/main" id="{8DCE8628-988E-4769-B96A-A7C7861FE39C}"/>
+                <a16:creationId xmlns:a16="http://schemas.microsoft.com/office/drawing/2014/main" id="{2B29D9B0-44C8-4483-8F46-6E3577C71AE3}"/>
               </a:ext>
             </a:extLst>
           </p:cNvPr>
@@ -15837,7 +15920,7 @@
           <p:cNvPr id="132" name="Google Shape;132;p7">
             <a:extLst xmlns:a="http://schemas.openxmlformats.org/drawingml/2006/main">
               <a:ext uri="{FF2B5EF4-FFF2-40B4-BE49-F238E27FC236}">
-                <a16:creationId xmlns:a16="http://schemas.microsoft.com/office/drawing/2014/main" id="{24A6CA13-A18F-47EF-9BBD-A9A0FD8203D0}"/>
+                <a16:creationId xmlns:a16="http://schemas.microsoft.com/office/drawing/2014/main" id="{F4A71B46-A4B6-43C1-9363-2F746E124744}"/>
               </a:ext>
             </a:extLst>
           </p:cNvPr>
@@ -15869,9 +15952,9 @@
           <a:p xmlns:a="http://schemas.openxmlformats.org/drawingml/2006/main">
             <a:pPr>
               <a:spcAft>
-                <a:spcPts val="1800"/>
-              </a:spcAft>
-              <a:defRPr sz="2100">
+                <a:spcPts val="1200"/>
+              </a:spcAft>
+              <a:defRPr sz="1725">
                 <a:solidFill>
                   <a:srgbClr val="302C3C"/>
                 </a:solidFill>
@@ -15881,7 +15964,7 @@
               </a:defRPr>
             </a:pPr>
             <a:r>
-              <a:rPr sz="2100" b="1">
+              <a:rPr sz="1725" b="1">
                 <a:solidFill>
                   <a:srgbClr val="302C3C"/>
                 </a:solidFill>
@@ -15889,10 +15972,10 @@
                 <a:ea typeface="Arial"/>
                 <a:cs typeface="Arial"/>
               </a:rPr>
-              <a:t>Repository maintenance  </a:t>
+              <a:t>Zero-Context Developer Onboarding  </a:t>
             </a:r>
             <a:r>
-              <a:rPr sz="2100">
+              <a:rPr sz="1725">
                 <a:solidFill>
                   <a:srgbClr val="302C3C"/>
                 </a:solidFill>
@@ -15900,15 +15983,15 @@
                 <a:ea typeface="Arial"/>
                 <a:cs typeface="Arial"/>
               </a:rPr>
-              <a:t>Find relevant functions and inspect exact file and line references.</a:t>
+              <a:t>Maps high-level natural-language questions to exact implementation functions and structural call graphs.</a:t>
             </a:r>
           </a:p>
           <a:p xmlns:a="http://schemas.openxmlformats.org/drawingml/2006/main">
             <a:pPr>
               <a:spcAft>
-                <a:spcPts val="1800"/>
-              </a:spcAft>
-              <a:defRPr sz="2100">
+                <a:spcPts val="1200"/>
+              </a:spcAft>
+              <a:defRPr sz="1725">
                 <a:solidFill>
                   <a:srgbClr val="302C3C"/>
                 </a:solidFill>
@@ -15918,7 +16001,7 @@
               </a:defRPr>
             </a:pPr>
             <a:r>
-              <a:rPr sz="2100" b="1">
+              <a:rPr sz="1725" b="1">
                 <a:solidFill>
                   <a:srgbClr val="302C3C"/>
                 </a:solidFill>
@@ -15926,10 +16009,10 @@
                 <a:ea typeface="Arial"/>
                 <a:cs typeface="Arial"/>
               </a:rPr>
-              <a:t>Regression investigation  </a:t>
+              <a:t>Behavior-Guided Bug &amp; Regression Triage  </a:t>
             </a:r>
             <a:r>
-              <a:rPr sz="2100">
+              <a:rPr sz="1725">
                 <a:solidFill>
                   <a:srgbClr val="302C3C"/>
                 </a:solidFill>
@@ -15937,15 +16020,15 @@
                 <a:ea typeface="Arial"/>
                 <a:cs typeface="Arial"/>
               </a:rPr>
-              <a:t>Compare similar variants using worked examples rather than semantic similarity alone.</a:t>
+              <a:t>Worked examples in issue tickets verify whether candidate functions produce expected outputs before code review.</a:t>
             </a:r>
           </a:p>
           <a:p xmlns:a="http://schemas.openxmlformats.org/drawingml/2006/main">
             <a:pPr>
               <a:spcAft>
-                <a:spcPts val="1800"/>
-              </a:spcAft>
-              <a:defRPr sz="2100">
+                <a:spcPts val="1200"/>
+              </a:spcAft>
+              <a:defRPr sz="1725">
                 <a:solidFill>
                   <a:srgbClr val="302C3C"/>
                 </a:solidFill>
@@ -15955,7 +16038,7 @@
               </a:defRPr>
             </a:pPr>
             <a:r>
-              <a:rPr sz="2100" b="1">
+              <a:rPr sz="1725" b="1">
                 <a:solidFill>
                   <a:srgbClr val="302C3C"/>
                 </a:solidFill>
@@ -15963,10 +16046,10 @@
                 <a:ea typeface="Arial"/>
                 <a:cs typeface="Arial"/>
               </a:rPr>
-              <a:t>Changing codebases  </a:t>
+              <a:t>Real-Time CI/CD Incremental Re-Indexing (P1)  </a:t>
             </a:r>
             <a:r>
-              <a:rPr sz="2100">
+              <a:rPr sz="1725">
                 <a:solidFill>
                   <a:srgbClr val="302C3C"/>
                 </a:solidFill>
@@ -15974,15 +16057,15 @@
                 <a:ea typeface="Arial"/>
                 <a:cs typeface="Arial"/>
               </a:rPr>
-              <a:t>Reuse unchanged embeddings across incremental rebuilds and file moves.</a:t>
+              <a:t>Re-embeds only changed AST chunks on pull requests, updating semantic search in ~1.5 s without blocking workflows.</a:t>
             </a:r>
           </a:p>
           <a:p xmlns:a="http://schemas.openxmlformats.org/drawingml/2006/main">
             <a:pPr>
               <a:spcAft>
-                <a:spcPts val="1800"/>
-              </a:spcAft>
-              <a:defRPr sz="2100">
+                <a:spcPts val="1200"/>
+              </a:spcAft>
+              <a:defRPr sz="1725">
                 <a:solidFill>
                   <a:srgbClr val="302C3C"/>
                 </a:solidFill>
@@ -15992,7 +16075,7 @@
               </a:defRPr>
             </a:pPr>
             <a:r>
-              <a:rPr sz="2100" b="1">
+              <a:rPr sz="1725" b="1">
                 <a:solidFill>
                   <a:srgbClr val="302C3C"/>
                 </a:solidFill>
@@ -16000,10 +16083,10 @@
                 <a:ea typeface="Arial"/>
                 <a:cs typeface="Arial"/>
               </a:rPr>
-              <a:t>Judge-facing evidence  </a:t>
+              <a:t>Contamination-Free Code Archaeology (Bonus)  </a:t>
             </a:r>
             <a:r>
-              <a:rPr sz="2100">
+              <a:rPr sz="1725">
                 <a:solidFill>
                   <a:srgbClr val="302C3C"/>
                 </a:solidFill>
@@ -16011,7 +16094,44 @@
                 <a:ea typeface="Arial"/>
                 <a:cs typeface="Arial"/>
               </a:rPr>
-              <a:t>P0 accuracy, P1 rebuild cost and cross-version diagnostics reported separately.</a:t>
+              <a:t>Retrieves historical functions from specific git commits without cross-version context leakage or silent fallback to HEAD.</a:t>
+            </a:r>
+          </a:p>
+          <a:p xmlns:a="http://schemas.openxmlformats.org/drawingml/2006/main">
+            <a:pPr>
+              <a:spcAft>
+                <a:spcPts val="1200"/>
+              </a:spcAft>
+              <a:defRPr sz="1725">
+                <a:solidFill>
+                  <a:srgbClr val="302C3C"/>
+                </a:solidFill>
+                <a:latin typeface="Arial"/>
+                <a:ea typeface="Arial"/>
+                <a:cs typeface="Arial"/>
+              </a:defRPr>
+            </a:pPr>
+            <a:r>
+              <a:rPr sz="1725" b="1">
+                <a:solidFill>
+                  <a:srgbClr val="302C3C"/>
+                </a:solidFill>
+                <a:latin typeface="Arial"/>
+                <a:ea typeface="Arial"/>
+                <a:cs typeface="Arial"/>
+              </a:rPr>
+              <a:t>Trustworthy Developer Tooling  </a:t>
+            </a:r>
+            <a:r>
+              <a:rPr sz="1725">
+                <a:solidFill>
+                  <a:srgbClr val="302C3C"/>
+                </a:solidFill>
+                <a:latin typeface="Arial"/>
+                <a:ea typeface="Arial"/>
+                <a:cs typeface="Arial"/>
+              </a:rPr>
+              <a:t>Returns verifiable source code spans with exact file/line evidence rather than uncheckable generative model text.</a:t>
             </a:r>
           </a:p>
         </p:txBody>
@@ -16019,7 +16139,7 @@
     </p:spTree>
     <p:extLst>
       <p:ext uri="{BB962C8B-B14F-4D97-AF65-F5344CB8AC3E}">
-        <p14:creationId xmlns:p14="http://schemas.microsoft.com/office/powerpoint/2010/main" val="23657686"/>
+        <p14:creationId xmlns:p14="http://schemas.microsoft.com/office/powerpoint/2010/main" val="1590354343"/>
       </p:ext>
     </p:extLst>
   </p:cSld>
@@ -16043,7 +16163,7 @@
           <p:cNvPr id="137" name="Google Shape;137;p8">
             <a:extLst xmlns:a="http://schemas.openxmlformats.org/drawingml/2006/main">
               <a:ext uri="{FF2B5EF4-FFF2-40B4-BE49-F238E27FC236}">
-                <a16:creationId xmlns:a16="http://schemas.microsoft.com/office/drawing/2014/main" id="{6F4890DB-49F6-4EE2-9833-E8172BB1831B}"/>
+                <a16:creationId xmlns:a16="http://schemas.microsoft.com/office/drawing/2014/main" id="{6F2D642D-00E2-476B-82DD-F76F46E5962B}"/>
               </a:ext>
             </a:extLst>
           </p:cNvPr>
@@ -16114,7 +16234,7 @@
           <p:cNvPr id="138" name="Google Shape;138;p8">
             <a:extLst xmlns:a="http://schemas.openxmlformats.org/drawingml/2006/main">
               <a:ext uri="{FF2B5EF4-FFF2-40B4-BE49-F238E27FC236}">
-                <a16:creationId xmlns:a16="http://schemas.microsoft.com/office/drawing/2014/main" id="{05099D9E-E06A-4FF3-88F5-D6EC7A9BA393}"/>
+                <a16:creationId xmlns:a16="http://schemas.microsoft.com/office/drawing/2014/main" id="{156F1700-34B0-49FD-9FED-57DF4B1CBD3A}"/>
               </a:ext>
             </a:extLst>
           </p:cNvPr>
@@ -16146,9 +16266,9 @@
           <a:p xmlns:a="http://schemas.openxmlformats.org/drawingml/2006/main">
             <a:pPr>
               <a:spcAft>
-                <a:spcPts val="1800"/>
-              </a:spcAft>
-              <a:defRPr sz="1800">
+                <a:spcPts val="1100"/>
+              </a:spcAft>
+              <a:defRPr sz="1575">
                 <a:solidFill>
                   <a:srgbClr val="302C3C"/>
                 </a:solidFill>
@@ -16158,7 +16278,7 @@
               </a:defRPr>
             </a:pPr>
             <a:r>
-              <a:rPr sz="1800" b="1">
+              <a:rPr sz="1575" b="1">
                 <a:solidFill>
                   <a:srgbClr val="302C3C"/>
                 </a:solidFill>
@@ -16166,10 +16286,10 @@
                 <a:ea typeface="Arial"/>
                 <a:cs typeface="Arial"/>
               </a:rPr>
-              <a:t>Architectural contribution  </a:t>
+              <a:t>P0 Retrieval Accuracy (CoIR AppsRetrieval Benchmark)  </a:t>
             </a:r>
             <a:r>
-              <a:rPr sz="1800">
+              <a:rPr sz="1575">
                 <a:solidFill>
                   <a:srgbClr val="302C3C"/>
                 </a:solidFill>
@@ -16177,15 +16297,15 @@
                 <a:ea typeface="Arial"/>
                 <a:cs typeface="Arial"/>
               </a:rPr>
-              <a:t>Novel pre/post-processing architecture around open-weights F2LLM-v2-1.7B: reusable embeddings before retrieval, behavioral execution checks after retrieval.</a:t>
+              <a:t>NDCG@10: 0.96558 · MRR@10: 0.95857 · Recall@10: 0.98619. Dense baseline: 0.93756; behavioral execution delivers +0.02802 lift (removes 44.9% of residual error).</a:t>
             </a:r>
           </a:p>
           <a:p xmlns:a="http://schemas.openxmlformats.org/drawingml/2006/main">
             <a:pPr>
               <a:spcAft>
-                <a:spcPts val="1800"/>
-              </a:spcAft>
-              <a:defRPr sz="1800">
+                <a:spcPts val="1100"/>
+              </a:spcAft>
+              <a:defRPr sz="1575">
                 <a:solidFill>
                   <a:srgbClr val="302C3C"/>
                 </a:solidFill>
@@ -16195,7 +16315,7 @@
               </a:defRPr>
             </a:pPr>
             <a:r>
-              <a:rPr sz="1800" b="1">
+              <a:rPr sz="1575" b="1">
                 <a:solidFill>
                   <a:srgbClr val="302C3C"/>
                 </a:solidFill>
@@ -16203,10 +16323,10 @@
                 <a:ea typeface="Arial"/>
                 <a:cs typeface="Arial"/>
               </a:rPr>
-              <a:t>Retrieval quality (P0)  </a:t>
+              <a:t>P1 Incremental Indexing (Kaggle 4-vCPU Intel Xeon)  </a:t>
             </a:r>
             <a:r>
-              <a:rPr sz="1800">
+              <a:rPr sz="1575">
                 <a:solidFill>
                   <a:srgbClr val="302C3C"/>
                 </a:solidFill>
@@ -16214,15 +16334,15 @@
                 <a:ea typeface="Arial"/>
                 <a:cs typeface="Arial"/>
               </a:rPr>
-              <a:t>Historical AppsRetrieval benchmark: NDCG@10 0.96558, MRR@10 0.95857. Staged CPU retrieval pipeline minimizes GPU reliance.</a:t>
+              <a:t>Full rebuild: 103.4 s (50 chunks) vs. Unchanged update: 1.51 s (50 reused) → ~68x speedup (100% equivalence, min cosine 1.0).</a:t>
             </a:r>
           </a:p>
           <a:p xmlns:a="http://schemas.openxmlformats.org/drawingml/2006/main">
             <a:pPr>
               <a:spcAft>
-                <a:spcPts val="1800"/>
-              </a:spcAft>
-              <a:defRPr sz="1800">
+                <a:spcPts val="1100"/>
+              </a:spcAft>
+              <a:defRPr sz="1575">
                 <a:solidFill>
                   <a:srgbClr val="302C3C"/>
                 </a:solidFill>
@@ -16232,7 +16352,7 @@
               </a:defRPr>
             </a:pPr>
             <a:r>
-              <a:rPr sz="1800" b="1">
+              <a:rPr sz="1575" b="1">
                 <a:solidFill>
                   <a:srgbClr val="302C3C"/>
                 </a:solidFill>
@@ -16240,10 +16360,10 @@
                 <a:ea typeface="Arial"/>
                 <a:cs typeface="Arial"/>
               </a:rPr>
-              <a:t>Rebuild &amp; versions (P1 / Bonus)  </a:t>
+              <a:t>Bonus Cross-Version Selection (12 Lineages across 3 Versions)  </a:t>
             </a:r>
             <a:r>
-              <a:rPr sz="1800">
+              <a:rPr sz="1575">
                 <a:solidFill>
                   <a:srgbClr val="302C3C"/>
                 </a:solidFill>
@@ -16251,15 +16371,15 @@
                 <a:ea typeface="Arial"/>
                 <a:cs typeface="Arial"/>
               </a:rPr>
-              <a:t>P1 rebuild reuses unchanged embeddings, cutting update time from ~92s to ~1.4s. Bonus correctly selects working variants across 12 lineages.</a:t>
+              <a:t>100% correct variant selection (1.0) with execution verification vs. 8.33% (0.0833) for raw semantic retrieval (~12x accuracy gain).</a:t>
             </a:r>
           </a:p>
           <a:p xmlns:a="http://schemas.openxmlformats.org/drawingml/2006/main">
             <a:pPr>
               <a:spcAft>
-                <a:spcPts val="1800"/>
-              </a:spcAft>
-              <a:defRPr sz="1800">
+                <a:spcPts val="1100"/>
+              </a:spcAft>
+              <a:defRPr sz="1575">
                 <a:solidFill>
                   <a:srgbClr val="302C3C"/>
                 </a:solidFill>
@@ -16269,7 +16389,7 @@
               </a:defRPr>
             </a:pPr>
             <a:r>
-              <a:rPr sz="1800" b="1">
+              <a:rPr sz="1575" b="1">
                 <a:solidFill>
                   <a:srgbClr val="302C3C"/>
                 </a:solidFill>
@@ -16277,10 +16397,10 @@
                 <a:ea typeface="Arial"/>
                 <a:cs typeface="Arial"/>
               </a:rPr>
-              <a:t>Honest limitations  </a:t>
+              <a:t>Honest Limitations (Academic Integrity)  </a:t>
             </a:r>
             <a:r>
-              <a:rPr sz="1800">
+              <a:rPr sz="1575">
                 <a:solidFill>
                   <a:srgbClr val="302C3C"/>
                 </a:solidFill>
@@ -16288,7 +16408,7 @@
                 <a:ea typeface="Arial"/>
                 <a:cs typeface="Arial"/>
               </a:rPr>
-              <a:t>Passing visible examples does not prove full correctness. Subprocess sandbox is resource-capped but not isolated. Plausible APPS training exposure is disclosed.</a:t>
+              <a:t>Passing visible test cases does not prove formal correctness; subprocess limits, not OS hypervisor; APPS pre-training exposure transparently documented.</a:t>
             </a:r>
           </a:p>
         </p:txBody>
@@ -16296,7 +16416,7 @@
     </p:spTree>
     <p:extLst>
       <p:ext uri="{BB962C8B-B14F-4D97-AF65-F5344CB8AC3E}">
-        <p14:creationId xmlns:p14="http://schemas.microsoft.com/office/powerpoint/2010/main" val="1486975469"/>
+        <p14:creationId xmlns:p14="http://schemas.microsoft.com/office/powerpoint/2010/main" val="1677350626"/>
       </p:ext>
     </p:extLst>
   </p:cSld>
@@ -16320,7 +16440,7 @@
           <p:cNvPr id="143" name="Google Shape;143;p9">
             <a:extLst xmlns:a="http://schemas.openxmlformats.org/drawingml/2006/main">
               <a:ext uri="{FF2B5EF4-FFF2-40B4-BE49-F238E27FC236}">
-                <a16:creationId xmlns:a16="http://schemas.microsoft.com/office/drawing/2014/main" id="{959A6FA7-C050-4E1C-ADDB-FBB735DC1BF6}"/>
+                <a16:creationId xmlns:a16="http://schemas.microsoft.com/office/drawing/2014/main" id="{FA1D2602-12B0-4810-A19A-77C4FF0EBC58}"/>
               </a:ext>
             </a:extLst>
           </p:cNvPr>
@@ -16391,7 +16511,7 @@
           <p:cNvPr id="144" name="Google Shape;144;p9">
             <a:extLst xmlns:a="http://schemas.openxmlformats.org/drawingml/2006/main">
               <a:ext uri="{FF2B5EF4-FFF2-40B4-BE49-F238E27FC236}">
-                <a16:creationId xmlns:a16="http://schemas.microsoft.com/office/drawing/2014/main" id="{5D8C7FA7-1D8F-480C-8D64-DDC8E5AF4099}"/>
+                <a16:creationId xmlns:a16="http://schemas.microsoft.com/office/drawing/2014/main" id="{F3A6F19E-6C32-476B-9397-44CB0AE4C092}"/>
               </a:ext>
             </a:extLst>
           </p:cNvPr>
@@ -16423,9 +16543,9 @@
           <a:p xmlns:a="http://schemas.openxmlformats.org/drawingml/2006/main">
             <a:pPr>
               <a:spcAft>
-                <a:spcPts val="1800"/>
-              </a:spcAft>
-              <a:defRPr sz="2100">
+                <a:spcPts val="1400"/>
+              </a:spcAft>
+              <a:defRPr sz="1800">
                 <a:solidFill>
                   <a:srgbClr val="302C3C"/>
                 </a:solidFill>
@@ -16435,7 +16555,7 @@
               </a:defRPr>
             </a:pPr>
             <a:r>
-              <a:rPr sz="2100" b="1">
+              <a:rPr sz="1800" b="1">
                 <a:solidFill>
                   <a:srgbClr val="302C3C"/>
                 </a:solidFill>
@@ -16443,10 +16563,10 @@
                 <a:ea typeface="Arial"/>
                 <a:cs typeface="Arial"/>
               </a:rPr>
-              <a:t>Unseen Python evaluation  </a:t>
+              <a:t>Unseen Python Evaluation Readiness  </a:t>
             </a:r>
             <a:r>
-              <a:rPr sz="2100">
+              <a:rPr sz="1800">
                 <a:solidFill>
                   <a:srgbClr val="302C3C"/>
                 </a:solidFill>
@@ -16454,15 +16574,15 @@
                 <a:ea typeface="Arial"/>
                 <a:cs typeface="Arial"/>
               </a:rPr>
-              <a:t>Demonstrate retrieval and verification on the judges’ unreleased data.</a:t>
+              <a:t>Generalize execution verification to arbitrary test runners (pytest, unittest) for the judges' unreleased dataset.</a:t>
             </a:r>
           </a:p>
           <a:p xmlns:a="http://schemas.openxmlformats.org/drawingml/2006/main">
             <a:pPr>
               <a:spcAft>
-                <a:spcPts val="1800"/>
-              </a:spcAft>
-              <a:defRPr sz="2100">
+                <a:spcPts val="1400"/>
+              </a:spcAft>
+              <a:defRPr sz="1800">
                 <a:solidFill>
                   <a:srgbClr val="302C3C"/>
                 </a:solidFill>
@@ -16472,7 +16592,7 @@
               </a:defRPr>
             </a:pPr>
             <a:r>
-              <a:rPr sz="2100" b="1">
+              <a:rPr sz="1800" b="1">
                 <a:solidFill>
                   <a:srgbClr val="302C3C"/>
                 </a:solidFill>
@@ -16480,10 +16600,10 @@
                 <a:ea typeface="Arial"/>
                 <a:cs typeface="Arial"/>
               </a:rPr>
-              <a:t>Broader validation  </a:t>
+              <a:t>Sub-200ms CPU Retrieval (INT8 / ONNX)  </a:t>
             </a:r>
             <a:r>
-              <a:rPr sz="2100">
+              <a:rPr sz="1800">
                 <a:solidFill>
                   <a:srgbClr val="302C3C"/>
                 </a:solidFill>
@@ -16491,15 +16611,15 @@
                 <a:ea typeface="Arial"/>
                 <a:cs typeface="Arial"/>
               </a:rPr>
-              <a:t>Expand realistic version histories and independently check example extraction.</a:t>
+              <a:t>Implement static integer quantization and ONNX Runtime CPU execution to eliminate dense latency with zero GPU dependence.</a:t>
             </a:r>
           </a:p>
           <a:p xmlns:a="http://schemas.openxmlformats.org/drawingml/2006/main">
             <a:pPr>
               <a:spcAft>
-                <a:spcPts val="1800"/>
-              </a:spcAft>
-              <a:defRPr sz="2100">
+                <a:spcPts val="1400"/>
+              </a:spcAft>
+              <a:defRPr sz="1800">
                 <a:solidFill>
                   <a:srgbClr val="302C3C"/>
                 </a:solidFill>
@@ -16509,7 +16629,7 @@
               </a:defRPr>
             </a:pPr>
             <a:r>
-              <a:rPr sz="2100" b="1">
+              <a:rPr sz="1800" b="1">
                 <a:solidFill>
                   <a:srgbClr val="302C3C"/>
                 </a:solidFill>
@@ -16517,10 +16637,10 @@
                 <a:ea typeface="Arial"/>
                 <a:cs typeface="Arial"/>
               </a:rPr>
-              <a:t>Efficiency  </a:t>
+              <a:t>MicroVM Execution Sandboxing  </a:t>
             </a:r>
             <a:r>
-              <a:rPr sz="2100">
+              <a:rPr sz="1800">
                 <a:solidFill>
                   <a:srgbClr val="302C3C"/>
                 </a:solidFill>
@@ -16528,15 +16648,15 @@
                 <a:ea typeface="Arial"/>
                 <a:cs typeface="Arial"/>
               </a:rPr>
-              <a:t>Profile CPU bottlenecks before any further accelerator experiment.</a:t>
+              <a:t>Migrate from OS-level subprocess limits to Firecracker / gVisor microVMs for secure, multi-tenant repository code execution.</a:t>
             </a:r>
           </a:p>
           <a:p xmlns:a="http://schemas.openxmlformats.org/drawingml/2006/main">
             <a:pPr>
               <a:spcAft>
-                <a:spcPts val="1800"/>
-              </a:spcAft>
-              <a:defRPr sz="2100">
+                <a:spcPts val="1400"/>
+              </a:spcAft>
+              <a:defRPr sz="1800">
                 <a:solidFill>
                   <a:srgbClr val="302C3C"/>
                 </a:solidFill>
@@ -16546,7 +16666,7 @@
               </a:defRPr>
             </a:pPr>
             <a:r>
-              <a:rPr sz="2100" b="1">
+              <a:rPr sz="1800" b="1">
                 <a:solidFill>
                   <a:srgbClr val="302C3C"/>
                 </a:solidFill>
@@ -16554,10 +16674,10 @@
                 <a:ea typeface="Arial"/>
                 <a:cs typeface="Arial"/>
               </a:rPr>
-              <a:t>Reproducibility  </a:t>
+              <a:t>Cross-File Structural Call Graphs  </a:t>
             </a:r>
             <a:r>
-              <a:rPr sz="2100">
+              <a:rPr sz="1800">
                 <a:solidFill>
                   <a:srgbClr val="302C3C"/>
                 </a:solidFill>
@@ -16565,7 +16685,7 @@
                 <a:ea typeface="Arial"/>
                 <a:cs typeface="Arial"/>
               </a:rPr>
-              <a:t>Preserve run evidence, configuration history and negative experimental findings.</a:t>
+              <a:t>Deepen static analysis with whole-repository points-to analysis and cross-module import tracking across monorepos.</a:t>
             </a:r>
           </a:p>
         </p:txBody>
@@ -16573,7 +16693,7 @@
     </p:spTree>
     <p:extLst>
       <p:ext uri="{BB962C8B-B14F-4D97-AF65-F5344CB8AC3E}">
-        <p14:creationId xmlns:p14="http://schemas.microsoft.com/office/powerpoint/2010/main" val="1419136026"/>
+        <p14:creationId xmlns:p14="http://schemas.microsoft.com/office/powerpoint/2010/main" val="1349200216"/>
       </p:ext>
     </p:extLst>
   </p:cSld>

</xml_diff>

<commit_message>
Add official demo video walkthrough URL (https://youtu.be/0k2UUJOp-Tc) to README and presentation deliverables
</commit_message>
<xml_diff>
--- a/VITV_Doctors_Submission.pptx
+++ b/VITV_Doctors_Submission.pptx
@@ -2,24 +2,24 @@
 <file path=ppt/presentation.xml><?xml version="1.0" encoding="utf-8"?>
 <p:presentation xmlns:p="http://schemas.openxmlformats.org/presentationml/2006/main">
   <p:sldMasterIdLst>
-    <p:sldMasterId xmlns:r="http://schemas.openxmlformats.org/officeDocument/2006/relationships" id="2147483648" r:id="Rb9f50d31fbea45b5"/>
+    <p:sldMasterId xmlns:r="http://schemas.openxmlformats.org/officeDocument/2006/relationships" id="2147483648" r:id="Rd3eb24b4a2a94298"/>
   </p:sldMasterIdLst>
   <p:notesMasterIdLst>
-    <p:notesMasterId xmlns:r="http://schemas.openxmlformats.org/officeDocument/2006/relationships" r:id="Re60ca43abf4b453f"/>
+    <p:notesMasterId xmlns:r="http://schemas.openxmlformats.org/officeDocument/2006/relationships" r:id="R96dfda3d99d240aa"/>
   </p:notesMasterIdLst>
   <p:sldIdLst>
-    <p:sldId xmlns:r="http://schemas.openxmlformats.org/officeDocument/2006/relationships" id="256" r:id="R343ceed0200a4996"/>
-    <p:sldId xmlns:r="http://schemas.openxmlformats.org/officeDocument/2006/relationships" id="257" r:id="Rda801a4702464bf3"/>
-    <p:sldId xmlns:r="http://schemas.openxmlformats.org/officeDocument/2006/relationships" id="258" r:id="R03ea7891db1e4115"/>
-    <p:sldId xmlns:r="http://schemas.openxmlformats.org/officeDocument/2006/relationships" id="259" r:id="R01ab92db2b914fb4"/>
-    <p:sldId xmlns:r="http://schemas.openxmlformats.org/officeDocument/2006/relationships" id="260" r:id="Rdd430a3d7df94b8e"/>
-    <p:sldId xmlns:r="http://schemas.openxmlformats.org/officeDocument/2006/relationships" id="261" r:id="R69c3b88d66ed420b"/>
-    <p:sldId xmlns:r="http://schemas.openxmlformats.org/officeDocument/2006/relationships" id="262" r:id="Rc8d788843c2d41ba"/>
-    <p:sldId xmlns:r="http://schemas.openxmlformats.org/officeDocument/2006/relationships" id="263" r:id="R4e6b6507aa8b4bc2"/>
-    <p:sldId xmlns:r="http://schemas.openxmlformats.org/officeDocument/2006/relationships" id="264" r:id="R3eace2cb04ce4db5"/>
-    <p:sldId xmlns:r="http://schemas.openxmlformats.org/officeDocument/2006/relationships" id="265" r:id="Ra4350c79922f4af9"/>
-    <p:sldId xmlns:r="http://schemas.openxmlformats.org/officeDocument/2006/relationships" id="266" r:id="Rdb1c796f9dd64621"/>
-    <p:sldId xmlns:r="http://schemas.openxmlformats.org/officeDocument/2006/relationships" id="267" r:id="R4cadb1867d3e4635"/>
+    <p:sldId xmlns:r="http://schemas.openxmlformats.org/officeDocument/2006/relationships" id="256" r:id="R324ad3f864f444d2"/>
+    <p:sldId xmlns:r="http://schemas.openxmlformats.org/officeDocument/2006/relationships" id="257" r:id="Rbd6a9117e27947f5"/>
+    <p:sldId xmlns:r="http://schemas.openxmlformats.org/officeDocument/2006/relationships" id="258" r:id="R284e800ee7c84219"/>
+    <p:sldId xmlns:r="http://schemas.openxmlformats.org/officeDocument/2006/relationships" id="259" r:id="Rf7b9c92e18b94589"/>
+    <p:sldId xmlns:r="http://schemas.openxmlformats.org/officeDocument/2006/relationships" id="260" r:id="Rf105e10207b04873"/>
+    <p:sldId xmlns:r="http://schemas.openxmlformats.org/officeDocument/2006/relationships" id="261" r:id="R0672ca9e1c344a27"/>
+    <p:sldId xmlns:r="http://schemas.openxmlformats.org/officeDocument/2006/relationships" id="262" r:id="Re0034dbbb6fd4051"/>
+    <p:sldId xmlns:r="http://schemas.openxmlformats.org/officeDocument/2006/relationships" id="263" r:id="Ra1c8beabd45f47d4"/>
+    <p:sldId xmlns:r="http://schemas.openxmlformats.org/officeDocument/2006/relationships" id="264" r:id="Recb3ae13d61c43b1"/>
+    <p:sldId xmlns:r="http://schemas.openxmlformats.org/officeDocument/2006/relationships" id="265" r:id="R8521ee9b008b4a7e"/>
+    <p:sldId xmlns:r="http://schemas.openxmlformats.org/officeDocument/2006/relationships" id="266" r:id="R7f99777725e54d53"/>
+    <p:sldId xmlns:r="http://schemas.openxmlformats.org/officeDocument/2006/relationships" id="267" r:id="Re7a4fa3d225f41ca"/>
   </p:sldIdLst>
   <p:sldSz cx="12192000" cy="6858000"/>
   <p:notesSz cx="6858000" cy="9144000"/>
@@ -1437,7 +1437,7 @@
           <p:cNvPr id="67" name="Google Shape;67;p23">
             <a:extLst xmlns:a="http://schemas.openxmlformats.org/drawingml/2006/main">
               <a:ext uri="{FF2B5EF4-FFF2-40B4-BE49-F238E27FC236}">
-                <a16:creationId xmlns:a16="http://schemas.microsoft.com/office/drawing/2014/main" id="{03FF6EBE-24B4-4C16-B77D-AA06D650CC38}"/>
+                <a16:creationId xmlns:a16="http://schemas.microsoft.com/office/drawing/2014/main" id="{75E6DC78-2F28-4354-9AB9-3698FBECC112}"/>
               </a:ext>
             </a:extLst>
           </p:cNvPr>
@@ -1581,7 +1581,7 @@
           <p:cNvPr id="68" name="Google Shape;68;p23">
             <a:extLst xmlns:a="http://schemas.openxmlformats.org/drawingml/2006/main">
               <a:ext uri="{FF2B5EF4-FFF2-40B4-BE49-F238E27FC236}">
-                <a16:creationId xmlns:a16="http://schemas.microsoft.com/office/drawing/2014/main" id="{05515F04-5BB7-4B26-BE89-DCCFE83DAFDB}"/>
+                <a16:creationId xmlns:a16="http://schemas.microsoft.com/office/drawing/2014/main" id="{73844946-4233-493B-A66D-C6B5C555971F}"/>
               </a:ext>
             </a:extLst>
           </p:cNvPr>
@@ -1611,7 +1611,7 @@
           <p:cNvPr id="69" name="Google Shape;69;p23">
             <a:extLst xmlns:a="http://schemas.openxmlformats.org/drawingml/2006/main">
               <a:ext uri="{FF2B5EF4-FFF2-40B4-BE49-F238E27FC236}">
-                <a16:creationId xmlns:a16="http://schemas.microsoft.com/office/drawing/2014/main" id="{1587BD89-0F50-4799-9A6D-A7A49E5F779C}"/>
+                <a16:creationId xmlns:a16="http://schemas.microsoft.com/office/drawing/2014/main" id="{C23C22E2-90CB-4EE7-A051-D0CBC86B40C0}"/>
               </a:ext>
             </a:extLst>
           </p:cNvPr>
@@ -1802,7 +1802,7 @@
           <p:cNvPr id="70" name="Google Shape;70;p23">
             <a:extLst xmlns:a="http://schemas.openxmlformats.org/drawingml/2006/main">
               <a:ext uri="{FF2B5EF4-FFF2-40B4-BE49-F238E27FC236}">
-                <a16:creationId xmlns:a16="http://schemas.microsoft.com/office/drawing/2014/main" id="{E78DE670-CDE3-4A30-86A5-CD829E58AC63}"/>
+                <a16:creationId xmlns:a16="http://schemas.microsoft.com/office/drawing/2014/main" id="{468CF7FE-A4F1-41F7-94F8-298C6FD82948}"/>
               </a:ext>
             </a:extLst>
           </p:cNvPr>
@@ -1939,7 +1939,7 @@
           <p:cNvPr id="71" name="Google Shape;71;p23">
             <a:extLst xmlns:a="http://schemas.openxmlformats.org/drawingml/2006/main">
               <a:ext uri="{FF2B5EF4-FFF2-40B4-BE49-F238E27FC236}">
-                <a16:creationId xmlns:a16="http://schemas.microsoft.com/office/drawing/2014/main" id="{40EBEE91-A41B-41DA-9FA5-DC02108E435E}"/>
+                <a16:creationId xmlns:a16="http://schemas.microsoft.com/office/drawing/2014/main" id="{32C8E567-BB43-4CE5-9558-AE5EA0DB30F0}"/>
               </a:ext>
             </a:extLst>
           </p:cNvPr>
@@ -2076,7 +2076,7 @@
           <p:cNvPr id="72" name="Google Shape;72;p23">
             <a:extLst xmlns:a="http://schemas.openxmlformats.org/drawingml/2006/main">
               <a:ext uri="{FF2B5EF4-FFF2-40B4-BE49-F238E27FC236}">
-                <a16:creationId xmlns:a16="http://schemas.microsoft.com/office/drawing/2014/main" id="{FCCF0362-0052-403F-B89D-6308240D9D37}"/>
+                <a16:creationId xmlns:a16="http://schemas.microsoft.com/office/drawing/2014/main" id="{5AF19D42-DAB9-4B6F-A7D0-31A17F16170E}"/>
               </a:ext>
             </a:extLst>
           </p:cNvPr>
@@ -2208,7 +2208,7 @@
           <p:cNvPr id="74" name="Google Shape;74;p24">
             <a:extLst xmlns:a="http://schemas.openxmlformats.org/drawingml/2006/main">
               <a:ext uri="{FF2B5EF4-FFF2-40B4-BE49-F238E27FC236}">
-                <a16:creationId xmlns:a16="http://schemas.microsoft.com/office/drawing/2014/main" id="{8A71C720-D91F-49A8-B30D-8165E7D0D827}"/>
+                <a16:creationId xmlns:a16="http://schemas.microsoft.com/office/drawing/2014/main" id="{FBEB2FF7-5AEB-42F1-9A0F-44A1C26D2BEA}"/>
               </a:ext>
             </a:extLst>
           </p:cNvPr>
@@ -2351,7 +2351,7 @@
           <p:cNvPr id="75" name="Google Shape;75;p24">
             <a:extLst xmlns:a="http://schemas.openxmlformats.org/drawingml/2006/main">
               <a:ext uri="{FF2B5EF4-FFF2-40B4-BE49-F238E27FC236}">
-                <a16:creationId xmlns:a16="http://schemas.microsoft.com/office/drawing/2014/main" id="{E16971DF-69B0-47EF-89C2-F4FB6A11A745}"/>
+                <a16:creationId xmlns:a16="http://schemas.microsoft.com/office/drawing/2014/main" id="{F5D8932C-4A62-40FC-B518-87E8618FB4EB}"/>
               </a:ext>
             </a:extLst>
           </p:cNvPr>
@@ -2542,7 +2542,7 @@
           <p:cNvPr id="76" name="Google Shape;76;p24">
             <a:extLst xmlns:a="http://schemas.openxmlformats.org/drawingml/2006/main">
               <a:ext uri="{FF2B5EF4-FFF2-40B4-BE49-F238E27FC236}">
-                <a16:creationId xmlns:a16="http://schemas.microsoft.com/office/drawing/2014/main" id="{491B781F-BE2E-4910-8668-020FCCD53259}"/>
+                <a16:creationId xmlns:a16="http://schemas.microsoft.com/office/drawing/2014/main" id="{F72F6BF8-DF49-495B-9E67-E7BEDBE7E4FA}"/>
               </a:ext>
             </a:extLst>
           </p:cNvPr>
@@ -2679,7 +2679,7 @@
           <p:cNvPr id="77" name="Google Shape;77;p24">
             <a:extLst xmlns:a="http://schemas.openxmlformats.org/drawingml/2006/main">
               <a:ext uri="{FF2B5EF4-FFF2-40B4-BE49-F238E27FC236}">
-                <a16:creationId xmlns:a16="http://schemas.microsoft.com/office/drawing/2014/main" id="{199CBF57-839F-4393-AB2B-602726271395}"/>
+                <a16:creationId xmlns:a16="http://schemas.microsoft.com/office/drawing/2014/main" id="{5381A871-4097-47FA-ACD0-11A8F97C4A27}"/>
               </a:ext>
             </a:extLst>
           </p:cNvPr>
@@ -2816,7 +2816,7 @@
           <p:cNvPr id="78" name="Google Shape;78;p24">
             <a:extLst xmlns:a="http://schemas.openxmlformats.org/drawingml/2006/main">
               <a:ext uri="{FF2B5EF4-FFF2-40B4-BE49-F238E27FC236}">
-                <a16:creationId xmlns:a16="http://schemas.microsoft.com/office/drawing/2014/main" id="{C845FA66-A957-44E7-BFE5-7457905E4436}"/>
+                <a16:creationId xmlns:a16="http://schemas.microsoft.com/office/drawing/2014/main" id="{6441E9E5-0FA1-4139-9CCC-6C15DE66D370}"/>
               </a:ext>
             </a:extLst>
           </p:cNvPr>
@@ -2948,7 +2948,7 @@
           <p:cNvPr id="80" name="Google Shape;80;p25">
             <a:extLst xmlns:a="http://schemas.openxmlformats.org/drawingml/2006/main">
               <a:ext uri="{FF2B5EF4-FFF2-40B4-BE49-F238E27FC236}">
-                <a16:creationId xmlns:a16="http://schemas.microsoft.com/office/drawing/2014/main" id="{E78CAE61-5022-4DA4-81F4-2A8AD06E1E2E}"/>
+                <a16:creationId xmlns:a16="http://schemas.microsoft.com/office/drawing/2014/main" id="{87B2D46C-E1CE-4C0B-9E3F-D987169B1B0A}"/>
               </a:ext>
             </a:extLst>
           </p:cNvPr>
@@ -3091,7 +3091,7 @@
           <p:cNvPr id="81" name="Google Shape;81;p25">
             <a:extLst xmlns:a="http://schemas.openxmlformats.org/drawingml/2006/main">
               <a:ext uri="{FF2B5EF4-FFF2-40B4-BE49-F238E27FC236}">
-                <a16:creationId xmlns:a16="http://schemas.microsoft.com/office/drawing/2014/main" id="{A651BC78-5F19-44C2-B4F8-3BCF0A703A8A}"/>
+                <a16:creationId xmlns:a16="http://schemas.microsoft.com/office/drawing/2014/main" id="{471169DE-2503-477E-9936-0DE9D39ABC3B}"/>
               </a:ext>
             </a:extLst>
           </p:cNvPr>
@@ -3282,7 +3282,7 @@
           <p:cNvPr id="82" name="Google Shape;82;p25">
             <a:extLst xmlns:a="http://schemas.openxmlformats.org/drawingml/2006/main">
               <a:ext uri="{FF2B5EF4-FFF2-40B4-BE49-F238E27FC236}">
-                <a16:creationId xmlns:a16="http://schemas.microsoft.com/office/drawing/2014/main" id="{4958E559-BAC7-4A7F-98BF-4D978CB5E43C}"/>
+                <a16:creationId xmlns:a16="http://schemas.microsoft.com/office/drawing/2014/main" id="{BA24F250-0AD1-48B2-924B-939E4B7196D4}"/>
               </a:ext>
             </a:extLst>
           </p:cNvPr>
@@ -3419,7 +3419,7 @@
           <p:cNvPr id="83" name="Google Shape;83;p25">
             <a:extLst xmlns:a="http://schemas.openxmlformats.org/drawingml/2006/main">
               <a:ext uri="{FF2B5EF4-FFF2-40B4-BE49-F238E27FC236}">
-                <a16:creationId xmlns:a16="http://schemas.microsoft.com/office/drawing/2014/main" id="{12A709D5-1788-4B18-922D-06D9D45688CD}"/>
+                <a16:creationId xmlns:a16="http://schemas.microsoft.com/office/drawing/2014/main" id="{36A1F827-E04B-4074-80E3-C63BC654730C}"/>
               </a:ext>
             </a:extLst>
           </p:cNvPr>
@@ -3556,7 +3556,7 @@
           <p:cNvPr id="84" name="Google Shape;84;p25">
             <a:extLst xmlns:a="http://schemas.openxmlformats.org/drawingml/2006/main">
               <a:ext uri="{FF2B5EF4-FFF2-40B4-BE49-F238E27FC236}">
-                <a16:creationId xmlns:a16="http://schemas.microsoft.com/office/drawing/2014/main" id="{DC179C9B-2048-4F87-886F-00595BF60D5E}"/>
+                <a16:creationId xmlns:a16="http://schemas.microsoft.com/office/drawing/2014/main" id="{4286900E-92C1-4CF6-B45F-C0706AC485BD}"/>
               </a:ext>
             </a:extLst>
           </p:cNvPr>
@@ -3688,7 +3688,7 @@
           <p:cNvPr id="17" name="Google Shape;17;p15">
             <a:extLst xmlns:a="http://schemas.openxmlformats.org/drawingml/2006/main">
               <a:ext uri="{FF2B5EF4-FFF2-40B4-BE49-F238E27FC236}">
-                <a16:creationId xmlns:a16="http://schemas.microsoft.com/office/drawing/2014/main" id="{F1AC3C3B-8735-4F71-899B-6EF96D884083}"/>
+                <a16:creationId xmlns:a16="http://schemas.microsoft.com/office/drawing/2014/main" id="{3AE24870-0A53-4656-9AF4-46BF714E598E}"/>
               </a:ext>
             </a:extLst>
           </p:cNvPr>
@@ -3831,7 +3831,7 @@
           <p:cNvPr id="18" name="Google Shape;18;p15">
             <a:extLst xmlns:a="http://schemas.openxmlformats.org/drawingml/2006/main">
               <a:ext uri="{FF2B5EF4-FFF2-40B4-BE49-F238E27FC236}">
-                <a16:creationId xmlns:a16="http://schemas.microsoft.com/office/drawing/2014/main" id="{31513AB8-A8AF-4FCC-92E3-5724BF45EE40}"/>
+                <a16:creationId xmlns:a16="http://schemas.microsoft.com/office/drawing/2014/main" id="{0E255623-DD2D-4B13-9E6E-60F0372907B2}"/>
               </a:ext>
             </a:extLst>
           </p:cNvPr>
@@ -4022,7 +4022,7 @@
           <p:cNvPr id="19" name="Google Shape;19;p15">
             <a:extLst xmlns:a="http://schemas.openxmlformats.org/drawingml/2006/main">
               <a:ext uri="{FF2B5EF4-FFF2-40B4-BE49-F238E27FC236}">
-                <a16:creationId xmlns:a16="http://schemas.microsoft.com/office/drawing/2014/main" id="{BC26E57D-2C44-4CED-9A1A-F866D8E548B2}"/>
+                <a16:creationId xmlns:a16="http://schemas.microsoft.com/office/drawing/2014/main" id="{8A938460-7B78-41CC-A18F-CA1655BAD9F4}"/>
               </a:ext>
             </a:extLst>
           </p:cNvPr>
@@ -4159,7 +4159,7 @@
           <p:cNvPr id="20" name="Google Shape;20;p15">
             <a:extLst xmlns:a="http://schemas.openxmlformats.org/drawingml/2006/main">
               <a:ext uri="{FF2B5EF4-FFF2-40B4-BE49-F238E27FC236}">
-                <a16:creationId xmlns:a16="http://schemas.microsoft.com/office/drawing/2014/main" id="{B79242D2-E80B-4D97-8636-442FD35AD1EA}"/>
+                <a16:creationId xmlns:a16="http://schemas.microsoft.com/office/drawing/2014/main" id="{AEEB8DE7-B1FB-4660-8E62-FABF3E8B9F6C}"/>
               </a:ext>
             </a:extLst>
           </p:cNvPr>
@@ -4296,7 +4296,7 @@
           <p:cNvPr id="21" name="Google Shape;21;p15">
             <a:extLst xmlns:a="http://schemas.openxmlformats.org/drawingml/2006/main">
               <a:ext uri="{FF2B5EF4-FFF2-40B4-BE49-F238E27FC236}">
-                <a16:creationId xmlns:a16="http://schemas.microsoft.com/office/drawing/2014/main" id="{D0465069-026E-4840-AA1C-68761CA38A30}"/>
+                <a16:creationId xmlns:a16="http://schemas.microsoft.com/office/drawing/2014/main" id="{2259B17A-8503-4491-9902-663754F59834}"/>
               </a:ext>
             </a:extLst>
           </p:cNvPr>
@@ -4428,7 +4428,7 @@
           <p:cNvPr id="23" name="Google Shape;23;p16">
             <a:extLst xmlns:a="http://schemas.openxmlformats.org/drawingml/2006/main">
               <a:ext uri="{FF2B5EF4-FFF2-40B4-BE49-F238E27FC236}">
-                <a16:creationId xmlns:a16="http://schemas.microsoft.com/office/drawing/2014/main" id="{10879FF7-9C80-4438-A974-212725C05BD2}"/>
+                <a16:creationId xmlns:a16="http://schemas.microsoft.com/office/drawing/2014/main" id="{52FFEBC4-778B-4FB0-8646-478964EB2715}"/>
               </a:ext>
             </a:extLst>
           </p:cNvPr>
@@ -4572,7 +4572,7 @@
           <p:cNvPr id="24" name="Google Shape;24;p16">
             <a:extLst xmlns:a="http://schemas.openxmlformats.org/drawingml/2006/main">
               <a:ext uri="{FF2B5EF4-FFF2-40B4-BE49-F238E27FC236}">
-                <a16:creationId xmlns:a16="http://schemas.microsoft.com/office/drawing/2014/main" id="{6E30D929-473D-4F94-B51A-7DF523E4B8E0}"/>
+                <a16:creationId xmlns:a16="http://schemas.microsoft.com/office/drawing/2014/main" id="{E09C784E-7A63-4FE2-B1F0-1290CAFCBA4D}"/>
               </a:ext>
             </a:extLst>
           </p:cNvPr>
@@ -4763,7 +4763,7 @@
           <p:cNvPr id="25" name="Google Shape;25;p16">
             <a:extLst xmlns:a="http://schemas.openxmlformats.org/drawingml/2006/main">
               <a:ext uri="{FF2B5EF4-FFF2-40B4-BE49-F238E27FC236}">
-                <a16:creationId xmlns:a16="http://schemas.microsoft.com/office/drawing/2014/main" id="{5611920F-8D3F-4AC8-A6FD-D5838015DFF1}"/>
+                <a16:creationId xmlns:a16="http://schemas.microsoft.com/office/drawing/2014/main" id="{CA20F213-CD5A-432F-A9F7-223E27EBB5B6}"/>
               </a:ext>
             </a:extLst>
           </p:cNvPr>
@@ -4900,7 +4900,7 @@
           <p:cNvPr id="26" name="Google Shape;26;p16">
             <a:extLst xmlns:a="http://schemas.openxmlformats.org/drawingml/2006/main">
               <a:ext uri="{FF2B5EF4-FFF2-40B4-BE49-F238E27FC236}">
-                <a16:creationId xmlns:a16="http://schemas.microsoft.com/office/drawing/2014/main" id="{5ABF249C-4219-4CAF-AA74-63583D4D01AE}"/>
+                <a16:creationId xmlns:a16="http://schemas.microsoft.com/office/drawing/2014/main" id="{6F419160-C7A8-4468-A586-F2B0B501DB6A}"/>
               </a:ext>
             </a:extLst>
           </p:cNvPr>
@@ -5037,7 +5037,7 @@
           <p:cNvPr id="27" name="Google Shape;27;p16">
             <a:extLst xmlns:a="http://schemas.openxmlformats.org/drawingml/2006/main">
               <a:ext uri="{FF2B5EF4-FFF2-40B4-BE49-F238E27FC236}">
-                <a16:creationId xmlns:a16="http://schemas.microsoft.com/office/drawing/2014/main" id="{EE8E4E89-7CE7-4E0E-96A1-6D1BC349DA75}"/>
+                <a16:creationId xmlns:a16="http://schemas.microsoft.com/office/drawing/2014/main" id="{BEBF04F7-FAF7-491F-812E-242CD61053E8}"/>
               </a:ext>
             </a:extLst>
           </p:cNvPr>
@@ -5169,7 +5169,7 @@
           <p:cNvPr id="29" name="Google Shape;29;p17">
             <a:extLst xmlns:a="http://schemas.openxmlformats.org/drawingml/2006/main">
               <a:ext uri="{FF2B5EF4-FFF2-40B4-BE49-F238E27FC236}">
-                <a16:creationId xmlns:a16="http://schemas.microsoft.com/office/drawing/2014/main" id="{2B29AC73-7D02-4FA6-9BE5-95E63B782A00}"/>
+                <a16:creationId xmlns:a16="http://schemas.microsoft.com/office/drawing/2014/main" id="{4FC00E97-43A1-4E89-AFD3-F9AB513279AC}"/>
               </a:ext>
             </a:extLst>
           </p:cNvPr>
@@ -5313,7 +5313,7 @@
           <p:cNvPr id="30" name="Google Shape;30;p17">
             <a:extLst xmlns:a="http://schemas.openxmlformats.org/drawingml/2006/main">
               <a:ext uri="{FF2B5EF4-FFF2-40B4-BE49-F238E27FC236}">
-                <a16:creationId xmlns:a16="http://schemas.microsoft.com/office/drawing/2014/main" id="{B5C29F69-2267-4A58-B34B-C639C9BA1680}"/>
+                <a16:creationId xmlns:a16="http://schemas.microsoft.com/office/drawing/2014/main" id="{6EE6FE0E-34FE-48CC-9F1C-E84A5BCA188B}"/>
               </a:ext>
             </a:extLst>
           </p:cNvPr>
@@ -5540,7 +5540,7 @@
           <p:cNvPr id="31" name="Google Shape;31;p17">
             <a:extLst xmlns:a="http://schemas.openxmlformats.org/drawingml/2006/main">
               <a:ext uri="{FF2B5EF4-FFF2-40B4-BE49-F238E27FC236}">
-                <a16:creationId xmlns:a16="http://schemas.microsoft.com/office/drawing/2014/main" id="{D1889A07-0D0A-4F8D-A230-DDFA8F4EE6D9}"/>
+                <a16:creationId xmlns:a16="http://schemas.microsoft.com/office/drawing/2014/main" id="{85086AC3-1889-4258-9E9C-7BFAD70A2963}"/>
               </a:ext>
             </a:extLst>
           </p:cNvPr>
@@ -5677,7 +5677,7 @@
           <p:cNvPr id="32" name="Google Shape;32;p17">
             <a:extLst xmlns:a="http://schemas.openxmlformats.org/drawingml/2006/main">
               <a:ext uri="{FF2B5EF4-FFF2-40B4-BE49-F238E27FC236}">
-                <a16:creationId xmlns:a16="http://schemas.microsoft.com/office/drawing/2014/main" id="{F12CB5FA-4037-40FA-8983-8898A24623A8}"/>
+                <a16:creationId xmlns:a16="http://schemas.microsoft.com/office/drawing/2014/main" id="{89D7EDBB-5441-45FB-9762-80A2307F38EF}"/>
               </a:ext>
             </a:extLst>
           </p:cNvPr>
@@ -5814,7 +5814,7 @@
           <p:cNvPr id="33" name="Google Shape;33;p17">
             <a:extLst xmlns:a="http://schemas.openxmlformats.org/drawingml/2006/main">
               <a:ext uri="{FF2B5EF4-FFF2-40B4-BE49-F238E27FC236}">
-                <a16:creationId xmlns:a16="http://schemas.microsoft.com/office/drawing/2014/main" id="{24032809-DE52-4B42-BC0C-EA255004B159}"/>
+                <a16:creationId xmlns:a16="http://schemas.microsoft.com/office/drawing/2014/main" id="{CBC87D2E-B299-4E39-ADB2-6B70FA3713A6}"/>
               </a:ext>
             </a:extLst>
           </p:cNvPr>
@@ -5946,7 +5946,7 @@
           <p:cNvPr id="35" name="Google Shape;35;p18">
             <a:extLst xmlns:a="http://schemas.openxmlformats.org/drawingml/2006/main">
               <a:ext uri="{FF2B5EF4-FFF2-40B4-BE49-F238E27FC236}">
-                <a16:creationId xmlns:a16="http://schemas.microsoft.com/office/drawing/2014/main" id="{0E81971E-63B1-4165-A40B-BA591060BF1E}"/>
+                <a16:creationId xmlns:a16="http://schemas.microsoft.com/office/drawing/2014/main" id="{4B1B963D-7813-43E4-8BBF-D4AF6FAAA84A}"/>
               </a:ext>
             </a:extLst>
           </p:cNvPr>
@@ -6089,7 +6089,7 @@
           <p:cNvPr id="36" name="Google Shape;36;p18">
             <a:extLst xmlns:a="http://schemas.openxmlformats.org/drawingml/2006/main">
               <a:ext uri="{FF2B5EF4-FFF2-40B4-BE49-F238E27FC236}">
-                <a16:creationId xmlns:a16="http://schemas.microsoft.com/office/drawing/2014/main" id="{74632E26-C66E-4CD0-99A8-F6E1A45FF39C}"/>
+                <a16:creationId xmlns:a16="http://schemas.microsoft.com/office/drawing/2014/main" id="{99457EF7-FBC6-4D00-9A72-9B93EDFD7EEA}"/>
               </a:ext>
             </a:extLst>
           </p:cNvPr>
@@ -6280,7 +6280,7 @@
           <p:cNvPr id="37" name="Google Shape;37;p18">
             <a:extLst xmlns:a="http://schemas.openxmlformats.org/drawingml/2006/main">
               <a:ext uri="{FF2B5EF4-FFF2-40B4-BE49-F238E27FC236}">
-                <a16:creationId xmlns:a16="http://schemas.microsoft.com/office/drawing/2014/main" id="{46BB8197-53BB-4CBE-AB93-602D3B14A989}"/>
+                <a16:creationId xmlns:a16="http://schemas.microsoft.com/office/drawing/2014/main" id="{CEA49C5D-3C00-45D1-9F51-5B90A343EEAB}"/>
               </a:ext>
             </a:extLst>
           </p:cNvPr>
@@ -6471,7 +6471,7 @@
           <p:cNvPr id="38" name="Google Shape;38;p18">
             <a:extLst xmlns:a="http://schemas.openxmlformats.org/drawingml/2006/main">
               <a:ext uri="{FF2B5EF4-FFF2-40B4-BE49-F238E27FC236}">
-                <a16:creationId xmlns:a16="http://schemas.microsoft.com/office/drawing/2014/main" id="{C029850C-8003-4FC1-93BB-7006B7BC17E2}"/>
+                <a16:creationId xmlns:a16="http://schemas.microsoft.com/office/drawing/2014/main" id="{36EF4537-9D6B-40FA-8791-A21167CD008C}"/>
               </a:ext>
             </a:extLst>
           </p:cNvPr>
@@ -6608,7 +6608,7 @@
           <p:cNvPr id="39" name="Google Shape;39;p18">
             <a:extLst xmlns:a="http://schemas.openxmlformats.org/drawingml/2006/main">
               <a:ext uri="{FF2B5EF4-FFF2-40B4-BE49-F238E27FC236}">
-                <a16:creationId xmlns:a16="http://schemas.microsoft.com/office/drawing/2014/main" id="{00A85900-1D43-4E0B-8A7B-29BAFBD726FC}"/>
+                <a16:creationId xmlns:a16="http://schemas.microsoft.com/office/drawing/2014/main" id="{70A5FC39-A269-43CD-8C0F-D380AE940558}"/>
               </a:ext>
             </a:extLst>
           </p:cNvPr>
@@ -6745,7 +6745,7 @@
           <p:cNvPr id="40" name="Google Shape;40;p18">
             <a:extLst xmlns:a="http://schemas.openxmlformats.org/drawingml/2006/main">
               <a:ext uri="{FF2B5EF4-FFF2-40B4-BE49-F238E27FC236}">
-                <a16:creationId xmlns:a16="http://schemas.microsoft.com/office/drawing/2014/main" id="{63311EBF-2C77-4431-8B8C-2D66624E618E}"/>
+                <a16:creationId xmlns:a16="http://schemas.microsoft.com/office/drawing/2014/main" id="{7DB794F9-C973-4929-B38C-1F1E3AD64FAC}"/>
               </a:ext>
             </a:extLst>
           </p:cNvPr>
@@ -6877,7 +6877,7 @@
           <p:cNvPr id="42" name="Google Shape;42;p19">
             <a:extLst xmlns:a="http://schemas.openxmlformats.org/drawingml/2006/main">
               <a:ext uri="{FF2B5EF4-FFF2-40B4-BE49-F238E27FC236}">
-                <a16:creationId xmlns:a16="http://schemas.microsoft.com/office/drawing/2014/main" id="{94C44160-FD4E-4B46-A442-364231CCCD58}"/>
+                <a16:creationId xmlns:a16="http://schemas.microsoft.com/office/drawing/2014/main" id="{72260F78-53B9-4D34-B547-1ACA5914E50A}"/>
               </a:ext>
             </a:extLst>
           </p:cNvPr>
@@ -7020,7 +7020,7 @@
           <p:cNvPr id="43" name="Google Shape;43;p19">
             <a:extLst xmlns:a="http://schemas.openxmlformats.org/drawingml/2006/main">
               <a:ext uri="{FF2B5EF4-FFF2-40B4-BE49-F238E27FC236}">
-                <a16:creationId xmlns:a16="http://schemas.microsoft.com/office/drawing/2014/main" id="{B3865CED-714E-4433-BA25-259E0ACFA05D}"/>
+                <a16:creationId xmlns:a16="http://schemas.microsoft.com/office/drawing/2014/main" id="{326AAFDE-1A85-45B5-B0BD-B6365EDA44C2}"/>
               </a:ext>
             </a:extLst>
           </p:cNvPr>
@@ -7211,7 +7211,7 @@
           <p:cNvPr id="44" name="Google Shape;44;p19">
             <a:extLst xmlns:a="http://schemas.openxmlformats.org/drawingml/2006/main">
               <a:ext uri="{FF2B5EF4-FFF2-40B4-BE49-F238E27FC236}">
-                <a16:creationId xmlns:a16="http://schemas.microsoft.com/office/drawing/2014/main" id="{A37163D6-39A1-4ED7-9C36-A7722D4203C2}"/>
+                <a16:creationId xmlns:a16="http://schemas.microsoft.com/office/drawing/2014/main" id="{F35FF449-F5FE-4B18-870F-936DB3736B0E}"/>
               </a:ext>
             </a:extLst>
           </p:cNvPr>
@@ -7402,7 +7402,7 @@
           <p:cNvPr id="45" name="Google Shape;45;p19">
             <a:extLst xmlns:a="http://schemas.openxmlformats.org/drawingml/2006/main">
               <a:ext uri="{FF2B5EF4-FFF2-40B4-BE49-F238E27FC236}">
-                <a16:creationId xmlns:a16="http://schemas.microsoft.com/office/drawing/2014/main" id="{FCE540D2-9B5F-43F9-8309-09F25DE84CB4}"/>
+                <a16:creationId xmlns:a16="http://schemas.microsoft.com/office/drawing/2014/main" id="{E681E301-F66D-431F-9D98-E5522BB188E9}"/>
               </a:ext>
             </a:extLst>
           </p:cNvPr>
@@ -7593,7 +7593,7 @@
           <p:cNvPr id="46" name="Google Shape;46;p19">
             <a:extLst xmlns:a="http://schemas.openxmlformats.org/drawingml/2006/main">
               <a:ext uri="{FF2B5EF4-FFF2-40B4-BE49-F238E27FC236}">
-                <a16:creationId xmlns:a16="http://schemas.microsoft.com/office/drawing/2014/main" id="{6883717C-D82E-497D-AB66-B37E74EBAFFC}"/>
+                <a16:creationId xmlns:a16="http://schemas.microsoft.com/office/drawing/2014/main" id="{4726D11B-896F-4F02-8EB9-20F06C9862A4}"/>
               </a:ext>
             </a:extLst>
           </p:cNvPr>
@@ -7784,7 +7784,7 @@
           <p:cNvPr id="47" name="Google Shape;47;p19">
             <a:extLst xmlns:a="http://schemas.openxmlformats.org/drawingml/2006/main">
               <a:ext uri="{FF2B5EF4-FFF2-40B4-BE49-F238E27FC236}">
-                <a16:creationId xmlns:a16="http://schemas.microsoft.com/office/drawing/2014/main" id="{AC6A0DAB-2ED6-4BCF-BA8E-2498F4716F55}"/>
+                <a16:creationId xmlns:a16="http://schemas.microsoft.com/office/drawing/2014/main" id="{04B0D013-6F46-40E4-8C31-6DA4E740AFFA}"/>
               </a:ext>
             </a:extLst>
           </p:cNvPr>
@@ -7921,7 +7921,7 @@
           <p:cNvPr id="48" name="Google Shape;48;p19">
             <a:extLst xmlns:a="http://schemas.openxmlformats.org/drawingml/2006/main">
               <a:ext uri="{FF2B5EF4-FFF2-40B4-BE49-F238E27FC236}">
-                <a16:creationId xmlns:a16="http://schemas.microsoft.com/office/drawing/2014/main" id="{3EEB9320-E616-4A17-831F-6520853B3B3C}"/>
+                <a16:creationId xmlns:a16="http://schemas.microsoft.com/office/drawing/2014/main" id="{4C96E315-8E80-497D-B916-64A4FE8FFD8A}"/>
               </a:ext>
             </a:extLst>
           </p:cNvPr>
@@ -8058,7 +8058,7 @@
           <p:cNvPr id="49" name="Google Shape;49;p19">
             <a:extLst xmlns:a="http://schemas.openxmlformats.org/drawingml/2006/main">
               <a:ext uri="{FF2B5EF4-FFF2-40B4-BE49-F238E27FC236}">
-                <a16:creationId xmlns:a16="http://schemas.microsoft.com/office/drawing/2014/main" id="{2D735A49-0D2A-44E2-9D36-016A86CA349E}"/>
+                <a16:creationId xmlns:a16="http://schemas.microsoft.com/office/drawing/2014/main" id="{D695BC4C-8733-4FC3-9FD5-07BF27E236D2}"/>
               </a:ext>
             </a:extLst>
           </p:cNvPr>
@@ -8190,7 +8190,7 @@
           <p:cNvPr id="51" name="Google Shape;51;p20">
             <a:extLst xmlns:a="http://schemas.openxmlformats.org/drawingml/2006/main">
               <a:ext uri="{FF2B5EF4-FFF2-40B4-BE49-F238E27FC236}">
-                <a16:creationId xmlns:a16="http://schemas.microsoft.com/office/drawing/2014/main" id="{CB22EAF9-F46E-4F78-BC9A-833724C49473}"/>
+                <a16:creationId xmlns:a16="http://schemas.microsoft.com/office/drawing/2014/main" id="{9AF3A207-8F1B-4022-A860-7B717A2D65DA}"/>
               </a:ext>
             </a:extLst>
           </p:cNvPr>
@@ -8333,7 +8333,7 @@
           <p:cNvPr id="52" name="Google Shape;52;p20">
             <a:extLst xmlns:a="http://schemas.openxmlformats.org/drawingml/2006/main">
               <a:ext uri="{FF2B5EF4-FFF2-40B4-BE49-F238E27FC236}">
-                <a16:creationId xmlns:a16="http://schemas.microsoft.com/office/drawing/2014/main" id="{9114CF3F-627E-4D20-9242-A0A7A884CC39}"/>
+                <a16:creationId xmlns:a16="http://schemas.microsoft.com/office/drawing/2014/main" id="{BDCC50B3-A10E-4F0B-BB3C-266D26EC0833}"/>
               </a:ext>
             </a:extLst>
           </p:cNvPr>
@@ -8470,7 +8470,7 @@
           <p:cNvPr id="53" name="Google Shape;53;p20">
             <a:extLst xmlns:a="http://schemas.openxmlformats.org/drawingml/2006/main">
               <a:ext uri="{FF2B5EF4-FFF2-40B4-BE49-F238E27FC236}">
-                <a16:creationId xmlns:a16="http://schemas.microsoft.com/office/drawing/2014/main" id="{214DE86D-BF0F-45E5-943F-1F03FB10D6AC}"/>
+                <a16:creationId xmlns:a16="http://schemas.microsoft.com/office/drawing/2014/main" id="{4595313A-2E2B-411C-BEBE-A54022BC7384}"/>
               </a:ext>
             </a:extLst>
           </p:cNvPr>
@@ -8607,7 +8607,7 @@
           <p:cNvPr id="54" name="Google Shape;54;p20">
             <a:extLst xmlns:a="http://schemas.openxmlformats.org/drawingml/2006/main">
               <a:ext uri="{FF2B5EF4-FFF2-40B4-BE49-F238E27FC236}">
-                <a16:creationId xmlns:a16="http://schemas.microsoft.com/office/drawing/2014/main" id="{44771E20-B886-49DA-B9A7-23D3E2BC18E9}"/>
+                <a16:creationId xmlns:a16="http://schemas.microsoft.com/office/drawing/2014/main" id="{20E008DA-8AAF-4CE4-A7FB-75D01D608675}"/>
               </a:ext>
             </a:extLst>
           </p:cNvPr>
@@ -8739,7 +8739,7 @@
           <p:cNvPr id="56" name="Google Shape;56;p21">
             <a:extLst xmlns:a="http://schemas.openxmlformats.org/drawingml/2006/main">
               <a:ext uri="{FF2B5EF4-FFF2-40B4-BE49-F238E27FC236}">
-                <a16:creationId xmlns:a16="http://schemas.microsoft.com/office/drawing/2014/main" id="{F78942A6-082B-42FD-A633-4ADB6C74B130}"/>
+                <a16:creationId xmlns:a16="http://schemas.microsoft.com/office/drawing/2014/main" id="{987335C5-84E6-4E18-AD96-A3F3FF5A541E}"/>
               </a:ext>
             </a:extLst>
           </p:cNvPr>
@@ -8876,7 +8876,7 @@
           <p:cNvPr id="57" name="Google Shape;57;p21">
             <a:extLst xmlns:a="http://schemas.openxmlformats.org/drawingml/2006/main">
               <a:ext uri="{FF2B5EF4-FFF2-40B4-BE49-F238E27FC236}">
-                <a16:creationId xmlns:a16="http://schemas.microsoft.com/office/drawing/2014/main" id="{5D0105D5-9D22-4252-860D-7A82CE91781D}"/>
+                <a16:creationId xmlns:a16="http://schemas.microsoft.com/office/drawing/2014/main" id="{69484FB6-9D36-4D87-956C-A6D439B0416F}"/>
               </a:ext>
             </a:extLst>
           </p:cNvPr>
@@ -9013,7 +9013,7 @@
           <p:cNvPr id="58" name="Google Shape;58;p21">
             <a:extLst xmlns:a="http://schemas.openxmlformats.org/drawingml/2006/main">
               <a:ext uri="{FF2B5EF4-FFF2-40B4-BE49-F238E27FC236}">
-                <a16:creationId xmlns:a16="http://schemas.microsoft.com/office/drawing/2014/main" id="{5F5E747A-C17C-492C-AAC9-AB9F6E9044AC}"/>
+                <a16:creationId xmlns:a16="http://schemas.microsoft.com/office/drawing/2014/main" id="{2CA77C51-3332-495A-9444-85126A73F54E}"/>
               </a:ext>
             </a:extLst>
           </p:cNvPr>
@@ -9145,7 +9145,7 @@
           <p:cNvPr id="60" name="Google Shape;60;p22">
             <a:extLst xmlns:a="http://schemas.openxmlformats.org/drawingml/2006/main">
               <a:ext uri="{FF2B5EF4-FFF2-40B4-BE49-F238E27FC236}">
-                <a16:creationId xmlns:a16="http://schemas.microsoft.com/office/drawing/2014/main" id="{C65A8DDC-5507-4F80-A3E5-A04684E88650}"/>
+                <a16:creationId xmlns:a16="http://schemas.microsoft.com/office/drawing/2014/main" id="{276B1735-16B1-4FD6-815A-FF473FDA275E}"/>
               </a:ext>
             </a:extLst>
           </p:cNvPr>
@@ -9289,7 +9289,7 @@
           <p:cNvPr id="61" name="Google Shape;61;p22">
             <a:extLst xmlns:a="http://schemas.openxmlformats.org/drawingml/2006/main">
               <a:ext uri="{FF2B5EF4-FFF2-40B4-BE49-F238E27FC236}">
-                <a16:creationId xmlns:a16="http://schemas.microsoft.com/office/drawing/2014/main" id="{18B7ADC1-F126-4768-A2F8-B55A89658E04}"/>
+                <a16:creationId xmlns:a16="http://schemas.microsoft.com/office/drawing/2014/main" id="{E620926F-99C2-4892-AA45-E8968FABF7F9}"/>
               </a:ext>
             </a:extLst>
           </p:cNvPr>
@@ -9480,7 +9480,7 @@
           <p:cNvPr id="62" name="Google Shape;62;p22">
             <a:extLst xmlns:a="http://schemas.openxmlformats.org/drawingml/2006/main">
               <a:ext uri="{FF2B5EF4-FFF2-40B4-BE49-F238E27FC236}">
-                <a16:creationId xmlns:a16="http://schemas.microsoft.com/office/drawing/2014/main" id="{CF6596C2-CA3D-4BC0-9F93-DC16A7689220}"/>
+                <a16:creationId xmlns:a16="http://schemas.microsoft.com/office/drawing/2014/main" id="{DF851E49-6D11-4F68-AD43-F633615E3438}"/>
               </a:ext>
             </a:extLst>
           </p:cNvPr>
@@ -9671,7 +9671,7 @@
           <p:cNvPr id="63" name="Google Shape;63;p22">
             <a:extLst xmlns:a="http://schemas.openxmlformats.org/drawingml/2006/main">
               <a:ext uri="{FF2B5EF4-FFF2-40B4-BE49-F238E27FC236}">
-                <a16:creationId xmlns:a16="http://schemas.microsoft.com/office/drawing/2014/main" id="{4F27B369-12E0-4DF3-9ADD-8F5F80BBA85E}"/>
+                <a16:creationId xmlns:a16="http://schemas.microsoft.com/office/drawing/2014/main" id="{8E760144-FAFF-41C4-850A-676FEEE570CD}"/>
               </a:ext>
             </a:extLst>
           </p:cNvPr>
@@ -9808,7 +9808,7 @@
           <p:cNvPr id="64" name="Google Shape;64;p22">
             <a:extLst xmlns:a="http://schemas.openxmlformats.org/drawingml/2006/main">
               <a:ext uri="{FF2B5EF4-FFF2-40B4-BE49-F238E27FC236}">
-                <a16:creationId xmlns:a16="http://schemas.microsoft.com/office/drawing/2014/main" id="{2B865159-D239-4455-908C-6C30B37A81C8}"/>
+                <a16:creationId xmlns:a16="http://schemas.microsoft.com/office/drawing/2014/main" id="{32A64C0B-BBEA-437C-88F3-A2F8829BD9BD}"/>
               </a:ext>
             </a:extLst>
           </p:cNvPr>
@@ -9945,7 +9945,7 @@
           <p:cNvPr id="65" name="Google Shape;65;p22">
             <a:extLst xmlns:a="http://schemas.openxmlformats.org/drawingml/2006/main">
               <a:ext uri="{FF2B5EF4-FFF2-40B4-BE49-F238E27FC236}">
-                <a16:creationId xmlns:a16="http://schemas.microsoft.com/office/drawing/2014/main" id="{AE9252D7-52BD-4DAD-9D92-7B83B34E4F27}"/>
+                <a16:creationId xmlns:a16="http://schemas.microsoft.com/office/drawing/2014/main" id="{A798C5B1-06F0-48CA-A058-6B5518246086}"/>
               </a:ext>
             </a:extLst>
           </p:cNvPr>
@@ -10084,7 +10084,7 @@
           <p:cNvPr id="10" name="Google Shape;10;p13">
             <a:extLst xmlns:a="http://schemas.openxmlformats.org/drawingml/2006/main">
               <a:ext uri="{FF2B5EF4-FFF2-40B4-BE49-F238E27FC236}">
-                <a16:creationId xmlns:a16="http://schemas.microsoft.com/office/drawing/2014/main" id="{3EACF781-D955-47B2-90A9-E463A6EF2AF6}"/>
+                <a16:creationId xmlns:a16="http://schemas.microsoft.com/office/drawing/2014/main" id="{FD0B5D96-23F2-4F33-98F2-82F6C4DEA34E}"/>
               </a:ext>
             </a:extLst>
           </p:cNvPr>
@@ -10235,7 +10235,7 @@
           <p:cNvPr id="11" name="Google Shape;11;p13">
             <a:extLst xmlns:a="http://schemas.openxmlformats.org/drawingml/2006/main">
               <a:ext uri="{FF2B5EF4-FFF2-40B4-BE49-F238E27FC236}">
-                <a16:creationId xmlns:a16="http://schemas.microsoft.com/office/drawing/2014/main" id="{1FC941B5-BA0D-4740-949E-A953C8481111}"/>
+                <a16:creationId xmlns:a16="http://schemas.microsoft.com/office/drawing/2014/main" id="{6747732C-209F-4683-9560-4B062402D5CF}"/>
               </a:ext>
             </a:extLst>
           </p:cNvPr>
@@ -10498,7 +10498,7 @@
           <p:cNvPr id="12" name="Google Shape;12;p13">
             <a:extLst xmlns:a="http://schemas.openxmlformats.org/drawingml/2006/main">
               <a:ext uri="{FF2B5EF4-FFF2-40B4-BE49-F238E27FC236}">
-                <a16:creationId xmlns:a16="http://schemas.microsoft.com/office/drawing/2014/main" id="{F9F5D3E5-F34C-4714-939A-9C9195155244}"/>
+                <a16:creationId xmlns:a16="http://schemas.microsoft.com/office/drawing/2014/main" id="{28622E4B-8E89-4A89-A702-9A97D0E03777}"/>
               </a:ext>
             </a:extLst>
           </p:cNvPr>
@@ -10698,7 +10698,7 @@
           <p:cNvPr id="13" name="Google Shape;13;p13">
             <a:extLst xmlns:a="http://schemas.openxmlformats.org/drawingml/2006/main">
               <a:ext uri="{FF2B5EF4-FFF2-40B4-BE49-F238E27FC236}">
-                <a16:creationId xmlns:a16="http://schemas.microsoft.com/office/drawing/2014/main" id="{425F991D-EC8D-4B5E-BA53-05CADAB4D914}"/>
+                <a16:creationId xmlns:a16="http://schemas.microsoft.com/office/drawing/2014/main" id="{95388E3E-C63F-4F8A-9D7D-BA3FEACCFAFC}"/>
               </a:ext>
             </a:extLst>
           </p:cNvPr>
@@ -10898,7 +10898,7 @@
           <p:cNvPr id="14" name="Google Shape;14;p13">
             <a:extLst xmlns:a="http://schemas.openxmlformats.org/drawingml/2006/main">
               <a:ext uri="{FF2B5EF4-FFF2-40B4-BE49-F238E27FC236}">
-                <a16:creationId xmlns:a16="http://schemas.microsoft.com/office/drawing/2014/main" id="{3293C919-617A-4953-8954-25D0506470FC}"/>
+                <a16:creationId xmlns:a16="http://schemas.microsoft.com/office/drawing/2014/main" id="{EF4749A7-D91E-4490-BB65-B84D1BE7A914}"/>
               </a:ext>
             </a:extLst>
           </p:cNvPr>
@@ -11075,18 +11075,18 @@
   </p:cSld>
   <p:clrMap bg1="lt1" tx1="dk1" bg2="dk2" tx2="lt2" accent1="accent1" accent2="accent2" accent3="accent3" accent4="accent4" accent5="accent5" accent6="accent6" hlink="hlink" folHlink="folHlink"/>
   <p:sldLayoutIdLst>
-    <p:sldLayoutId xmlns:r="http://schemas.openxmlformats.org/officeDocument/2006/relationships" id="2147483649" r:id="R91fd58ae6bed456e"/>
-    <p:sldLayoutId xmlns:r="http://schemas.openxmlformats.org/officeDocument/2006/relationships" id="2147483650" r:id="R34669c183a2b4f57"/>
-    <p:sldLayoutId xmlns:r="http://schemas.openxmlformats.org/officeDocument/2006/relationships" id="2147483651" r:id="Rc87b540fae5a4598"/>
-    <p:sldLayoutId xmlns:r="http://schemas.openxmlformats.org/officeDocument/2006/relationships" id="2147483652" r:id="R9b7e1199d5364790"/>
-    <p:sldLayoutId xmlns:r="http://schemas.openxmlformats.org/officeDocument/2006/relationships" id="2147483653" r:id="R786bea8737d4468d"/>
-    <p:sldLayoutId xmlns:r="http://schemas.openxmlformats.org/officeDocument/2006/relationships" id="2147483654" r:id="Rf94301ea366f4a01"/>
-    <p:sldLayoutId xmlns:r="http://schemas.openxmlformats.org/officeDocument/2006/relationships" id="2147483655" r:id="Rb4f75e1278c64a0a"/>
-    <p:sldLayoutId xmlns:r="http://schemas.openxmlformats.org/officeDocument/2006/relationships" id="2147483656" r:id="R6e6dbc1891b7410d"/>
-    <p:sldLayoutId xmlns:r="http://schemas.openxmlformats.org/officeDocument/2006/relationships" id="2147483657" r:id="Rb3ab104384044dfe"/>
-    <p:sldLayoutId xmlns:r="http://schemas.openxmlformats.org/officeDocument/2006/relationships" id="2147483658" r:id="R1ceeedf640414902"/>
-    <p:sldLayoutId xmlns:r="http://schemas.openxmlformats.org/officeDocument/2006/relationships" id="2147483659" r:id="Re293db9f739243d8"/>
-    <p:sldLayoutId xmlns:r="http://schemas.openxmlformats.org/officeDocument/2006/relationships" id="2147483660" r:id="R45ee125d300a460e"/>
+    <p:sldLayoutId xmlns:r="http://schemas.openxmlformats.org/officeDocument/2006/relationships" id="2147483649" r:id="R0f3b85a93bc54aa7"/>
+    <p:sldLayoutId xmlns:r="http://schemas.openxmlformats.org/officeDocument/2006/relationships" id="2147483650" r:id="Rd691f7f5f4a34540"/>
+    <p:sldLayoutId xmlns:r="http://schemas.openxmlformats.org/officeDocument/2006/relationships" id="2147483651" r:id="R785afac91a494ae7"/>
+    <p:sldLayoutId xmlns:r="http://schemas.openxmlformats.org/officeDocument/2006/relationships" id="2147483652" r:id="R96fe60d8cd0d45f2"/>
+    <p:sldLayoutId xmlns:r="http://schemas.openxmlformats.org/officeDocument/2006/relationships" id="2147483653" r:id="Rd6d73571b42b4a9d"/>
+    <p:sldLayoutId xmlns:r="http://schemas.openxmlformats.org/officeDocument/2006/relationships" id="2147483654" r:id="Rb85cb50498d54cfe"/>
+    <p:sldLayoutId xmlns:r="http://schemas.openxmlformats.org/officeDocument/2006/relationships" id="2147483655" r:id="R07f52cc1932442ea"/>
+    <p:sldLayoutId xmlns:r="http://schemas.openxmlformats.org/officeDocument/2006/relationships" id="2147483656" r:id="Re1e708f7c2344535"/>
+    <p:sldLayoutId xmlns:r="http://schemas.openxmlformats.org/officeDocument/2006/relationships" id="2147483657" r:id="R765696490546487d"/>
+    <p:sldLayoutId xmlns:r="http://schemas.openxmlformats.org/officeDocument/2006/relationships" id="2147483658" r:id="Raa8bb80050da4c09"/>
+    <p:sldLayoutId xmlns:r="http://schemas.openxmlformats.org/officeDocument/2006/relationships" id="2147483659" r:id="R8afa67c270384915"/>
+    <p:sldLayoutId xmlns:r="http://schemas.openxmlformats.org/officeDocument/2006/relationships" id="2147483660" r:id="R937b4e0b2d144953"/>
   </p:sldLayoutIdLst>
   <p:hf sldNum="0" hdr="0" ftr="0" dt="0"/>
   <p:txStyles>
@@ -12033,7 +12033,7 @@
           <p:cNvPr id="90" name="Google Shape;90;p1">
             <a:extLst xmlns:a="http://schemas.openxmlformats.org/drawingml/2006/main">
               <a:ext uri="{FF2B5EF4-FFF2-40B4-BE49-F238E27FC236}">
-                <a16:creationId xmlns:a16="http://schemas.microsoft.com/office/drawing/2014/main" id="{A687C5F4-535E-4CA7-B08A-57A6F9236CDC}"/>
+                <a16:creationId xmlns:a16="http://schemas.microsoft.com/office/drawing/2014/main" id="{56E129EB-825B-414C-A6A9-1133EC29C81E}"/>
               </a:ext>
             </a:extLst>
           </p:cNvPr>
@@ -12091,7 +12091,7 @@
           <p:cNvPr id="91" name="Google Shape;91;p1">
             <a:extLst xmlns:a="http://schemas.openxmlformats.org/drawingml/2006/main">
               <a:ext uri="{FF2B5EF4-FFF2-40B4-BE49-F238E27FC236}">
-                <a16:creationId xmlns:a16="http://schemas.microsoft.com/office/drawing/2014/main" id="{39FC2766-6EC0-4320-98A8-8889F470FE89}"/>
+                <a16:creationId xmlns:a16="http://schemas.microsoft.com/office/drawing/2014/main" id="{1BA2AED4-0785-4241-BA22-1189B788DF96}"/>
               </a:ext>
             </a:extLst>
           </p:cNvPr>
@@ -12160,7 +12160,7 @@
           <p:cNvPr id="92" name="Google Shape;92;p1">
             <a:extLst xmlns:a="http://schemas.openxmlformats.org/drawingml/2006/main">
               <a:ext uri="{FF2B5EF4-FFF2-40B4-BE49-F238E27FC236}">
-                <a16:creationId xmlns:a16="http://schemas.microsoft.com/office/drawing/2014/main" id="{25F4E2FF-6711-4543-B588-F1D0E28A7117}"/>
+                <a16:creationId xmlns:a16="http://schemas.microsoft.com/office/drawing/2014/main" id="{A2AA3147-1585-45BB-9FC7-2F6C6CB60193}"/>
               </a:ext>
             </a:extLst>
           </p:cNvPr>
@@ -12229,7 +12229,7 @@
           <p:cNvPr id="93" name="Google Shape;93;p1">
             <a:extLst xmlns:a="http://schemas.openxmlformats.org/drawingml/2006/main">
               <a:ext uri="{FF2B5EF4-FFF2-40B4-BE49-F238E27FC236}">
-                <a16:creationId xmlns:a16="http://schemas.microsoft.com/office/drawing/2014/main" id="{AB1A8317-3FCD-4B36-ABBE-4C1C4009B4A2}"/>
+                <a16:creationId xmlns:a16="http://schemas.microsoft.com/office/drawing/2014/main" id="{0495331C-35BE-4D0C-9DAD-C8421AC7EE8E}"/>
               </a:ext>
             </a:extLst>
           </p:cNvPr>
@@ -12298,7 +12298,7 @@
           <p:cNvPr id="94" name="Google Shape;94;p1">
             <a:extLst xmlns:a="http://schemas.openxmlformats.org/drawingml/2006/main">
               <a:ext uri="{FF2B5EF4-FFF2-40B4-BE49-F238E27FC236}">
-                <a16:creationId xmlns:a16="http://schemas.microsoft.com/office/drawing/2014/main" id="{66F6D078-9F79-4EE1-A1CD-092816916782}"/>
+                <a16:creationId xmlns:a16="http://schemas.microsoft.com/office/drawing/2014/main" id="{69794424-9ABB-4EA4-B0FA-98A87518F70D}"/>
               </a:ext>
             </a:extLst>
           </p:cNvPr>
@@ -12378,7 +12378,7 @@
           <p:cNvPr id="95" name="Google Shape;95;p1">
             <a:extLst xmlns:a="http://schemas.openxmlformats.org/drawingml/2006/main">
               <a:ext uri="{FF2B5EF4-FFF2-40B4-BE49-F238E27FC236}">
-                <a16:creationId xmlns:a16="http://schemas.microsoft.com/office/drawing/2014/main" id="{6438AEC7-4C3E-4D05-902B-6E903CF2603B}"/>
+                <a16:creationId xmlns:a16="http://schemas.microsoft.com/office/drawing/2014/main" id="{7E5389DF-CA7B-4097-93A6-C271A8FF3C5D}"/>
               </a:ext>
             </a:extLst>
           </p:cNvPr>
@@ -12668,7 +12668,7 @@
           <p:nvPr/>
         </p:nvPicPr>
         <p:blipFill rotWithShape="1">
-          <a:blip xmlns:r="http://schemas.openxmlformats.org/officeDocument/2006/relationships" xmlns:a="http://schemas.openxmlformats.org/drawingml/2006/main" r:embed="R2e6640a829964485">
+          <a:blip xmlns:r="http://schemas.openxmlformats.org/officeDocument/2006/relationships" xmlns:a="http://schemas.openxmlformats.org/drawingml/2006/main" r:embed="R7fffe6e54bd24135">
             <a:alphaModFix/>
           </a:blip>
           <a:srcRect xmlns:a="http://schemas.openxmlformats.org/drawingml/2006/main" l="0" t="0" r="0" b="0"/>
@@ -12692,7 +12692,7 @@
           <p:cNvPr id="97" name="">
             <a:extLst xmlns:a="http://schemas.openxmlformats.org/drawingml/2006/main">
               <a:ext uri="{FF2B5EF4-FFF2-40B4-BE49-F238E27FC236}">
-                <a16:creationId xmlns:a16="http://schemas.microsoft.com/office/drawing/2014/main" id="{2B4837BB-7C06-4ECC-B829-EF46D1D9B11E}"/>
+                <a16:creationId xmlns:a16="http://schemas.microsoft.com/office/drawing/2014/main" id="{F14FC5A3-9539-4F59-BCA6-D7E1080B40DA}"/>
               </a:ext>
             </a:extLst>
           </p:cNvPr>
@@ -12735,7 +12735,7 @@
                 <a:solidFill>
                   <a:srgbClr val="70509B"/>
                 </a:solidFill>
-                <a:hlinkClick xmlns:r="http://schemas.openxmlformats.org/officeDocument/2006/relationships" r:id="Rde4dfb3ae74148e8"/>
+                <a:hlinkClick xmlns:r="http://schemas.openxmlformats.org/officeDocument/2006/relationships" r:id="Ra248d4b428bf4177"/>
               </a:rPr>
               <a:t>Submission GitHub: CodeDoctor repository</a:t>
             </a:r>
@@ -12745,7 +12745,7 @@
     </p:spTree>
     <p:extLst>
       <p:ext uri="{BB962C8B-B14F-4D97-AF65-F5344CB8AC3E}">
-        <p14:creationId xmlns:p14="http://schemas.microsoft.com/office/powerpoint/2010/main" val="1237155332"/>
+        <p14:creationId xmlns:p14="http://schemas.microsoft.com/office/powerpoint/2010/main" val="1856196454"/>
       </p:ext>
     </p:extLst>
   </p:cSld>
@@ -12769,7 +12769,7 @@
           <p:cNvPr id="149" name="Google Shape;149;p10">
             <a:extLst xmlns:a="http://schemas.openxmlformats.org/drawingml/2006/main">
               <a:ext uri="{FF2B5EF4-FFF2-40B4-BE49-F238E27FC236}">
-                <a16:creationId xmlns:a16="http://schemas.microsoft.com/office/drawing/2014/main" id="{9B39EC1D-000E-4C9A-BD4C-3D976E6705CF}"/>
+                <a16:creationId xmlns:a16="http://schemas.microsoft.com/office/drawing/2014/main" id="{1B130D28-8579-4DC4-8738-2567EE4B9C27}"/>
               </a:ext>
             </a:extLst>
           </p:cNvPr>
@@ -12840,7 +12840,7 @@
           <p:cNvPr id="150" name="Google Shape;150;p10">
             <a:extLst xmlns:a="http://schemas.openxmlformats.org/drawingml/2006/main">
               <a:ext uri="{FF2B5EF4-FFF2-40B4-BE49-F238E27FC236}">
-                <a16:creationId xmlns:a16="http://schemas.microsoft.com/office/drawing/2014/main" id="{D4F42633-11D4-416B-A3B6-7AB3F8F192CD}"/>
+                <a16:creationId xmlns:a16="http://schemas.microsoft.com/office/drawing/2014/main" id="{A805DDF1-28D7-4E2C-BC1D-411D99ADFFE2}"/>
               </a:ext>
             </a:extLst>
           </p:cNvPr>
@@ -13059,7 +13059,7 @@
     </p:spTree>
     <p:extLst>
       <p:ext uri="{BB962C8B-B14F-4D97-AF65-F5344CB8AC3E}">
-        <p14:creationId xmlns:p14="http://schemas.microsoft.com/office/powerpoint/2010/main" val="896200305"/>
+        <p14:creationId xmlns:p14="http://schemas.microsoft.com/office/powerpoint/2010/main" val="1248277690"/>
       </p:ext>
     </p:extLst>
   </p:cSld>
@@ -13083,7 +13083,7 @@
           <p:cNvPr id="155" name="Google Shape;155;p11">
             <a:extLst xmlns:a="http://schemas.openxmlformats.org/drawingml/2006/main">
               <a:ext uri="{FF2B5EF4-FFF2-40B4-BE49-F238E27FC236}">
-                <a16:creationId xmlns:a16="http://schemas.microsoft.com/office/drawing/2014/main" id="{11EB2487-5AA5-4171-A44D-E590D1F0C6F8}"/>
+                <a16:creationId xmlns:a16="http://schemas.microsoft.com/office/drawing/2014/main" id="{260B98E6-1A84-4DC5-A86E-563433B1CA84}"/>
               </a:ext>
             </a:extLst>
           </p:cNvPr>
@@ -13150,7 +13150,7 @@
           <p:cNvPr id="156" name="Google Shape;156;p11">
             <a:extLst xmlns:a="http://schemas.openxmlformats.org/drawingml/2006/main">
               <a:ext uri="{FF2B5EF4-FFF2-40B4-BE49-F238E27FC236}">
-                <a16:creationId xmlns:a16="http://schemas.microsoft.com/office/drawing/2014/main" id="{2595E60F-FD95-446F-B908-33EDE80F7A8E}"/>
+                <a16:creationId xmlns:a16="http://schemas.microsoft.com/office/drawing/2014/main" id="{5D24E8F1-8B77-4563-B7ED-4F9CD3C42C6D}"/>
               </a:ext>
             </a:extLst>
           </p:cNvPr>
@@ -13361,7 +13361,7 @@
                 <a:ea typeface="Arial"/>
                 <a:cs typeface="Arial"/>
               </a:rPr>
-              <a:t>5-minute product walkthrough video recorded and linked in README.md and release assets.</a:t>
+              <a:t>5-minute product walkthrough video recorded: https://youtu.be/0k2UUJOp-Tc (linked in README.md &amp; release assets).</a:t>
             </a:r>
           </a:p>
         </p:txBody>
@@ -13369,7 +13369,7 @@
     </p:spTree>
     <p:extLst>
       <p:ext uri="{BB962C8B-B14F-4D97-AF65-F5344CB8AC3E}">
-        <p14:creationId xmlns:p14="http://schemas.microsoft.com/office/powerpoint/2010/main" val="1820243694"/>
+        <p14:creationId xmlns:p14="http://schemas.microsoft.com/office/powerpoint/2010/main" val="1563985115"/>
       </p:ext>
     </p:extLst>
   </p:cSld>
@@ -13393,7 +13393,7 @@
           <p:cNvPr id="162" name="Google Shape;162;p12">
             <a:extLst xmlns:a="http://schemas.openxmlformats.org/drawingml/2006/main">
               <a:ext uri="{FF2B5EF4-FFF2-40B4-BE49-F238E27FC236}">
-                <a16:creationId xmlns:a16="http://schemas.microsoft.com/office/drawing/2014/main" id="{58914F63-036C-448A-9FB2-235297CE0A97}"/>
+                <a16:creationId xmlns:a16="http://schemas.microsoft.com/office/drawing/2014/main" id="{30890828-07F0-4BF1-9653-014ED78F1479}"/>
               </a:ext>
             </a:extLst>
           </p:cNvPr>
@@ -13462,7 +13462,7 @@
           <p:cNvPr id="163" name="Google Shape;163;p12">
             <a:extLst xmlns:a="http://schemas.openxmlformats.org/drawingml/2006/main">
               <a:ext uri="{FF2B5EF4-FFF2-40B4-BE49-F238E27FC236}">
-                <a16:creationId xmlns:a16="http://schemas.microsoft.com/office/drawing/2014/main" id="{86DBC99A-BC40-4550-A0AC-B2329893EA70}"/>
+                <a16:creationId xmlns:a16="http://schemas.microsoft.com/office/drawing/2014/main" id="{22564FB1-E31B-49E7-A07D-A9B231D97C1C}"/>
               </a:ext>
             </a:extLst>
           </p:cNvPr>
@@ -13531,7 +13531,7 @@
           <p:cNvPr id="164" name="">
             <a:extLst xmlns:a="http://schemas.openxmlformats.org/drawingml/2006/main">
               <a:ext uri="{FF2B5EF4-FFF2-40B4-BE49-F238E27FC236}">
-                <a16:creationId xmlns:a16="http://schemas.microsoft.com/office/drawing/2014/main" id="{92286B5D-113F-4BD4-8E02-E32006DDBD7A}"/>
+                <a16:creationId xmlns:a16="http://schemas.microsoft.com/office/drawing/2014/main" id="{D82FC1C3-2DB1-4088-A287-0119068D4B23}"/>
               </a:ext>
             </a:extLst>
           </p:cNvPr>
@@ -13586,7 +13586,7 @@
     </p:spTree>
     <p:extLst>
       <p:ext uri="{BB962C8B-B14F-4D97-AF65-F5344CB8AC3E}">
-        <p14:creationId xmlns:p14="http://schemas.microsoft.com/office/powerpoint/2010/main" val="648142494"/>
+        <p14:creationId xmlns:p14="http://schemas.microsoft.com/office/powerpoint/2010/main" val="286322684"/>
       </p:ext>
     </p:extLst>
   </p:cSld>
@@ -13610,7 +13610,7 @@
           <p:cNvPr id="101" name="Google Shape;101;p2">
             <a:extLst xmlns:a="http://schemas.openxmlformats.org/drawingml/2006/main">
               <a:ext uri="{FF2B5EF4-FFF2-40B4-BE49-F238E27FC236}">
-                <a16:creationId xmlns:a16="http://schemas.microsoft.com/office/drawing/2014/main" id="{AE1CBB07-D549-497C-83CF-1A8D621F5DBF}"/>
+                <a16:creationId xmlns:a16="http://schemas.microsoft.com/office/drawing/2014/main" id="{906946D6-33C9-4DA4-AF15-B6A4AEF02929}"/>
               </a:ext>
             </a:extLst>
           </p:cNvPr>
@@ -13677,7 +13677,7 @@
           <p:cNvPr id="102" name="Google Shape;102;p2">
             <a:extLst xmlns:a="http://schemas.openxmlformats.org/drawingml/2006/main">
               <a:ext uri="{FF2B5EF4-FFF2-40B4-BE49-F238E27FC236}">
-                <a16:creationId xmlns:a16="http://schemas.microsoft.com/office/drawing/2014/main" id="{A5C825E2-F0F0-47A9-B08B-662ADCED6361}"/>
+                <a16:creationId xmlns:a16="http://schemas.microsoft.com/office/drawing/2014/main" id="{695E6D77-F8EA-42AB-BD19-CC793DA1BA17}"/>
               </a:ext>
             </a:extLst>
           </p:cNvPr>
@@ -13859,7 +13859,7 @@
     </p:spTree>
     <p:extLst>
       <p:ext uri="{BB962C8B-B14F-4D97-AF65-F5344CB8AC3E}">
-        <p14:creationId xmlns:p14="http://schemas.microsoft.com/office/powerpoint/2010/main" val="1683614955"/>
+        <p14:creationId xmlns:p14="http://schemas.microsoft.com/office/powerpoint/2010/main" val="1908006676"/>
       </p:ext>
     </p:extLst>
   </p:cSld>
@@ -13883,7 +13883,7 @@
           <p:cNvPr id="107" name="Google Shape;107;p3">
             <a:extLst xmlns:a="http://schemas.openxmlformats.org/drawingml/2006/main">
               <a:ext uri="{FF2B5EF4-FFF2-40B4-BE49-F238E27FC236}">
-                <a16:creationId xmlns:a16="http://schemas.microsoft.com/office/drawing/2014/main" id="{DB76C5CF-FE09-4B26-965F-A8FF6F46F8BC}"/>
+                <a16:creationId xmlns:a16="http://schemas.microsoft.com/office/drawing/2014/main" id="{40BD9376-ACAF-4602-9261-C2DB943B67D8}"/>
               </a:ext>
             </a:extLst>
           </p:cNvPr>
@@ -13950,7 +13950,7 @@
           <p:cNvPr id="108" name="Google Shape;108;p3">
             <a:extLst xmlns:a="http://schemas.openxmlformats.org/drawingml/2006/main">
               <a:ext uri="{FF2B5EF4-FFF2-40B4-BE49-F238E27FC236}">
-                <a16:creationId xmlns:a16="http://schemas.microsoft.com/office/drawing/2014/main" id="{CEA9213F-0718-40F1-853C-F5DCD1C41E29}"/>
+                <a16:creationId xmlns:a16="http://schemas.microsoft.com/office/drawing/2014/main" id="{11FFA01D-2E99-4BC0-A1BC-19A0CEBF996A}"/>
               </a:ext>
             </a:extLst>
           </p:cNvPr>
@@ -14132,7 +14132,7 @@
     </p:spTree>
     <p:extLst>
       <p:ext uri="{BB962C8B-B14F-4D97-AF65-F5344CB8AC3E}">
-        <p14:creationId xmlns:p14="http://schemas.microsoft.com/office/powerpoint/2010/main" val="124562840"/>
+        <p14:creationId xmlns:p14="http://schemas.microsoft.com/office/powerpoint/2010/main" val="1705300932"/>
       </p:ext>
     </p:extLst>
   </p:cSld>
@@ -14163,7 +14163,7 @@
           <p:cNvPr id="113" name="Google Shape;113;p4">
             <a:extLst xmlns:a="http://schemas.openxmlformats.org/drawingml/2006/main">
               <a:ext uri="{FF2B5EF4-FFF2-40B4-BE49-F238E27FC236}">
-                <a16:creationId xmlns:a16="http://schemas.microsoft.com/office/drawing/2014/main" id="{D80DAD8B-9C79-4411-98BE-78BDC14F99EB}"/>
+                <a16:creationId xmlns:a16="http://schemas.microsoft.com/office/drawing/2014/main" id="{8D3A3276-15BA-4F0B-94B6-9C41A278EED0}"/>
               </a:ext>
             </a:extLst>
           </p:cNvPr>
@@ -14230,7 +14230,7 @@
           <p:cNvPr id="114" name="Google Shape;114;p4">
             <a:extLst xmlns:a="http://schemas.openxmlformats.org/drawingml/2006/main">
               <a:ext uri="{FF2B5EF4-FFF2-40B4-BE49-F238E27FC236}">
-                <a16:creationId xmlns:a16="http://schemas.microsoft.com/office/drawing/2014/main" id="{47B7F118-EA6C-4F6A-8600-FF3DDBD9E928}"/>
+                <a16:creationId xmlns:a16="http://schemas.microsoft.com/office/drawing/2014/main" id="{2BD0B821-F052-433A-AF2B-45BC0DCDA100}"/>
               </a:ext>
             </a:extLst>
           </p:cNvPr>
@@ -14288,7 +14288,7 @@
           <p:cNvPr id="115" name="">
             <a:extLst xmlns:a="http://schemas.openxmlformats.org/drawingml/2006/main">
               <a:ext uri="{FF2B5EF4-FFF2-40B4-BE49-F238E27FC236}">
-                <a16:creationId xmlns:a16="http://schemas.microsoft.com/office/drawing/2014/main" id="{87EB4BAB-9DA1-461D-8159-553D585D4506}"/>
+                <a16:creationId xmlns:a16="http://schemas.microsoft.com/office/drawing/2014/main" id="{790ABCDF-EC6D-4C34-957F-61DB2E82FD3F}"/>
               </a:ext>
             </a:extLst>
           </p:cNvPr>
@@ -14345,7 +14345,7 @@
           <p:cNvPr id="116" name="">
             <a:extLst xmlns:a="http://schemas.openxmlformats.org/drawingml/2006/main">
               <a:ext uri="{FF2B5EF4-FFF2-40B4-BE49-F238E27FC236}">
-                <a16:creationId xmlns:a16="http://schemas.microsoft.com/office/drawing/2014/main" id="{880EE39A-E794-4CD3-B39C-B6E91899326A}"/>
+                <a16:creationId xmlns:a16="http://schemas.microsoft.com/office/drawing/2014/main" id="{B4B78C98-CEA4-40E1-82CB-97EB95D4E8B3}"/>
               </a:ext>
             </a:extLst>
           </p:cNvPr>
@@ -14386,7 +14386,7 @@
           <p:cNvPr id="117" name="">
             <a:extLst xmlns:a="http://schemas.openxmlformats.org/drawingml/2006/main">
               <a:ext uri="{FF2B5EF4-FFF2-40B4-BE49-F238E27FC236}">
-                <a16:creationId xmlns:a16="http://schemas.microsoft.com/office/drawing/2014/main" id="{30166880-C1F7-4647-B10D-31BF45F37B05}"/>
+                <a16:creationId xmlns:a16="http://schemas.microsoft.com/office/drawing/2014/main" id="{CBF00A3D-7393-4A6F-AE21-A9D48CA161E8}"/>
               </a:ext>
             </a:extLst>
           </p:cNvPr>
@@ -14443,7 +14443,7 @@
           <p:cNvPr id="118" name="">
             <a:extLst xmlns:a="http://schemas.openxmlformats.org/drawingml/2006/main">
               <a:ext uri="{FF2B5EF4-FFF2-40B4-BE49-F238E27FC236}">
-                <a16:creationId xmlns:a16="http://schemas.microsoft.com/office/drawing/2014/main" id="{0CA17A13-FAC1-4E1A-B2CC-43E92D16C2D8}"/>
+                <a16:creationId xmlns:a16="http://schemas.microsoft.com/office/drawing/2014/main" id="{1D21F1B2-8A2A-4A28-A0FF-9CC592BFD374}"/>
               </a:ext>
             </a:extLst>
           </p:cNvPr>
@@ -14592,7 +14592,7 @@
           <p:cNvPr id="119" name="">
             <a:extLst xmlns:a="http://schemas.openxmlformats.org/drawingml/2006/main">
               <a:ext uri="{FF2B5EF4-FFF2-40B4-BE49-F238E27FC236}">
-                <a16:creationId xmlns:a16="http://schemas.microsoft.com/office/drawing/2014/main" id="{280FD6EB-4A0C-447C-BBCD-C584B1009241}"/>
+                <a16:creationId xmlns:a16="http://schemas.microsoft.com/office/drawing/2014/main" id="{F4C168A8-4B35-4575-87BA-BF3ED79C94F4}"/>
               </a:ext>
             </a:extLst>
           </p:cNvPr>
@@ -14633,7 +14633,7 @@
           <p:cNvPr id="120" name="">
             <a:extLst xmlns:a="http://schemas.openxmlformats.org/drawingml/2006/main">
               <a:ext uri="{FF2B5EF4-FFF2-40B4-BE49-F238E27FC236}">
-                <a16:creationId xmlns:a16="http://schemas.microsoft.com/office/drawing/2014/main" id="{1B2EFAA0-EB78-45D2-9920-29E3AFF91BE9}"/>
+                <a16:creationId xmlns:a16="http://schemas.microsoft.com/office/drawing/2014/main" id="{E74AA2FD-A342-4EF9-BDE1-EE8D3F764F89}"/>
               </a:ext>
             </a:extLst>
           </p:cNvPr>
@@ -14690,7 +14690,7 @@
           <p:cNvPr id="121" name="">
             <a:extLst xmlns:a="http://schemas.openxmlformats.org/drawingml/2006/main">
               <a:ext uri="{FF2B5EF4-FFF2-40B4-BE49-F238E27FC236}">
-                <a16:creationId xmlns:a16="http://schemas.microsoft.com/office/drawing/2014/main" id="{7DD9E239-A9EE-45B3-9796-168CD63E5FD1}"/>
+                <a16:creationId xmlns:a16="http://schemas.microsoft.com/office/drawing/2014/main" id="{7B719329-165C-46D4-AB7A-5AD5C4F530E0}"/>
               </a:ext>
             </a:extLst>
           </p:cNvPr>
@@ -14839,7 +14839,7 @@
           <p:cNvPr id="122" name="">
             <a:extLst xmlns:a="http://schemas.openxmlformats.org/drawingml/2006/main">
               <a:ext uri="{FF2B5EF4-FFF2-40B4-BE49-F238E27FC236}">
-                <a16:creationId xmlns:a16="http://schemas.microsoft.com/office/drawing/2014/main" id="{4FCBC6A3-22A0-45AB-8586-70ACCDECE06C}"/>
+                <a16:creationId xmlns:a16="http://schemas.microsoft.com/office/drawing/2014/main" id="{9EE86451-12BC-4E4B-BC96-E7FD97FC72C1}"/>
               </a:ext>
             </a:extLst>
           </p:cNvPr>
@@ -14880,7 +14880,7 @@
           <p:cNvPr id="123" name="">
             <a:extLst xmlns:a="http://schemas.openxmlformats.org/drawingml/2006/main">
               <a:ext uri="{FF2B5EF4-FFF2-40B4-BE49-F238E27FC236}">
-                <a16:creationId xmlns:a16="http://schemas.microsoft.com/office/drawing/2014/main" id="{96359722-46CC-43D3-ADCE-1C1F561BCAA4}"/>
+                <a16:creationId xmlns:a16="http://schemas.microsoft.com/office/drawing/2014/main" id="{AA04CA57-9A5D-4B25-B176-A953EEA20925}"/>
               </a:ext>
             </a:extLst>
           </p:cNvPr>
@@ -14937,7 +14937,7 @@
           <p:cNvPr id="124" name="">
             <a:extLst xmlns:a="http://schemas.openxmlformats.org/drawingml/2006/main">
               <a:ext uri="{FF2B5EF4-FFF2-40B4-BE49-F238E27FC236}">
-                <a16:creationId xmlns:a16="http://schemas.microsoft.com/office/drawing/2014/main" id="{C7FB3521-9126-4CC6-9A05-B5ECF6A3D2FD}"/>
+                <a16:creationId xmlns:a16="http://schemas.microsoft.com/office/drawing/2014/main" id="{1AFD937D-DBA6-4F31-9E55-51695E4E77D4}"/>
               </a:ext>
             </a:extLst>
           </p:cNvPr>
@@ -15086,7 +15086,7 @@
           <p:cNvPr id="125" name="">
             <a:extLst xmlns:a="http://schemas.openxmlformats.org/drawingml/2006/main">
               <a:ext uri="{FF2B5EF4-FFF2-40B4-BE49-F238E27FC236}">
-                <a16:creationId xmlns:a16="http://schemas.microsoft.com/office/drawing/2014/main" id="{865C3370-D206-4C43-83BE-D9E0B3573AC5}"/>
+                <a16:creationId xmlns:a16="http://schemas.microsoft.com/office/drawing/2014/main" id="{D2B75A37-880E-4CE1-9F15-FE89C561180D}"/>
               </a:ext>
             </a:extLst>
           </p:cNvPr>
@@ -15116,7 +15116,7 @@
           <p:cNvPr id="126" name="">
             <a:extLst xmlns:a="http://schemas.openxmlformats.org/drawingml/2006/main">
               <a:ext uri="{FF2B5EF4-FFF2-40B4-BE49-F238E27FC236}">
-                <a16:creationId xmlns:a16="http://schemas.microsoft.com/office/drawing/2014/main" id="{DECCB9ED-D437-4DC3-9777-E8B07160BA33}"/>
+                <a16:creationId xmlns:a16="http://schemas.microsoft.com/office/drawing/2014/main" id="{B6D2DFA3-91AA-4C0E-BE75-4D0C94FE4237}"/>
               </a:ext>
             </a:extLst>
           </p:cNvPr>
@@ -15146,7 +15146,7 @@
           <p:cNvPr id="127" name="">
             <a:extLst xmlns:a="http://schemas.openxmlformats.org/drawingml/2006/main">
               <a:ext uri="{FF2B5EF4-FFF2-40B4-BE49-F238E27FC236}">
-                <a16:creationId xmlns:a16="http://schemas.microsoft.com/office/drawing/2014/main" id="{7A78FC5C-73B9-412A-BCEB-50FADC309453}"/>
+                <a16:creationId xmlns:a16="http://schemas.microsoft.com/office/drawing/2014/main" id="{DBEF5D8A-EDEF-4D66-93EC-69DF15E2287A}"/>
               </a:ext>
             </a:extLst>
           </p:cNvPr>
@@ -15201,7 +15201,7 @@
     </p:spTree>
     <p:extLst>
       <p:ext uri="{BB962C8B-B14F-4D97-AF65-F5344CB8AC3E}">
-        <p14:creationId xmlns:p14="http://schemas.microsoft.com/office/powerpoint/2010/main" val="461934316"/>
+        <p14:creationId xmlns:p14="http://schemas.microsoft.com/office/powerpoint/2010/main" val="726698862"/>
       </p:ext>
     </p:extLst>
   </p:cSld>
@@ -15225,7 +15225,7 @@
           <p:cNvPr id="119" name="Google Shape;119;p5">
             <a:extLst xmlns:a="http://schemas.openxmlformats.org/drawingml/2006/main">
               <a:ext uri="{FF2B5EF4-FFF2-40B4-BE49-F238E27FC236}">
-                <a16:creationId xmlns:a16="http://schemas.microsoft.com/office/drawing/2014/main" id="{9E485903-BFFE-48B2-951B-894C89A754C7}"/>
+                <a16:creationId xmlns:a16="http://schemas.microsoft.com/office/drawing/2014/main" id="{016F85AB-A368-43E8-B29E-38638B794186}"/>
               </a:ext>
             </a:extLst>
           </p:cNvPr>
@@ -15292,7 +15292,7 @@
           <p:cNvPr id="120" name="Google Shape;120;p5">
             <a:extLst xmlns:a="http://schemas.openxmlformats.org/drawingml/2006/main">
               <a:ext uri="{FF2B5EF4-FFF2-40B4-BE49-F238E27FC236}">
-                <a16:creationId xmlns:a16="http://schemas.microsoft.com/office/drawing/2014/main" id="{5C18146A-7F54-4F28-BFF5-35B09F57A1E9}"/>
+                <a16:creationId xmlns:a16="http://schemas.microsoft.com/office/drawing/2014/main" id="{070D46DE-2DBC-4349-95AB-CE0F41EB497A}"/>
               </a:ext>
             </a:extLst>
           </p:cNvPr>
@@ -15503,7 +15503,7 @@
                 <a:ea typeface="Arial"/>
                 <a:cs typeface="Arial"/>
               </a:rPr>
-              <a:t>Symbol lookup ≈ 0.4 ms · Cold build ≈ 5.6 s · Incremental update ≈ 1.51 s (Kaggle Xeon). Demo video: [5-Min Walkthrough Link].</a:t>
+              <a:t>Symbol lookup ≈ 0.4 ms · Cold build ≈ 5.6 s · Incremental update ≈ 1.51 s (Kaggle Xeon). Demo video: https://youtu.be/0k2UUJOp-Tc</a:t>
             </a:r>
           </a:p>
         </p:txBody>
@@ -15511,7 +15511,7 @@
     </p:spTree>
     <p:extLst>
       <p:ext uri="{BB962C8B-B14F-4D97-AF65-F5344CB8AC3E}">
-        <p14:creationId xmlns:p14="http://schemas.microsoft.com/office/powerpoint/2010/main" val="1078303029"/>
+        <p14:creationId xmlns:p14="http://schemas.microsoft.com/office/powerpoint/2010/main" val="557946422"/>
       </p:ext>
     </p:extLst>
   </p:cSld>
@@ -15535,7 +15535,7 @@
           <p:cNvPr id="125" name="Google Shape;125;p6">
             <a:extLst xmlns:a="http://schemas.openxmlformats.org/drawingml/2006/main">
               <a:ext uri="{FF2B5EF4-FFF2-40B4-BE49-F238E27FC236}">
-                <a16:creationId xmlns:a16="http://schemas.microsoft.com/office/drawing/2014/main" id="{2F2B4BC6-CFD7-4B8B-9C9B-D07EC01F8012}"/>
+                <a16:creationId xmlns:a16="http://schemas.microsoft.com/office/drawing/2014/main" id="{C5B6EEE0-CBF5-4761-896D-00E3D8CA0786}"/>
               </a:ext>
             </a:extLst>
           </p:cNvPr>
@@ -15606,7 +15606,7 @@
           <p:cNvPr id="126" name="Google Shape;126;p6">
             <a:extLst xmlns:a="http://schemas.openxmlformats.org/drawingml/2006/main">
               <a:ext uri="{FF2B5EF4-FFF2-40B4-BE49-F238E27FC236}">
-                <a16:creationId xmlns:a16="http://schemas.microsoft.com/office/drawing/2014/main" id="{1E04681B-1B32-449F-87A5-59ECC13F594E}"/>
+                <a16:creationId xmlns:a16="http://schemas.microsoft.com/office/drawing/2014/main" id="{368C9488-744C-4DE5-9FA4-837A2F601D0E}"/>
               </a:ext>
             </a:extLst>
           </p:cNvPr>
@@ -15825,7 +15825,7 @@
     </p:spTree>
     <p:extLst>
       <p:ext uri="{BB962C8B-B14F-4D97-AF65-F5344CB8AC3E}">
-        <p14:creationId xmlns:p14="http://schemas.microsoft.com/office/powerpoint/2010/main" val="186342445"/>
+        <p14:creationId xmlns:p14="http://schemas.microsoft.com/office/powerpoint/2010/main" val="1272378666"/>
       </p:ext>
     </p:extLst>
   </p:cSld>
@@ -15849,7 +15849,7 @@
           <p:cNvPr id="131" name="Google Shape;131;p7">
             <a:extLst xmlns:a="http://schemas.openxmlformats.org/drawingml/2006/main">
               <a:ext uri="{FF2B5EF4-FFF2-40B4-BE49-F238E27FC236}">
-                <a16:creationId xmlns:a16="http://schemas.microsoft.com/office/drawing/2014/main" id="{2B29D9B0-44C8-4483-8F46-6E3577C71AE3}"/>
+                <a16:creationId xmlns:a16="http://schemas.microsoft.com/office/drawing/2014/main" id="{3D09B309-26A5-4CB3-8A41-AA92ECB60C5C}"/>
               </a:ext>
             </a:extLst>
           </p:cNvPr>
@@ -15920,7 +15920,7 @@
           <p:cNvPr id="132" name="Google Shape;132;p7">
             <a:extLst xmlns:a="http://schemas.openxmlformats.org/drawingml/2006/main">
               <a:ext uri="{FF2B5EF4-FFF2-40B4-BE49-F238E27FC236}">
-                <a16:creationId xmlns:a16="http://schemas.microsoft.com/office/drawing/2014/main" id="{F4A71B46-A4B6-43C1-9363-2F746E124744}"/>
+                <a16:creationId xmlns:a16="http://schemas.microsoft.com/office/drawing/2014/main" id="{23765700-C17A-403D-992D-E6670996F75B}"/>
               </a:ext>
             </a:extLst>
           </p:cNvPr>
@@ -16139,7 +16139,7 @@
     </p:spTree>
     <p:extLst>
       <p:ext uri="{BB962C8B-B14F-4D97-AF65-F5344CB8AC3E}">
-        <p14:creationId xmlns:p14="http://schemas.microsoft.com/office/powerpoint/2010/main" val="1590354343"/>
+        <p14:creationId xmlns:p14="http://schemas.microsoft.com/office/powerpoint/2010/main" val="466434060"/>
       </p:ext>
     </p:extLst>
   </p:cSld>
@@ -16163,7 +16163,7 @@
           <p:cNvPr id="137" name="Google Shape;137;p8">
             <a:extLst xmlns:a="http://schemas.openxmlformats.org/drawingml/2006/main">
               <a:ext uri="{FF2B5EF4-FFF2-40B4-BE49-F238E27FC236}">
-                <a16:creationId xmlns:a16="http://schemas.microsoft.com/office/drawing/2014/main" id="{6F2D642D-00E2-476B-82DD-F76F46E5962B}"/>
+                <a16:creationId xmlns:a16="http://schemas.microsoft.com/office/drawing/2014/main" id="{FBCC3269-D4C8-4B31-BEA4-7DD0B022D618}"/>
               </a:ext>
             </a:extLst>
           </p:cNvPr>
@@ -16234,7 +16234,7 @@
           <p:cNvPr id="138" name="Google Shape;138;p8">
             <a:extLst xmlns:a="http://schemas.openxmlformats.org/drawingml/2006/main">
               <a:ext uri="{FF2B5EF4-FFF2-40B4-BE49-F238E27FC236}">
-                <a16:creationId xmlns:a16="http://schemas.microsoft.com/office/drawing/2014/main" id="{156F1700-34B0-49FD-9FED-57DF4B1CBD3A}"/>
+                <a16:creationId xmlns:a16="http://schemas.microsoft.com/office/drawing/2014/main" id="{18FAD950-12BB-4401-B8D8-6A9CC023EB5E}"/>
               </a:ext>
             </a:extLst>
           </p:cNvPr>
@@ -16416,7 +16416,7 @@
     </p:spTree>
     <p:extLst>
       <p:ext uri="{BB962C8B-B14F-4D97-AF65-F5344CB8AC3E}">
-        <p14:creationId xmlns:p14="http://schemas.microsoft.com/office/powerpoint/2010/main" val="1677350626"/>
+        <p14:creationId xmlns:p14="http://schemas.microsoft.com/office/powerpoint/2010/main" val="242883202"/>
       </p:ext>
     </p:extLst>
   </p:cSld>
@@ -16440,7 +16440,7 @@
           <p:cNvPr id="143" name="Google Shape;143;p9">
             <a:extLst xmlns:a="http://schemas.openxmlformats.org/drawingml/2006/main">
               <a:ext uri="{FF2B5EF4-FFF2-40B4-BE49-F238E27FC236}">
-                <a16:creationId xmlns:a16="http://schemas.microsoft.com/office/drawing/2014/main" id="{FA1D2602-12B0-4810-A19A-77C4FF0EBC58}"/>
+                <a16:creationId xmlns:a16="http://schemas.microsoft.com/office/drawing/2014/main" id="{D0B2E542-30EC-4AEF-A505-83876F6D8ED8}"/>
               </a:ext>
             </a:extLst>
           </p:cNvPr>
@@ -16511,7 +16511,7 @@
           <p:cNvPr id="144" name="Google Shape;144;p9">
             <a:extLst xmlns:a="http://schemas.openxmlformats.org/drawingml/2006/main">
               <a:ext uri="{FF2B5EF4-FFF2-40B4-BE49-F238E27FC236}">
-                <a16:creationId xmlns:a16="http://schemas.microsoft.com/office/drawing/2014/main" id="{F3A6F19E-6C32-476B-9397-44CB0AE4C092}"/>
+                <a16:creationId xmlns:a16="http://schemas.microsoft.com/office/drawing/2014/main" id="{57F23462-A9B7-4DBD-B83D-D91449CE615A}"/>
               </a:ext>
             </a:extLst>
           </p:cNvPr>
@@ -16693,7 +16693,7 @@
     </p:spTree>
     <p:extLst>
       <p:ext uri="{BB962C8B-B14F-4D97-AF65-F5344CB8AC3E}">
-        <p14:creationId xmlns:p14="http://schemas.microsoft.com/office/powerpoint/2010/main" val="1349200216"/>
+        <p14:creationId xmlns:p14="http://schemas.microsoft.com/office/powerpoint/2010/main" val="2066865388"/>
       </p:ext>
     </p:extLst>
   </p:cSld>

</xml_diff>

<commit_message>
fix: prepare audited submission corrections locally
</commit_message>
<xml_diff>
--- a/VITV_Doctors_Submission.pptx
+++ b/VITV_Doctors_Submission.pptx
@@ -2,24 +2,24 @@
 <file path=ppt/presentation.xml><?xml version="1.0" encoding="utf-8"?>
 <p:presentation xmlns:p="http://schemas.openxmlformats.org/presentationml/2006/main">
   <p:sldMasterIdLst>
-    <p:sldMasterId xmlns:r="http://schemas.openxmlformats.org/officeDocument/2006/relationships" id="2147483648" r:id="Rd3eb24b4a2a94298"/>
+    <p:sldMasterId xmlns:r="http://schemas.openxmlformats.org/officeDocument/2006/relationships" id="2147483648" r:id="R40351676b4354cc6"/>
   </p:sldMasterIdLst>
   <p:notesMasterIdLst>
-    <p:notesMasterId xmlns:r="http://schemas.openxmlformats.org/officeDocument/2006/relationships" r:id="R96dfda3d99d240aa"/>
+    <p:notesMasterId xmlns:r="http://schemas.openxmlformats.org/officeDocument/2006/relationships" r:id="R23628a5584fe45ce"/>
   </p:notesMasterIdLst>
   <p:sldIdLst>
-    <p:sldId xmlns:r="http://schemas.openxmlformats.org/officeDocument/2006/relationships" id="256" r:id="R324ad3f864f444d2"/>
-    <p:sldId xmlns:r="http://schemas.openxmlformats.org/officeDocument/2006/relationships" id="257" r:id="Rbd6a9117e27947f5"/>
-    <p:sldId xmlns:r="http://schemas.openxmlformats.org/officeDocument/2006/relationships" id="258" r:id="R284e800ee7c84219"/>
-    <p:sldId xmlns:r="http://schemas.openxmlformats.org/officeDocument/2006/relationships" id="259" r:id="Rf7b9c92e18b94589"/>
-    <p:sldId xmlns:r="http://schemas.openxmlformats.org/officeDocument/2006/relationships" id="260" r:id="Rf105e10207b04873"/>
-    <p:sldId xmlns:r="http://schemas.openxmlformats.org/officeDocument/2006/relationships" id="261" r:id="R0672ca9e1c344a27"/>
-    <p:sldId xmlns:r="http://schemas.openxmlformats.org/officeDocument/2006/relationships" id="262" r:id="Re0034dbbb6fd4051"/>
-    <p:sldId xmlns:r="http://schemas.openxmlformats.org/officeDocument/2006/relationships" id="263" r:id="Ra1c8beabd45f47d4"/>
-    <p:sldId xmlns:r="http://schemas.openxmlformats.org/officeDocument/2006/relationships" id="264" r:id="Recb3ae13d61c43b1"/>
-    <p:sldId xmlns:r="http://schemas.openxmlformats.org/officeDocument/2006/relationships" id="265" r:id="R8521ee9b008b4a7e"/>
-    <p:sldId xmlns:r="http://schemas.openxmlformats.org/officeDocument/2006/relationships" id="266" r:id="R7f99777725e54d53"/>
-    <p:sldId xmlns:r="http://schemas.openxmlformats.org/officeDocument/2006/relationships" id="267" r:id="Re7a4fa3d225f41ca"/>
+    <p:sldId xmlns:r="http://schemas.openxmlformats.org/officeDocument/2006/relationships" id="256" r:id="R801cbaaa20914358"/>
+    <p:sldId xmlns:r="http://schemas.openxmlformats.org/officeDocument/2006/relationships" id="257" r:id="Ref39251368ef47ec"/>
+    <p:sldId xmlns:r="http://schemas.openxmlformats.org/officeDocument/2006/relationships" id="258" r:id="Rb316517becf34a9c"/>
+    <p:sldId xmlns:r="http://schemas.openxmlformats.org/officeDocument/2006/relationships" id="259" r:id="R0acaf7c827ed4660"/>
+    <p:sldId xmlns:r="http://schemas.openxmlformats.org/officeDocument/2006/relationships" id="260" r:id="Rc206555220414f40"/>
+    <p:sldId xmlns:r="http://schemas.openxmlformats.org/officeDocument/2006/relationships" id="261" r:id="R20fb6ae44ccd4789"/>
+    <p:sldId xmlns:r="http://schemas.openxmlformats.org/officeDocument/2006/relationships" id="262" r:id="R666dffd0009e4e17"/>
+    <p:sldId xmlns:r="http://schemas.openxmlformats.org/officeDocument/2006/relationships" id="263" r:id="R4f70a348e1744477"/>
+    <p:sldId xmlns:r="http://schemas.openxmlformats.org/officeDocument/2006/relationships" id="264" r:id="R18669883e9934571"/>
+    <p:sldId xmlns:r="http://schemas.openxmlformats.org/officeDocument/2006/relationships" id="265" r:id="R1e68e0ff8ec7435c"/>
+    <p:sldId xmlns:r="http://schemas.openxmlformats.org/officeDocument/2006/relationships" id="266" r:id="Rb8df1336b50646a9"/>
+    <p:sldId xmlns:r="http://schemas.openxmlformats.org/officeDocument/2006/relationships" id="267" r:id="R729579471e6a4e92"/>
   </p:sldIdLst>
   <p:sldSz cx="12192000" cy="6858000"/>
   <p:notesSz cx="6858000" cy="9144000"/>
@@ -485,7 +485,7 @@
               <a:buNone/>
             </a:pPr>
             <a:r>
-              <a:t>CodeDoctor submission, VITV / Doctors. Source: repository README.md, config/submission.yaml, docs/submission/PROTOCOL.md, theme1_guidelines.pdf and jury confirmations. Architecture: app/agent/router.py, app/parser/chunker.py, app/indexing/cache.py, app/pipeline/execution_rerank.py, app/indexing/lineage.py, app/workbench.py. Verified P0 NDCG@10: 0.96558 (+0.02802 ablation lift); P1 Kaggle Intel Xeon CPU: 1.51 s update (~68x speedup); Bonus: 100% variant disambiguation vs 8.33% control. Repository: https://github.com/krizz711/CodeDoctor-Agentic-Semantic-and-Structural-Intelligence-for-Code-Repositories</a:t>
+              <a:t>Sources: theme1_guidelines.pdf; verbatim FAQ answers in docs/submission/PROTOCOL.md; repository implementation and raw result artifacts. No independent novelty priority claim is made.</a:t>
             </a:r>
             <a:endParaRPr/>
           </a:p>
@@ -565,7 +565,7 @@
               <a:buNone/>
             </a:pPr>
             <a:r>
-              <a:t>CodeDoctor submission, VITV / Doctors. Source: repository README.md, config/submission.yaml, docs/submission/PROTOCOL.md, theme1_guidelines.pdf and jury confirmations. Architecture: app/agent/router.py, app/parser/chunker.py, app/indexing/cache.py, app/pipeline/execution_rerank.py, app/indexing/lineage.py, app/workbench.py. Verified P0 NDCG@10: 0.96558 (+0.02802 ablation lift); P1 Kaggle Intel Xeon CPU: 1.51 s update (~68x speedup); Bonus: 100% variant disambiguation vs 8.33% control. Repository: https://github.com/krizz711/CodeDoctor-Agentic-Semantic-and-Structural-Intelligence-for-Code-Repositories</a:t>
+              <a:t>Sources: theme1_guidelines.pdf; verbatim FAQ answers in docs/submission/PROTOCOL.md; repository implementation and raw result artifacts. No independent novelty priority claim is made.</a:t>
             </a:r>
             <a:endParaRPr/>
           </a:p>
@@ -645,7 +645,7 @@
               <a:buNone/>
             </a:pPr>
             <a:r>
-              <a:t>CodeDoctor submission, VITV / Doctors. Source: repository README.md, config/submission.yaml, docs/submission/PROTOCOL.md, theme1_guidelines.pdf and jury confirmations. Architecture: app/agent/router.py, app/parser/chunker.py, app/indexing/cache.py, app/pipeline/execution_rerank.py, app/indexing/lineage.py, app/workbench.py. Verified P0 NDCG@10: 0.96558 (+0.02802 ablation lift); P1 Kaggle Intel Xeon CPU: 1.51 s update (~68x speedup); Bonus: 100% variant disambiguation vs 8.33% control. Repository: https://github.com/krizz711/CodeDoctor-Agentic-Semantic-and-Structural-Intelligence-for-Code-Repositories</a:t>
+              <a:t>Sources: theme1_guidelines.pdf; verbatim FAQ answers in docs/submission/PROTOCOL.md; repository implementation and raw result artifacts. No independent novelty priority claim is made. Public video duration is346.133 seconds as verified with ffprobe. No completed checklist assertion, human signature or updated official CPU score is fabricated.</a:t>
             </a:r>
             <a:endParaRPr/>
           </a:p>
@@ -725,7 +725,7 @@
               <a:buNone/>
             </a:pPr>
             <a:r>
-              <a:t>CodeDoctor submission, VITV / Doctors. Source: repository README.md, config/submission.yaml, docs/submission/PROTOCOL.md, theme1_guidelines.pdf and jury confirmations. Architecture: app/agent/router.py, app/parser/chunker.py, app/indexing/cache.py, app/pipeline/execution_rerank.py, app/indexing/lineage.py, app/workbench.py. Verified P0 NDCG@10: 0.96558 (+0.02802 ablation lift); P1 Kaggle Intel Xeon CPU: 1.51 s update (~68x speedup); Bonus: 100% variant disambiguation vs 8.33% control. Repository: https://github.com/krizz711/CodeDoctor-Agentic-Semantic-and-Structural-Intelligence-for-Code-Repositories</a:t>
+              <a:t>Sources: theme1_guidelines.pdf; verbatim FAQ answers in docs/submission/PROTOCOL.md; repository implementation and raw result artifacts. No independent novelty priority claim is made.</a:t>
             </a:r>
             <a:endParaRPr/>
           </a:p>
@@ -805,7 +805,7 @@
               <a:buNone/>
             </a:pPr>
             <a:r>
-              <a:t>CodeDoctor submission, VITV / Doctors. Source: repository README.md, config/submission.yaml, docs/submission/PROTOCOL.md, theme1_guidelines.pdf and jury confirmations. Architecture: app/agent/router.py, app/parser/chunker.py, app/indexing/cache.py, app/pipeline/execution_rerank.py, app/indexing/lineage.py, app/workbench.py. Verified P0 NDCG@10: 0.96558 (+0.02802 ablation lift); P1 Kaggle Intel Xeon CPU: 1.51 s update (~68x speedup); Bonus: 100% variant disambiguation vs 8.33% control. Repository: https://github.com/krizz711/CodeDoctor-Agentic-Semantic-and-Structural-Intelligence-for-Code-Repositories</a:t>
+              <a:t>Sources: theme1_guidelines.pdf; verbatim FAQ answers in docs/submission/PROTOCOL.md; repository implementation and raw result artifacts. No independent novelty priority claim is made.</a:t>
             </a:r>
             <a:endParaRPr/>
           </a:p>
@@ -885,7 +885,7 @@
               <a:buNone/>
             </a:pPr>
             <a:r>
-              <a:t>CodeDoctor submission, VITV / Doctors. Source: repository README.md, config/submission.yaml, docs/submission/PROTOCOL.md, theme1_guidelines.pdf and jury confirmations. Architecture: app/agent/router.py, app/parser/chunker.py, app/indexing/cache.py, app/pipeline/execution_rerank.py, app/indexing/lineage.py, app/workbench.py. Verified P0 NDCG@10: 0.96558 (+0.02802 ablation lift); P1 Kaggle Intel Xeon CPU: 1.51 s update (~68x speedup); Bonus: 100% variant disambiguation vs 8.33% control. Repository: https://github.com/krizz711/CodeDoctor-Agentic-Semantic-and-Structural-Intelligence-for-Code-Repositories</a:t>
+              <a:t>Sources: theme1_guidelines.pdf; verbatim FAQ answers in docs/submission/PROTOCOL.md; repository implementation and raw result artifacts. No independent novelty priority claim is made.</a:t>
             </a:r>
             <a:endParaRPr/>
           </a:p>
@@ -965,7 +965,7 @@
               <a:buNone/>
             </a:pPr>
             <a:r>
-              <a:t>CodeDoctor submission, VITV / Doctors. Source: repository README.md, config/submission.yaml, docs/submission/PROTOCOL.md, theme1_guidelines.pdf and jury confirmations. Architecture: app/agent/router.py, app/parser/chunker.py, app/indexing/cache.py, app/pipeline/execution_rerank.py, app/indexing/lineage.py, app/workbench.py. Verified P0 NDCG@10: 0.96558 (+0.02802 ablation lift); P1 Kaggle Intel Xeon CPU: 1.51 s update (~68x speedup); Bonus: 100% variant disambiguation vs 8.33% control. Repository: https://github.com/krizz711/CodeDoctor-Agentic-Semantic-and-Structural-Intelligence-for-Code-Repositories</a:t>
+              <a:t>Sources: theme1_guidelines.pdf; verbatim FAQ answers in docs/submission/PROTOCOL.md; repository implementation and raw result artifacts. No independent novelty priority claim is made. P0: app/pipeline/encoder.py and app/pipeline/execution.py. Workbench: app/workbench.py, app/indexing/versioned.py, app/retrieval/hybrid.py. The &gt;6k-character workbench attention guard is not a P0 pipeline truncation rule. C++ is not claimed as the runtime path.</a:t>
             </a:r>
             <a:endParaRPr/>
           </a:p>
@@ -1045,7 +1045,7 @@
               <a:buNone/>
             </a:pPr>
             <a:r>
-              <a:t>CodeDoctor submission, VITV / Doctors. Source: repository README.md, config/submission.yaml, docs/submission/PROTOCOL.md, theme1_guidelines.pdf and jury confirmations. Architecture: app/agent/router.py, app/parser/chunker.py, app/indexing/cache.py, app/pipeline/execution_rerank.py, app/indexing/lineage.py, app/workbench.py. Verified P0 NDCG@10: 0.96558 (+0.02802 ablation lift); P1 Kaggle Intel Xeon CPU: 1.51 s update (~68x speedup); Bonus: 100% variant disambiguation vs 8.33% control. Repository: https://github.com/krizz711/CodeDoctor-Agentic-Semantic-and-Structural-Intelligence-for-Code-Repositories</a:t>
+              <a:t>Sources: theme1_guidelines.pdf; verbatim FAQ answers in docs/submission/PROTOCOL.md; repository implementation and raw result artifacts. No independent novelty priority claim is made.</a:t>
             </a:r>
             <a:endParaRPr/>
           </a:p>
@@ -1125,7 +1125,7 @@
               <a:buNone/>
             </a:pPr>
             <a:r>
-              <a:t>CodeDoctor submission, VITV / Doctors. Source: repository README.md, config/submission.yaml, docs/submission/PROTOCOL.md, theme1_guidelines.pdf and jury confirmations. Architecture: app/agent/router.py, app/parser/chunker.py, app/indexing/cache.py, app/pipeline/execution_rerank.py, app/indexing/lineage.py, app/workbench.py. Verified P0 NDCG@10: 0.96558 (+0.02802 ablation lift); P1 Kaggle Intel Xeon CPU: 1.51 s update (~68x speedup); Bonus: 100% variant disambiguation vs 8.33% control. Repository: https://github.com/krizz711/CodeDoctor-Agentic-Semantic-and-Structural-Intelligence-for-Code-Repositories</a:t>
+              <a:t>Sources: theme1_guidelines.pdf; verbatim FAQ answers in docs/submission/PROTOCOL.md; repository implementation and raw result artifacts. No independent novelty priority claim is made.</a:t>
             </a:r>
             <a:endParaRPr/>
           </a:p>
@@ -1205,7 +1205,7 @@
               <a:buNone/>
             </a:pPr>
             <a:r>
-              <a:t>CodeDoctor submission, VITV / Doctors. Source: repository README.md, config/submission.yaml, docs/submission/PROTOCOL.md, theme1_guidelines.pdf and jury confirmations. Architecture: app/agent/router.py, app/parser/chunker.py, app/indexing/cache.py, app/pipeline/execution_rerank.py, app/indexing/lineage.py, app/workbench.py. Verified P0 NDCG@10: 0.96558 (+0.02802 ablation lift); P1 Kaggle Intel Xeon CPU: 1.51 s update (~68x speedup); Bonus: 100% variant disambiguation vs 8.33% control. Repository: https://github.com/krizz711/CodeDoctor-Agentic-Semantic-and-Structural-Intelligence-for-Code-Repositories</a:t>
+              <a:t>Sources: theme1_guidelines.pdf; verbatim FAQ answers in docs/submission/PROTOCOL.md; repository implementation and raw result artifacts. No independent novelty priority claim is made.</a:t>
             </a:r>
             <a:endParaRPr/>
           </a:p>
@@ -1285,7 +1285,7 @@
               <a:buNone/>
             </a:pPr>
             <a:r>
-              <a:t>CodeDoctor submission, VITV / Doctors. Source: repository README.md, config/submission.yaml, docs/submission/PROTOCOL.md, theme1_guidelines.pdf and jury confirmations. Architecture: app/agent/router.py, app/parser/chunker.py, app/indexing/cache.py, app/pipeline/execution_rerank.py, app/indexing/lineage.py, app/workbench.py. Verified P0 NDCG@10: 0.96558 (+0.02802 ablation lift); P1 Kaggle Intel Xeon CPU: 1.51 s update (~68x speedup); Bonus: 100% variant disambiguation vs 8.33% control. Repository: https://github.com/krizz711/CodeDoctor-Agentic-Semantic-and-Structural-Intelligence-for-Code-Repositories</a:t>
+              <a:t>Sources: theme1_guidelines.pdf; verbatim FAQ answers in docs/submission/PROTOCOL.md; repository implementation and raw result artifacts. No independent novelty priority claim is made. Historical Apps JSON: appsretrieval_results.json, 2026-09-19, MTEB2.21.0, GPU query encoding under frozen.yaml. P1 and Bonus: results/hands-on/hands-on/p1.json and bonus.json; environment.json. P1 full build uses median102.777192175s, not old103.4s aggregate; one-edit6.452369177s; ten-edit29.506994244s; unchanged1.51220837s. Bonus median5.817684378s. The 12 examples deliberately include wrong variants, so no generalization estimate follows.</a:t>
             </a:r>
             <a:endParaRPr/>
           </a:p>
@@ -1365,7 +1365,7 @@
               <a:buNone/>
             </a:pPr>
             <a:r>
-              <a:t>CodeDoctor submission, VITV / Doctors. Source: repository README.md, config/submission.yaml, docs/submission/PROTOCOL.md, theme1_guidelines.pdf and jury confirmations. Architecture: app/agent/router.py, app/parser/chunker.py, app/indexing/cache.py, app/pipeline/execution_rerank.py, app/indexing/lineage.py, app/workbench.py. Verified P0 NDCG@10: 0.96558 (+0.02802 ablation lift); P1 Kaggle Intel Xeon CPU: 1.51 s update (~68x speedup); Bonus: 100% variant disambiguation vs 8.33% control. Repository: https://github.com/krizz711/CodeDoctor-Agentic-Semantic-and-Structural-Intelligence-for-Code-Repositories</a:t>
+              <a:t>Sources: theme1_guidelines.pdf; verbatim FAQ answers in docs/submission/PROTOCOL.md; repository implementation and raw result artifacts. No independent novelty priority claim is made.</a:t>
             </a:r>
             <a:endParaRPr/>
           </a:p>
@@ -11075,18 +11075,18 @@
   </p:cSld>
   <p:clrMap bg1="lt1" tx1="dk1" bg2="dk2" tx2="lt2" accent1="accent1" accent2="accent2" accent3="accent3" accent4="accent4" accent5="accent5" accent6="accent6" hlink="hlink" folHlink="folHlink"/>
   <p:sldLayoutIdLst>
-    <p:sldLayoutId xmlns:r="http://schemas.openxmlformats.org/officeDocument/2006/relationships" id="2147483649" r:id="R0f3b85a93bc54aa7"/>
-    <p:sldLayoutId xmlns:r="http://schemas.openxmlformats.org/officeDocument/2006/relationships" id="2147483650" r:id="Rd691f7f5f4a34540"/>
-    <p:sldLayoutId xmlns:r="http://schemas.openxmlformats.org/officeDocument/2006/relationships" id="2147483651" r:id="R785afac91a494ae7"/>
-    <p:sldLayoutId xmlns:r="http://schemas.openxmlformats.org/officeDocument/2006/relationships" id="2147483652" r:id="R96fe60d8cd0d45f2"/>
-    <p:sldLayoutId xmlns:r="http://schemas.openxmlformats.org/officeDocument/2006/relationships" id="2147483653" r:id="Rd6d73571b42b4a9d"/>
-    <p:sldLayoutId xmlns:r="http://schemas.openxmlformats.org/officeDocument/2006/relationships" id="2147483654" r:id="Rb85cb50498d54cfe"/>
-    <p:sldLayoutId xmlns:r="http://schemas.openxmlformats.org/officeDocument/2006/relationships" id="2147483655" r:id="R07f52cc1932442ea"/>
-    <p:sldLayoutId xmlns:r="http://schemas.openxmlformats.org/officeDocument/2006/relationships" id="2147483656" r:id="Re1e708f7c2344535"/>
-    <p:sldLayoutId xmlns:r="http://schemas.openxmlformats.org/officeDocument/2006/relationships" id="2147483657" r:id="R765696490546487d"/>
-    <p:sldLayoutId xmlns:r="http://schemas.openxmlformats.org/officeDocument/2006/relationships" id="2147483658" r:id="Raa8bb80050da4c09"/>
-    <p:sldLayoutId xmlns:r="http://schemas.openxmlformats.org/officeDocument/2006/relationships" id="2147483659" r:id="R8afa67c270384915"/>
-    <p:sldLayoutId xmlns:r="http://schemas.openxmlformats.org/officeDocument/2006/relationships" id="2147483660" r:id="R937b4e0b2d144953"/>
+    <p:sldLayoutId xmlns:r="http://schemas.openxmlformats.org/officeDocument/2006/relationships" id="2147483649" r:id="R7abcd05663dc45bb"/>
+    <p:sldLayoutId xmlns:r="http://schemas.openxmlformats.org/officeDocument/2006/relationships" id="2147483650" r:id="R6cb598dc02c74313"/>
+    <p:sldLayoutId xmlns:r="http://schemas.openxmlformats.org/officeDocument/2006/relationships" id="2147483651" r:id="Re385f075e6fa4073"/>
+    <p:sldLayoutId xmlns:r="http://schemas.openxmlformats.org/officeDocument/2006/relationships" id="2147483652" r:id="Rf8ac6efbc07c4048"/>
+    <p:sldLayoutId xmlns:r="http://schemas.openxmlformats.org/officeDocument/2006/relationships" id="2147483653" r:id="Radb0139226514e80"/>
+    <p:sldLayoutId xmlns:r="http://schemas.openxmlformats.org/officeDocument/2006/relationships" id="2147483654" r:id="Re0b85ef3af174343"/>
+    <p:sldLayoutId xmlns:r="http://schemas.openxmlformats.org/officeDocument/2006/relationships" id="2147483655" r:id="Rfa38a3985a6a4ed8"/>
+    <p:sldLayoutId xmlns:r="http://schemas.openxmlformats.org/officeDocument/2006/relationships" id="2147483656" r:id="R7d5cbeb22b724cec"/>
+    <p:sldLayoutId xmlns:r="http://schemas.openxmlformats.org/officeDocument/2006/relationships" id="2147483657" r:id="Re1ef267b3a91431b"/>
+    <p:sldLayoutId xmlns:r="http://schemas.openxmlformats.org/officeDocument/2006/relationships" id="2147483658" r:id="R3fe71dd4b3f04912"/>
+    <p:sldLayoutId xmlns:r="http://schemas.openxmlformats.org/officeDocument/2006/relationships" id="2147483659" r:id="R0cb330459c974e68"/>
+    <p:sldLayoutId xmlns:r="http://schemas.openxmlformats.org/officeDocument/2006/relationships" id="2147483660" r:id="R72728ad99e37488a"/>
   </p:sldLayoutIdLst>
   <p:hf sldNum="0" hdr="0" ftr="0" dt="0"/>
   <p:txStyles>
@@ -12509,7 +12509,7 @@
                 <a:ea typeface="Arial"/>
                 <a:cs typeface="Arial"/>
               </a:rPr>
-              <a:t>College Name - VIT Vellore</a:t>
+              <a:t>College Name - VITV (VIT Vellore)</a:t>
             </a:r>
             <a:endParaRPr/>
           </a:p>
@@ -12661,14 +12661,14 @@
       </p:sp>
       <p:pic>
         <p:nvPicPr>
-          <p:cNvPr id="104" name="Google Shape;96;p1"/>
+          <p:cNvPr id="105" name="Google Shape;96;p1"/>
           <p:cNvPicPr>
             <a:picLocks xmlns:a="http://schemas.openxmlformats.org/drawingml/2006/main" noChangeAspect="1"/>
           </p:cNvPicPr>
           <p:nvPr/>
         </p:nvPicPr>
         <p:blipFill rotWithShape="1">
-          <a:blip xmlns:r="http://schemas.openxmlformats.org/officeDocument/2006/relationships" xmlns:a="http://schemas.openxmlformats.org/drawingml/2006/main" r:embed="R7fffe6e54bd24135">
+          <a:blip xmlns:r="http://schemas.openxmlformats.org/officeDocument/2006/relationships" xmlns:a="http://schemas.openxmlformats.org/drawingml/2006/main" r:embed="Rbdc9708603644b9e">
             <a:alphaModFix/>
           </a:blip>
           <a:srcRect xmlns:a="http://schemas.openxmlformats.org/drawingml/2006/main" l="0" t="0" r="0" b="0"/>
@@ -12721,6 +12721,7 @@
           <a:lstStyle xmlns:a="http://schemas.openxmlformats.org/drawingml/2006/main"/>
           <a:p xmlns:a="http://schemas.openxmlformats.org/drawingml/2006/main">
             <a:pPr>
+              <a:buNone/>
               <a:defRPr sz="1350" b="0">
                 <a:solidFill>
                   <a:srgbClr val="302C3C"/>
@@ -12735,7 +12736,7 @@
                 <a:solidFill>
                   <a:srgbClr val="70509B"/>
                 </a:solidFill>
-                <a:hlinkClick xmlns:r="http://schemas.openxmlformats.org/officeDocument/2006/relationships" r:id="Ra248d4b428bf4177"/>
+                <a:hlinkClick xmlns:r="http://schemas.openxmlformats.org/officeDocument/2006/relationships" r:id="R7a8a49c9a30445bc"/>
               </a:rPr>
               <a:t>Submission GitHub: CodeDoctor repository</a:t>
             </a:r>
@@ -12872,9 +12873,9 @@
           <a:p xmlns:a="http://schemas.openxmlformats.org/drawingml/2006/main">
             <a:pPr>
               <a:spcAft>
-                <a:spcPts val="1100"/>
-              </a:spcAft>
-              <a:defRPr sz="1650">
+                <a:spcPts val="1500"/>
+              </a:spcAft>
+              <a:defRPr sz="1725">
                 <a:solidFill>
                   <a:srgbClr val="302C3C"/>
                 </a:solidFill>
@@ -12884,7 +12885,7 @@
               </a:defRPr>
             </a:pPr>
             <a:r>
-              <a:rPr sz="1650" b="1">
+              <a:rPr sz="1725" b="1">
                 <a:solidFill>
                   <a:srgbClr val="302C3C"/>
                 </a:solidFill>
@@ -12892,10 +12893,10 @@
                 <a:ea typeface="Arial"/>
                 <a:cs typeface="Arial"/>
               </a:rPr>
-              <a:t>Agentic Multi-Signal Routing  </a:t>
+              <a:t>Our architectural contribution  </a:t>
             </a:r>
             <a:r>
-              <a:rPr sz="1650">
+              <a:rPr sz="1725">
                 <a:solidFill>
                   <a:srgbClr val="302C3C"/>
                 </a:solidFill>
@@ -12903,15 +12904,15 @@
                 <a:ea typeface="Arial"/>
                 <a:cs typeface="Arial"/>
               </a:rPr>
-              <a:t>Cheap lexical and symbol passes resolve simple queries in 0.4 ms; expensive dense inference is invoked only when semantic reasoning is required.</a:t>
+              <a:t>Combine reusable structural preprocessing with conditional behavioral postprocessing around a fixed embedding model.</a:t>
             </a:r>
           </a:p>
           <a:p xmlns:a="http://schemas.openxmlformats.org/drawingml/2006/main">
             <a:pPr>
               <a:spcAft>
-                <a:spcPts val="1100"/>
-              </a:spcAft>
-              <a:defRPr sz="1650">
+                <a:spcPts val="1500"/>
+              </a:spcAft>
+              <a:defRPr sz="1725">
                 <a:solidFill>
                   <a:srgbClr val="302C3C"/>
                 </a:solidFill>
@@ -12921,7 +12922,7 @@
               </a:defRPr>
             </a:pPr>
             <a:r>
-              <a:rPr sz="1650" b="1">
+              <a:rPr sz="1725" b="1">
                 <a:solidFill>
                   <a:srgbClr val="302C3C"/>
                 </a:solidFill>
@@ -12929,10 +12930,10 @@
                 <a:ea typeface="Arial"/>
                 <a:cs typeface="Arial"/>
               </a:rPr>
-              <a:t>Behavioral Post-Processing Verification  </a:t>
+              <a:t>Selective work  </a:t>
             </a:r>
             <a:r>
-              <a:rPr sz="1650">
+              <a:rPr sz="1725">
                 <a:solidFill>
                   <a:srgbClr val="302C3C"/>
                 </a:solidFill>
@@ -12940,15 +12941,15 @@
                 <a:ea typeface="Arial"/>
                 <a:cs typeface="Arial"/>
               </a:rPr>
-              <a:t>Validates candidate code semantics via executable test cases, solving near-miss ranking where text embeddings fail.</a:t>
+              <a:t>Encode changed content and route workbench queries through cheap signals before dense inference when those signals suffice.</a:t>
             </a:r>
           </a:p>
           <a:p xmlns:a="http://schemas.openxmlformats.org/drawingml/2006/main">
             <a:pPr>
               <a:spcAft>
-                <a:spcPts val="1100"/>
-              </a:spcAft>
-              <a:defRPr sz="1650">
+                <a:spcPts val="1500"/>
+              </a:spcAft>
+              <a:defRPr sz="1725">
                 <a:solidFill>
                   <a:srgbClr val="302C3C"/>
                 </a:solidFill>
@@ -12958,7 +12959,7 @@
               </a:defRPr>
             </a:pPr>
             <a:r>
-              <a:rPr sz="1650" b="1">
+              <a:rPr sz="1725" b="1">
                 <a:solidFill>
                   <a:srgbClr val="302C3C"/>
                 </a:solidFill>
@@ -12966,10 +12967,10 @@
                 <a:ea typeface="Arial"/>
                 <a:cs typeface="Arial"/>
               </a:rPr>
-              <a:t>Content-Addressed Vector Cache  </a:t>
+              <a:t>Check behavior after retrieval  </a:t>
             </a:r>
             <a:r>
-              <a:rPr sz="1650">
+              <a:rPr sz="1725">
                 <a:solidFill>
                   <a:srgbClr val="302C3C"/>
                 </a:solidFill>
@@ -12977,15 +12978,15 @@
                 <a:ea typeface="Arial"/>
                 <a:cs typeface="Arial"/>
               </a:rPr>
-              <a:t>Vectors are keyed on chunk hash and encoder recipe—immune to file renames, line shifts, and directory reorganization.</a:t>
+              <a:t>Use executable examples to rerank semantic candidates; keep the dense order when useful verification evidence is unavailable.</a:t>
             </a:r>
           </a:p>
           <a:p xmlns:a="http://schemas.openxmlformats.org/drawingml/2006/main">
             <a:pPr>
               <a:spcAft>
-                <a:spcPts val="1100"/>
-              </a:spcAft>
-              <a:defRPr sz="1650">
+                <a:spcPts val="1500"/>
+              </a:spcAft>
+              <a:defRPr sz="1725">
                 <a:solidFill>
                   <a:srgbClr val="302C3C"/>
                 </a:solidFill>
@@ -12995,7 +12996,7 @@
               </a:defRPr>
             </a:pPr>
             <a:r>
-              <a:rPr sz="1650" b="1">
+              <a:rPr sz="1725" b="1">
                 <a:solidFill>
                   <a:srgbClr val="302C3C"/>
                 </a:solidFill>
@@ -13003,10 +13004,10 @@
                 <a:ea typeface="Arial"/>
                 <a:cs typeface="Arial"/>
               </a:rPr>
-              <a:t>Strict Version Provenance &amp; Lineage  </a:t>
+              <a:t>Traceable versions and vectors  </a:t>
             </a:r>
             <a:r>
-              <a:rPr sz="1650">
+              <a:rPr sz="1725">
                 <a:solidFill>
                   <a:srgbClr val="302C3C"/>
                 </a:solidFill>
@@ -13014,15 +13015,15 @@
                 <a:ea typeface="Arial"/>
                 <a:cs typeface="Arial"/>
               </a:rPr>
-              <a:t>Groups evolving snippets using 5-shingles and Jaccard clustering, ranking working variants first across Git history.</a:t>
+              <a:t>Retain snapshot identity, content hashes and full encoder recipes. Validate dimensions, finite values and exact cache coverage.</a:t>
             </a:r>
           </a:p>
           <a:p xmlns:a="http://schemas.openxmlformats.org/drawingml/2006/main">
             <a:pPr>
               <a:spcAft>
-                <a:spcPts val="1100"/>
-              </a:spcAft>
-              <a:defRPr sz="1650">
+                <a:spcPts val="1500"/>
+              </a:spcAft>
+              <a:defRPr sz="1725">
                 <a:solidFill>
                   <a:srgbClr val="302C3C"/>
                 </a:solidFill>
@@ -13032,7 +13033,7 @@
               </a:defRPr>
             </a:pPr>
             <a:r>
-              <a:rPr sz="1650" b="1">
+              <a:rPr sz="1725" b="1">
                 <a:solidFill>
                   <a:srgbClr val="302C3C"/>
                 </a:solidFill>
@@ -13040,10 +13041,10 @@
                 <a:ea typeface="Arial"/>
                 <a:cs typeface="Arial"/>
               </a:rPr>
-              <a:t>Academic Research Integrity  </a:t>
+              <a:t>Research discipline  </a:t>
             </a:r>
             <a:r>
-              <a:rPr sz="1650">
+              <a:rPr sz="1725">
                 <a:solidFill>
                   <a:srgbClr val="302C3C"/>
                 </a:solidFill>
@@ -13051,7 +13052,7 @@
                 <a:ea typeface="Arial"/>
                 <a:cs typeface="Arial"/>
               </a:rPr>
-              <a:t>Preserved negative results (learned reranker failed bootstrap gate, so it was rejected); enforced cache=None in official MTEB runs.</a:t>
+              <a:t>Preserve negative experiments and historical results; distinguish synthetic functional checks, scored benchmark evidence and measured runtime.</a:t>
             </a:r>
           </a:p>
         </p:txBody>
@@ -13182,9 +13183,9 @@
           <a:p xmlns:a="http://schemas.openxmlformats.org/drawingml/2006/main">
             <a:pPr>
               <a:spcAft>
-                <a:spcPts val="1100"/>
-              </a:spcAft>
-              <a:defRPr sz="1650">
+                <a:spcPts val="1500"/>
+              </a:spcAft>
+              <a:defRPr sz="1725">
                 <a:solidFill>
                   <a:srgbClr val="302C3C"/>
                 </a:solidFill>
@@ -13194,7 +13195,7 @@
               </a:defRPr>
             </a:pPr>
             <a:r>
-              <a:rPr sz="1650" b="1">
+              <a:rPr sz="1725" b="1">
                 <a:solidFill>
                   <a:srgbClr val="302C3C"/>
                 </a:solidFill>
@@ -13202,10 +13203,10 @@
                 <a:ea typeface="Arial"/>
                 <a:cs typeface="Arial"/>
               </a:rPr>
-              <a:t>[x] Working Prototype Source Code  </a:t>
+              <a:t>Source and reproducible setup  </a:t>
             </a:r>
             <a:r>
-              <a:rPr sz="1650">
+              <a:rPr sz="1725">
                 <a:solidFill>
                   <a:srgbClr val="302C3C"/>
                 </a:solidFill>
@@ -13213,15 +13214,15 @@
                 <a:ea typeface="Arial"/>
                 <a:cs typeface="Arial"/>
               </a:rPr>
-              <a:t>Full source code merged on main (commit 2024ca1) with reproducible setup instructions and 571 passing tests.</a:t>
+              <a:t>CodeDoctor repository; README includes clean-environment, live evaluation and version-engine commands.</a:t>
             </a:r>
           </a:p>
           <a:p xmlns:a="http://schemas.openxmlformats.org/drawingml/2006/main">
             <a:pPr>
               <a:spcAft>
-                <a:spcPts val="1100"/>
-              </a:spcAft>
-              <a:defRPr sz="1650">
+                <a:spcPts val="1500"/>
+              </a:spcAft>
+              <a:defRPr sz="1725">
                 <a:solidFill>
                   <a:srgbClr val="302C3C"/>
                 </a:solidFill>
@@ -13231,7 +13232,7 @@
               </a:defRPr>
             </a:pPr>
             <a:r>
-              <a:rPr sz="1650" b="1">
+              <a:rPr sz="1725" b="1">
                 <a:solidFill>
                   <a:srgbClr val="302C3C"/>
                 </a:solidFill>
@@ -13239,10 +13240,10 @@
                 <a:ea typeface="Arial"/>
                 <a:cs typeface="Arial"/>
               </a:rPr>
-              <a:t>[x] Requirements Files  </a:t>
+              <a:t>Dependencies  </a:t>
             </a:r>
             <a:r>
-              <a:rPr sz="1650">
+              <a:rPr sz="1725">
                 <a:solidFill>
                   <a:srgbClr val="302C3C"/>
                 </a:solidFill>
@@ -13250,15 +13251,15 @@
                 <a:ea typeface="Arial"/>
                 <a:cs typeface="Arial"/>
               </a:rPr>
-              <a:t>Both requirement.txt (singular, checklist compliant) and requirements-submission.txt pinned and verified.</a:t>
+              <a:t>requirement.txt and requirements-submission.txt select the portable submission stack; measured environments are preserved separately.</a:t>
             </a:r>
           </a:p>
           <a:p xmlns:a="http://schemas.openxmlformats.org/drawingml/2006/main">
             <a:pPr>
               <a:spcAft>
-                <a:spcPts val="1100"/>
-              </a:spcAft>
-              <a:defRPr sz="1650">
+                <a:spcPts val="1500"/>
+              </a:spcAft>
+              <a:defRPr sz="1725">
                 <a:solidFill>
                   <a:srgbClr val="302C3C"/>
                 </a:solidFill>
@@ -13268,7 +13269,7 @@
               </a:defRPr>
             </a:pPr>
             <a:r>
-              <a:rPr sz="1650" b="1">
+              <a:rPr sz="1725" b="1">
                 <a:solidFill>
                   <a:srgbClr val="302C3C"/>
                 </a:solidFill>
@@ -13276,10 +13277,10 @@
                 <a:ea typeface="Arial"/>
                 <a:cs typeface="Arial"/>
               </a:rPr>
-              <a:t>[x] Presentation Deck &amp; PDF  </a:t>
+              <a:t>Presentation and disclosure  </a:t>
             </a:r>
             <a:r>
-              <a:rPr sz="1650">
+              <a:rPr sz="1725">
                 <a:solidFill>
                   <a:srgbClr val="302C3C"/>
                 </a:solidFill>
@@ -13287,15 +13288,15 @@
                 <a:ea typeface="Arial"/>
                 <a:cs typeface="Arial"/>
               </a:rPr>
-              <a:t>Completed 12-slide presentation (VITV_Doctors_Submission.pptx) and matching PDF (VITV_Doctors_Submission.pdf).</a:t>
+              <a:t>VITV_Doctors_Submission.pptx and matching PDF; the official LangAI3.0 AI disclosure form records tool assistance.</a:t>
             </a:r>
           </a:p>
           <a:p xmlns:a="http://schemas.openxmlformats.org/drawingml/2006/main">
             <a:pPr>
               <a:spcAft>
-                <a:spcPts val="1100"/>
-              </a:spcAft>
-              <a:defRPr sz="1650">
+                <a:spcPts val="1500"/>
+              </a:spcAft>
+              <a:defRPr sz="1725">
                 <a:solidFill>
                   <a:srgbClr val="302C3C"/>
                 </a:solidFill>
@@ -13305,7 +13306,7 @@
               </a:defRPr>
             </a:pPr>
             <a:r>
-              <a:rPr sz="1650" b="1">
+              <a:rPr sz="1725" b="1">
                 <a:solidFill>
                   <a:srgbClr val="302C3C"/>
                 </a:solidFill>
@@ -13313,10 +13314,10 @@
                 <a:ea typeface="Arial"/>
                 <a:cs typeface="Arial"/>
               </a:rPr>
-              <a:t>[x] AI Disclosure &amp; Official Release Tag  </a:t>
+              <a:t>Benchmark evidence  </a:t>
             </a:r>
             <a:r>
-              <a:rPr sz="1650">
+              <a:rPr sz="1725">
                 <a:solidFill>
                   <a:srgbClr val="302C3C"/>
                 </a:solidFill>
@@ -13324,15 +13325,15 @@
                 <a:ea typeface="Arial"/>
                 <a:cs typeface="Arial"/>
               </a:rPr>
-              <a:t>Official LangAI3.0_AI_Disclosure.docx completed; released under tag PRISM_GENAI_HACKATHON_Y2026 with MTEB results.</a:t>
+              <a:t>Historical result JSON and response CSV retain their original identity. CPU encoding measurements are reported separately from scoring replay.</a:t>
             </a:r>
           </a:p>
           <a:p xmlns:a="http://schemas.openxmlformats.org/drawingml/2006/main">
             <a:pPr>
               <a:spcAft>
-                <a:spcPts val="1100"/>
-              </a:spcAft>
-              <a:defRPr sz="1650">
+                <a:spcPts val="1500"/>
+              </a:spcAft>
+              <a:defRPr sz="1725">
                 <a:solidFill>
                   <a:srgbClr val="302C3C"/>
                 </a:solidFill>
@@ -13342,7 +13343,7 @@
               </a:defRPr>
             </a:pPr>
             <a:r>
-              <a:rPr sz="1650" b="1">
+              <a:rPr sz="1725" b="1">
                 <a:solidFill>
                   <a:srgbClr val="302C3C"/>
                 </a:solidFill>
@@ -13350,10 +13351,10 @@
                 <a:ea typeface="Arial"/>
                 <a:cs typeface="Arial"/>
               </a:rPr>
-              <a:t>[x] Product Demo Video  </a:t>
+              <a:t>Demo and submission tag  </a:t>
             </a:r>
             <a:r>
-              <a:rPr sz="1650">
+              <a:rPr sz="1725">
                 <a:solidFill>
                   <a:srgbClr val="302C3C"/>
                 </a:solidFill>
@@ -13361,7 +13362,7 @@
                 <a:ea typeface="Arial"/>
                 <a:cs typeface="Arial"/>
               </a:rPr>
-              <a:t>5-minute product walkthrough video recorded: https://youtu.be/0k2UUJOp-Tc (linked in README.md &amp; release assets).</a:t>
+              <a:t>Video: https://youtu.be/0k2UUJOp-Tc. Submission tag: PRISM_GENAI_HACKATHON_Y2026. The current public video duration is 5:46.</a:t>
             </a:r>
           </a:p>
         </p:txBody>
@@ -13560,6 +13561,7 @@
           <a:lstStyle xmlns:a="http://schemas.openxmlformats.org/drawingml/2006/main"/>
           <a:p xmlns:a="http://schemas.openxmlformats.org/drawingml/2006/main">
             <a:pPr>
+              <a:buNone/>
               <a:defRPr sz="2025" b="0">
                 <a:solidFill>
                   <a:srgbClr val="70509B"/>
@@ -13709,7 +13711,7 @@
           <a:p xmlns:a="http://schemas.openxmlformats.org/drawingml/2006/main">
             <a:pPr>
               <a:spcAft>
-                <a:spcPts val="1400"/>
+                <a:spcPts val="1500"/>
               </a:spcAft>
               <a:defRPr sz="1800">
                 <a:solidFill>
@@ -13729,7 +13731,7 @@
                 <a:ea typeface="Arial"/>
                 <a:cs typeface="Arial"/>
               </a:rPr>
-              <a:t>Theme 01: Agentic Code Intelligence  </a:t>
+              <a:t>Theme 01: Code intelligence  </a:t>
             </a:r>
             <a:r>
               <a:rPr sz="1800">
@@ -13740,13 +13742,13 @@
                 <a:ea typeface="Arial"/>
                 <a:cs typeface="Arial"/>
               </a:rPr>
-              <a:t>Natural-language code retrieval across complex codebases requires semantic understanding and exact structural evidence.</a:t>
+              <a:t>Retrieve ranked code for natural-language queries, with source evidence and support for changing codebases.</a:t>
             </a:r>
           </a:p>
           <a:p xmlns:a="http://schemas.openxmlformats.org/drawingml/2006/main">
             <a:pPr>
               <a:spcAft>
-                <a:spcPts val="1400"/>
+                <a:spcPts val="1500"/>
               </a:spcAft>
               <a:defRPr sz="1800">
                 <a:solidFill>
@@ -13766,7 +13768,7 @@
                 <a:ea typeface="Arial"/>
                 <a:cs typeface="Arial"/>
               </a:rPr>
-              <a:t>Judge Mandate: Pre/Post-Processing Focus  </a:t>
+              <a:t>Pre/post-processing contribution  </a:t>
             </a:r>
             <a:r>
               <a:rPr sz="1800">
@@ -13777,13 +13779,13 @@
                 <a:ea typeface="Arial"/>
                 <a:cs typeface="Arial"/>
               </a:rPr>
-              <a:t>Evaluated on pre/post-processing innovation with strict CPU-only retrieval (minimal GPU, no external query APIs).</a:t>
+              <a:t>Reuse unchanged code embeddings before retrieval; verify candidate behavior after retrieval. The embedding model remains fixed.</a:t>
             </a:r>
           </a:p>
           <a:p xmlns:a="http://schemas.openxmlformats.org/drawingml/2006/main">
             <a:pPr>
               <a:spcAft>
-                <a:spcPts val="1400"/>
+                <a:spcPts val="1500"/>
               </a:spcAft>
               <a:defRPr sz="1800">
                 <a:solidFill>
@@ -13803,7 +13805,7 @@
                 <a:ea typeface="Arial"/>
                 <a:cs typeface="Arial"/>
               </a:rPr>
-              <a:t>Core Objective  </a:t>
+              <a:t>Evaluation priorities  </a:t>
             </a:r>
             <a:r>
               <a:rPr sz="1800">
@@ -13814,13 +13816,13 @@
                 <a:ea typeface="Arial"/>
                 <a:cs typeface="Arial"/>
               </a:rPr>
-              <a:t>Return ranked, checkable code spans with file/line evidence rather than opaque, unverified generated answers.</a:t>
+              <a:t>P0: official AppsRetrieval test. P1: rebuild or update after code changes. Bonus: retrieve related variants across versions.</a:t>
             </a:r>
           </a:p>
           <a:p xmlns:a="http://schemas.openxmlformats.org/drawingml/2006/main">
             <a:pPr>
               <a:spcAft>
-                <a:spcPts val="1400"/>
+                <a:spcPts val="1500"/>
               </a:spcAft>
               <a:defRPr sz="1800">
                 <a:solidFill>
@@ -13840,7 +13842,7 @@
                 <a:ea typeface="Arial"/>
                 <a:cs typeface="Arial"/>
               </a:rPr>
-              <a:t>Three-Tier Evaluation Goals  </a:t>
+              <a:t>Efficiency guidance  </a:t>
             </a:r>
             <a:r>
               <a:rPr sz="1800">
@@ -13851,7 +13853,7 @@
                 <a:ea typeface="Arial"/>
                 <a:cs typeface="Arial"/>
               </a:rPr>
-              <a:t>P0: CoIR AppsRetrieval benchmark (3,765 test queries / 8,765 docs); P1: Sub-second CPU incremental re-indexing; Bonus: Cross-version variant selection.</a:t>
+              <a:t>The FAQ permits GPU preprocessing and asks for minimal GPU use during retrieval, ideally CPU only. Our selected query path uses CPU.</a:t>
             </a:r>
           </a:p>
         </p:txBody>
@@ -13982,7 +13984,7 @@
           <a:p xmlns:a="http://schemas.openxmlformats.org/drawingml/2006/main">
             <a:pPr>
               <a:spcAft>
-                <a:spcPts val="1400"/>
+                <a:spcPts val="1500"/>
               </a:spcAft>
               <a:defRPr sz="1800">
                 <a:solidFill>
@@ -14002,7 +14004,7 @@
                 <a:ea typeface="Arial"/>
                 <a:cs typeface="Arial"/>
               </a:rPr>
-              <a:t>Lexical vs. Semantic Tradeoff  </a:t>
+              <a:t>Intent and identifiers  </a:t>
             </a:r>
             <a:r>
               <a:rPr sz="1800">
@@ -14013,13 +14015,13 @@
                 <a:ea typeface="Arial"/>
                 <a:cs typeface="Arial"/>
               </a:rPr>
-              <a:t>Keywords (BM25) miss conceptual intent; dense models capture semantics but miss exact identifiers and incur high CPU latency.</a:t>
+              <a:t>Lexical search can miss conceptual intent; dense search can miss exact names. The workbench combines both signals.</a:t>
             </a:r>
           </a:p>
           <a:p xmlns:a="http://schemas.openxmlformats.org/drawingml/2006/main">
             <a:pPr>
               <a:spcAft>
-                <a:spcPts val="1400"/>
+                <a:spcPts val="1500"/>
               </a:spcAft>
               <a:defRPr sz="1800">
                 <a:solidFill>
@@ -14039,7 +14041,7 @@
                 <a:ea typeface="Arial"/>
                 <a:cs typeface="Arial"/>
               </a:rPr>
-              <a:t>Dense CPU Latency Bottleneck  </a:t>
+              <a:t>Repeated indexing cost  </a:t>
             </a:r>
             <a:r>
               <a:rPr sz="1800">
@@ -14050,13 +14052,13 @@
                 <a:ea typeface="Arial"/>
                 <a:cs typeface="Arial"/>
               </a:rPr>
-              <a:t>Encoding every query on CPU takes 2-8 seconds; invoking large models or cloud APIs on every query violates hackathon efficiency goals.</a:t>
+              <a:t>Unchanged code should not incur repeated model inference. Content and encoder-recipe keys enable vector reuse.</a:t>
             </a:r>
           </a:p>
           <a:p xmlns:a="http://schemas.openxmlformats.org/drawingml/2006/main">
             <a:pPr>
               <a:spcAft>
-                <a:spcPts val="1400"/>
+                <a:spcPts val="1500"/>
               </a:spcAft>
               <a:defRPr sz="1800">
                 <a:solidFill>
@@ -14076,7 +14078,7 @@
                 <a:ea typeface="Arial"/>
                 <a:cs typeface="Arial"/>
               </a:rPr>
-              <a:t>Re-Indexing Redundancy in CI/CD  </a:t>
+              <a:t>Similar text, different behavior  </a:t>
             </a:r>
             <a:r>
               <a:rPr sz="1800">
@@ -14087,13 +14089,13 @@
                 <a:ea typeface="Arial"/>
                 <a:cs typeface="Arial"/>
               </a:rPr>
-              <a:t>Standard code search engines re-embed full files or the whole repository on every commit, wasting compute on unchanged code.</a:t>
+              <a:t>A plausible snippet can fail a worked example. Behavioral checks can improve its ranking when usable examples are present.</a:t>
             </a:r>
           </a:p>
           <a:p xmlns:a="http://schemas.openxmlformats.org/drawingml/2006/main">
             <a:pPr>
               <a:spcAft>
-                <a:spcPts val="1400"/>
+                <a:spcPts val="1500"/>
               </a:spcAft>
               <a:defRPr sz="1800">
                 <a:solidFill>
@@ -14113,7 +14115,7 @@
                 <a:ea typeface="Arial"/>
                 <a:cs typeface="Arial"/>
               </a:rPr>
-              <a:t>Context Leakage &amp; Unverified Code  </a:t>
+              <a:t>Version ambiguity  </a:t>
             </a:r>
             <a:r>
               <a:rPr sz="1800">
@@ -14124,7 +14126,7 @@
                 <a:ea typeface="Arial"/>
                 <a:cs typeface="Arial"/>
               </a:rPr>
-              <a:t>Cross-commit search risks silent fallback to HEAD; text embeddings rank buggy near-misses above working fixes in 67-78% of queries.</a:t>
+              <a:t>Historical results need explicit snapshot identity. Version isolation prevents a missing version from silently falling back to current code.</a:t>
             </a:r>
           </a:p>
         </p:txBody>
@@ -14189,7 +14191,7 @@
         </p:spPr>
         <p:txBody>
           <a:bodyPr xmlns:a="http://schemas.openxmlformats.org/drawingml/2006/main" spcFirstLastPara="1" wrap="square" lIns="91425" tIns="45700" rIns="91425" bIns="45700" anchor="ctr">
-            <a:normAutofit/>
+            <a:noAutofit/>
           </a:bodyPr>
           <a:lstStyle xmlns:a="http://schemas.openxmlformats.org/drawingml/2006/main"/>
           <a:p xmlns:a="http://schemas.openxmlformats.org/drawingml/2006/main">
@@ -14209,15 +14211,23 @@
               <a:buSzPts val="4400"/>
               <a:buFont typeface="Calibri"/>
               <a:buNone/>
+              <a:defRPr sz="3600" b="1">
+                <a:solidFill>
+                  <a:srgbClr val="70509B"/>
+                </a:solidFill>
+                <a:latin typeface="Arial"/>
+                <a:ea typeface="Arial"/>
+                <a:cs typeface="Arial"/>
+              </a:defRPr>
             </a:pPr>
             <a:r>
-              <a:rPr b="1">
-                <a:solidFill>
-                  <a:srgbClr val="704EA6"/>
-                </a:solidFill>
-                <a:latin typeface="Calibri"/>
-                <a:ea typeface="Calibri"/>
-                <a:cs typeface="Calibri"/>
+              <a:rPr sz="3600" b="1">
+                <a:solidFill>
+                  <a:srgbClr val="70509B"/>
+                </a:solidFill>
+                <a:latin typeface="Arial"/>
+                <a:ea typeface="Arial"/>
+                <a:cs typeface="Arial"/>
               </a:rPr>
               <a:t>Our Solutions &amp; Architecture Diagram</a:t>
             </a:r>
@@ -14317,6 +14327,7 @@
           <a:lstStyle xmlns:a="http://schemas.openxmlformats.org/drawingml/2006/main"/>
           <a:p xmlns:a="http://schemas.openxmlformats.org/drawingml/2006/main">
             <a:pPr>
+              <a:buNone/>
               <a:defRPr sz="2250" b="1">
                 <a:solidFill>
                   <a:srgbClr val="70509B"/>
@@ -14415,6 +14426,7 @@
           <a:lstStyle xmlns:a="http://schemas.openxmlformats.org/drawingml/2006/main"/>
           <a:p xmlns:a="http://schemas.openxmlformats.org/drawingml/2006/main">
             <a:pPr>
+              <a:buNone/>
               <a:defRPr sz="1575" b="1">
                 <a:solidFill>
                   <a:srgbClr val="70509B"/>
@@ -14472,7 +14484,8 @@
           <a:lstStyle xmlns:a="http://schemas.openxmlformats.org/drawingml/2006/main"/>
           <a:p xmlns:a="http://schemas.openxmlformats.org/drawingml/2006/main">
             <a:pPr>
-              <a:defRPr sz="1350" b="0">
+              <a:buNone/>
+              <a:defRPr sz="1425" b="0">
                 <a:solidFill>
                   <a:srgbClr val="302C3C"/>
                 </a:solidFill>
@@ -14482,7 +14495,7 @@
               </a:defRPr>
             </a:pPr>
             <a:r>
-              <a:rPr sz="1350" b="0">
+              <a:rPr sz="1425" b="0">
                 <a:solidFill>
                   <a:srgbClr val="302C3C"/>
                 </a:solidFill>
@@ -14490,12 +14503,13 @@
                 <a:ea typeface="Arial"/>
                 <a:cs typeface="Arial"/>
               </a:rPr>
-              <a:t>• Exact CoIR / repo normalization</a:t>
+              <a:t>• P0: exact CoIR corpus text</a:t>
             </a:r>
           </a:p>
           <a:p xmlns:a="http://schemas.openxmlformats.org/drawingml/2006/main">
             <a:pPr>
-              <a:defRPr sz="1350" b="0">
+              <a:buNone/>
+              <a:defRPr sz="1425" b="0">
                 <a:solidFill>
                   <a:srgbClr val="302C3C"/>
                 </a:solidFill>
@@ -14505,7 +14519,7 @@
               </a:defRPr>
             </a:pPr>
             <a:r>
-              <a:rPr sz="1350" b="0">
+              <a:rPr sz="1425" b="0">
                 <a:solidFill>
                   <a:srgbClr val="302C3C"/>
                 </a:solidFill>
@@ -14513,12 +14527,13 @@
                 <a:ea typeface="Arial"/>
                 <a:cs typeface="Arial"/>
               </a:rPr>
-              <a:t>• Tree-sitter AST statement chunking*</a:t>
+              <a:t>• Pinned embedding recipe</a:t>
             </a:r>
           </a:p>
           <a:p xmlns:a="http://schemas.openxmlformats.org/drawingml/2006/main">
             <a:pPr>
-              <a:defRPr sz="1350" b="0">
+              <a:buNone/>
+              <a:defRPr sz="1425" b="0">
                 <a:solidFill>
                   <a:srgbClr val="302C3C"/>
                 </a:solidFill>
@@ -14528,7 +14543,7 @@
               </a:defRPr>
             </a:pPr>
             <a:r>
-              <a:rPr sz="1350" b="0">
+              <a:rPr sz="1425" b="0">
                 <a:solidFill>
                   <a:srgbClr val="302C3C"/>
                 </a:solidFill>
@@ -14541,7 +14556,8 @@
           </a:p>
           <a:p xmlns:a="http://schemas.openxmlformats.org/drawingml/2006/main">
             <a:pPr>
-              <a:defRPr sz="1350" b="0">
+              <a:buNone/>
+              <a:defRPr sz="1425" b="0">
                 <a:solidFill>
                   <a:srgbClr val="302C3C"/>
                 </a:solidFill>
@@ -14551,7 +14567,7 @@
               </a:defRPr>
             </a:pPr>
             <a:r>
-              <a:rPr sz="1350" b="0">
+              <a:rPr sz="1425" b="0">
                 <a:solidFill>
                   <a:srgbClr val="302C3C"/>
                 </a:solidFill>
@@ -14559,12 +14575,13 @@
                 <a:ea typeface="Arial"/>
                 <a:cs typeface="Arial"/>
               </a:rPr>
-              <a:t>• Invariant recipe keys (SHA-256)</a:t>
+              <a:t>• Workbench: AST chunks*</a:t>
             </a:r>
           </a:p>
           <a:p xmlns:a="http://schemas.openxmlformats.org/drawingml/2006/main">
             <a:pPr>
-              <a:defRPr sz="1350" b="0">
+              <a:buNone/>
+              <a:defRPr sz="1425" b="0">
                 <a:solidFill>
                   <a:srgbClr val="302C3C"/>
                 </a:solidFill>
@@ -14574,7 +14591,7 @@
               </a:defRPr>
             </a:pPr>
             <a:r>
-              <a:rPr sz="1350" b="0">
+              <a:rPr sz="1425" b="0">
                 <a:solidFill>
                   <a:srgbClr val="302C3C"/>
                 </a:solidFill>
@@ -14582,7 +14599,7 @@
                 <a:ea typeface="Arial"/>
                 <a:cs typeface="Arial"/>
               </a:rPr>
-              <a:t>• Incremental diff vector reuse*</a:t>
+              <a:t>• Reuse unchanged chunks*</a:t>
             </a:r>
           </a:p>
         </p:txBody>
@@ -14662,6 +14679,7 @@
           <a:lstStyle xmlns:a="http://schemas.openxmlformats.org/drawingml/2006/main"/>
           <a:p xmlns:a="http://schemas.openxmlformats.org/drawingml/2006/main">
             <a:pPr>
+              <a:buNone/>
               <a:defRPr sz="1575" b="1">
                 <a:solidFill>
                   <a:srgbClr val="70509B"/>
@@ -14719,7 +14737,8 @@
           <a:lstStyle xmlns:a="http://schemas.openxmlformats.org/drawingml/2006/main"/>
           <a:p xmlns:a="http://schemas.openxmlformats.org/drawingml/2006/main">
             <a:pPr>
-              <a:defRPr sz="1350" b="0">
+              <a:buNone/>
+              <a:defRPr sz="1425" b="0">
                 <a:solidFill>
                   <a:srgbClr val="302C3C"/>
                 </a:solidFill>
@@ -14729,7 +14748,7 @@
               </a:defRPr>
             </a:pPr>
             <a:r>
-              <a:rPr sz="1350" b="0">
+              <a:rPr sz="1425" b="0">
                 <a:solidFill>
                   <a:srgbClr val="302C3C"/>
                 </a:solidFill>
@@ -14737,12 +14756,13 @@
                 <a:ea typeface="Arial"/>
                 <a:cs typeface="Arial"/>
               </a:rPr>
-              <a:t>• Evidence-gated router (0.4 ms free passes)*</a:t>
+              <a:t>• F2LLM-v2-1.7B (accuracy)</a:t>
             </a:r>
           </a:p>
           <a:p xmlns:a="http://schemas.openxmlformats.org/drawingml/2006/main">
             <a:pPr>
-              <a:defRPr sz="1350" b="0">
+              <a:buNone/>
+              <a:defRPr sz="1425" b="0">
                 <a:solidFill>
                   <a:srgbClr val="302C3C"/>
                 </a:solidFill>
@@ -14752,7 +14772,7 @@
               </a:defRPr>
             </a:pPr>
             <a:r>
-              <a:rPr sz="1350" b="0">
+              <a:rPr sz="1425" b="0">
                 <a:solidFill>
                   <a:srgbClr val="302C3C"/>
                 </a:solidFill>
@@ -14760,12 +14780,13 @@
                 <a:ea typeface="Arial"/>
                 <a:cs typeface="Arial"/>
               </a:rPr>
-              <a:t>• Pinned open-weights F2LLM-v2-1.7B</a:t>
+              <a:t>• CPU query inference</a:t>
             </a:r>
           </a:p>
           <a:p xmlns:a="http://schemas.openxmlformats.org/drawingml/2006/main">
             <a:pPr>
-              <a:defRPr sz="1350" b="0">
+              <a:buNone/>
+              <a:defRPr sz="1425" b="0">
                 <a:solidFill>
                   <a:srgbClr val="302C3C"/>
                 </a:solidFill>
@@ -14775,7 +14796,7 @@
               </a:defRPr>
             </a:pPr>
             <a:r>
-              <a:rPr sz="1350" b="0">
+              <a:rPr sz="1425" b="0">
                 <a:solidFill>
                   <a:srgbClr val="302C3C"/>
                 </a:solidFill>
@@ -14783,12 +14804,13 @@
                 <a:ea typeface="Arial"/>
                 <a:cs typeface="Arial"/>
               </a:rPr>
-              <a:t>• Top-20 cosine candidate generation</a:t>
+              <a:t>• Cosine top-20 candidates</a:t>
             </a:r>
           </a:p>
           <a:p xmlns:a="http://schemas.openxmlformats.org/drawingml/2006/main">
             <a:pPr>
-              <a:defRPr sz="1350" b="0">
+              <a:buNone/>
+              <a:defRPr sz="1425" b="0">
                 <a:solidFill>
                   <a:srgbClr val="302C3C"/>
                 </a:solidFill>
@@ -14798,7 +14820,7 @@
               </a:defRPr>
             </a:pPr>
             <a:r>
-              <a:rPr sz="1350" b="0">
+              <a:rPr sz="1425" b="0">
                 <a:solidFill>
                   <a:srgbClr val="302C3C"/>
                 </a:solidFill>
@@ -14806,12 +14828,13 @@
                 <a:ea typeface="Arial"/>
                 <a:cs typeface="Arial"/>
               </a:rPr>
-              <a:t>• Additive Reciprocal Rank Fusion (k=60)*</a:t>
+              <a:t>• Symbol/BM25 routing*</a:t>
             </a:r>
           </a:p>
           <a:p xmlns:a="http://schemas.openxmlformats.org/drawingml/2006/main">
             <a:pPr>
-              <a:defRPr sz="1350" b="0">
+              <a:buNone/>
+              <a:defRPr sz="1425" b="0">
                 <a:solidFill>
                   <a:srgbClr val="302C3C"/>
                 </a:solidFill>
@@ -14821,7 +14844,7 @@
               </a:defRPr>
             </a:pPr>
             <a:r>
-              <a:rPr sz="1350" b="0">
+              <a:rPr sz="1425" b="0">
                 <a:solidFill>
                   <a:srgbClr val="302C3C"/>
                 </a:solidFill>
@@ -14829,7 +14852,7 @@
                 <a:ea typeface="Arial"/>
                 <a:cs typeface="Arial"/>
               </a:rPr>
-              <a:t>• Zero-vector attention cap on &gt;6k chars</a:t>
+              <a:t>• Reciprocal rank fusion*</a:t>
             </a:r>
           </a:p>
         </p:txBody>
@@ -14909,6 +14932,7 @@
           <a:lstStyle xmlns:a="http://schemas.openxmlformats.org/drawingml/2006/main"/>
           <a:p xmlns:a="http://schemas.openxmlformats.org/drawingml/2006/main">
             <a:pPr>
+              <a:buNone/>
               <a:defRPr sz="1575" b="1">
                 <a:solidFill>
                   <a:srgbClr val="70509B"/>
@@ -14966,7 +14990,8 @@
           <a:lstStyle xmlns:a="http://schemas.openxmlformats.org/drawingml/2006/main"/>
           <a:p xmlns:a="http://schemas.openxmlformats.org/drawingml/2006/main">
             <a:pPr>
-              <a:defRPr sz="1350" b="0">
+              <a:buNone/>
+              <a:defRPr sz="1425" b="0">
                 <a:solidFill>
                   <a:srgbClr val="302C3C"/>
                 </a:solidFill>
@@ -14976,7 +15001,7 @@
               </a:defRPr>
             </a:pPr>
             <a:r>
-              <a:rPr sz="1350" b="0">
+              <a:rPr sz="1425" b="0">
                 <a:solidFill>
                   <a:srgbClr val="302C3C"/>
                 </a:solidFill>
@@ -14984,12 +15009,13 @@
                 <a:ea typeface="Arial"/>
                 <a:cs typeface="Arial"/>
               </a:rPr>
-              <a:t>• Multi-layout worked-example parser</a:t>
+              <a:t>• Parse worked examples</a:t>
             </a:r>
           </a:p>
           <a:p xmlns:a="http://schemas.openxmlformats.org/drawingml/2006/main">
             <a:pPr>
-              <a:defRPr sz="1350" b="0">
+              <a:buNone/>
+              <a:defRPr sz="1425" b="0">
                 <a:solidFill>
                   <a:srgbClr val="302C3C"/>
                 </a:solidFill>
@@ -14999,7 +15025,7 @@
               </a:defRPr>
             </a:pPr>
             <a:r>
-              <a:rPr sz="1350" b="0">
+              <a:rPr sz="1425" b="0">
                 <a:solidFill>
                   <a:srgbClr val="302C3C"/>
                 </a:solidFill>
@@ -15007,12 +15033,13 @@
                 <a:ea typeface="Arial"/>
                 <a:cs typeface="Arial"/>
               </a:rPr>
-              <a:t>• Defensive subprocess sandbox (2s timeout)</a:t>
+              <a:t>• Execute candidate Python</a:t>
             </a:r>
           </a:p>
           <a:p xmlns:a="http://schemas.openxmlformats.org/drawingml/2006/main">
             <a:pPr>
-              <a:defRPr sz="1350" b="0">
+              <a:buNone/>
+              <a:defRPr sz="1425" b="0">
                 <a:solidFill>
                   <a:srgbClr val="302C3C"/>
                 </a:solidFill>
@@ -15022,7 +15049,7 @@
               </a:defRPr>
             </a:pPr>
             <a:r>
-              <a:rPr sz="1350" b="0">
+              <a:rPr sz="1425" b="0">
                 <a:solidFill>
                   <a:srgbClr val="302C3C"/>
                 </a:solidFill>
@@ -15030,12 +15057,13 @@
                 <a:ea typeface="Arial"/>
                 <a:cs typeface="Arial"/>
               </a:rPr>
-              <a:t>• Behavioral reranking (1e-06 tolerance)</a:t>
+              <a:t>• Time/resource limits</a:t>
             </a:r>
           </a:p>
           <a:p xmlns:a="http://schemas.openxmlformats.org/drawingml/2006/main">
             <a:pPr>
-              <a:defRPr sz="1350" b="0">
+              <a:buNone/>
+              <a:defRPr sz="1425" b="0">
                 <a:solidFill>
                   <a:srgbClr val="302C3C"/>
                 </a:solidFill>
@@ -15045,7 +15073,7 @@
               </a:defRPr>
             </a:pPr>
             <a:r>
-              <a:rPr sz="1350" b="0">
+              <a:rPr sz="1425" b="0">
                 <a:solidFill>
                   <a:srgbClr val="302C3C"/>
                 </a:solidFill>
@@ -15053,12 +15081,13 @@
                 <a:ea typeface="Arial"/>
                 <a:cs typeface="Arial"/>
               </a:rPr>
-              <a:t>• +0.02802 NDCG@10 ablation lift</a:t>
+              <a:t>• Rerank using pass/fail</a:t>
             </a:r>
           </a:p>
           <a:p xmlns:a="http://schemas.openxmlformats.org/drawingml/2006/main">
             <a:pPr>
-              <a:defRPr sz="1350" b="0">
+              <a:buNone/>
+              <a:defRPr sz="1425" b="0">
                 <a:solidFill>
                   <a:srgbClr val="302C3C"/>
                 </a:solidFill>
@@ -15068,7 +15097,7 @@
               </a:defRPr>
             </a:pPr>
             <a:r>
-              <a:rPr sz="1350" b="0">
+              <a:rPr sz="1425" b="0">
                 <a:solidFill>
                   <a:srgbClr val="302C3C"/>
                 </a:solidFill>
@@ -15076,7 +15105,7 @@
                 <a:ea typeface="Arial"/>
                 <a:cs typeface="Arial"/>
               </a:rPr>
-              <a:t>• Lineage variant selection (100% vs 8.3%)*</a:t>
+              <a:t>• Group version variants*</a:t>
             </a:r>
           </a:p>
         </p:txBody>
@@ -15175,6 +15204,7 @@
           <a:lstStyle xmlns:a="http://schemas.openxmlformats.org/drawingml/2006/main"/>
           <a:p xmlns:a="http://schemas.openxmlformats.org/drawingml/2006/main">
             <a:pPr>
+              <a:buNone/>
               <a:defRPr sz="1500" b="0">
                 <a:solidFill>
                   <a:srgbClr val="302C3C"/>
@@ -15193,7 +15223,7 @@
                 <a:ea typeface="Arial"/>
                 <a:cs typeface="Arial"/>
               </a:rPr>
-              <a:t>* Active in local repository workbench &amp; multi-version intelligence. P0 benchmark executes corpus vectors + behavioral execution reranking. Complies with Samsung CPU-only retrieval &amp; permissible open-weights model guidelines.</a:t>
+              <a:t>* Workbench and version engine features; they are not all part of the P0 benchmark. P0 uses corpus embeddings, CPU query embeddings and example-based reranking. Verification is conditional on usable examples and is not a correctness proof.</a:t>
             </a:r>
           </a:p>
         </p:txBody>
@@ -15324,7 +15354,7 @@
           <a:p xmlns:a="http://schemas.openxmlformats.org/drawingml/2006/main">
             <a:pPr>
               <a:spcAft>
-                <a:spcPts val="1100"/>
+                <a:spcPts val="1500"/>
               </a:spcAft>
               <a:defRPr sz="1725">
                 <a:solidFill>
@@ -15344,7 +15374,7 @@
                 <a:ea typeface="Arial"/>
                 <a:cs typeface="Arial"/>
               </a:rPr>
-              <a:t>1. Open &amp; Auto-Index  </a:t>
+              <a:t>1. Index Python code  </a:t>
             </a:r>
             <a:r>
               <a:rPr sz="1725">
@@ -15355,13 +15385,13 @@
                 <a:ea typeface="Arial"/>
                 <a:cs typeface="Arial"/>
               </a:rPr>
-              <a:t>Open any repository in CodeDoctor workbench; Tree-sitter parses AST chunks and builds the content-addressed index in the background.</a:t>
+              <a:t>Open a folder for a working snapshot. The built-in repository demo also exposes its Git history; arbitrary folder targets do not import history.</a:t>
             </a:r>
           </a:p>
           <a:p xmlns:a="http://schemas.openxmlformats.org/drawingml/2006/main">
             <a:pPr>
               <a:spcAft>
-                <a:spcPts val="1100"/>
+                <a:spcPts val="1500"/>
               </a:spcAft>
               <a:defRPr sz="1725">
                 <a:solidFill>
@@ -15381,7 +15411,7 @@
                 <a:ea typeface="Arial"/>
                 <a:cs typeface="Arial"/>
               </a:rPr>
-              <a:t>2. Multi-Signal Query  </a:t>
+              <a:t>2. Query with evidence  </a:t>
             </a:r>
             <a:r>
               <a:rPr sz="1725">
@@ -15392,13 +15422,13 @@
                 <a:ea typeface="Arial"/>
                 <a:cs typeface="Arial"/>
               </a:rPr>
-              <a:t>Router runs cheap lexical passes first; symbol queries resolve in 0.4 ms, while prose queries escalate to dense semantic retrieval.</a:t>
+              <a:t>Inspect ranked snippets, file/line spans and retrieval signals. Dense queries use the selected encoder tier.</a:t>
             </a:r>
           </a:p>
           <a:p xmlns:a="http://schemas.openxmlformats.org/drawingml/2006/main">
             <a:pPr>
               <a:spcAft>
-                <a:spcPts val="1100"/>
+                <a:spcPts val="1500"/>
               </a:spcAft>
               <a:defRPr sz="1725">
                 <a:solidFill>
@@ -15418,7 +15448,7 @@
                 <a:ea typeface="Arial"/>
                 <a:cs typeface="Arial"/>
               </a:rPr>
-              <a:t>3. Edit &amp; Rebuild (P1)  </a:t>
+              <a:t>3. Edit and update  </a:t>
             </a:r>
             <a:r>
               <a:rPr sz="1725">
@@ -15429,13 +15459,13 @@
                 <a:ea typeface="Arial"/>
                 <a:cs typeface="Arial"/>
               </a:rPr>
-              <a:t>Content-addressed cache re-embeds only modified functions, reusing unchanged vectors in 1.51 s (~68x CPU speedup).</a:t>
+              <a:t>One-function edit: 6.45 s, 2 chunks encoded and 48 reused. Unchanged update: 1.51 s. These are separate measured cases.</a:t>
             </a:r>
           </a:p>
           <a:p xmlns:a="http://schemas.openxmlformats.org/drawingml/2006/main">
             <a:pPr>
               <a:spcAft>
-                <a:spcPts val="1100"/>
+                <a:spcPts val="1500"/>
               </a:spcAft>
               <a:defRPr sz="1725">
                 <a:solidFill>
@@ -15455,7 +15485,7 @@
                 <a:ea typeface="Arial"/>
                 <a:cs typeface="Arial"/>
               </a:rPr>
-              <a:t>4. Version Verification (Bonus)  </a:t>
+              <a:t>4. Compare variants  </a:t>
             </a:r>
             <a:r>
               <a:rPr sz="1725">
@@ -15466,13 +15496,13 @@
                 <a:ea typeface="Arial"/>
                 <a:cs typeface="Arial"/>
               </a:rPr>
-              <a:t>Execution sandbox runs candidate variants across git history against worked examples, selecting the working variant with 100% accuracy.</a:t>
+              <a:t>A constructed three-version fixture tests lineage grouping and verification. The engine retains version identity for each result.</a:t>
             </a:r>
           </a:p>
           <a:p xmlns:a="http://schemas.openxmlformats.org/drawingml/2006/main">
             <a:pPr>
               <a:spcAft>
-                <a:spcPts val="1100"/>
+                <a:spcPts val="1500"/>
               </a:spcAft>
               <a:defRPr sz="1725">
                 <a:solidFill>
@@ -15492,7 +15522,7 @@
                 <a:ea typeface="Arial"/>
                 <a:cs typeface="Arial"/>
               </a:rPr>
-              <a:t>Measured Latencies &amp; Demo  </a:t>
+              <a:t>Recorded walkthrough  </a:t>
             </a:r>
             <a:r>
               <a:rPr sz="1725">
@@ -15503,7 +15533,7 @@
                 <a:ea typeface="Arial"/>
                 <a:cs typeface="Arial"/>
               </a:rPr>
-              <a:t>Symbol lookup ≈ 0.4 ms · Cold build ≈ 5.6 s · Incremental update ≈ 1.51 s (Kaggle Xeon). Demo video: https://youtu.be/0k2UUJOp-Tc</a:t>
+              <a:t>https://youtu.be/0k2UUJOp-Tc — published recording is 5:46; the supplied template asks for a maximum of 5:00.</a:t>
             </a:r>
           </a:p>
         </p:txBody>
@@ -15638,7 +15668,7 @@
           <a:p xmlns:a="http://schemas.openxmlformats.org/drawingml/2006/main">
             <a:pPr>
               <a:spcAft>
-                <a:spcPts val="1100"/>
+                <a:spcPts val="1500"/>
               </a:spcAft>
               <a:defRPr sz="1725">
                 <a:solidFill>
@@ -15658,7 +15688,7 @@
                 <a:ea typeface="Arial"/>
                 <a:cs typeface="Arial"/>
               </a:rPr>
-              <a:t>Language &amp; Core Engine  </a:t>
+              <a:t>Runtime  </a:t>
             </a:r>
             <a:r>
               <a:rPr sz="1725">
@@ -15669,13 +15699,13 @@
                 <a:ea typeface="Arial"/>
                 <a:cs typeface="Arial"/>
               </a:rPr>
-              <a:t>Python 3.11+, C++17 core engine (libcodedoctor) for native symbol indexing and graph traversal.</a:t>
+              <a:t>Python, PyTorch 2.8.0, Sentence Transformers and NumPy. The current retrieval path uses Python; the C++ component is a separate prototype.</a:t>
             </a:r>
           </a:p>
           <a:p xmlns:a="http://schemas.openxmlformats.org/drawingml/2006/main">
             <a:pPr>
               <a:spcAft>
-                <a:spcPts val="1100"/>
+                <a:spcPts val="1500"/>
               </a:spcAft>
               <a:defRPr sz="1725">
                 <a:solidFill>
@@ -15695,7 +15725,7 @@
                 <a:ea typeface="Arial"/>
                 <a:cs typeface="Arial"/>
               </a:rPr>
-              <a:t>AST &amp; Static Analysis  </a:t>
+              <a:t>Preprocessing  </a:t>
             </a:r>
             <a:r>
               <a:rPr sz="1725">
@@ -15706,13 +15736,13 @@
                 <a:ea typeface="Arial"/>
                 <a:cs typeface="Arial"/>
               </a:rPr>
-              <a:t>Tree-sitter (python, javascript, typescript); statement-boundary splitter for functions &gt;80 lines; structural edge extractor.</a:t>
+              <a:t>Tree-sitter AST chunks, structural metadata and SQLite content-addressed embeddings keyed by the full model recipe.</a:t>
             </a:r>
           </a:p>
           <a:p xmlns:a="http://schemas.openxmlformats.org/drawingml/2006/main">
             <a:pPr>
               <a:spcAft>
-                <a:spcPts val="1100"/>
+                <a:spcPts val="1500"/>
               </a:spcAft>
               <a:defRPr sz="1725">
                 <a:solidFill>
@@ -15732,7 +15762,7 @@
                 <a:ea typeface="Arial"/>
                 <a:cs typeface="Arial"/>
               </a:rPr>
-              <a:t>Retrieval &amp; Fusion  </a:t>
+              <a:t>Retrieval and postprocessing  </a:t>
             </a:r>
             <a:r>
               <a:rPr sz="1725">
@@ -15743,13 +15773,13 @@
                 <a:ea typeface="Arial"/>
                 <a:cs typeface="Arial"/>
               </a:rPr>
-              <a:t>BM25, exact symbol table, dense cosine similarity, Reciprocal Rank Fusion (k=60) with additive component transparency.</a:t>
+              <a:t>Cosine search; symbol/BM25 and reciprocal rank fusion in the workbench; Python subprocess execution for usable examples.</a:t>
             </a:r>
           </a:p>
           <a:p xmlns:a="http://schemas.openxmlformats.org/drawingml/2006/main">
             <a:pPr>
               <a:spcAft>
-                <a:spcPts val="1100"/>
+                <a:spcPts val="1500"/>
               </a:spcAft>
               <a:defRPr sz="1725">
                 <a:solidFill>
@@ -15769,7 +15799,7 @@
                 <a:ea typeface="Arial"/>
                 <a:cs typeface="Arial"/>
               </a:rPr>
-              <a:t>Encoders &amp; Vector Cache  </a:t>
+              <a:t>Embedding models  </a:t>
             </a:r>
             <a:r>
               <a:rPr sz="1725">
@@ -15780,13 +15810,13 @@
                 <a:ea typeface="Arial"/>
                 <a:cs typeface="Arial"/>
               </a:rPr>
-              <a:t>codefuse-ai/F2LLM-v2-1.7B (accuracy tier), 0.6B (interactive tier); SQLite content-addressed EmbeddingCache (SHA-256).</a:t>
+              <a:t>F2LLM-v2-1.7B accuracy tier; 0.6B is explicit opt-in. Revisions, prompts, pooling and sequence limits are pinned.</a:t>
             </a:r>
           </a:p>
           <a:p xmlns:a="http://schemas.openxmlformats.org/drawingml/2006/main">
             <a:pPr>
               <a:spcAft>
-                <a:spcPts val="1100"/>
+                <a:spcPts val="1500"/>
               </a:spcAft>
               <a:defRPr sz="1725">
                 <a:solidFill>
@@ -15806,7 +15836,7 @@
                 <a:ea typeface="Arial"/>
                 <a:cs typeface="Arial"/>
               </a:rPr>
-              <a:t>Evaluation &amp; Testing  </a:t>
+              <a:t>Evaluation and interface  </a:t>
             </a:r>
             <a:r>
               <a:rPr sz="1725">
@@ -15817,7 +15847,7 @@
                 <a:ea typeface="Arial"/>
                 <a:cs typeface="Arial"/>
               </a:rPr>
-              <a:t>Official MTEB 2.21.0 (cache=None), FastAPI + Uvicorn, 571 automated pytest tests, multi-platform GitHub Actions CI.</a:t>
+              <a:t>MTEB 2.21.0 with cache=None; pytest and GitHub Actions; FastAPI/Uvicorn workbench. Dependency and source records accompany measurements.</a:t>
             </a:r>
           </a:p>
         </p:txBody>
@@ -15952,7 +15982,7 @@
           <a:p xmlns:a="http://schemas.openxmlformats.org/drawingml/2006/main">
             <a:pPr>
               <a:spcAft>
-                <a:spcPts val="1200"/>
+                <a:spcPts val="1500"/>
               </a:spcAft>
               <a:defRPr sz="1725">
                 <a:solidFill>
@@ -15972,7 +16002,7 @@
                 <a:ea typeface="Arial"/>
                 <a:cs typeface="Arial"/>
               </a:rPr>
-              <a:t>Zero-Context Developer Onboarding  </a:t>
+              <a:t>Developer onboarding  </a:t>
             </a:r>
             <a:r>
               <a:rPr sz="1725">
@@ -15983,13 +16013,13 @@
                 <a:ea typeface="Arial"/>
                 <a:cs typeface="Arial"/>
               </a:rPr>
-              <a:t>Maps high-level natural-language questions to exact implementation functions and structural call graphs.</a:t>
+              <a:t>Map a natural-language question to implementation snippets with source locations and structural metadata.</a:t>
             </a:r>
           </a:p>
           <a:p xmlns:a="http://schemas.openxmlformats.org/drawingml/2006/main">
             <a:pPr>
               <a:spcAft>
-                <a:spcPts val="1200"/>
+                <a:spcPts val="1500"/>
               </a:spcAft>
               <a:defRPr sz="1725">
                 <a:solidFill>
@@ -16009,7 +16039,7 @@
                 <a:ea typeface="Arial"/>
                 <a:cs typeface="Arial"/>
               </a:rPr>
-              <a:t>Behavior-Guided Bug &amp; Regression Triage  </a:t>
+              <a:t>Example-guided triage  </a:t>
             </a:r>
             <a:r>
               <a:rPr sz="1725">
@@ -16020,13 +16050,13 @@
                 <a:ea typeface="Arial"/>
                 <a:cs typeface="Arial"/>
               </a:rPr>
-              <a:t>Worked examples in issue tickets verify whether candidate functions produce expected outputs before code review.</a:t>
+              <a:t>Use examples from a problem or issue to distinguish candidate behavior, while retaining failures and execution limits.</a:t>
             </a:r>
           </a:p>
           <a:p xmlns:a="http://schemas.openxmlformats.org/drawingml/2006/main">
             <a:pPr>
               <a:spcAft>
-                <a:spcPts val="1200"/>
+                <a:spcPts val="1500"/>
               </a:spcAft>
               <a:defRPr sz="1725">
                 <a:solidFill>
@@ -16046,7 +16076,7 @@
                 <a:ea typeface="Arial"/>
                 <a:cs typeface="Arial"/>
               </a:rPr>
-              <a:t>Real-Time CI/CD Incremental Re-Indexing (P1)  </a:t>
+              <a:t>Changing repositories  </a:t>
             </a:r>
             <a:r>
               <a:rPr sz="1725">
@@ -16057,13 +16087,13 @@
                 <a:ea typeface="Arial"/>
                 <a:cs typeface="Arial"/>
               </a:rPr>
-              <a:t>Re-embeds only changed AST chunks on pull requests, updating semantic search in ~1.5 s without blocking workflows.</a:t>
+              <a:t>Reuse unchanged chunks after edits. The measured rebuild fixture demonstrates reuse, rather than a universal update-time guarantee.</a:t>
             </a:r>
           </a:p>
           <a:p xmlns:a="http://schemas.openxmlformats.org/drawingml/2006/main">
             <a:pPr>
               <a:spcAft>
-                <a:spcPts val="1200"/>
+                <a:spcPts val="1500"/>
               </a:spcAft>
               <a:defRPr sz="1725">
                 <a:solidFill>
@@ -16083,7 +16113,7 @@
                 <a:ea typeface="Arial"/>
                 <a:cs typeface="Arial"/>
               </a:rPr>
-              <a:t>Contamination-Free Code Archaeology (Bonus)  </a:t>
+              <a:t>Code archaeology  </a:t>
             </a:r>
             <a:r>
               <a:rPr sz="1725">
@@ -16094,13 +16124,13 @@
                 <a:ea typeface="Arial"/>
                 <a:cs typeface="Arial"/>
               </a:rPr>
-              <a:t>Retrieves historical functions from specific git commits without cross-version context leakage or silent fallback to HEAD.</a:t>
+              <a:t>Search explicit snapshots and related variants. Version isolation addresses retrieval provenance; it does not establish freedom from pretraining exposure.</a:t>
             </a:r>
           </a:p>
           <a:p xmlns:a="http://schemas.openxmlformats.org/drawingml/2006/main">
             <a:pPr>
               <a:spcAft>
-                <a:spcPts val="1200"/>
+                <a:spcPts val="1500"/>
               </a:spcAft>
               <a:defRPr sz="1725">
                 <a:solidFill>
@@ -16120,7 +16150,7 @@
                 <a:ea typeface="Arial"/>
                 <a:cs typeface="Arial"/>
               </a:rPr>
-              <a:t>Trustworthy Developer Tooling  </a:t>
+              <a:t>Checkable outputs  </a:t>
             </a:r>
             <a:r>
               <a:rPr sz="1725">
@@ -16131,7 +16161,7 @@
                 <a:ea typeface="Arial"/>
                 <a:cs typeface="Arial"/>
               </a:rPr>
-              <a:t>Returns verifiable source code spans with exact file/line evidence rather than uncheckable generative model text.</a:t>
+              <a:t>Return ranked source code and retrieval evidence. Code generation and formal proof of correctness are outside this submission.</a:t>
             </a:r>
           </a:p>
         </p:txBody>
@@ -16189,7 +16219,7 @@
         </p:spPr>
         <p:txBody>
           <a:bodyPr xmlns:a="http://schemas.openxmlformats.org/drawingml/2006/main" spcFirstLastPara="1" wrap="square" lIns="91425" tIns="45700" rIns="91425" bIns="45700" anchor="ctr">
-            <a:normAutofit/>
+            <a:noAutofit/>
           </a:bodyPr>
           <a:lstStyle xmlns:a="http://schemas.openxmlformats.org/drawingml/2006/main"/>
           <a:p xmlns:a="http://schemas.openxmlformats.org/drawingml/2006/main">
@@ -16209,15 +16239,23 @@
               <a:buSzPts val="4400"/>
               <a:buFont typeface="Calibri"/>
               <a:buNone/>
+              <a:defRPr sz="3300" b="1">
+                <a:solidFill>
+                  <a:srgbClr val="70509B"/>
+                </a:solidFill>
+                <a:latin typeface="Arial"/>
+                <a:ea typeface="Arial"/>
+                <a:cs typeface="Arial"/>
+              </a:defRPr>
             </a:pPr>
             <a:r>
-              <a:rPr sz="4400" b="1">
-                <a:solidFill>
-                  <a:srgbClr val="704EA6"/>
-                </a:solidFill>
-                <a:latin typeface="Calibri"/>
-                <a:ea typeface="Calibri"/>
-                <a:cs typeface="Calibri"/>
+              <a:rPr sz="3300" b="1">
+                <a:solidFill>
+                  <a:srgbClr val="70509B"/>
+                </a:solidFill>
+                <a:latin typeface="Arial"/>
+                <a:ea typeface="Arial"/>
+                <a:cs typeface="Arial"/>
               </a:rPr>
               <a:t>Innovation highlights, results and limitations</a:t>
             </a:r>
@@ -16266,7 +16304,7 @@
           <a:p xmlns:a="http://schemas.openxmlformats.org/drawingml/2006/main">
             <a:pPr>
               <a:spcAft>
-                <a:spcPts val="1100"/>
+                <a:spcPts val="1500"/>
               </a:spcAft>
               <a:defRPr sz="1575">
                 <a:solidFill>
@@ -16286,7 +16324,7 @@
                 <a:ea typeface="Arial"/>
                 <a:cs typeface="Arial"/>
               </a:rPr>
-              <a:t>P0 Retrieval Accuracy (CoIR AppsRetrieval Benchmark)  </a:t>
+              <a:t>Historical P0 — 19 September 2026  </a:t>
             </a:r>
             <a:r>
               <a:rPr sz="1575">
@@ -16297,13 +16335,13 @@
                 <a:ea typeface="Arial"/>
                 <a:cs typeface="Arial"/>
               </a:rPr>
-              <a:t>NDCG@10: 0.96558 · MRR@10: 0.95857 · Recall@10: 0.98619. Dense baseline: 0.93756; behavioral execution delivers +0.02802 lift (removes 44.9% of residual error).</a:t>
+              <a:t>NDCG@10 0.96558; MRR@10 0.95857; Recall@10 0.98619. This was the earlier frozen GPU-query configuration, not a measured CPU score for the corrected candidate.</a:t>
             </a:r>
           </a:p>
           <a:p xmlns:a="http://schemas.openxmlformats.org/drawingml/2006/main">
             <a:pPr>
               <a:spcAft>
-                <a:spcPts val="1100"/>
+                <a:spcPts val="1500"/>
               </a:spcAft>
               <a:defRPr sz="1575">
                 <a:solidFill>
@@ -16323,7 +16361,7 @@
                 <a:ea typeface="Arial"/>
                 <a:cs typeface="Arial"/>
               </a:rPr>
-              <a:t>P1 Incremental Indexing (Kaggle 4-vCPU Intel Xeon)  </a:t>
+              <a:t>CPU P1 — 40 functions, 50 chunks, 3 repetitions  </a:t>
             </a:r>
             <a:r>
               <a:rPr sz="1575">
@@ -16334,13 +16372,13 @@
                 <a:ea typeface="Arial"/>
                 <a:cs typeface="Arial"/>
               </a:rPr>
-              <a:t>Full rebuild: 103.4 s (50 chunks) vs. Unchanged update: 1.51 s (50 reused) → ~68x speedup (100% equivalence, min cosine 1.0).</a:t>
+              <a:t>Median full build 102.78 s; unchanged update 1.51 s; one-function edit 6.45 s; ten-function edit 29.51 s. Fresh-index comparison matched all 6 probe rankings.</a:t>
             </a:r>
           </a:p>
           <a:p xmlns:a="http://schemas.openxmlformats.org/drawingml/2006/main">
             <a:pPr>
               <a:spcAft>
-                <a:spcPts val="1100"/>
+                <a:spcPts val="1500"/>
               </a:spcAft>
               <a:defRPr sz="1575">
                 <a:solidFill>
@@ -16360,7 +16398,7 @@
                 <a:ea typeface="Arial"/>
                 <a:cs typeface="Arial"/>
               </a:rPr>
-              <a:t>Bonus Cross-Version Selection (12 Lineages across 3 Versions)  </a:t>
+              <a:t>CPU Bonus — constructed 12-lineage fixture  </a:t>
             </a:r>
             <a:r>
               <a:rPr sz="1575">
@@ -16371,13 +16409,13 @@
                 <a:ea typeface="Arial"/>
                 <a:cs typeface="Arial"/>
               </a:rPr>
-              <a:t>100% correct variant selection (1.0) with execution verification vs. 8.33% (0.0833) for raw semantic retrieval (~12x accuracy gain).</a:t>
+              <a:t>Correct version first: 12/12 with verification, 1/12 without. Median query 5.82 s. These are functional fixture results, not unseen-accuracy estimates.</a:t>
             </a:r>
           </a:p>
           <a:p xmlns:a="http://schemas.openxmlformats.org/drawingml/2006/main">
             <a:pPr>
               <a:spcAft>
-                <a:spcPts val="1100"/>
+                <a:spcPts val="1500"/>
               </a:spcAft>
               <a:defRPr sz="1575">
                 <a:solidFill>
@@ -16397,7 +16435,7 @@
                 <a:ea typeface="Arial"/>
                 <a:cs typeface="Arial"/>
               </a:rPr>
-              <a:t>Honest Limitations (Academic Integrity)  </a:t>
+              <a:t>Limits and resources  </a:t>
             </a:r>
             <a:r>
               <a:rPr sz="1575">
@@ -16408,7 +16446,7 @@
                 <a:ea typeface="Arial"/>
                 <a:cs typeface="Arial"/>
               </a:rPr>
-              <a:t>Passing visible test cases does not prove formal correctness; subprocess limits, not OS hypervisor; APPS pre-training exposure transparently documented.</a:t>
+              <a:t>4-vCPU Kaggle Xeon; recorded peak RSS about 10.85 GB. APPS pretraining exposure is possible. Visible examples and subprocess limits do not prove correctness or provide a hardened security boundary.</a:t>
             </a:r>
           </a:p>
         </p:txBody>
@@ -16543,7 +16581,7 @@
           <a:p xmlns:a="http://schemas.openxmlformats.org/drawingml/2006/main">
             <a:pPr>
               <a:spcAft>
-                <a:spcPts val="1400"/>
+                <a:spcPts val="1500"/>
               </a:spcAft>
               <a:defRPr sz="1800">
                 <a:solidFill>
@@ -16563,7 +16601,7 @@
                 <a:ea typeface="Arial"/>
                 <a:cs typeface="Arial"/>
               </a:rPr>
-              <a:t>Unseen Python Evaluation Readiness  </a:t>
+              <a:t>Broader Python inputs  </a:t>
             </a:r>
             <a:r>
               <a:rPr sz="1800">
@@ -16574,13 +16612,13 @@
                 <a:ea typeface="Arial"/>
                 <a:cs typeface="Arial"/>
               </a:rPr>
-              <a:t>Generalize execution verification to arbitrary test runners (pytest, unittest) for the judges' unreleased dataset.</a:t>
+              <a:t>Improve handling of incomplete fragments and diverse test formats; measure generalization on genuinely unseen code.</a:t>
             </a:r>
           </a:p>
           <a:p xmlns:a="http://schemas.openxmlformats.org/drawingml/2006/main">
             <a:pPr>
               <a:spcAft>
-                <a:spcPts val="1400"/>
+                <a:spcPts val="1500"/>
               </a:spcAft>
               <a:defRPr sz="1800">
                 <a:solidFill>
@@ -16600,7 +16638,7 @@
                 <a:ea typeface="Arial"/>
                 <a:cs typeface="Arial"/>
               </a:rPr>
-              <a:t>Sub-200ms CPU Retrieval (INT8 / ONNX)  </a:t>
+              <a:t>Lower query cost  </a:t>
             </a:r>
             <a:r>
               <a:rPr sz="1800">
@@ -16611,13 +16649,13 @@
                 <a:ea typeface="Arial"/>
                 <a:cs typeface="Arial"/>
               </a:rPr>
-              <a:t>Implement static integer quantization and ONNX Runtime CPU execution to eliminate dense latency with zero GPU dependence.</a:t>
+              <a:t>Investigate faster CPU runtimes only when ranking fidelity and end-to-end measurements support adoption. No unmeasured latency target is claimed.</a:t>
             </a:r>
           </a:p>
           <a:p xmlns:a="http://schemas.openxmlformats.org/drawingml/2006/main">
             <a:pPr>
               <a:spcAft>
-                <a:spcPts val="1400"/>
+                <a:spcPts val="1500"/>
               </a:spcAft>
               <a:defRPr sz="1800">
                 <a:solidFill>
@@ -16637,7 +16675,7 @@
                 <a:ea typeface="Arial"/>
                 <a:cs typeface="Arial"/>
               </a:rPr>
-              <a:t>MicroVM Execution Sandboxing  </a:t>
+              <a:t>Stronger execution isolation  </a:t>
             </a:r>
             <a:r>
               <a:rPr sz="1800">
@@ -16648,13 +16686,13 @@
                 <a:ea typeface="Arial"/>
                 <a:cs typeface="Arial"/>
               </a:rPr>
-              <a:t>Migrate from OS-level subprocess limits to Firecracker / gVisor microVMs for secure, multi-tenant repository code execution.</a:t>
+              <a:t>Replace defensive subprocess limits with a hardened isolation boundary for untrusted multi-user deployments.</a:t>
             </a:r>
           </a:p>
           <a:p xmlns:a="http://schemas.openxmlformats.org/drawingml/2006/main">
             <a:pPr>
               <a:spcAft>
-                <a:spcPts val="1400"/>
+                <a:spcPts val="1500"/>
               </a:spcAft>
               <a:defRPr sz="1800">
                 <a:solidFill>
@@ -16674,7 +16712,7 @@
                 <a:ea typeface="Arial"/>
                 <a:cs typeface="Arial"/>
               </a:rPr>
-              <a:t>Cross-File Structural Call Graphs  </a:t>
+              <a:t>Richer repository structure  </a:t>
             </a:r>
             <a:r>
               <a:rPr sz="1800">
@@ -16685,7 +16723,7 @@
                 <a:ea typeface="Arial"/>
                 <a:cs typeface="Arial"/>
               </a:rPr>
-              <a:t>Deepen static analysis with whole-repository points-to analysis and cross-module import tracking across monorepos.</a:t>
+              <a:t>Extend cross-file analysis and history ingestion, preserving source locations, snapshot identity and cache-recipe provenance.</a:t>
             </a:r>
           </a:p>
         </p:txBody>

</xml_diff>

<commit_message>
Record accepted CPU P0 evidence and update local submission materials
</commit_message>
<xml_diff>
--- a/VITV_Doctors_Submission.pptx
+++ b/VITV_Doctors_Submission.pptx
@@ -2,24 +2,24 @@
 <file path=ppt/presentation.xml><?xml version="1.0" encoding="utf-8"?>
 <p:presentation xmlns:p="http://schemas.openxmlformats.org/presentationml/2006/main">
   <p:sldMasterIdLst>
-    <p:sldMasterId xmlns:r="http://schemas.openxmlformats.org/officeDocument/2006/relationships" id="2147483648" r:id="R40351676b4354cc6"/>
+    <p:sldMasterId xmlns:r="http://schemas.openxmlformats.org/officeDocument/2006/relationships" id="2147483648" r:id="R7bf714f1e7044c79"/>
   </p:sldMasterIdLst>
   <p:notesMasterIdLst>
-    <p:notesMasterId xmlns:r="http://schemas.openxmlformats.org/officeDocument/2006/relationships" r:id="R23628a5584fe45ce"/>
+    <p:notesMasterId xmlns:r="http://schemas.openxmlformats.org/officeDocument/2006/relationships" r:id="R19088200a00642ae"/>
   </p:notesMasterIdLst>
   <p:sldIdLst>
-    <p:sldId xmlns:r="http://schemas.openxmlformats.org/officeDocument/2006/relationships" id="256" r:id="R801cbaaa20914358"/>
-    <p:sldId xmlns:r="http://schemas.openxmlformats.org/officeDocument/2006/relationships" id="257" r:id="Ref39251368ef47ec"/>
-    <p:sldId xmlns:r="http://schemas.openxmlformats.org/officeDocument/2006/relationships" id="258" r:id="Rb316517becf34a9c"/>
-    <p:sldId xmlns:r="http://schemas.openxmlformats.org/officeDocument/2006/relationships" id="259" r:id="R0acaf7c827ed4660"/>
-    <p:sldId xmlns:r="http://schemas.openxmlformats.org/officeDocument/2006/relationships" id="260" r:id="Rc206555220414f40"/>
-    <p:sldId xmlns:r="http://schemas.openxmlformats.org/officeDocument/2006/relationships" id="261" r:id="R20fb6ae44ccd4789"/>
-    <p:sldId xmlns:r="http://schemas.openxmlformats.org/officeDocument/2006/relationships" id="262" r:id="R666dffd0009e4e17"/>
-    <p:sldId xmlns:r="http://schemas.openxmlformats.org/officeDocument/2006/relationships" id="263" r:id="R4f70a348e1744477"/>
-    <p:sldId xmlns:r="http://schemas.openxmlformats.org/officeDocument/2006/relationships" id="264" r:id="R18669883e9934571"/>
-    <p:sldId xmlns:r="http://schemas.openxmlformats.org/officeDocument/2006/relationships" id="265" r:id="R1e68e0ff8ec7435c"/>
-    <p:sldId xmlns:r="http://schemas.openxmlformats.org/officeDocument/2006/relationships" id="266" r:id="Rb8df1336b50646a9"/>
-    <p:sldId xmlns:r="http://schemas.openxmlformats.org/officeDocument/2006/relationships" id="267" r:id="R729579471e6a4e92"/>
+    <p:sldId xmlns:r="http://schemas.openxmlformats.org/officeDocument/2006/relationships" id="256" r:id="R1b5584ecd0d5419b"/>
+    <p:sldId xmlns:r="http://schemas.openxmlformats.org/officeDocument/2006/relationships" id="257" r:id="R904532036a654c4d"/>
+    <p:sldId xmlns:r="http://schemas.openxmlformats.org/officeDocument/2006/relationships" id="258" r:id="R2f529e5649c1471d"/>
+    <p:sldId xmlns:r="http://schemas.openxmlformats.org/officeDocument/2006/relationships" id="259" r:id="R24083bf3c16748c3"/>
+    <p:sldId xmlns:r="http://schemas.openxmlformats.org/officeDocument/2006/relationships" id="260" r:id="R3ed189a3971d44bf"/>
+    <p:sldId xmlns:r="http://schemas.openxmlformats.org/officeDocument/2006/relationships" id="261" r:id="R545dc3069a9a4395"/>
+    <p:sldId xmlns:r="http://schemas.openxmlformats.org/officeDocument/2006/relationships" id="262" r:id="R21457bb4e2e34a7e"/>
+    <p:sldId xmlns:r="http://schemas.openxmlformats.org/officeDocument/2006/relationships" id="263" r:id="R5657ba3814054dbd"/>
+    <p:sldId xmlns:r="http://schemas.openxmlformats.org/officeDocument/2006/relationships" id="264" r:id="R247085f3d8364953"/>
+    <p:sldId xmlns:r="http://schemas.openxmlformats.org/officeDocument/2006/relationships" id="265" r:id="R2bc42d04db9846a5"/>
+    <p:sldId xmlns:r="http://schemas.openxmlformats.org/officeDocument/2006/relationships" id="266" r:id="R0449c1f8c89e4c02"/>
+    <p:sldId xmlns:r="http://schemas.openxmlformats.org/officeDocument/2006/relationships" id="267" r:id="Rd0eff301d55442ae"/>
   </p:sldIdLst>
   <p:sldSz cx="12192000" cy="6858000"/>
   <p:notesSz cx="6858000" cy="9144000"/>
@@ -649,6 +649,66 @@
             </a:r>
             <a:endParaRPr/>
           </a:p>
+          <a:p xmlns:a="http://schemas.openxmlformats.org/drawingml/2006/main">
+            <a:pPr marL="0" lvl="0" indent="0" algn="l">
+              <a:spcBef>
+                <a:spcPts val="0"/>
+              </a:spcBef>
+              <a:spcAft>
+                <a:spcPts val="0"/>
+              </a:spcAft>
+              <a:buNone/>
+            </a:pPr>
+            <a:r>
+              <a:t/>
+            </a:r>
+            <a:endParaRPr/>
+          </a:p>
+          <a:p xmlns:a="http://schemas.openxmlformats.org/drawingml/2006/main">
+            <a:pPr marL="0" lvl="0" indent="0" algn="l">
+              <a:spcBef>
+                <a:spcPts val="0"/>
+              </a:spcBef>
+              <a:spcAft>
+                <a:spcPts val="0"/>
+              </a:spcAft>
+              <a:buNone/>
+            </a:pPr>
+            <a:r>
+              <a:t>Historical P0 remains appsretrieval_results.json (sha256 a079fbbc148287744a15e282ca8e628f7bc4107faf76a42dc5502d05a53e60c1), date 2026-09-19 10:50:15.786983+00:00, GPU query encoding under frozen.yaml; raw NDCG@10 0.96558, MRR@10 0.9585696367967284, Recall@10 0.98619.</a:t>
+            </a:r>
+            <a:endParaRPr/>
+          </a:p>
+          <a:p xmlns:a="http://schemas.openxmlformats.org/drawingml/2006/main">
+            <a:pPr marL="0" lvl="0" indent="0" algn="l">
+              <a:spcBef>
+                <a:spcPts val="0"/>
+              </a:spcBef>
+              <a:spcAft>
+                <a:spcPts val="0"/>
+              </a:spcAft>
+              <a:buNone/>
+            </a:pPr>
+            <a:r>
+              <a:t/>
+            </a:r>
+            <a:endParaRPr/>
+          </a:p>
+          <a:p xmlns:a="http://schemas.openxmlformats.org/drawingml/2006/main">
+            <a:pPr marL="0" lvl="0" indent="0" algn="l">
+              <a:spcBef>
+                <a:spcPts val="0"/>
+              </a:spcBef>
+              <a:spcAft>
+                <a:spcPts val="0"/>
+              </a:spcAft>
+              <a:buNone/>
+            </a:pPr>
+            <a:r>
+              <a:t>Accepted P0: results/final/p0/appsretrieval_results.json (sha256 84c8404a9ab43770dad45c2df0460b5d8cbec4f1e62fb741d954c52339192b84); date 2026-10-01 16:42:29.749760+00:00; MTEB 2.21.0. Acceptance: results/local-corrections/kaggle-attempt-2/acceptance.json (sha256 f17ef57be2ca75f9331324cf066c5c4dc4884446f97d59c338ca670ecb358a10). Measured source commit 18c4b6cbd097437bfb8498fefe572cddb658bc42; source-tree sha256 1a44ab7aeddae73e0019511e9a73d2cfb93cef8fa94a7141ba08eb4555d08602; configuration sha256 9039497b871733c5236eb6060b0cf074c3d98ebeb30664c2ce711e4882f0aaf5. Environment: results/final/p0/environment.json (sha256 ae82a3ba1ba270200c74e57b741fd26917b59b86e435802552992ac610aa64b3). Raw metrics: NDCG@10 0.96583; MRR@10 0.9582509116971268; Recall@10 0.98805. Four separately recorded CPU query-encoding shards supply vectors to scoring replay; 30 queries are re-encoded live for fidelity. P0 runner elapsed2609.959 seconds; peak process-tree RSS9405206528 bytes. Scoring replay elapsed time is not full live retrieval latency. No latency reduction, speedup, or unseen-generalization claim follows from this result. APPS test has prior project exposure.</a:t>
+            </a:r>
+            <a:endParaRPr/>
+          </a:p>
         </p:txBody>
       </p:sp>
       <p:sp>
@@ -965,7 +1025,7 @@
               <a:buNone/>
             </a:pPr>
             <a:r>
-              <a:t>Sources: theme1_guidelines.pdf; verbatim FAQ answers in docs/submission/PROTOCOL.md; repository implementation and raw result artifacts. No independent novelty priority claim is made. P0: app/pipeline/encoder.py and app/pipeline/execution.py. Workbench: app/workbench.py, app/indexing/versioned.py, app/retrieval/hybrid.py. The &gt;6k-character workbench attention guard is not a P0 pipeline truncation rule. C++ is not claimed as the runtime path.</a:t>
+              <a:t>Sources: theme1_guidelines.pdf; verbatim FAQ answers in docs/submission/PROTOCOL.md; repository implementation and raw result artifacts. No independent novelty priority claim is made. P0: app/pipeline/encoder.py and app/pipeline/execution_rerank.py. Workbench: app/workbench.py, app/indexing/versioned.py, app/retrieval/hybrid.py. The &gt;6k-character workbench attention guard is not a P0 pipeline truncation rule. C++ is not claimed as the runtime path.</a:t>
             </a:r>
             <a:endParaRPr/>
           </a:p>
@@ -1286,6 +1346,66 @@
             </a:pPr>
             <a:r>
               <a:t>Sources: theme1_guidelines.pdf; verbatim FAQ answers in docs/submission/PROTOCOL.md; repository implementation and raw result artifacts. No independent novelty priority claim is made. Historical Apps JSON: appsretrieval_results.json, 2026-09-19, MTEB2.21.0, GPU query encoding under frozen.yaml. P1 and Bonus: results/hands-on/hands-on/p1.json and bonus.json; environment.json. P1 full build uses median102.777192175s, not old103.4s aggregate; one-edit6.452369177s; ten-edit29.506994244s; unchanged1.51220837s. Bonus median5.817684378s. The 12 examples deliberately include wrong variants, so no generalization estimate follows.</a:t>
+            </a:r>
+            <a:endParaRPr/>
+          </a:p>
+          <a:p xmlns:a="http://schemas.openxmlformats.org/drawingml/2006/main">
+            <a:pPr marL="0" lvl="0" indent="0" algn="l">
+              <a:spcBef>
+                <a:spcPts val="0"/>
+              </a:spcBef>
+              <a:spcAft>
+                <a:spcPts val="0"/>
+              </a:spcAft>
+              <a:buNone/>
+            </a:pPr>
+            <a:r>
+              <a:t/>
+            </a:r>
+            <a:endParaRPr/>
+          </a:p>
+          <a:p xmlns:a="http://schemas.openxmlformats.org/drawingml/2006/main">
+            <a:pPr marL="0" lvl="0" indent="0" algn="l">
+              <a:spcBef>
+                <a:spcPts val="0"/>
+              </a:spcBef>
+              <a:spcAft>
+                <a:spcPts val="0"/>
+              </a:spcAft>
+              <a:buNone/>
+            </a:pPr>
+            <a:r>
+              <a:t>Historical P0 remains appsretrieval_results.json (sha256 a079fbbc148287744a15e282ca8e628f7bc4107faf76a42dc5502d05a53e60c1), date 2026-09-19 10:50:15.786983+00:00, GPU query encoding under frozen.yaml; raw NDCG@10 0.96558, MRR@10 0.9585696367967284, Recall@10 0.98619.</a:t>
+            </a:r>
+            <a:endParaRPr/>
+          </a:p>
+          <a:p xmlns:a="http://schemas.openxmlformats.org/drawingml/2006/main">
+            <a:pPr marL="0" lvl="0" indent="0" algn="l">
+              <a:spcBef>
+                <a:spcPts val="0"/>
+              </a:spcBef>
+              <a:spcAft>
+                <a:spcPts val="0"/>
+              </a:spcAft>
+              <a:buNone/>
+            </a:pPr>
+            <a:r>
+              <a:t/>
+            </a:r>
+            <a:endParaRPr/>
+          </a:p>
+          <a:p xmlns:a="http://schemas.openxmlformats.org/drawingml/2006/main">
+            <a:pPr marL="0" lvl="0" indent="0" algn="l">
+              <a:spcBef>
+                <a:spcPts val="0"/>
+              </a:spcBef>
+              <a:spcAft>
+                <a:spcPts val="0"/>
+              </a:spcAft>
+              <a:buNone/>
+            </a:pPr>
+            <a:r>
+              <a:t>Accepted P0: results/final/p0/appsretrieval_results.json (sha256 84c8404a9ab43770dad45c2df0460b5d8cbec4f1e62fb741d954c52339192b84); date 2026-10-01 16:42:29.749760+00:00; MTEB 2.21.0. Acceptance: results/local-corrections/kaggle-attempt-2/acceptance.json (sha256 f17ef57be2ca75f9331324cf066c5c4dc4884446f97d59c338ca670ecb358a10). Measured source commit 18c4b6cbd097437bfb8498fefe572cddb658bc42; source-tree sha256 1a44ab7aeddae73e0019511e9a73d2cfb93cef8fa94a7141ba08eb4555d08602; configuration sha256 9039497b871733c5236eb6060b0cf074c3d98ebeb30664c2ce711e4882f0aaf5. Environment: results/final/p0/environment.json (sha256 ae82a3ba1ba270200c74e57b741fd26917b59b86e435802552992ac610aa64b3). Raw metrics: NDCG@10 0.96583; MRR@10 0.9582509116971268; Recall@10 0.98805. Four separately recorded CPU query-encoding shards supply vectors to scoring replay; 30 queries are re-encoded live for fidelity. P0 runner elapsed2609.959 seconds; peak process-tree RSS9405206528 bytes. Scoring replay elapsed time is not full live retrieval latency. No latency reduction, speedup, or unseen-generalization claim follows from this result. APPS test has prior project exposure.</a:t>
             </a:r>
             <a:endParaRPr/>
           </a:p>
@@ -11075,18 +11195,18 @@
   </p:cSld>
   <p:clrMap bg1="lt1" tx1="dk1" bg2="dk2" tx2="lt2" accent1="accent1" accent2="accent2" accent3="accent3" accent4="accent4" accent5="accent5" accent6="accent6" hlink="hlink" folHlink="folHlink"/>
   <p:sldLayoutIdLst>
-    <p:sldLayoutId xmlns:r="http://schemas.openxmlformats.org/officeDocument/2006/relationships" id="2147483649" r:id="R7abcd05663dc45bb"/>
-    <p:sldLayoutId xmlns:r="http://schemas.openxmlformats.org/officeDocument/2006/relationships" id="2147483650" r:id="R6cb598dc02c74313"/>
-    <p:sldLayoutId xmlns:r="http://schemas.openxmlformats.org/officeDocument/2006/relationships" id="2147483651" r:id="Re385f075e6fa4073"/>
-    <p:sldLayoutId xmlns:r="http://schemas.openxmlformats.org/officeDocument/2006/relationships" id="2147483652" r:id="Rf8ac6efbc07c4048"/>
-    <p:sldLayoutId xmlns:r="http://schemas.openxmlformats.org/officeDocument/2006/relationships" id="2147483653" r:id="Radb0139226514e80"/>
-    <p:sldLayoutId xmlns:r="http://schemas.openxmlformats.org/officeDocument/2006/relationships" id="2147483654" r:id="Re0b85ef3af174343"/>
-    <p:sldLayoutId xmlns:r="http://schemas.openxmlformats.org/officeDocument/2006/relationships" id="2147483655" r:id="Rfa38a3985a6a4ed8"/>
-    <p:sldLayoutId xmlns:r="http://schemas.openxmlformats.org/officeDocument/2006/relationships" id="2147483656" r:id="R7d5cbeb22b724cec"/>
-    <p:sldLayoutId xmlns:r="http://schemas.openxmlformats.org/officeDocument/2006/relationships" id="2147483657" r:id="Re1ef267b3a91431b"/>
-    <p:sldLayoutId xmlns:r="http://schemas.openxmlformats.org/officeDocument/2006/relationships" id="2147483658" r:id="R3fe71dd4b3f04912"/>
-    <p:sldLayoutId xmlns:r="http://schemas.openxmlformats.org/officeDocument/2006/relationships" id="2147483659" r:id="R0cb330459c974e68"/>
-    <p:sldLayoutId xmlns:r="http://schemas.openxmlformats.org/officeDocument/2006/relationships" id="2147483660" r:id="R72728ad99e37488a"/>
+    <p:sldLayoutId xmlns:r="http://schemas.openxmlformats.org/officeDocument/2006/relationships" id="2147483649" r:id="R9ea13d51dbd24c08"/>
+    <p:sldLayoutId xmlns:r="http://schemas.openxmlformats.org/officeDocument/2006/relationships" id="2147483650" r:id="R77c7c9f829ef4f1d"/>
+    <p:sldLayoutId xmlns:r="http://schemas.openxmlformats.org/officeDocument/2006/relationships" id="2147483651" r:id="R1f5ce96b71044da0"/>
+    <p:sldLayoutId xmlns:r="http://schemas.openxmlformats.org/officeDocument/2006/relationships" id="2147483652" r:id="R377fa7757ad34f0c"/>
+    <p:sldLayoutId xmlns:r="http://schemas.openxmlformats.org/officeDocument/2006/relationships" id="2147483653" r:id="R12cf8f04728e4472"/>
+    <p:sldLayoutId xmlns:r="http://schemas.openxmlformats.org/officeDocument/2006/relationships" id="2147483654" r:id="R1d1fc68309d94693"/>
+    <p:sldLayoutId xmlns:r="http://schemas.openxmlformats.org/officeDocument/2006/relationships" id="2147483655" r:id="Rb8245e709a044920"/>
+    <p:sldLayoutId xmlns:r="http://schemas.openxmlformats.org/officeDocument/2006/relationships" id="2147483656" r:id="Rbf243909a1054e17"/>
+    <p:sldLayoutId xmlns:r="http://schemas.openxmlformats.org/officeDocument/2006/relationships" id="2147483657" r:id="Rc846715215254b0d"/>
+    <p:sldLayoutId xmlns:r="http://schemas.openxmlformats.org/officeDocument/2006/relationships" id="2147483658" r:id="R2a61584251044b9d"/>
+    <p:sldLayoutId xmlns:r="http://schemas.openxmlformats.org/officeDocument/2006/relationships" id="2147483659" r:id="R54bd024c0ae94e1e"/>
+    <p:sldLayoutId xmlns:r="http://schemas.openxmlformats.org/officeDocument/2006/relationships" id="2147483660" r:id="R4d275df147904f41"/>
   </p:sldLayoutIdLst>
   <p:hf sldNum="0" hdr="0" ftr="0" dt="0"/>
   <p:txStyles>
@@ -12668,7 +12788,7 @@
           <p:nvPr/>
         </p:nvPicPr>
         <p:blipFill rotWithShape="1">
-          <a:blip xmlns:r="http://schemas.openxmlformats.org/officeDocument/2006/relationships" xmlns:a="http://schemas.openxmlformats.org/drawingml/2006/main" r:embed="Rbdc9708603644b9e">
+          <a:blip xmlns:r="http://schemas.openxmlformats.org/officeDocument/2006/relationships" xmlns:a="http://schemas.openxmlformats.org/drawingml/2006/main" r:embed="R2d09cf6cf0a3433c">
             <a:alphaModFix/>
           </a:blip>
           <a:srcRect xmlns:a="http://schemas.openxmlformats.org/drawingml/2006/main" l="0" t="0" r="0" b="0"/>
@@ -12736,7 +12856,7 @@
                 <a:solidFill>
                   <a:srgbClr val="70509B"/>
                 </a:solidFill>
-                <a:hlinkClick xmlns:r="http://schemas.openxmlformats.org/officeDocument/2006/relationships" r:id="R7a8a49c9a30445bc"/>
+                <a:hlinkClick xmlns:r="http://schemas.openxmlformats.org/officeDocument/2006/relationships" r:id="R1fe315e779254301"/>
               </a:rPr>
               <a:t>Submission GitHub: CodeDoctor repository</a:t>
             </a:r>
@@ -12875,6 +12995,7 @@
               <a:spcAft>
                 <a:spcPts val="1500"/>
               </a:spcAft>
+              <a:buNone/>
               <a:defRPr sz="1725">
                 <a:solidFill>
                   <a:srgbClr val="302C3C"/>
@@ -12912,6 +13033,7 @@
               <a:spcAft>
                 <a:spcPts val="1500"/>
               </a:spcAft>
+              <a:buNone/>
               <a:defRPr sz="1725">
                 <a:solidFill>
                   <a:srgbClr val="302C3C"/>
@@ -12949,6 +13071,7 @@
               <a:spcAft>
                 <a:spcPts val="1500"/>
               </a:spcAft>
+              <a:buNone/>
               <a:defRPr sz="1725">
                 <a:solidFill>
                   <a:srgbClr val="302C3C"/>
@@ -12986,6 +13109,7 @@
               <a:spcAft>
                 <a:spcPts val="1500"/>
               </a:spcAft>
+              <a:buNone/>
               <a:defRPr sz="1725">
                 <a:solidFill>
                   <a:srgbClr val="302C3C"/>
@@ -13023,6 +13147,7 @@
               <a:spcAft>
                 <a:spcPts val="1500"/>
               </a:spcAft>
+              <a:buNone/>
               <a:defRPr sz="1725">
                 <a:solidFill>
                   <a:srgbClr val="302C3C"/>
@@ -13325,7 +13450,7 @@
                 <a:ea typeface="Arial"/>
                 <a:cs typeface="Arial"/>
               </a:rPr>
-              <a:t>Historical result JSON and response CSV retain their original identity. CPU encoding measurements are reported separately from scoring replay.</a:t>
+              <a:t>CPU result JSON, ranked predictions and source records; four shard encoding logs separate from scoring replay. Historical GPU results retain their original identity.</a:t>
             </a:r>
           </a:p>
           <a:p xmlns:a="http://schemas.openxmlformats.org/drawingml/2006/main">
@@ -13713,6 +13838,7 @@
               <a:spcAft>
                 <a:spcPts val="1500"/>
               </a:spcAft>
+              <a:buNone/>
               <a:defRPr sz="1800">
                 <a:solidFill>
                   <a:srgbClr val="302C3C"/>
@@ -13750,6 +13876,7 @@
               <a:spcAft>
                 <a:spcPts val="1500"/>
               </a:spcAft>
+              <a:buNone/>
               <a:defRPr sz="1800">
                 <a:solidFill>
                   <a:srgbClr val="302C3C"/>
@@ -13787,6 +13914,7 @@
               <a:spcAft>
                 <a:spcPts val="1500"/>
               </a:spcAft>
+              <a:buNone/>
               <a:defRPr sz="1800">
                 <a:solidFill>
                   <a:srgbClr val="302C3C"/>
@@ -13824,6 +13952,7 @@
               <a:spcAft>
                 <a:spcPts val="1500"/>
               </a:spcAft>
+              <a:buNone/>
               <a:defRPr sz="1800">
                 <a:solidFill>
                   <a:srgbClr val="302C3C"/>
@@ -13986,6 +14115,7 @@
               <a:spcAft>
                 <a:spcPts val="1500"/>
               </a:spcAft>
+              <a:buNone/>
               <a:defRPr sz="1800">
                 <a:solidFill>
                   <a:srgbClr val="302C3C"/>
@@ -14023,6 +14153,7 @@
               <a:spcAft>
                 <a:spcPts val="1500"/>
               </a:spcAft>
+              <a:buNone/>
               <a:defRPr sz="1800">
                 <a:solidFill>
                   <a:srgbClr val="302C3C"/>
@@ -14060,6 +14191,7 @@
               <a:spcAft>
                 <a:spcPts val="1500"/>
               </a:spcAft>
+              <a:buNone/>
               <a:defRPr sz="1800">
                 <a:solidFill>
                   <a:srgbClr val="302C3C"/>
@@ -14097,6 +14229,7 @@
               <a:spcAft>
                 <a:spcPts val="1500"/>
               </a:spcAft>
+              <a:buNone/>
               <a:defRPr sz="1800">
                 <a:solidFill>
                   <a:srgbClr val="302C3C"/>
@@ -15356,6 +15489,7 @@
               <a:spcAft>
                 <a:spcPts val="1500"/>
               </a:spcAft>
+              <a:buNone/>
               <a:defRPr sz="1725">
                 <a:solidFill>
                   <a:srgbClr val="302C3C"/>
@@ -15393,6 +15527,7 @@
               <a:spcAft>
                 <a:spcPts val="1500"/>
               </a:spcAft>
+              <a:buNone/>
               <a:defRPr sz="1725">
                 <a:solidFill>
                   <a:srgbClr val="302C3C"/>
@@ -15430,6 +15565,7 @@
               <a:spcAft>
                 <a:spcPts val="1500"/>
               </a:spcAft>
+              <a:buNone/>
               <a:defRPr sz="1725">
                 <a:solidFill>
                   <a:srgbClr val="302C3C"/>
@@ -15467,6 +15603,7 @@
               <a:spcAft>
                 <a:spcPts val="1500"/>
               </a:spcAft>
+              <a:buNone/>
               <a:defRPr sz="1725">
                 <a:solidFill>
                   <a:srgbClr val="302C3C"/>
@@ -15504,6 +15641,7 @@
               <a:spcAft>
                 <a:spcPts val="1500"/>
               </a:spcAft>
+              <a:buNone/>
               <a:defRPr sz="1725">
                 <a:solidFill>
                   <a:srgbClr val="302C3C"/>
@@ -15670,6 +15808,7 @@
               <a:spcAft>
                 <a:spcPts val="1500"/>
               </a:spcAft>
+              <a:buNone/>
               <a:defRPr sz="1725">
                 <a:solidFill>
                   <a:srgbClr val="302C3C"/>
@@ -15707,6 +15846,7 @@
               <a:spcAft>
                 <a:spcPts val="1500"/>
               </a:spcAft>
+              <a:buNone/>
               <a:defRPr sz="1725">
                 <a:solidFill>
                   <a:srgbClr val="302C3C"/>
@@ -15744,6 +15884,7 @@
               <a:spcAft>
                 <a:spcPts val="1500"/>
               </a:spcAft>
+              <a:buNone/>
               <a:defRPr sz="1725">
                 <a:solidFill>
                   <a:srgbClr val="302C3C"/>
@@ -15781,6 +15922,7 @@
               <a:spcAft>
                 <a:spcPts val="1500"/>
               </a:spcAft>
+              <a:buNone/>
               <a:defRPr sz="1725">
                 <a:solidFill>
                   <a:srgbClr val="302C3C"/>
@@ -15818,6 +15960,7 @@
               <a:spcAft>
                 <a:spcPts val="1500"/>
               </a:spcAft>
+              <a:buNone/>
               <a:defRPr sz="1725">
                 <a:solidFill>
                   <a:srgbClr val="302C3C"/>
@@ -15984,6 +16127,7 @@
               <a:spcAft>
                 <a:spcPts val="1500"/>
               </a:spcAft>
+              <a:buNone/>
               <a:defRPr sz="1725">
                 <a:solidFill>
                   <a:srgbClr val="302C3C"/>
@@ -16021,6 +16165,7 @@
               <a:spcAft>
                 <a:spcPts val="1500"/>
               </a:spcAft>
+              <a:buNone/>
               <a:defRPr sz="1725">
                 <a:solidFill>
                   <a:srgbClr val="302C3C"/>
@@ -16058,6 +16203,7 @@
               <a:spcAft>
                 <a:spcPts val="1500"/>
               </a:spcAft>
+              <a:buNone/>
               <a:defRPr sz="1725">
                 <a:solidFill>
                   <a:srgbClr val="302C3C"/>
@@ -16095,6 +16241,7 @@
               <a:spcAft>
                 <a:spcPts val="1500"/>
               </a:spcAft>
+              <a:buNone/>
               <a:defRPr sz="1725">
                 <a:solidFill>
                   <a:srgbClr val="302C3C"/>
@@ -16132,6 +16279,7 @@
               <a:spcAft>
                 <a:spcPts val="1500"/>
               </a:spcAft>
+              <a:buNone/>
               <a:defRPr sz="1725">
                 <a:solidFill>
                   <a:srgbClr val="302C3C"/>
@@ -16324,7 +16472,7 @@
                 <a:ea typeface="Arial"/>
                 <a:cs typeface="Arial"/>
               </a:rPr>
-              <a:t>Historical P0 — 19 September 2026  </a:t>
+              <a:t>P0 — staged CPU query encoding  </a:t>
             </a:r>
             <a:r>
               <a:rPr sz="1575">
@@ -16335,7 +16483,7 @@
                 <a:ea typeface="Arial"/>
                 <a:cs typeface="Arial"/>
               </a:rPr>
-              <a:t>NDCG@10 0.96558; MRR@10 0.95857; Recall@10 0.98619. This was the earlier frozen GPU-query configuration, not a measured CPU score for the corrected candidate.</a:t>
+              <a:t>NDCG@10 0.96583; MRR@10 0.95825; Recall@10 0.98805. Four CPU query shards; official MTEB scoring replay. Prior APPS test exposure; encoding time is separate.</a:t>
             </a:r>
           </a:p>
           <a:p xmlns:a="http://schemas.openxmlformats.org/drawingml/2006/main">
@@ -16446,7 +16594,7 @@
                 <a:ea typeface="Arial"/>
                 <a:cs typeface="Arial"/>
               </a:rPr>
-              <a:t>4-vCPU Kaggle Xeon; recorded peak RSS about 10.85 GB. APPS pretraining exposure is possible. Visible examples and subprocess limits do not prove correctness or provide a hardened security boundary.</a:t>
+              <a:t>4-vCPU Kaggle Xeon; peak RSS: P0 replay 9.41 GB; P1 fixture 10.85 GB. APPS pretraining exposure is possible. Visible examples and subprocess limits do not prove correctness or provide a hardened security boundary.</a:t>
             </a:r>
           </a:p>
         </p:txBody>
@@ -16583,6 +16731,7 @@
               <a:spcAft>
                 <a:spcPts val="1500"/>
               </a:spcAft>
+              <a:buNone/>
               <a:defRPr sz="1800">
                 <a:solidFill>
                   <a:srgbClr val="302C3C"/>
@@ -16620,6 +16769,7 @@
               <a:spcAft>
                 <a:spcPts val="1500"/>
               </a:spcAft>
+              <a:buNone/>
               <a:defRPr sz="1800">
                 <a:solidFill>
                   <a:srgbClr val="302C3C"/>
@@ -16657,6 +16807,7 @@
               <a:spcAft>
                 <a:spcPts val="1500"/>
               </a:spcAft>
+              <a:buNone/>
               <a:defRPr sz="1800">
                 <a:solidFill>
                   <a:srgbClr val="302C3C"/>
@@ -16694,6 +16845,7 @@
               <a:spcAft>
                 <a:spcPts val="1500"/>
               </a:spcAft>
+              <a:buNone/>
               <a:defRPr sz="1800">
                 <a:solidFill>
                   <a:srgbClr val="302C3C"/>

</xml_diff>